<commit_message>
vault backup: 2026-07-03 18:51:37
</commit_message>
<xml_diff>
--- a/assets/06-dataspace/image.pptx
+++ b/assets/06-dataspace/image.pptx
@@ -16,6 +16,7 @@
     <p:sldId id="382" r:id="rId10"/>
     <p:sldId id="383" r:id="rId11"/>
     <p:sldId id="384" r:id="rId12"/>
+    <p:sldId id="385" r:id="rId13"/>
   </p:sldIdLst>
   <p:sldSz cx="12192000" cy="6858000"/>
   <p:notesSz cx="6858000" cy="9144000"/>
@@ -135,7 +136,7 @@
   <pc:docChgLst>
     <pc:chgData name="헌정 임" userId="eb9ca9bd79f0560f" providerId="LiveId" clId="{A6339E56-8272-42D6-9D95-12E1A8284411}"/>
     <pc:docChg chg="undo custSel addSld modSld">
-      <pc:chgData name="헌정 임" userId="eb9ca9bd79f0560f" providerId="LiveId" clId="{A6339E56-8272-42D6-9D95-12E1A8284411}" dt="2026-07-03T07:34:30.993" v="20" actId="680"/>
+      <pc:chgData name="헌정 임" userId="eb9ca9bd79f0560f" providerId="LiveId" clId="{A6339E56-8272-42D6-9D95-12E1A8284411}" dt="2026-07-03T09:45:56.551" v="30" actId="1076"/>
       <pc:docMkLst>
         <pc:docMk/>
       </pc:docMkLst>
@@ -286,12 +287,59 @@
           <pc:sldMk cId="1773760154" sldId="383"/>
         </pc:sldMkLst>
       </pc:sldChg>
-      <pc:sldChg chg="new">
-        <pc:chgData name="헌정 임" userId="eb9ca9bd79f0560f" providerId="LiveId" clId="{A6339E56-8272-42D6-9D95-12E1A8284411}" dt="2026-07-03T07:34:30.993" v="20" actId="680"/>
+      <pc:sldChg chg="addSp new mod">
+        <pc:chgData name="헌정 임" userId="eb9ca9bd79f0560f" providerId="LiveId" clId="{A6339E56-8272-42D6-9D95-12E1A8284411}" dt="2026-07-03T09:43:23.158" v="21" actId="22"/>
         <pc:sldMkLst>
           <pc:docMk/>
           <pc:sldMk cId="2716414540" sldId="384"/>
         </pc:sldMkLst>
+        <pc:picChg chg="add">
+          <ac:chgData name="헌정 임" userId="eb9ca9bd79f0560f" providerId="LiveId" clId="{A6339E56-8272-42D6-9D95-12E1A8284411}" dt="2026-07-03T09:43:23.158" v="21" actId="22"/>
+          <ac:picMkLst>
+            <pc:docMk/>
+            <pc:sldMk cId="2716414540" sldId="384"/>
+            <ac:picMk id="4" creationId="{FB3FE90C-AB0C-FA41-F02C-017B65C7E1E0}"/>
+          </ac:picMkLst>
+        </pc:picChg>
+      </pc:sldChg>
+      <pc:sldChg chg="addSp modSp new mod">
+        <pc:chgData name="헌정 임" userId="eb9ca9bd79f0560f" providerId="LiveId" clId="{A6339E56-8272-42D6-9D95-12E1A8284411}" dt="2026-07-03T09:45:56.551" v="30" actId="1076"/>
+        <pc:sldMkLst>
+          <pc:docMk/>
+          <pc:sldMk cId="1983847626" sldId="385"/>
+        </pc:sldMkLst>
+        <pc:picChg chg="add mod">
+          <ac:chgData name="헌정 임" userId="eb9ca9bd79f0560f" providerId="LiveId" clId="{A6339E56-8272-42D6-9D95-12E1A8284411}" dt="2026-07-03T09:45:01.024" v="24" actId="1076"/>
+          <ac:picMkLst>
+            <pc:docMk/>
+            <pc:sldMk cId="1983847626" sldId="385"/>
+            <ac:picMk id="4" creationId="{D46C9835-FBA8-76FF-19E1-17A22C19FE4D}"/>
+          </ac:picMkLst>
+        </pc:picChg>
+        <pc:picChg chg="add mod">
+          <ac:chgData name="헌정 임" userId="eb9ca9bd79f0560f" providerId="LiveId" clId="{A6339E56-8272-42D6-9D95-12E1A8284411}" dt="2026-07-03T09:45:04.103" v="26" actId="1076"/>
+          <ac:picMkLst>
+            <pc:docMk/>
+            <pc:sldMk cId="1983847626" sldId="385"/>
+            <ac:picMk id="6" creationId="{FC127FFB-6F9B-41DE-A499-C39EB3281D17}"/>
+          </ac:picMkLst>
+        </pc:picChg>
+        <pc:picChg chg="add mod">
+          <ac:chgData name="헌정 임" userId="eb9ca9bd79f0560f" providerId="LiveId" clId="{A6339E56-8272-42D6-9D95-12E1A8284411}" dt="2026-07-03T09:45:33.755" v="28" actId="1076"/>
+          <ac:picMkLst>
+            <pc:docMk/>
+            <pc:sldMk cId="1983847626" sldId="385"/>
+            <ac:picMk id="8" creationId="{5FE4F172-8AD1-5C42-0140-DA4A2BE3DD96}"/>
+          </ac:picMkLst>
+        </pc:picChg>
+        <pc:picChg chg="add mod">
+          <ac:chgData name="헌정 임" userId="eb9ca9bd79f0560f" providerId="LiveId" clId="{A6339E56-8272-42D6-9D95-12E1A8284411}" dt="2026-07-03T09:45:56.551" v="30" actId="1076"/>
+          <ac:picMkLst>
+            <pc:docMk/>
+            <pc:sldMk cId="1983847626" sldId="385"/>
+            <ac:picMk id="10" creationId="{92735DA8-5C9C-348D-FD57-450DE0508F74}"/>
+          </ac:picMkLst>
+        </pc:picChg>
       </pc:sldChg>
     </pc:docChg>
   </pc:docChgLst>
@@ -3809,10 +3857,215 @@
           </a:p>
         </p:txBody>
       </p:sp>
+      <p:pic>
+        <p:nvPicPr>
+          <p:cNvPr id="4" name="그림 3">
+            <a:extLst>
+              <a:ext uri="{FF2B5EF4-FFF2-40B4-BE49-F238E27FC236}">
+                <a16:creationId xmlns:a16="http://schemas.microsoft.com/office/drawing/2014/main" id="{FB3FE90C-AB0C-FA41-F02C-017B65C7E1E0}"/>
+              </a:ext>
+            </a:extLst>
+          </p:cNvPr>
+          <p:cNvPicPr>
+            <a:picLocks noChangeAspect="1"/>
+          </p:cNvPicPr>
+          <p:nvPr/>
+        </p:nvPicPr>
+        <p:blipFill>
+          <a:blip r:embed="rId2"/>
+          <a:stretch>
+            <a:fillRect/>
+          </a:stretch>
+        </p:blipFill>
+        <p:spPr>
+          <a:xfrm>
+            <a:off x="0" y="28654"/>
+            <a:ext cx="12192000" cy="6800691"/>
+          </a:xfrm>
+          <a:prstGeom prst="rect">
+            <a:avLst/>
+          </a:prstGeom>
+        </p:spPr>
+      </p:pic>
     </p:spTree>
     <p:extLst>
       <p:ext uri="{BB962C8B-B14F-4D97-AF65-F5344CB8AC3E}">
         <p14:creationId xmlns:p14="http://schemas.microsoft.com/office/powerpoint/2010/main" val="2716414540"/>
+      </p:ext>
+    </p:extLst>
+  </p:cSld>
+  <p:clrMapOvr>
+    <a:masterClrMapping/>
+  </p:clrMapOvr>
+</p:sld>
+</file>
+
+<file path=ppt/slides/slide12.xml><?xml version="1.0" encoding="utf-8"?>
+<p:sld xmlns:a="http://schemas.openxmlformats.org/drawingml/2006/main" xmlns:r="http://schemas.openxmlformats.org/officeDocument/2006/relationships" xmlns:p="http://schemas.openxmlformats.org/presentationml/2006/main">
+  <p:cSld>
+    <p:spTree>
+      <p:nvGrpSpPr>
+        <p:cNvPr id="1" name=""/>
+        <p:cNvGrpSpPr/>
+        <p:nvPr/>
+      </p:nvGrpSpPr>
+      <p:grpSpPr>
+        <a:xfrm>
+          <a:off x="0" y="0"/>
+          <a:ext cx="0" cy="0"/>
+          <a:chOff x="0" y="0"/>
+          <a:chExt cx="0" cy="0"/>
+        </a:xfrm>
+      </p:grpSpPr>
+      <p:sp>
+        <p:nvSpPr>
+          <p:cNvPr id="2" name="제목 1">
+            <a:extLst>
+              <a:ext uri="{FF2B5EF4-FFF2-40B4-BE49-F238E27FC236}">
+                <a16:creationId xmlns:a16="http://schemas.microsoft.com/office/drawing/2014/main" id="{DA0C604D-4898-FB68-B7A1-BA45C421C029}"/>
+              </a:ext>
+            </a:extLst>
+          </p:cNvPr>
+          <p:cNvSpPr>
+            <a:spLocks noGrp="1"/>
+          </p:cNvSpPr>
+          <p:nvPr>
+            <p:ph type="title"/>
+          </p:nvPr>
+        </p:nvSpPr>
+        <p:spPr/>
+        <p:txBody>
+          <a:bodyPr/>
+          <a:lstStyle/>
+          <a:p>
+            <a:endParaRPr lang="ko-KR" altLang="en-US"/>
+          </a:p>
+        </p:txBody>
+      </p:sp>
+      <p:pic>
+        <p:nvPicPr>
+          <p:cNvPr id="4" name="그림 3">
+            <a:extLst>
+              <a:ext uri="{FF2B5EF4-FFF2-40B4-BE49-F238E27FC236}">
+                <a16:creationId xmlns:a16="http://schemas.microsoft.com/office/drawing/2014/main" id="{D46C9835-FBA8-76FF-19E1-17A22C19FE4D}"/>
+              </a:ext>
+            </a:extLst>
+          </p:cNvPr>
+          <p:cNvPicPr>
+            <a:picLocks noChangeAspect="1"/>
+          </p:cNvPicPr>
+          <p:nvPr/>
+        </p:nvPicPr>
+        <p:blipFill>
+          <a:blip r:embed="rId2"/>
+          <a:stretch>
+            <a:fillRect/>
+          </a:stretch>
+        </p:blipFill>
+        <p:spPr>
+          <a:xfrm>
+            <a:off x="207650" y="52363"/>
+            <a:ext cx="4333907" cy="6753274"/>
+          </a:xfrm>
+          <a:prstGeom prst="rect">
+            <a:avLst/>
+          </a:prstGeom>
+        </p:spPr>
+      </p:pic>
+      <p:pic>
+        <p:nvPicPr>
+          <p:cNvPr id="6" name="그림 5">
+            <a:extLst>
+              <a:ext uri="{FF2B5EF4-FFF2-40B4-BE49-F238E27FC236}">
+                <a16:creationId xmlns:a16="http://schemas.microsoft.com/office/drawing/2014/main" id="{FC127FFB-6F9B-41DE-A499-C39EB3281D17}"/>
+              </a:ext>
+            </a:extLst>
+          </p:cNvPr>
+          <p:cNvPicPr>
+            <a:picLocks noChangeAspect="1"/>
+          </p:cNvPicPr>
+          <p:nvPr/>
+        </p:nvPicPr>
+        <p:blipFill>
+          <a:blip r:embed="rId3"/>
+          <a:stretch>
+            <a:fillRect/>
+          </a:stretch>
+        </p:blipFill>
+        <p:spPr>
+          <a:xfrm>
+            <a:off x="4541557" y="0"/>
+            <a:ext cx="4248181" cy="6153195"/>
+          </a:xfrm>
+          <a:prstGeom prst="rect">
+            <a:avLst/>
+          </a:prstGeom>
+        </p:spPr>
+      </p:pic>
+      <p:pic>
+        <p:nvPicPr>
+          <p:cNvPr id="8" name="그림 7">
+            <a:extLst>
+              <a:ext uri="{FF2B5EF4-FFF2-40B4-BE49-F238E27FC236}">
+                <a16:creationId xmlns:a16="http://schemas.microsoft.com/office/drawing/2014/main" id="{5FE4F172-8AD1-5C42-0140-DA4A2BE3DD96}"/>
+              </a:ext>
+            </a:extLst>
+          </p:cNvPr>
+          <p:cNvPicPr>
+            <a:picLocks noChangeAspect="1"/>
+          </p:cNvPicPr>
+          <p:nvPr/>
+        </p:nvPicPr>
+        <p:blipFill>
+          <a:blip r:embed="rId4"/>
+          <a:stretch>
+            <a:fillRect/>
+          </a:stretch>
+        </p:blipFill>
+        <p:spPr>
+          <a:xfrm>
+            <a:off x="4512982" y="6202385"/>
+            <a:ext cx="4305331" cy="2209816"/>
+          </a:xfrm>
+          <a:prstGeom prst="rect">
+            <a:avLst/>
+          </a:prstGeom>
+        </p:spPr>
+      </p:pic>
+      <p:pic>
+        <p:nvPicPr>
+          <p:cNvPr id="10" name="그림 9">
+            <a:extLst>
+              <a:ext uri="{FF2B5EF4-FFF2-40B4-BE49-F238E27FC236}">
+                <a16:creationId xmlns:a16="http://schemas.microsoft.com/office/drawing/2014/main" id="{92735DA8-5C9C-348D-FD57-450DE0508F74}"/>
+              </a:ext>
+            </a:extLst>
+          </p:cNvPr>
+          <p:cNvPicPr>
+            <a:picLocks noChangeAspect="1"/>
+          </p:cNvPicPr>
+          <p:nvPr/>
+        </p:nvPicPr>
+        <p:blipFill>
+          <a:blip r:embed="rId5"/>
+          <a:stretch>
+            <a:fillRect/>
+          </a:stretch>
+        </p:blipFill>
+        <p:spPr>
+          <a:xfrm>
+            <a:off x="7905719" y="149057"/>
+            <a:ext cx="4286281" cy="5581691"/>
+          </a:xfrm>
+          <a:prstGeom prst="rect">
+            <a:avLst/>
+          </a:prstGeom>
+        </p:spPr>
+      </p:pic>
+    </p:spTree>
+    <p:extLst>
+      <p:ext uri="{BB962C8B-B14F-4D97-AF65-F5344CB8AC3E}">
+        <p14:creationId xmlns:p14="http://schemas.microsoft.com/office/powerpoint/2010/main" val="1983847626"/>
       </p:ext>
     </p:extLst>
   </p:cSld>

</xml_diff>

<commit_message>
vault backup: 2026-07-03 21:06:37
</commit_message>
<xml_diff>
--- a/assets/06-dataspace/image.pptx
+++ b/assets/06-dataspace/image.pptx
@@ -12,11 +12,9 @@
     <p:sldId id="260" r:id="rId6"/>
     <p:sldId id="380" r:id="rId7"/>
     <p:sldId id="261" r:id="rId8"/>
-    <p:sldId id="381" r:id="rId9"/>
-    <p:sldId id="382" r:id="rId10"/>
-    <p:sldId id="383" r:id="rId11"/>
-    <p:sldId id="384" r:id="rId12"/>
-    <p:sldId id="385" r:id="rId13"/>
+    <p:sldId id="386" r:id="rId9"/>
+    <p:sldId id="384" r:id="rId10"/>
+    <p:sldId id="385" r:id="rId11"/>
   </p:sldIdLst>
   <p:sldSz cx="12192000" cy="6858000"/>
   <p:notesSz cx="6858000" cy="9144000"/>
@@ -126,7 +124,7 @@
 <file path=ppt/revisionInfo.xml><?xml version="1.0" encoding="utf-8"?>
 <p1510:revInfo xmlns:a="http://schemas.openxmlformats.org/drawingml/2006/main" xmlns:r="http://schemas.openxmlformats.org/officeDocument/2006/relationships" xmlns:p1510="http://schemas.microsoft.com/office/powerpoint/2015/10/main">
   <p1510:revLst>
-    <p1510:client id="{77AFA03C-ADB3-48E7-9DEE-EC77C33AF38A}" v="3" dt="2026-07-03T07:33:57.187"/>
+    <p1510:client id="{77AFA03C-ADB3-48E7-9DEE-EC77C33AF38A}" v="6" dt="2026-07-03T11:57:33.435"/>
   </p1510:revLst>
 </p1510:revInfo>
 </file>
@@ -135,13 +133,13 @@
 <pc:chgInfo xmlns:a="http://schemas.openxmlformats.org/drawingml/2006/main" xmlns:r="http://schemas.openxmlformats.org/officeDocument/2006/relationships" xmlns:ac="http://schemas.microsoft.com/office/drawing/2013/main/command" xmlns:pc="http://schemas.microsoft.com/office/powerpoint/2013/main/command">
   <pc:docChgLst>
     <pc:chgData name="헌정 임" userId="eb9ca9bd79f0560f" providerId="LiveId" clId="{A6339E56-8272-42D6-9D95-12E1A8284411}"/>
-    <pc:docChg chg="undo custSel addSld modSld">
-      <pc:chgData name="헌정 임" userId="eb9ca9bd79f0560f" providerId="LiveId" clId="{A6339E56-8272-42D6-9D95-12E1A8284411}" dt="2026-07-03T09:45:56.551" v="30" actId="1076"/>
+    <pc:docChg chg="undo custSel addSld delSld modSld">
+      <pc:chgData name="헌정 임" userId="eb9ca9bd79f0560f" providerId="LiveId" clId="{A6339E56-8272-42D6-9D95-12E1A8284411}" dt="2026-07-03T12:02:03.542" v="53" actId="22"/>
       <pc:docMkLst>
         <pc:docMk/>
       </pc:docMkLst>
       <pc:sldChg chg="addSp delSp modSp new mod">
-        <pc:chgData name="헌정 임" userId="eb9ca9bd79f0560f" providerId="LiveId" clId="{A6339E56-8272-42D6-9D95-12E1A8284411}" dt="2026-07-03T07:34:12.688" v="16" actId="14100"/>
+        <pc:chgData name="헌정 임" userId="eb9ca9bd79f0560f" providerId="LiveId" clId="{A6339E56-8272-42D6-9D95-12E1A8284411}" dt="2026-07-03T12:00:20.867" v="48" actId="21"/>
         <pc:sldMkLst>
           <pc:docMk/>
           <pc:sldMk cId="1262162233" sldId="261"/>
@@ -168,6 +166,14 @@
             <pc:docMk/>
             <pc:sldMk cId="1262162233" sldId="261"/>
             <ac:picMk id="4" creationId="{B96D3F62-B0FA-7690-86A0-3A3B118E403B}"/>
+          </ac:picMkLst>
+        </pc:picChg>
+        <pc:picChg chg="add del">
+          <ac:chgData name="헌정 임" userId="eb9ca9bd79f0560f" providerId="LiveId" clId="{A6339E56-8272-42D6-9D95-12E1A8284411}" dt="2026-07-03T12:00:20.867" v="48" actId="21"/>
+          <ac:picMkLst>
+            <pc:docMk/>
+            <pc:sldMk cId="1262162233" sldId="261"/>
+            <ac:picMk id="7" creationId="{39B65CD4-95CF-E3C3-5111-A6CDB4FCAFE6}"/>
           </ac:picMkLst>
         </pc:picChg>
       </pc:sldChg>
@@ -266,22 +272,22 @@
           </ac:picMkLst>
         </pc:picChg>
       </pc:sldChg>
-      <pc:sldChg chg="new">
-        <pc:chgData name="헌정 임" userId="eb9ca9bd79f0560f" providerId="LiveId" clId="{A6339E56-8272-42D6-9D95-12E1A8284411}" dt="2026-07-03T07:34:30.491" v="17" actId="680"/>
+      <pc:sldChg chg="new del">
+        <pc:chgData name="헌정 임" userId="eb9ca9bd79f0560f" providerId="LiveId" clId="{A6339E56-8272-42D6-9D95-12E1A8284411}" dt="2026-07-03T12:00:40.476" v="49" actId="47"/>
         <pc:sldMkLst>
           <pc:docMk/>
           <pc:sldMk cId="2888748938" sldId="381"/>
         </pc:sldMkLst>
       </pc:sldChg>
-      <pc:sldChg chg="new">
-        <pc:chgData name="헌정 임" userId="eb9ca9bd79f0560f" providerId="LiveId" clId="{A6339E56-8272-42D6-9D95-12E1A8284411}" dt="2026-07-03T07:34:30.685" v="18" actId="680"/>
+      <pc:sldChg chg="new del">
+        <pc:chgData name="헌정 임" userId="eb9ca9bd79f0560f" providerId="LiveId" clId="{A6339E56-8272-42D6-9D95-12E1A8284411}" dt="2026-07-03T12:00:41.522" v="50" actId="47"/>
         <pc:sldMkLst>
           <pc:docMk/>
           <pc:sldMk cId="3995347164" sldId="382"/>
         </pc:sldMkLst>
       </pc:sldChg>
-      <pc:sldChg chg="new">
-        <pc:chgData name="헌정 임" userId="eb9ca9bd79f0560f" providerId="LiveId" clId="{A6339E56-8272-42D6-9D95-12E1A8284411}" dt="2026-07-03T07:34:30.849" v="19" actId="680"/>
+      <pc:sldChg chg="new del">
+        <pc:chgData name="헌정 임" userId="eb9ca9bd79f0560f" providerId="LiveId" clId="{A6339E56-8272-42D6-9D95-12E1A8284411}" dt="2026-07-03T12:00:42.728" v="51" actId="47"/>
         <pc:sldMkLst>
           <pc:docMk/>
           <pc:sldMk cId="1773760154" sldId="383"/>
@@ -303,21 +309,21 @@
         </pc:picChg>
       </pc:sldChg>
       <pc:sldChg chg="addSp modSp new mod">
-        <pc:chgData name="헌정 임" userId="eb9ca9bd79f0560f" providerId="LiveId" clId="{A6339E56-8272-42D6-9D95-12E1A8284411}" dt="2026-07-03T09:45:56.551" v="30" actId="1076"/>
+        <pc:chgData name="헌정 임" userId="eb9ca9bd79f0560f" providerId="LiveId" clId="{A6339E56-8272-42D6-9D95-12E1A8284411}" dt="2026-07-03T11:58:00.547" v="46" actId="1076"/>
         <pc:sldMkLst>
           <pc:docMk/>
           <pc:sldMk cId="1983847626" sldId="385"/>
         </pc:sldMkLst>
-        <pc:picChg chg="add mod">
-          <ac:chgData name="헌정 임" userId="eb9ca9bd79f0560f" providerId="LiveId" clId="{A6339E56-8272-42D6-9D95-12E1A8284411}" dt="2026-07-03T09:45:01.024" v="24" actId="1076"/>
+        <pc:picChg chg="add mod modCrop">
+          <ac:chgData name="헌정 임" userId="eb9ca9bd79f0560f" providerId="LiveId" clId="{A6339E56-8272-42D6-9D95-12E1A8284411}" dt="2026-07-03T11:57:29.577" v="38" actId="1076"/>
           <ac:picMkLst>
             <pc:docMk/>
             <pc:sldMk cId="1983847626" sldId="385"/>
             <ac:picMk id="4" creationId="{D46C9835-FBA8-76FF-19E1-17A22C19FE4D}"/>
           </ac:picMkLst>
         </pc:picChg>
-        <pc:picChg chg="add mod">
-          <ac:chgData name="헌정 임" userId="eb9ca9bd79f0560f" providerId="LiveId" clId="{A6339E56-8272-42D6-9D95-12E1A8284411}" dt="2026-07-03T09:45:04.103" v="26" actId="1076"/>
+        <pc:picChg chg="add mod modCrop">
+          <ac:chgData name="헌정 임" userId="eb9ca9bd79f0560f" providerId="LiveId" clId="{A6339E56-8272-42D6-9D95-12E1A8284411}" dt="2026-07-03T11:57:58.895" v="45" actId="1076"/>
           <ac:picMkLst>
             <pc:docMk/>
             <pc:sldMk cId="1983847626" sldId="385"/>
@@ -325,7 +331,7 @@
           </ac:picMkLst>
         </pc:picChg>
         <pc:picChg chg="add mod">
-          <ac:chgData name="헌정 임" userId="eb9ca9bd79f0560f" providerId="LiveId" clId="{A6339E56-8272-42D6-9D95-12E1A8284411}" dt="2026-07-03T09:45:33.755" v="28" actId="1076"/>
+          <ac:chgData name="헌정 임" userId="eb9ca9bd79f0560f" providerId="LiveId" clId="{A6339E56-8272-42D6-9D95-12E1A8284411}" dt="2026-07-03T11:57:57.423" v="44" actId="1076"/>
           <ac:picMkLst>
             <pc:docMk/>
             <pc:sldMk cId="1983847626" sldId="385"/>
@@ -333,11 +339,50 @@
           </ac:picMkLst>
         </pc:picChg>
         <pc:picChg chg="add mod">
-          <ac:chgData name="헌정 임" userId="eb9ca9bd79f0560f" providerId="LiveId" clId="{A6339E56-8272-42D6-9D95-12E1A8284411}" dt="2026-07-03T09:45:56.551" v="30" actId="1076"/>
+          <ac:chgData name="헌정 임" userId="eb9ca9bd79f0560f" providerId="LiveId" clId="{A6339E56-8272-42D6-9D95-12E1A8284411}" dt="2026-07-03T11:58:00.547" v="46" actId="1076"/>
           <ac:picMkLst>
             <pc:docMk/>
             <pc:sldMk cId="1983847626" sldId="385"/>
             <ac:picMk id="10" creationId="{92735DA8-5C9C-348D-FD57-450DE0508F74}"/>
+          </ac:picMkLst>
+        </pc:picChg>
+        <pc:picChg chg="add mod modCrop">
+          <ac:chgData name="헌정 임" userId="eb9ca9bd79f0560f" providerId="LiveId" clId="{A6339E56-8272-42D6-9D95-12E1A8284411}" dt="2026-07-03T11:56:57.442" v="32" actId="732"/>
+          <ac:picMkLst>
+            <pc:docMk/>
+            <pc:sldMk cId="1983847626" sldId="385"/>
+            <ac:picMk id="11" creationId="{190B6743-2176-3074-22CE-7C8BCB59873C}"/>
+          </ac:picMkLst>
+        </pc:picChg>
+        <pc:picChg chg="add mod modCrop">
+          <ac:chgData name="헌정 임" userId="eb9ca9bd79f0560f" providerId="LiveId" clId="{A6339E56-8272-42D6-9D95-12E1A8284411}" dt="2026-07-03T11:57:30.978" v="39" actId="1076"/>
+          <ac:picMkLst>
+            <pc:docMk/>
+            <pc:sldMk cId="1983847626" sldId="385"/>
+            <ac:picMk id="12" creationId="{8A1E3112-45E3-0CB1-E1B4-6F0256BAF1E3}"/>
+          </ac:picMkLst>
+        </pc:picChg>
+        <pc:picChg chg="add mod modCrop">
+          <ac:chgData name="헌정 임" userId="eb9ca9bd79f0560f" providerId="LiveId" clId="{A6339E56-8272-42D6-9D95-12E1A8284411}" dt="2026-07-03T11:57:44.864" v="41" actId="732"/>
+          <ac:picMkLst>
+            <pc:docMk/>
+            <pc:sldMk cId="1983847626" sldId="385"/>
+            <ac:picMk id="13" creationId="{1C9043BD-C001-5B13-4D1A-9C757CE0088D}"/>
+          </ac:picMkLst>
+        </pc:picChg>
+      </pc:sldChg>
+      <pc:sldChg chg="addSp new mod">
+        <pc:chgData name="헌정 임" userId="eb9ca9bd79f0560f" providerId="LiveId" clId="{A6339E56-8272-42D6-9D95-12E1A8284411}" dt="2026-07-03T12:02:03.542" v="53" actId="22"/>
+        <pc:sldMkLst>
+          <pc:docMk/>
+          <pc:sldMk cId="1787533717" sldId="386"/>
+        </pc:sldMkLst>
+        <pc:picChg chg="add">
+          <ac:chgData name="헌정 임" userId="eb9ca9bd79f0560f" providerId="LiveId" clId="{A6339E56-8272-42D6-9D95-12E1A8284411}" dt="2026-07-03T12:02:03.542" v="53" actId="22"/>
+          <ac:picMkLst>
+            <pc:docMk/>
+            <pc:sldMk cId="1787533717" sldId="386"/>
+            <ac:picMk id="4" creationId="{BCF4503C-9B6F-443B-6743-E905216D5ECC}"/>
           </ac:picMkLst>
         </pc:picChg>
       </pc:sldChg>
@@ -3782,146 +3827,6 @@
           <p:cNvPr id="2" name="제목 1">
             <a:extLst>
               <a:ext uri="{FF2B5EF4-FFF2-40B4-BE49-F238E27FC236}">
-                <a16:creationId xmlns:a16="http://schemas.microsoft.com/office/drawing/2014/main" id="{202C9A6E-0C40-1886-F24E-AF1CC833B61B}"/>
-              </a:ext>
-            </a:extLst>
-          </p:cNvPr>
-          <p:cNvSpPr>
-            <a:spLocks noGrp="1"/>
-          </p:cNvSpPr>
-          <p:nvPr>
-            <p:ph type="title"/>
-          </p:nvPr>
-        </p:nvSpPr>
-        <p:spPr/>
-        <p:txBody>
-          <a:bodyPr/>
-          <a:lstStyle/>
-          <a:p>
-            <a:endParaRPr lang="ko-KR" altLang="en-US"/>
-          </a:p>
-        </p:txBody>
-      </p:sp>
-    </p:spTree>
-    <p:extLst>
-      <p:ext uri="{BB962C8B-B14F-4D97-AF65-F5344CB8AC3E}">
-        <p14:creationId xmlns:p14="http://schemas.microsoft.com/office/powerpoint/2010/main" val="1773760154"/>
-      </p:ext>
-    </p:extLst>
-  </p:cSld>
-  <p:clrMapOvr>
-    <a:masterClrMapping/>
-  </p:clrMapOvr>
-</p:sld>
-</file>
-
-<file path=ppt/slides/slide11.xml><?xml version="1.0" encoding="utf-8"?>
-<p:sld xmlns:a="http://schemas.openxmlformats.org/drawingml/2006/main" xmlns:r="http://schemas.openxmlformats.org/officeDocument/2006/relationships" xmlns:p="http://schemas.openxmlformats.org/presentationml/2006/main">
-  <p:cSld>
-    <p:spTree>
-      <p:nvGrpSpPr>
-        <p:cNvPr id="1" name=""/>
-        <p:cNvGrpSpPr/>
-        <p:nvPr/>
-      </p:nvGrpSpPr>
-      <p:grpSpPr>
-        <a:xfrm>
-          <a:off x="0" y="0"/>
-          <a:ext cx="0" cy="0"/>
-          <a:chOff x="0" y="0"/>
-          <a:chExt cx="0" cy="0"/>
-        </a:xfrm>
-      </p:grpSpPr>
-      <p:sp>
-        <p:nvSpPr>
-          <p:cNvPr id="2" name="제목 1">
-            <a:extLst>
-              <a:ext uri="{FF2B5EF4-FFF2-40B4-BE49-F238E27FC236}">
-                <a16:creationId xmlns:a16="http://schemas.microsoft.com/office/drawing/2014/main" id="{95DFFF03-DF33-1257-F38B-21CE6EF8E69D}"/>
-              </a:ext>
-            </a:extLst>
-          </p:cNvPr>
-          <p:cNvSpPr>
-            <a:spLocks noGrp="1"/>
-          </p:cNvSpPr>
-          <p:nvPr>
-            <p:ph type="title"/>
-          </p:nvPr>
-        </p:nvSpPr>
-        <p:spPr/>
-        <p:txBody>
-          <a:bodyPr/>
-          <a:lstStyle/>
-          <a:p>
-            <a:endParaRPr lang="ko-KR" altLang="en-US"/>
-          </a:p>
-        </p:txBody>
-      </p:sp>
-      <p:pic>
-        <p:nvPicPr>
-          <p:cNvPr id="4" name="그림 3">
-            <a:extLst>
-              <a:ext uri="{FF2B5EF4-FFF2-40B4-BE49-F238E27FC236}">
-                <a16:creationId xmlns:a16="http://schemas.microsoft.com/office/drawing/2014/main" id="{FB3FE90C-AB0C-FA41-F02C-017B65C7E1E0}"/>
-              </a:ext>
-            </a:extLst>
-          </p:cNvPr>
-          <p:cNvPicPr>
-            <a:picLocks noChangeAspect="1"/>
-          </p:cNvPicPr>
-          <p:nvPr/>
-        </p:nvPicPr>
-        <p:blipFill>
-          <a:blip r:embed="rId2"/>
-          <a:stretch>
-            <a:fillRect/>
-          </a:stretch>
-        </p:blipFill>
-        <p:spPr>
-          <a:xfrm>
-            <a:off x="0" y="28654"/>
-            <a:ext cx="12192000" cy="6800691"/>
-          </a:xfrm>
-          <a:prstGeom prst="rect">
-            <a:avLst/>
-          </a:prstGeom>
-        </p:spPr>
-      </p:pic>
-    </p:spTree>
-    <p:extLst>
-      <p:ext uri="{BB962C8B-B14F-4D97-AF65-F5344CB8AC3E}">
-        <p14:creationId xmlns:p14="http://schemas.microsoft.com/office/powerpoint/2010/main" val="2716414540"/>
-      </p:ext>
-    </p:extLst>
-  </p:cSld>
-  <p:clrMapOvr>
-    <a:masterClrMapping/>
-  </p:clrMapOvr>
-</p:sld>
-</file>
-
-<file path=ppt/slides/slide12.xml><?xml version="1.0" encoding="utf-8"?>
-<p:sld xmlns:a="http://schemas.openxmlformats.org/drawingml/2006/main" xmlns:r="http://schemas.openxmlformats.org/officeDocument/2006/relationships" xmlns:p="http://schemas.openxmlformats.org/presentationml/2006/main">
-  <p:cSld>
-    <p:spTree>
-      <p:nvGrpSpPr>
-        <p:cNvPr id="1" name=""/>
-        <p:cNvGrpSpPr/>
-        <p:nvPr/>
-      </p:nvGrpSpPr>
-      <p:grpSpPr>
-        <a:xfrm>
-          <a:off x="0" y="0"/>
-          <a:ext cx="0" cy="0"/>
-          <a:chOff x="0" y="0"/>
-          <a:chExt cx="0" cy="0"/>
-        </a:xfrm>
-      </p:grpSpPr>
-      <p:sp>
-        <p:nvSpPr>
-          <p:cNvPr id="2" name="제목 1">
-            <a:extLst>
-              <a:ext uri="{FF2B5EF4-FFF2-40B4-BE49-F238E27FC236}">
                 <a16:creationId xmlns:a16="http://schemas.microsoft.com/office/drawing/2014/main" id="{DA0C604D-4898-FB68-B7A1-BA45C421C029}"/>
               </a:ext>
             </a:extLst>
@@ -3958,14 +3863,15 @@
         </p:nvPicPr>
         <p:blipFill>
           <a:blip r:embed="rId2"/>
+          <a:srcRect t="53795" b="23331"/>
           <a:stretch>
             <a:fillRect/>
           </a:stretch>
         </p:blipFill>
         <p:spPr>
           <a:xfrm>
-            <a:off x="207650" y="52363"/>
-            <a:ext cx="4333907" cy="6753274"/>
+            <a:off x="207650" y="4657603"/>
+            <a:ext cx="4333907" cy="1544782"/>
           </a:xfrm>
           <a:prstGeom prst="rect">
             <a:avLst/>
@@ -3988,14 +3894,15 @@
         </p:nvPicPr>
         <p:blipFill>
           <a:blip r:embed="rId3"/>
+          <a:srcRect t="48199"/>
           <a:stretch>
             <a:fillRect/>
           </a:stretch>
         </p:blipFill>
         <p:spPr>
           <a:xfrm>
-            <a:off x="4541557" y="0"/>
-            <a:ext cx="4248181" cy="6153195"/>
+            <a:off x="4541557" y="4087092"/>
+            <a:ext cx="4248181" cy="3187434"/>
           </a:xfrm>
           <a:prstGeom prst="rect">
             <a:avLst/>
@@ -4024,7 +3931,7 @@
         </p:blipFill>
         <p:spPr>
           <a:xfrm>
-            <a:off x="4512982" y="6202385"/>
+            <a:off x="4570133" y="6967971"/>
             <a:ext cx="4305331" cy="2209816"/>
           </a:xfrm>
           <a:prstGeom prst="rect">
@@ -4054,8 +3961,101 @@
         </p:blipFill>
         <p:spPr>
           <a:xfrm>
-            <a:off x="7905719" y="149057"/>
+            <a:off x="7905719" y="180933"/>
             <a:ext cx="4286281" cy="5581691"/>
+          </a:xfrm>
+          <a:prstGeom prst="rect">
+            <a:avLst/>
+          </a:prstGeom>
+        </p:spPr>
+      </p:pic>
+      <p:pic>
+        <p:nvPicPr>
+          <p:cNvPr id="11" name="그림 10">
+            <a:extLst>
+              <a:ext uri="{FF2B5EF4-FFF2-40B4-BE49-F238E27FC236}">
+                <a16:creationId xmlns:a16="http://schemas.microsoft.com/office/drawing/2014/main" id="{190B6743-2176-3074-22CE-7C8BCB59873C}"/>
+              </a:ext>
+            </a:extLst>
+          </p:cNvPr>
+          <p:cNvPicPr>
+            <a:picLocks noChangeAspect="1"/>
+          </p:cNvPicPr>
+          <p:nvPr/>
+        </p:nvPicPr>
+        <p:blipFill>
+          <a:blip r:embed="rId2"/>
+          <a:srcRect b="45959"/>
+          <a:stretch>
+            <a:fillRect/>
+          </a:stretch>
+        </p:blipFill>
+        <p:spPr>
+          <a:xfrm>
+            <a:off x="207650" y="946318"/>
+            <a:ext cx="4333907" cy="3649503"/>
+          </a:xfrm>
+          <a:prstGeom prst="rect">
+            <a:avLst/>
+          </a:prstGeom>
+        </p:spPr>
+      </p:pic>
+      <p:pic>
+        <p:nvPicPr>
+          <p:cNvPr id="12" name="그림 11">
+            <a:extLst>
+              <a:ext uri="{FF2B5EF4-FFF2-40B4-BE49-F238E27FC236}">
+                <a16:creationId xmlns:a16="http://schemas.microsoft.com/office/drawing/2014/main" id="{8A1E3112-45E3-0CB1-E1B4-6F0256BAF1E3}"/>
+              </a:ext>
+            </a:extLst>
+          </p:cNvPr>
+          <p:cNvPicPr>
+            <a:picLocks noChangeAspect="1"/>
+          </p:cNvPicPr>
+          <p:nvPr/>
+        </p:nvPicPr>
+        <p:blipFill>
+          <a:blip r:embed="rId2"/>
+          <a:srcRect t="76233"/>
+          <a:stretch>
+            <a:fillRect/>
+          </a:stretch>
+        </p:blipFill>
+        <p:spPr>
+          <a:xfrm>
+            <a:off x="207650" y="6624832"/>
+            <a:ext cx="4333907" cy="1605032"/>
+          </a:xfrm>
+          <a:prstGeom prst="rect">
+            <a:avLst/>
+          </a:prstGeom>
+        </p:spPr>
+      </p:pic>
+      <p:pic>
+        <p:nvPicPr>
+          <p:cNvPr id="13" name="그림 12">
+            <a:extLst>
+              <a:ext uri="{FF2B5EF4-FFF2-40B4-BE49-F238E27FC236}">
+                <a16:creationId xmlns:a16="http://schemas.microsoft.com/office/drawing/2014/main" id="{1C9043BD-C001-5B13-4D1A-9C757CE0088D}"/>
+              </a:ext>
+            </a:extLst>
+          </p:cNvPr>
+          <p:cNvPicPr>
+            <a:picLocks noChangeAspect="1"/>
+          </p:cNvPicPr>
+          <p:nvPr/>
+        </p:nvPicPr>
+        <p:blipFill>
+          <a:blip r:embed="rId3"/>
+          <a:srcRect b="51379"/>
+          <a:stretch>
+            <a:fillRect/>
+          </a:stretch>
+        </p:blipFill>
+        <p:spPr>
+          <a:xfrm>
+            <a:off x="4541557" y="1095376"/>
+            <a:ext cx="4248181" cy="2991716"/>
           </a:xfrm>
           <a:prstGeom prst="rect">
             <a:avLst/>
@@ -41261,7 +41261,7 @@
           <p:cNvPr id="2" name="제목 1">
             <a:extLst>
               <a:ext uri="{FF2B5EF4-FFF2-40B4-BE49-F238E27FC236}">
-                <a16:creationId xmlns:a16="http://schemas.microsoft.com/office/drawing/2014/main" id="{94FC513F-1296-0AAE-51A2-CA26854136BB}"/>
+                <a16:creationId xmlns:a16="http://schemas.microsoft.com/office/drawing/2014/main" id="{9C0FF6DA-7456-A694-495F-C85E2B36578C}"/>
               </a:ext>
             </a:extLst>
           </p:cNvPr>
@@ -41281,10 +41281,40 @@
           </a:p>
         </p:txBody>
       </p:sp>
+      <p:pic>
+        <p:nvPicPr>
+          <p:cNvPr id="4" name="그림 3">
+            <a:extLst>
+              <a:ext uri="{FF2B5EF4-FFF2-40B4-BE49-F238E27FC236}">
+                <a16:creationId xmlns:a16="http://schemas.microsoft.com/office/drawing/2014/main" id="{BCF4503C-9B6F-443B-6743-E905216D5ECC}"/>
+              </a:ext>
+            </a:extLst>
+          </p:cNvPr>
+          <p:cNvPicPr>
+            <a:picLocks noChangeAspect="1"/>
+          </p:cNvPicPr>
+          <p:nvPr/>
+        </p:nvPicPr>
+        <p:blipFill>
+          <a:blip r:embed="rId2"/>
+          <a:stretch>
+            <a:fillRect/>
+          </a:stretch>
+        </p:blipFill>
+        <p:spPr>
+          <a:xfrm>
+            <a:off x="0" y="39505"/>
+            <a:ext cx="12192000" cy="6778990"/>
+          </a:xfrm>
+          <a:prstGeom prst="rect">
+            <a:avLst/>
+          </a:prstGeom>
+        </p:spPr>
+      </p:pic>
     </p:spTree>
     <p:extLst>
       <p:ext uri="{BB962C8B-B14F-4D97-AF65-F5344CB8AC3E}">
-        <p14:creationId xmlns:p14="http://schemas.microsoft.com/office/powerpoint/2010/main" val="2888748938"/>
+        <p14:creationId xmlns:p14="http://schemas.microsoft.com/office/powerpoint/2010/main" val="1787533717"/>
       </p:ext>
     </p:extLst>
   </p:cSld>
@@ -41316,7 +41346,7 @@
           <p:cNvPr id="2" name="제목 1">
             <a:extLst>
               <a:ext uri="{FF2B5EF4-FFF2-40B4-BE49-F238E27FC236}">
-                <a16:creationId xmlns:a16="http://schemas.microsoft.com/office/drawing/2014/main" id="{4E7CF910-DBCF-4B8C-C459-7A525828B36D}"/>
+                <a16:creationId xmlns:a16="http://schemas.microsoft.com/office/drawing/2014/main" id="{95DFFF03-DF33-1257-F38B-21CE6EF8E69D}"/>
               </a:ext>
             </a:extLst>
           </p:cNvPr>
@@ -41336,10 +41366,40 @@
           </a:p>
         </p:txBody>
       </p:sp>
+      <p:pic>
+        <p:nvPicPr>
+          <p:cNvPr id="4" name="그림 3">
+            <a:extLst>
+              <a:ext uri="{FF2B5EF4-FFF2-40B4-BE49-F238E27FC236}">
+                <a16:creationId xmlns:a16="http://schemas.microsoft.com/office/drawing/2014/main" id="{FB3FE90C-AB0C-FA41-F02C-017B65C7E1E0}"/>
+              </a:ext>
+            </a:extLst>
+          </p:cNvPr>
+          <p:cNvPicPr>
+            <a:picLocks noChangeAspect="1"/>
+          </p:cNvPicPr>
+          <p:nvPr/>
+        </p:nvPicPr>
+        <p:blipFill>
+          <a:blip r:embed="rId2"/>
+          <a:stretch>
+            <a:fillRect/>
+          </a:stretch>
+        </p:blipFill>
+        <p:spPr>
+          <a:xfrm>
+            <a:off x="0" y="28654"/>
+            <a:ext cx="12192000" cy="6800691"/>
+          </a:xfrm>
+          <a:prstGeom prst="rect">
+            <a:avLst/>
+          </a:prstGeom>
+        </p:spPr>
+      </p:pic>
     </p:spTree>
     <p:extLst>
       <p:ext uri="{BB962C8B-B14F-4D97-AF65-F5344CB8AC3E}">
-        <p14:creationId xmlns:p14="http://schemas.microsoft.com/office/powerpoint/2010/main" val="3995347164"/>
+        <p14:creationId xmlns:p14="http://schemas.microsoft.com/office/powerpoint/2010/main" val="2716414540"/>
       </p:ext>
     </p:extLst>
   </p:cSld>

</xml_diff>

<commit_message>
vault backup: 2026-07-03 21:17:10
</commit_message>
<xml_diff>
--- a/assets/06-dataspace/image.pptx
+++ b/assets/06-dataspace/image.pptx
@@ -12,9 +12,11 @@
     <p:sldId id="260" r:id="rId6"/>
     <p:sldId id="380" r:id="rId7"/>
     <p:sldId id="261" r:id="rId8"/>
-    <p:sldId id="386" r:id="rId9"/>
+    <p:sldId id="389" r:id="rId9"/>
     <p:sldId id="384" r:id="rId10"/>
     <p:sldId id="385" r:id="rId11"/>
+    <p:sldId id="387" r:id="rId12"/>
+    <p:sldId id="388" r:id="rId13"/>
   </p:sldIdLst>
   <p:sldSz cx="12192000" cy="6858000"/>
   <p:notesSz cx="6858000" cy="9144000"/>
@@ -124,7 +126,7 @@
 <file path=ppt/revisionInfo.xml><?xml version="1.0" encoding="utf-8"?>
 <p1510:revInfo xmlns:a="http://schemas.openxmlformats.org/drawingml/2006/main" xmlns:r="http://schemas.openxmlformats.org/officeDocument/2006/relationships" xmlns:p1510="http://schemas.microsoft.com/office/powerpoint/2015/10/main">
   <p1510:revLst>
-    <p1510:client id="{77AFA03C-ADB3-48E7-9DEE-EC77C33AF38A}" v="6" dt="2026-07-03T11:57:33.435"/>
+    <p1510:client id="{77AFA03C-ADB3-48E7-9DEE-EC77C33AF38A}" v="8" dt="2026-07-03T12:17:03.275"/>
   </p1510:revLst>
 </p1510:revInfo>
 </file>
@@ -134,7 +136,7 @@
   <pc:docChgLst>
     <pc:chgData name="헌정 임" userId="eb9ca9bd79f0560f" providerId="LiveId" clId="{A6339E56-8272-42D6-9D95-12E1A8284411}"/>
     <pc:docChg chg="undo custSel addSld delSld modSld">
-      <pc:chgData name="헌정 임" userId="eb9ca9bd79f0560f" providerId="LiveId" clId="{A6339E56-8272-42D6-9D95-12E1A8284411}" dt="2026-07-03T12:02:03.542" v="53" actId="22"/>
+      <pc:chgData name="헌정 임" userId="eb9ca9bd79f0560f" providerId="LiveId" clId="{A6339E56-8272-42D6-9D95-12E1A8284411}" dt="2026-07-03T12:17:03.275" v="77"/>
       <pc:docMkLst>
         <pc:docMk/>
       </pc:docMkLst>
@@ -293,14 +295,14 @@
           <pc:sldMk cId="1773760154" sldId="383"/>
         </pc:sldMkLst>
       </pc:sldChg>
-      <pc:sldChg chg="addSp new mod">
-        <pc:chgData name="헌정 임" userId="eb9ca9bd79f0560f" providerId="LiveId" clId="{A6339E56-8272-42D6-9D95-12E1A8284411}" dt="2026-07-03T09:43:23.158" v="21" actId="22"/>
+      <pc:sldChg chg="addSp modSp new mod">
+        <pc:chgData name="헌정 임" userId="eb9ca9bd79f0560f" providerId="LiveId" clId="{A6339E56-8272-42D6-9D95-12E1A8284411}" dt="2026-07-03T12:15:52.502" v="73" actId="732"/>
         <pc:sldMkLst>
           <pc:docMk/>
           <pc:sldMk cId="2716414540" sldId="384"/>
         </pc:sldMkLst>
-        <pc:picChg chg="add">
-          <ac:chgData name="헌정 임" userId="eb9ca9bd79f0560f" providerId="LiveId" clId="{A6339E56-8272-42D6-9D95-12E1A8284411}" dt="2026-07-03T09:43:23.158" v="21" actId="22"/>
+        <pc:picChg chg="add mod modCrop">
+          <ac:chgData name="헌정 임" userId="eb9ca9bd79f0560f" providerId="LiveId" clId="{A6339E56-8272-42D6-9D95-12E1A8284411}" dt="2026-07-03T12:15:52.502" v="73" actId="732"/>
           <ac:picMkLst>
             <pc:docMk/>
             <pc:sldMk cId="2716414540" sldId="384"/>
@@ -308,8 +310,8 @@
           </ac:picMkLst>
         </pc:picChg>
       </pc:sldChg>
-      <pc:sldChg chg="addSp modSp new mod">
-        <pc:chgData name="헌정 임" userId="eb9ca9bd79f0560f" providerId="LiveId" clId="{A6339E56-8272-42D6-9D95-12E1A8284411}" dt="2026-07-03T11:58:00.547" v="46" actId="1076"/>
+      <pc:sldChg chg="addSp delSp modSp new mod">
+        <pc:chgData name="헌정 임" userId="eb9ca9bd79f0560f" providerId="LiveId" clId="{A6339E56-8272-42D6-9D95-12E1A8284411}" dt="2026-07-03T12:05:19.726" v="55" actId="21"/>
         <pc:sldMkLst>
           <pc:docMk/>
           <pc:sldMk cId="1983847626" sldId="385"/>
@@ -354,8 +356,8 @@
             <ac:picMk id="11" creationId="{190B6743-2176-3074-22CE-7C8BCB59873C}"/>
           </ac:picMkLst>
         </pc:picChg>
-        <pc:picChg chg="add mod modCrop">
-          <ac:chgData name="헌정 임" userId="eb9ca9bd79f0560f" providerId="LiveId" clId="{A6339E56-8272-42D6-9D95-12E1A8284411}" dt="2026-07-03T11:57:30.978" v="39" actId="1076"/>
+        <pc:picChg chg="add del mod modCrop">
+          <ac:chgData name="헌정 임" userId="eb9ca9bd79f0560f" providerId="LiveId" clId="{A6339E56-8272-42D6-9D95-12E1A8284411}" dt="2026-07-03T12:05:19.726" v="55" actId="21"/>
           <ac:picMkLst>
             <pc:docMk/>
             <pc:sldMk cId="1983847626" sldId="385"/>
@@ -371,8 +373,8 @@
           </ac:picMkLst>
         </pc:picChg>
       </pc:sldChg>
-      <pc:sldChg chg="addSp new mod">
-        <pc:chgData name="헌정 임" userId="eb9ca9bd79f0560f" providerId="LiveId" clId="{A6339E56-8272-42D6-9D95-12E1A8284411}" dt="2026-07-03T12:02:03.542" v="53" actId="22"/>
+      <pc:sldChg chg="addSp new del mod">
+        <pc:chgData name="헌정 임" userId="eb9ca9bd79f0560f" providerId="LiveId" clId="{A6339E56-8272-42D6-9D95-12E1A8284411}" dt="2026-07-03T12:16:11.907" v="74" actId="47"/>
         <pc:sldMkLst>
           <pc:docMk/>
           <pc:sldMk cId="1787533717" sldId="386"/>
@@ -383,6 +385,67 @@
             <pc:docMk/>
             <pc:sldMk cId="1787533717" sldId="386"/>
             <ac:picMk id="4" creationId="{BCF4503C-9B6F-443B-6743-E905216D5ECC}"/>
+          </ac:picMkLst>
+        </pc:picChg>
+      </pc:sldChg>
+      <pc:sldChg chg="addSp modSp new mod">
+        <pc:chgData name="헌정 임" userId="eb9ca9bd79f0560f" providerId="LiveId" clId="{A6339E56-8272-42D6-9D95-12E1A8284411}" dt="2026-07-03T12:12:52.088" v="70" actId="1037"/>
+        <pc:sldMkLst>
+          <pc:docMk/>
+          <pc:sldMk cId="333529903" sldId="387"/>
+        </pc:sldMkLst>
+        <pc:spChg chg="add mod">
+          <ac:chgData name="헌정 임" userId="eb9ca9bd79f0560f" providerId="LiveId" clId="{A6339E56-8272-42D6-9D95-12E1A8284411}" dt="2026-07-03T12:12:52.088" v="70" actId="1037"/>
+          <ac:spMkLst>
+            <pc:docMk/>
+            <pc:sldMk cId="333529903" sldId="387"/>
+            <ac:spMk id="5" creationId="{87597391-AF5F-C774-31F8-B1E520AE5465}"/>
+          </ac:spMkLst>
+        </pc:spChg>
+        <pc:picChg chg="add">
+          <ac:chgData name="헌정 임" userId="eb9ca9bd79f0560f" providerId="LiveId" clId="{A6339E56-8272-42D6-9D95-12E1A8284411}" dt="2026-07-03T12:12:43.039" v="57" actId="22"/>
+          <ac:picMkLst>
+            <pc:docMk/>
+            <pc:sldMk cId="333529903" sldId="387"/>
+            <ac:picMk id="4" creationId="{E8B297AB-20D8-0B14-8D8A-CAAF32A032DE}"/>
+          </ac:picMkLst>
+        </pc:picChg>
+      </pc:sldChg>
+      <pc:sldChg chg="addSp new mod">
+        <pc:chgData name="헌정 임" userId="eb9ca9bd79f0560f" providerId="LiveId" clId="{A6339E56-8272-42D6-9D95-12E1A8284411}" dt="2026-07-03T12:15:42.066" v="72" actId="22"/>
+        <pc:sldMkLst>
+          <pc:docMk/>
+          <pc:sldMk cId="1109579226" sldId="388"/>
+        </pc:sldMkLst>
+        <pc:picChg chg="add">
+          <ac:chgData name="헌정 임" userId="eb9ca9bd79f0560f" providerId="LiveId" clId="{A6339E56-8272-42D6-9D95-12E1A8284411}" dt="2026-07-03T12:15:42.066" v="72" actId="22"/>
+          <ac:picMkLst>
+            <pc:docMk/>
+            <pc:sldMk cId="1109579226" sldId="388"/>
+            <ac:picMk id="4" creationId="{C981B778-07B5-E856-C945-43C97FBF7C74}"/>
+          </ac:picMkLst>
+        </pc:picChg>
+      </pc:sldChg>
+      <pc:sldChg chg="addSp modSp new mod">
+        <pc:chgData name="헌정 임" userId="eb9ca9bd79f0560f" providerId="LiveId" clId="{A6339E56-8272-42D6-9D95-12E1A8284411}" dt="2026-07-03T12:17:03.275" v="77"/>
+        <pc:sldMkLst>
+          <pc:docMk/>
+          <pc:sldMk cId="1045847686" sldId="389"/>
+        </pc:sldMkLst>
+        <pc:spChg chg="add mod">
+          <ac:chgData name="헌정 임" userId="eb9ca9bd79f0560f" providerId="LiveId" clId="{A6339E56-8272-42D6-9D95-12E1A8284411}" dt="2026-07-03T12:17:03.275" v="77"/>
+          <ac:spMkLst>
+            <pc:docMk/>
+            <pc:sldMk cId="1045847686" sldId="389"/>
+            <ac:spMk id="5" creationId="{E46444B8-D07B-A88B-5B5A-B15E524E74BC}"/>
+          </ac:spMkLst>
+        </pc:spChg>
+        <pc:picChg chg="add">
+          <ac:chgData name="헌정 임" userId="eb9ca9bd79f0560f" providerId="LiveId" clId="{A6339E56-8272-42D6-9D95-12E1A8284411}" dt="2026-07-03T12:16:59.596" v="76" actId="22"/>
+          <ac:picMkLst>
+            <pc:docMk/>
+            <pc:sldMk cId="1045847686" sldId="389"/>
+            <ac:picMk id="4" creationId="{55B45E04-88A2-64A4-C741-E57B6BC3226B}"/>
           </ac:picMkLst>
         </pc:picChg>
       </pc:sldChg>
@@ -4075,6 +4138,257 @@
 </p:sld>
 </file>
 
+<file path=ppt/slides/slide11.xml><?xml version="1.0" encoding="utf-8"?>
+<p:sld xmlns:a="http://schemas.openxmlformats.org/drawingml/2006/main" xmlns:r="http://schemas.openxmlformats.org/officeDocument/2006/relationships" xmlns:p="http://schemas.openxmlformats.org/presentationml/2006/main">
+  <p:cSld>
+    <p:spTree>
+      <p:nvGrpSpPr>
+        <p:cNvPr id="1" name=""/>
+        <p:cNvGrpSpPr/>
+        <p:nvPr/>
+      </p:nvGrpSpPr>
+      <p:grpSpPr>
+        <a:xfrm>
+          <a:off x="0" y="0"/>
+          <a:ext cx="0" cy="0"/>
+          <a:chOff x="0" y="0"/>
+          <a:chExt cx="0" cy="0"/>
+        </a:xfrm>
+      </p:grpSpPr>
+      <p:sp>
+        <p:nvSpPr>
+          <p:cNvPr id="2" name="제목 1">
+            <a:extLst>
+              <a:ext uri="{FF2B5EF4-FFF2-40B4-BE49-F238E27FC236}">
+                <a16:creationId xmlns:a16="http://schemas.microsoft.com/office/drawing/2014/main" id="{D5A1BA7F-CD92-ACF2-5B13-F456190790AC}"/>
+              </a:ext>
+            </a:extLst>
+          </p:cNvPr>
+          <p:cNvSpPr>
+            <a:spLocks noGrp="1"/>
+          </p:cNvSpPr>
+          <p:nvPr>
+            <p:ph type="title"/>
+          </p:nvPr>
+        </p:nvSpPr>
+        <p:spPr/>
+        <p:txBody>
+          <a:bodyPr/>
+          <a:lstStyle/>
+          <a:p>
+            <a:endParaRPr lang="ko-KR" altLang="en-US"/>
+          </a:p>
+        </p:txBody>
+      </p:sp>
+      <p:pic>
+        <p:nvPicPr>
+          <p:cNvPr id="4" name="그림 3">
+            <a:extLst>
+              <a:ext uri="{FF2B5EF4-FFF2-40B4-BE49-F238E27FC236}">
+                <a16:creationId xmlns:a16="http://schemas.microsoft.com/office/drawing/2014/main" id="{E8B297AB-20D8-0B14-8D8A-CAAF32A032DE}"/>
+              </a:ext>
+            </a:extLst>
+          </p:cNvPr>
+          <p:cNvPicPr>
+            <a:picLocks noChangeAspect="1"/>
+          </p:cNvPicPr>
+          <p:nvPr/>
+        </p:nvPicPr>
+        <p:blipFill>
+          <a:blip r:embed="rId2"/>
+          <a:stretch>
+            <a:fillRect/>
+          </a:stretch>
+        </p:blipFill>
+        <p:spPr>
+          <a:xfrm>
+            <a:off x="0" y="28163"/>
+            <a:ext cx="12192000" cy="6801674"/>
+          </a:xfrm>
+          <a:prstGeom prst="rect">
+            <a:avLst/>
+          </a:prstGeom>
+        </p:spPr>
+      </p:pic>
+      <p:sp>
+        <p:nvSpPr>
+          <p:cNvPr id="5" name="직사각형 4">
+            <a:extLst>
+              <a:ext uri="{FF2B5EF4-FFF2-40B4-BE49-F238E27FC236}">
+                <a16:creationId xmlns:a16="http://schemas.microsoft.com/office/drawing/2014/main" id="{87597391-AF5F-C774-31F8-B1E520AE5465}"/>
+              </a:ext>
+            </a:extLst>
+          </p:cNvPr>
+          <p:cNvSpPr/>
+          <p:nvPr/>
+        </p:nvSpPr>
+        <p:spPr>
+          <a:xfrm>
+            <a:off x="10655687" y="147241"/>
+            <a:ext cx="1159847" cy="297260"/>
+          </a:xfrm>
+          <a:prstGeom prst="rect">
+            <a:avLst/>
+          </a:prstGeom>
+          <a:solidFill>
+            <a:srgbClr val="F2F2F2"/>
+          </a:solidFill>
+          <a:ln>
+            <a:noFill/>
+          </a:ln>
+        </p:spPr>
+        <p:style>
+          <a:lnRef idx="2">
+            <a:schemeClr val="accent1">
+              <a:shade val="50000"/>
+            </a:schemeClr>
+          </a:lnRef>
+          <a:fillRef idx="1">
+            <a:schemeClr val="accent1"/>
+          </a:fillRef>
+          <a:effectRef idx="0">
+            <a:schemeClr val="accent1"/>
+          </a:effectRef>
+          <a:fontRef idx="minor">
+            <a:schemeClr val="lt1"/>
+          </a:fontRef>
+        </p:style>
+        <p:txBody>
+          <a:bodyPr rtlCol="0" anchor="ctr"/>
+          <a:lstStyle/>
+          <a:p>
+            <a:pPr marL="0" marR="0" lvl="0" indent="0" algn="ctr" defTabSz="914400" rtl="0" eaLnBrk="1" fontAlgn="auto" latinLnBrk="1" hangingPunct="1">
+              <a:lnSpc>
+                <a:spcPct val="100000"/>
+              </a:lnSpc>
+              <a:spcBef>
+                <a:spcPts val="0"/>
+              </a:spcBef>
+              <a:spcAft>
+                <a:spcPts val="0"/>
+              </a:spcAft>
+              <a:buClrTx/>
+              <a:buSzTx/>
+              <a:buFontTx/>
+              <a:buNone/>
+              <a:tabLst/>
+              <a:defRPr/>
+            </a:pPr>
+            <a:endParaRPr kumimoji="0" lang="ko-KR" altLang="en-US" sz="1800" b="0" i="0" u="none" strike="noStrike" kern="1200" cap="none" spc="0" normalizeH="0" baseline="0" noProof="0">
+              <a:ln>
+                <a:noFill/>
+              </a:ln>
+              <a:solidFill>
+                <a:prstClr val="white"/>
+              </a:solidFill>
+              <a:effectLst/>
+              <a:uLnTx/>
+              <a:uFillTx/>
+              <a:latin typeface="Montserrat" pitchFamily="2" charset="0"/>
+              <a:ea typeface="맑은 고딕" panose="020B0503020000020004" pitchFamily="50" charset="-127"/>
+              <a:cs typeface="+mn-cs"/>
+            </a:endParaRPr>
+          </a:p>
+        </p:txBody>
+      </p:sp>
+    </p:spTree>
+    <p:extLst>
+      <p:ext uri="{BB962C8B-B14F-4D97-AF65-F5344CB8AC3E}">
+        <p14:creationId xmlns:p14="http://schemas.microsoft.com/office/powerpoint/2010/main" val="333529903"/>
+      </p:ext>
+    </p:extLst>
+  </p:cSld>
+  <p:clrMapOvr>
+    <a:masterClrMapping/>
+  </p:clrMapOvr>
+</p:sld>
+</file>
+
+<file path=ppt/slides/slide12.xml><?xml version="1.0" encoding="utf-8"?>
+<p:sld xmlns:a="http://schemas.openxmlformats.org/drawingml/2006/main" xmlns:r="http://schemas.openxmlformats.org/officeDocument/2006/relationships" xmlns:p="http://schemas.openxmlformats.org/presentationml/2006/main">
+  <p:cSld>
+    <p:spTree>
+      <p:nvGrpSpPr>
+        <p:cNvPr id="1" name=""/>
+        <p:cNvGrpSpPr/>
+        <p:nvPr/>
+      </p:nvGrpSpPr>
+      <p:grpSpPr>
+        <a:xfrm>
+          <a:off x="0" y="0"/>
+          <a:ext cx="0" cy="0"/>
+          <a:chOff x="0" y="0"/>
+          <a:chExt cx="0" cy="0"/>
+        </a:xfrm>
+      </p:grpSpPr>
+      <p:sp>
+        <p:nvSpPr>
+          <p:cNvPr id="2" name="제목 1">
+            <a:extLst>
+              <a:ext uri="{FF2B5EF4-FFF2-40B4-BE49-F238E27FC236}">
+                <a16:creationId xmlns:a16="http://schemas.microsoft.com/office/drawing/2014/main" id="{C806619F-2430-DB69-E007-F8C44168B1F1}"/>
+              </a:ext>
+            </a:extLst>
+          </p:cNvPr>
+          <p:cNvSpPr>
+            <a:spLocks noGrp="1"/>
+          </p:cNvSpPr>
+          <p:nvPr>
+            <p:ph type="title"/>
+          </p:nvPr>
+        </p:nvSpPr>
+        <p:spPr/>
+        <p:txBody>
+          <a:bodyPr/>
+          <a:lstStyle/>
+          <a:p>
+            <a:endParaRPr lang="ko-KR" altLang="en-US"/>
+          </a:p>
+        </p:txBody>
+      </p:sp>
+      <p:pic>
+        <p:nvPicPr>
+          <p:cNvPr id="4" name="그림 3">
+            <a:extLst>
+              <a:ext uri="{FF2B5EF4-FFF2-40B4-BE49-F238E27FC236}">
+                <a16:creationId xmlns:a16="http://schemas.microsoft.com/office/drawing/2014/main" id="{C981B778-07B5-E856-C945-43C97FBF7C74}"/>
+              </a:ext>
+            </a:extLst>
+          </p:cNvPr>
+          <p:cNvPicPr>
+            <a:picLocks noChangeAspect="1"/>
+          </p:cNvPicPr>
+          <p:nvPr/>
+        </p:nvPicPr>
+        <p:blipFill>
+          <a:blip r:embed="rId2"/>
+          <a:stretch>
+            <a:fillRect/>
+          </a:stretch>
+        </p:blipFill>
+        <p:spPr>
+          <a:xfrm>
+            <a:off x="849848" y="0"/>
+            <a:ext cx="10492303" cy="6858000"/>
+          </a:xfrm>
+          <a:prstGeom prst="rect">
+            <a:avLst/>
+          </a:prstGeom>
+        </p:spPr>
+      </p:pic>
+    </p:spTree>
+    <p:extLst>
+      <p:ext uri="{BB962C8B-B14F-4D97-AF65-F5344CB8AC3E}">
+        <p14:creationId xmlns:p14="http://schemas.microsoft.com/office/powerpoint/2010/main" val="1109579226"/>
+      </p:ext>
+    </p:extLst>
+  </p:cSld>
+  <p:clrMapOvr>
+    <a:masterClrMapping/>
+  </p:clrMapOvr>
+</p:sld>
+</file>
+
 <file path=ppt/slides/slide2.xml><?xml version="1.0" encoding="utf-8"?>
 <p:sld xmlns:a="http://schemas.openxmlformats.org/drawingml/2006/main" xmlns:r="http://schemas.openxmlformats.org/officeDocument/2006/relationships" xmlns:p="http://schemas.openxmlformats.org/presentationml/2006/main">
   <p:cSld>
@@ -41261,7 +41575,7 @@
           <p:cNvPr id="2" name="제목 1">
             <a:extLst>
               <a:ext uri="{FF2B5EF4-FFF2-40B4-BE49-F238E27FC236}">
-                <a16:creationId xmlns:a16="http://schemas.microsoft.com/office/drawing/2014/main" id="{9C0FF6DA-7456-A694-495F-C85E2B36578C}"/>
+                <a16:creationId xmlns:a16="http://schemas.microsoft.com/office/drawing/2014/main" id="{B79CA1F7-A8D8-7D2B-F2D0-0135DDB60E6A}"/>
               </a:ext>
             </a:extLst>
           </p:cNvPr>
@@ -41286,7 +41600,7 @@
           <p:cNvPr id="4" name="그림 3">
             <a:extLst>
               <a:ext uri="{FF2B5EF4-FFF2-40B4-BE49-F238E27FC236}">
-                <a16:creationId xmlns:a16="http://schemas.microsoft.com/office/drawing/2014/main" id="{BCF4503C-9B6F-443B-6743-E905216D5ECC}"/>
+                <a16:creationId xmlns:a16="http://schemas.microsoft.com/office/drawing/2014/main" id="{55B45E04-88A2-64A4-C741-E57B6BC3226B}"/>
               </a:ext>
             </a:extLst>
           </p:cNvPr>
@@ -41303,18 +41617,99 @@
         </p:blipFill>
         <p:spPr>
           <a:xfrm>
-            <a:off x="0" y="39505"/>
-            <a:ext cx="12192000" cy="6778990"/>
+            <a:off x="0" y="56653"/>
+            <a:ext cx="12192000" cy="6744694"/>
           </a:xfrm>
           <a:prstGeom prst="rect">
             <a:avLst/>
           </a:prstGeom>
         </p:spPr>
       </p:pic>
+      <p:sp>
+        <p:nvSpPr>
+          <p:cNvPr id="5" name="직사각형 4">
+            <a:extLst>
+              <a:ext uri="{FF2B5EF4-FFF2-40B4-BE49-F238E27FC236}">
+                <a16:creationId xmlns:a16="http://schemas.microsoft.com/office/drawing/2014/main" id="{E46444B8-D07B-A88B-5B5A-B15E524E74BC}"/>
+              </a:ext>
+            </a:extLst>
+          </p:cNvPr>
+          <p:cNvSpPr/>
+          <p:nvPr/>
+        </p:nvSpPr>
+        <p:spPr>
+          <a:xfrm>
+            <a:off x="10682902" y="109140"/>
+            <a:ext cx="1159847" cy="297260"/>
+          </a:xfrm>
+          <a:prstGeom prst="rect">
+            <a:avLst/>
+          </a:prstGeom>
+          <a:solidFill>
+            <a:srgbClr val="F2F2F2"/>
+          </a:solidFill>
+          <a:ln>
+            <a:noFill/>
+          </a:ln>
+        </p:spPr>
+        <p:style>
+          <a:lnRef idx="2">
+            <a:schemeClr val="accent1">
+              <a:shade val="50000"/>
+            </a:schemeClr>
+          </a:lnRef>
+          <a:fillRef idx="1">
+            <a:schemeClr val="accent1"/>
+          </a:fillRef>
+          <a:effectRef idx="0">
+            <a:schemeClr val="accent1"/>
+          </a:effectRef>
+          <a:fontRef idx="minor">
+            <a:schemeClr val="lt1"/>
+          </a:fontRef>
+        </p:style>
+        <p:txBody>
+          <a:bodyPr rtlCol="0" anchor="ctr"/>
+          <a:lstStyle/>
+          <a:p>
+            <a:pPr marL="0" marR="0" lvl="0" indent="0" algn="ctr" defTabSz="914400" rtl="0" eaLnBrk="1" fontAlgn="auto" latinLnBrk="1" hangingPunct="1">
+              <a:lnSpc>
+                <a:spcPct val="100000"/>
+              </a:lnSpc>
+              <a:spcBef>
+                <a:spcPts val="0"/>
+              </a:spcBef>
+              <a:spcAft>
+                <a:spcPts val="0"/>
+              </a:spcAft>
+              <a:buClrTx/>
+              <a:buSzTx/>
+              <a:buFontTx/>
+              <a:buNone/>
+              <a:tabLst/>
+              <a:defRPr/>
+            </a:pPr>
+            <a:endParaRPr kumimoji="0" lang="ko-KR" altLang="en-US" sz="1800" b="0" i="0" u="none" strike="noStrike" kern="1200" cap="none" spc="0" normalizeH="0" baseline="0" noProof="0">
+              <a:ln>
+                <a:noFill/>
+              </a:ln>
+              <a:solidFill>
+                <a:prstClr val="white"/>
+              </a:solidFill>
+              <a:effectLst/>
+              <a:uLnTx/>
+              <a:uFillTx/>
+              <a:latin typeface="Montserrat" pitchFamily="2" charset="0"/>
+              <a:ea typeface="맑은 고딕" panose="020B0503020000020004" pitchFamily="50" charset="-127"/>
+              <a:cs typeface="+mn-cs"/>
+            </a:endParaRPr>
+          </a:p>
+        </p:txBody>
+      </p:sp>
     </p:spTree>
     <p:extLst>
       <p:ext uri="{BB962C8B-B14F-4D97-AF65-F5344CB8AC3E}">
-        <p14:creationId xmlns:p14="http://schemas.microsoft.com/office/powerpoint/2010/main" val="1787533717"/>
+        <p14:creationId xmlns:p14="http://schemas.microsoft.com/office/powerpoint/2010/main" val="1045847686"/>
       </p:ext>
     </p:extLst>
   </p:cSld>
@@ -41382,14 +41777,15 @@
         </p:nvPicPr>
         <p:blipFill>
           <a:blip r:embed="rId2"/>
+          <a:srcRect l="15491"/>
           <a:stretch>
             <a:fillRect/>
           </a:stretch>
         </p:blipFill>
         <p:spPr>
           <a:xfrm>
-            <a:off x="0" y="28654"/>
-            <a:ext cx="12192000" cy="6800691"/>
+            <a:off x="1888670" y="28654"/>
+            <a:ext cx="10303329" cy="6800691"/>
           </a:xfrm>
           <a:prstGeom prst="rect">
             <a:avLst/>

</xml_diff>

<commit_message>
vault backup: 2026-07-03 21:17:21
</commit_message>
<xml_diff>
--- a/assets/06-dataspace/image.pptx
+++ b/assets/06-dataspace/image.pptx
@@ -136,7 +136,7 @@
   <pc:docChgLst>
     <pc:chgData name="헌정 임" userId="eb9ca9bd79f0560f" providerId="LiveId" clId="{A6339E56-8272-42D6-9D95-12E1A8284411}"/>
     <pc:docChg chg="undo custSel addSld delSld modSld">
-      <pc:chgData name="헌정 임" userId="eb9ca9bd79f0560f" providerId="LiveId" clId="{A6339E56-8272-42D6-9D95-12E1A8284411}" dt="2026-07-03T12:17:03.275" v="77"/>
+      <pc:chgData name="헌정 임" userId="eb9ca9bd79f0560f" providerId="LiveId" clId="{A6339E56-8272-42D6-9D95-12E1A8284411}" dt="2026-07-03T12:17:12.336" v="79" actId="21"/>
       <pc:docMkLst>
         <pc:docMk/>
       </pc:docMkLst>
@@ -426,8 +426,8 @@
           </ac:picMkLst>
         </pc:picChg>
       </pc:sldChg>
-      <pc:sldChg chg="addSp modSp new mod">
-        <pc:chgData name="헌정 임" userId="eb9ca9bd79f0560f" providerId="LiveId" clId="{A6339E56-8272-42D6-9D95-12E1A8284411}" dt="2026-07-03T12:17:03.275" v="77"/>
+      <pc:sldChg chg="addSp delSp modSp new mod">
+        <pc:chgData name="헌정 임" userId="eb9ca9bd79f0560f" providerId="LiveId" clId="{A6339E56-8272-42D6-9D95-12E1A8284411}" dt="2026-07-03T12:17:12.336" v="79" actId="21"/>
         <pc:sldMkLst>
           <pc:docMk/>
           <pc:sldMk cId="1045847686" sldId="389"/>
@@ -446,6 +446,14 @@
             <pc:docMk/>
             <pc:sldMk cId="1045847686" sldId="389"/>
             <ac:picMk id="4" creationId="{55B45E04-88A2-64A4-C741-E57B6BC3226B}"/>
+          </ac:picMkLst>
+        </pc:picChg>
+        <pc:picChg chg="add del">
+          <ac:chgData name="헌정 임" userId="eb9ca9bd79f0560f" providerId="LiveId" clId="{A6339E56-8272-42D6-9D95-12E1A8284411}" dt="2026-07-03T12:17:12.336" v="79" actId="21"/>
+          <ac:picMkLst>
+            <pc:docMk/>
+            <pc:sldMk cId="1045847686" sldId="389"/>
+            <ac:picMk id="7" creationId="{BADC532B-33D3-D4C5-8D4E-1052EEA3C666}"/>
           </ac:picMkLst>
         </pc:picChg>
       </pc:sldChg>

</xml_diff>

<commit_message>
vault backup: 2026-07-03 21:27:19
</commit_message>
<xml_diff>
--- a/assets/06-dataspace/image.pptx
+++ b/assets/06-dataspace/image.pptx
@@ -126,7 +126,7 @@
 <file path=ppt/revisionInfo.xml><?xml version="1.0" encoding="utf-8"?>
 <p1510:revInfo xmlns:a="http://schemas.openxmlformats.org/drawingml/2006/main" xmlns:r="http://schemas.openxmlformats.org/officeDocument/2006/relationships" xmlns:p1510="http://schemas.microsoft.com/office/powerpoint/2015/10/main">
   <p1510:revLst>
-    <p1510:client id="{77AFA03C-ADB3-48E7-9DEE-EC77C33AF38A}" v="8" dt="2026-07-03T12:17:03.275"/>
+    <p1510:client id="{77AFA03C-ADB3-48E7-9DEE-EC77C33AF38A}" v="9" dt="2026-07-03T12:18:21.776"/>
   </p1510:revLst>
 </p1510:revInfo>
 </file>
@@ -136,7 +136,7 @@
   <pc:docChgLst>
     <pc:chgData name="헌정 임" userId="eb9ca9bd79f0560f" providerId="LiveId" clId="{A6339E56-8272-42D6-9D95-12E1A8284411}"/>
     <pc:docChg chg="undo custSel addSld delSld modSld">
-      <pc:chgData name="헌정 임" userId="eb9ca9bd79f0560f" providerId="LiveId" clId="{A6339E56-8272-42D6-9D95-12E1A8284411}" dt="2026-07-03T12:17:12.336" v="79" actId="21"/>
+      <pc:chgData name="헌정 임" userId="eb9ca9bd79f0560f" providerId="LiveId" clId="{A6339E56-8272-42D6-9D95-12E1A8284411}" dt="2026-07-03T12:18:28.759" v="87" actId="21"/>
       <pc:docMkLst>
         <pc:docMk/>
       </pc:docMkLst>
@@ -411,18 +411,42 @@
           </ac:picMkLst>
         </pc:picChg>
       </pc:sldChg>
-      <pc:sldChg chg="addSp new mod">
-        <pc:chgData name="헌정 임" userId="eb9ca9bd79f0560f" providerId="LiveId" clId="{A6339E56-8272-42D6-9D95-12E1A8284411}" dt="2026-07-03T12:15:42.066" v="72" actId="22"/>
+      <pc:sldChg chg="addSp delSp modSp new mod">
+        <pc:chgData name="헌정 임" userId="eb9ca9bd79f0560f" providerId="LiveId" clId="{A6339E56-8272-42D6-9D95-12E1A8284411}" dt="2026-07-03T12:18:28.759" v="87" actId="21"/>
         <pc:sldMkLst>
           <pc:docMk/>
           <pc:sldMk cId="1109579226" sldId="388"/>
         </pc:sldMkLst>
-        <pc:picChg chg="add">
-          <ac:chgData name="헌정 임" userId="eb9ca9bd79f0560f" providerId="LiveId" clId="{A6339E56-8272-42D6-9D95-12E1A8284411}" dt="2026-07-03T12:15:42.066" v="72" actId="22"/>
+        <pc:spChg chg="add mod">
+          <ac:chgData name="헌정 임" userId="eb9ca9bd79f0560f" providerId="LiveId" clId="{A6339E56-8272-42D6-9D95-12E1A8284411}" dt="2026-07-03T12:18:21.776" v="85"/>
+          <ac:spMkLst>
+            <pc:docMk/>
+            <pc:sldMk cId="1109579226" sldId="388"/>
+            <ac:spMk id="7" creationId="{14B85EC4-8F40-3159-DBE0-117F5C1C36A2}"/>
+          </ac:spMkLst>
+        </pc:spChg>
+        <pc:picChg chg="add del mod modCrop">
+          <ac:chgData name="헌정 임" userId="eb9ca9bd79f0560f" providerId="LiveId" clId="{A6339E56-8272-42D6-9D95-12E1A8284411}" dt="2026-07-03T12:17:46.315" v="83" actId="478"/>
           <ac:picMkLst>
             <pc:docMk/>
             <pc:sldMk cId="1109579226" sldId="388"/>
             <ac:picMk id="4" creationId="{C981B778-07B5-E856-C945-43C97FBF7C74}"/>
+          </ac:picMkLst>
+        </pc:picChg>
+        <pc:picChg chg="add">
+          <ac:chgData name="헌정 임" userId="eb9ca9bd79f0560f" providerId="LiveId" clId="{A6339E56-8272-42D6-9D95-12E1A8284411}" dt="2026-07-03T12:18:18.247" v="84" actId="22"/>
+          <ac:picMkLst>
+            <pc:docMk/>
+            <pc:sldMk cId="1109579226" sldId="388"/>
+            <ac:picMk id="6" creationId="{48EF2E57-901F-B412-D2ED-829178775CF8}"/>
+          </ac:picMkLst>
+        </pc:picChg>
+        <pc:picChg chg="add del">
+          <ac:chgData name="헌정 임" userId="eb9ca9bd79f0560f" providerId="LiveId" clId="{A6339E56-8272-42D6-9D95-12E1A8284411}" dt="2026-07-03T12:18:28.759" v="87" actId="21"/>
+          <ac:picMkLst>
+            <pc:docMk/>
+            <pc:sldMk cId="1109579226" sldId="388"/>
+            <ac:picMk id="9" creationId="{D97FD00F-7F9A-0DC2-4006-41A12726F1EE}"/>
           </ac:picMkLst>
         </pc:picChg>
       </pc:sldChg>
@@ -4356,10 +4380,10 @@
       </p:sp>
       <p:pic>
         <p:nvPicPr>
-          <p:cNvPr id="4" name="그림 3">
+          <p:cNvPr id="6" name="그림 5">
             <a:extLst>
               <a:ext uri="{FF2B5EF4-FFF2-40B4-BE49-F238E27FC236}">
-                <a16:creationId xmlns:a16="http://schemas.microsoft.com/office/drawing/2014/main" id="{C981B778-07B5-E856-C945-43C97FBF7C74}"/>
+                <a16:creationId xmlns:a16="http://schemas.microsoft.com/office/drawing/2014/main" id="{48EF2E57-901F-B412-D2ED-829178775CF8}"/>
               </a:ext>
             </a:extLst>
           </p:cNvPr>
@@ -4376,14 +4400,95 @@
         </p:blipFill>
         <p:spPr>
           <a:xfrm>
-            <a:off x="849848" y="0"/>
-            <a:ext cx="10492303" cy="6858000"/>
+            <a:off x="0" y="55194"/>
+            <a:ext cx="12192000" cy="6747612"/>
           </a:xfrm>
           <a:prstGeom prst="rect">
             <a:avLst/>
           </a:prstGeom>
         </p:spPr>
       </p:pic>
+      <p:sp>
+        <p:nvSpPr>
+          <p:cNvPr id="7" name="직사각형 6">
+            <a:extLst>
+              <a:ext uri="{FF2B5EF4-FFF2-40B4-BE49-F238E27FC236}">
+                <a16:creationId xmlns:a16="http://schemas.microsoft.com/office/drawing/2014/main" id="{14B85EC4-8F40-3159-DBE0-117F5C1C36A2}"/>
+              </a:ext>
+            </a:extLst>
+          </p:cNvPr>
+          <p:cNvSpPr/>
+          <p:nvPr/>
+        </p:nvSpPr>
+        <p:spPr>
+          <a:xfrm>
+            <a:off x="10655687" y="147241"/>
+            <a:ext cx="1159847" cy="297260"/>
+          </a:xfrm>
+          <a:prstGeom prst="rect">
+            <a:avLst/>
+          </a:prstGeom>
+          <a:solidFill>
+            <a:srgbClr val="F2F2F2"/>
+          </a:solidFill>
+          <a:ln>
+            <a:noFill/>
+          </a:ln>
+        </p:spPr>
+        <p:style>
+          <a:lnRef idx="2">
+            <a:schemeClr val="accent1">
+              <a:shade val="50000"/>
+            </a:schemeClr>
+          </a:lnRef>
+          <a:fillRef idx="1">
+            <a:schemeClr val="accent1"/>
+          </a:fillRef>
+          <a:effectRef idx="0">
+            <a:schemeClr val="accent1"/>
+          </a:effectRef>
+          <a:fontRef idx="minor">
+            <a:schemeClr val="lt1"/>
+          </a:fontRef>
+        </p:style>
+        <p:txBody>
+          <a:bodyPr rtlCol="0" anchor="ctr"/>
+          <a:lstStyle/>
+          <a:p>
+            <a:pPr marL="0" marR="0" lvl="0" indent="0" algn="ctr" defTabSz="914400" rtl="0" eaLnBrk="1" fontAlgn="auto" latinLnBrk="1" hangingPunct="1">
+              <a:lnSpc>
+                <a:spcPct val="100000"/>
+              </a:lnSpc>
+              <a:spcBef>
+                <a:spcPts val="0"/>
+              </a:spcBef>
+              <a:spcAft>
+                <a:spcPts val="0"/>
+              </a:spcAft>
+              <a:buClrTx/>
+              <a:buSzTx/>
+              <a:buFontTx/>
+              <a:buNone/>
+              <a:tabLst/>
+              <a:defRPr/>
+            </a:pPr>
+            <a:endParaRPr kumimoji="0" lang="ko-KR" altLang="en-US" sz="1800" b="0" i="0" u="none" strike="noStrike" kern="1200" cap="none" spc="0" normalizeH="0" baseline="0" noProof="0">
+              <a:ln>
+                <a:noFill/>
+              </a:ln>
+              <a:solidFill>
+                <a:prstClr val="white"/>
+              </a:solidFill>
+              <a:effectLst/>
+              <a:uLnTx/>
+              <a:uFillTx/>
+              <a:latin typeface="Montserrat" pitchFamily="2" charset="0"/>
+              <a:ea typeface="맑은 고딕" panose="020B0503020000020004" pitchFamily="50" charset="-127"/>
+              <a:cs typeface="+mn-cs"/>
+            </a:endParaRPr>
+          </a:p>
+        </p:txBody>
+      </p:sp>
     </p:spTree>
     <p:extLst>
       <p:ext uri="{BB962C8B-B14F-4D97-AF65-F5344CB8AC3E}">

</xml_diff>

<commit_message>
vault backup: 2026-07-03 21:37:29
</commit_message>
<xml_diff>
--- a/assets/06-dataspace/image.pptx
+++ b/assets/06-dataspace/image.pptx
@@ -5,18 +5,22 @@
     <p:sldMasterId id="2147483648" r:id="rId1"/>
   </p:sldMasterIdLst>
   <p:sldIdLst>
-    <p:sldId id="256" r:id="rId2"/>
-    <p:sldId id="257" r:id="rId3"/>
-    <p:sldId id="259" r:id="rId4"/>
-    <p:sldId id="258" r:id="rId5"/>
-    <p:sldId id="260" r:id="rId6"/>
-    <p:sldId id="380" r:id="rId7"/>
-    <p:sldId id="261" r:id="rId8"/>
-    <p:sldId id="389" r:id="rId9"/>
-    <p:sldId id="384" r:id="rId10"/>
-    <p:sldId id="385" r:id="rId11"/>
-    <p:sldId id="387" r:id="rId12"/>
-    <p:sldId id="388" r:id="rId13"/>
+    <p:sldId id="390" r:id="rId2"/>
+    <p:sldId id="391" r:id="rId3"/>
+    <p:sldId id="261" r:id="rId4"/>
+    <p:sldId id="389" r:id="rId5"/>
+    <p:sldId id="384" r:id="rId6"/>
+    <p:sldId id="385" r:id="rId7"/>
+    <p:sldId id="387" r:id="rId8"/>
+    <p:sldId id="388" r:id="rId9"/>
+    <p:sldId id="392" r:id="rId10"/>
+    <p:sldId id="393" r:id="rId11"/>
+    <p:sldId id="256" r:id="rId12"/>
+    <p:sldId id="257" r:id="rId13"/>
+    <p:sldId id="259" r:id="rId14"/>
+    <p:sldId id="258" r:id="rId15"/>
+    <p:sldId id="260" r:id="rId16"/>
+    <p:sldId id="380" r:id="rId17"/>
   </p:sldIdLst>
   <p:sldSz cx="12192000" cy="6858000"/>
   <p:notesSz cx="6858000" cy="9144000"/>
@@ -126,7 +130,7 @@
 <file path=ppt/revisionInfo.xml><?xml version="1.0" encoding="utf-8"?>
 <p1510:revInfo xmlns:a="http://schemas.openxmlformats.org/drawingml/2006/main" xmlns:r="http://schemas.openxmlformats.org/officeDocument/2006/relationships" xmlns:p1510="http://schemas.microsoft.com/office/powerpoint/2015/10/main">
   <p1510:revLst>
-    <p1510:client id="{77AFA03C-ADB3-48E7-9DEE-EC77C33AF38A}" v="9" dt="2026-07-03T12:18:21.776"/>
+    <p1510:client id="{77AFA03C-ADB3-48E7-9DEE-EC77C33AF38A}" v="10" dt="2026-07-03T12:36:22.062"/>
   </p1510:revLst>
 </p1510:revInfo>
 </file>
@@ -136,10 +140,80 @@
   <pc:docChgLst>
     <pc:chgData name="헌정 임" userId="eb9ca9bd79f0560f" providerId="LiveId" clId="{A6339E56-8272-42D6-9D95-12E1A8284411}"/>
     <pc:docChg chg="undo custSel addSld delSld modSld">
-      <pc:chgData name="헌정 임" userId="eb9ca9bd79f0560f" providerId="LiveId" clId="{A6339E56-8272-42D6-9D95-12E1A8284411}" dt="2026-07-03T12:18:28.759" v="87" actId="21"/>
+      <pc:chgData name="헌정 임" userId="eb9ca9bd79f0560f" providerId="LiveId" clId="{A6339E56-8272-42D6-9D95-12E1A8284411}" dt="2026-07-03T12:37:16.613" v="104" actId="693"/>
       <pc:docMkLst>
         <pc:docMk/>
       </pc:docMkLst>
+      <pc:sldChg chg="del">
+        <pc:chgData name="헌정 임" userId="eb9ca9bd79f0560f" providerId="LiveId" clId="{A6339E56-8272-42D6-9D95-12E1A8284411}" dt="2026-07-03T12:36:19.623" v="97" actId="2696"/>
+        <pc:sldMkLst>
+          <pc:docMk/>
+          <pc:sldMk cId="2282982365" sldId="256"/>
+        </pc:sldMkLst>
+      </pc:sldChg>
+      <pc:sldChg chg="add">
+        <pc:chgData name="헌정 임" userId="eb9ca9bd79f0560f" providerId="LiveId" clId="{A6339E56-8272-42D6-9D95-12E1A8284411}" dt="2026-07-03T12:36:22.057" v="100"/>
+        <pc:sldMkLst>
+          <pc:docMk/>
+          <pc:sldMk cId="3589339983" sldId="256"/>
+        </pc:sldMkLst>
+      </pc:sldChg>
+      <pc:sldChg chg="add del">
+        <pc:chgData name="헌정 임" userId="eb9ca9bd79f0560f" providerId="LiveId" clId="{A6339E56-8272-42D6-9D95-12E1A8284411}" dt="2026-07-03T12:36:19.623" v="97" actId="2696"/>
+        <pc:sldMkLst>
+          <pc:docMk/>
+          <pc:sldMk cId="1331024538" sldId="257"/>
+        </pc:sldMkLst>
+      </pc:sldChg>
+      <pc:sldChg chg="add">
+        <pc:chgData name="헌정 임" userId="eb9ca9bd79f0560f" providerId="LiveId" clId="{A6339E56-8272-42D6-9D95-12E1A8284411}" dt="2026-07-03T12:36:22.057" v="100"/>
+        <pc:sldMkLst>
+          <pc:docMk/>
+          <pc:sldMk cId="4276870801" sldId="257"/>
+        </pc:sldMkLst>
+      </pc:sldChg>
+      <pc:sldChg chg="add del">
+        <pc:chgData name="헌정 임" userId="eb9ca9bd79f0560f" providerId="LiveId" clId="{A6339E56-8272-42D6-9D95-12E1A8284411}" dt="2026-07-03T12:36:19.623" v="97" actId="2696"/>
+        <pc:sldMkLst>
+          <pc:docMk/>
+          <pc:sldMk cId="1040387894" sldId="258"/>
+        </pc:sldMkLst>
+      </pc:sldChg>
+      <pc:sldChg chg="add">
+        <pc:chgData name="헌정 임" userId="eb9ca9bd79f0560f" providerId="LiveId" clId="{A6339E56-8272-42D6-9D95-12E1A8284411}" dt="2026-07-03T12:36:22.057" v="100"/>
+        <pc:sldMkLst>
+          <pc:docMk/>
+          <pc:sldMk cId="1992724321" sldId="258"/>
+        </pc:sldMkLst>
+      </pc:sldChg>
+      <pc:sldChg chg="add">
+        <pc:chgData name="헌정 임" userId="eb9ca9bd79f0560f" providerId="LiveId" clId="{A6339E56-8272-42D6-9D95-12E1A8284411}" dt="2026-07-03T12:36:22.057" v="100"/>
+        <pc:sldMkLst>
+          <pc:docMk/>
+          <pc:sldMk cId="580931778" sldId="259"/>
+        </pc:sldMkLst>
+      </pc:sldChg>
+      <pc:sldChg chg="add del">
+        <pc:chgData name="헌정 임" userId="eb9ca9bd79f0560f" providerId="LiveId" clId="{A6339E56-8272-42D6-9D95-12E1A8284411}" dt="2026-07-03T12:36:19.623" v="97" actId="2696"/>
+        <pc:sldMkLst>
+          <pc:docMk/>
+          <pc:sldMk cId="3313299812" sldId="259"/>
+        </pc:sldMkLst>
+      </pc:sldChg>
+      <pc:sldChg chg="add">
+        <pc:chgData name="헌정 임" userId="eb9ca9bd79f0560f" providerId="LiveId" clId="{A6339E56-8272-42D6-9D95-12E1A8284411}" dt="2026-07-03T12:36:22.057" v="100"/>
+        <pc:sldMkLst>
+          <pc:docMk/>
+          <pc:sldMk cId="1595150386" sldId="260"/>
+        </pc:sldMkLst>
+      </pc:sldChg>
+      <pc:sldChg chg="add del">
+        <pc:chgData name="헌정 임" userId="eb9ca9bd79f0560f" providerId="LiveId" clId="{A6339E56-8272-42D6-9D95-12E1A8284411}" dt="2026-07-03T12:36:19.623" v="97" actId="2696"/>
+        <pc:sldMkLst>
+          <pc:docMk/>
+          <pc:sldMk cId="2534719469" sldId="260"/>
+        </pc:sldMkLst>
+      </pc:sldChg>
       <pc:sldChg chg="addSp delSp modSp new mod">
         <pc:chgData name="헌정 임" userId="eb9ca9bd79f0560f" providerId="LiveId" clId="{A6339E56-8272-42D6-9D95-12E1A8284411}" dt="2026-07-03T12:00:20.867" v="48" actId="21"/>
         <pc:sldMkLst>
@@ -179,8 +253,8 @@
           </ac:picMkLst>
         </pc:picChg>
       </pc:sldChg>
-      <pc:sldChg chg="addSp delSp modSp add mod">
-        <pc:chgData name="헌정 임" userId="eb9ca9bd79f0560f" providerId="LiveId" clId="{A6339E56-8272-42D6-9D95-12E1A8284411}" dt="2026-07-03T07:33:44.446" v="7" actId="22"/>
+      <pc:sldChg chg="addSp delSp modSp add del mod">
+        <pc:chgData name="헌정 임" userId="eb9ca9bd79f0560f" providerId="LiveId" clId="{A6339E56-8272-42D6-9D95-12E1A8284411}" dt="2026-07-03T12:36:19.623" v="97" actId="2696"/>
         <pc:sldMkLst>
           <pc:docMk/>
           <pc:sldMk cId="2705008494" sldId="380"/>
@@ -273,6 +347,13 @@
             <ac:picMk id="21" creationId="{45B22327-4FC5-F33B-0FDA-3656FE283667}"/>
           </ac:picMkLst>
         </pc:picChg>
+      </pc:sldChg>
+      <pc:sldChg chg="add">
+        <pc:chgData name="헌정 임" userId="eb9ca9bd79f0560f" providerId="LiveId" clId="{A6339E56-8272-42D6-9D95-12E1A8284411}" dt="2026-07-03T12:36:22.057" v="100"/>
+        <pc:sldMkLst>
+          <pc:docMk/>
+          <pc:sldMk cId="3383271283" sldId="380"/>
+        </pc:sldMkLst>
       </pc:sldChg>
       <pc:sldChg chg="new del">
         <pc:chgData name="헌정 임" userId="eb9ca9bd79f0560f" providerId="LiveId" clId="{A6339E56-8272-42D6-9D95-12E1A8284411}" dt="2026-07-03T12:00:40.476" v="49" actId="47"/>
@@ -412,7 +493,7 @@
         </pc:picChg>
       </pc:sldChg>
       <pc:sldChg chg="addSp delSp modSp new mod">
-        <pc:chgData name="헌정 임" userId="eb9ca9bd79f0560f" providerId="LiveId" clId="{A6339E56-8272-42D6-9D95-12E1A8284411}" dt="2026-07-03T12:18:28.759" v="87" actId="21"/>
+        <pc:chgData name="헌정 임" userId="eb9ca9bd79f0560f" providerId="LiveId" clId="{A6339E56-8272-42D6-9D95-12E1A8284411}" dt="2026-07-03T12:36:12.746" v="94" actId="22"/>
         <pc:sldMkLst>
           <pc:docMk/>
           <pc:sldMk cId="1109579226" sldId="388"/>
@@ -449,6 +530,14 @@
             <ac:picMk id="9" creationId="{D97FD00F-7F9A-0DC2-4006-41A12726F1EE}"/>
           </ac:picMkLst>
         </pc:picChg>
+        <pc:picChg chg="add del">
+          <ac:chgData name="헌정 임" userId="eb9ca9bd79f0560f" providerId="LiveId" clId="{A6339E56-8272-42D6-9D95-12E1A8284411}" dt="2026-07-03T12:36:12.746" v="94" actId="22"/>
+          <ac:picMkLst>
+            <pc:docMk/>
+            <pc:sldMk cId="1109579226" sldId="388"/>
+            <ac:picMk id="11" creationId="{BEF2989B-9194-05A1-C035-164717E10200}"/>
+          </ac:picMkLst>
+        </pc:picChg>
       </pc:sldChg>
       <pc:sldChg chg="addSp delSp modSp new mod">
         <pc:chgData name="헌정 임" userId="eb9ca9bd79f0560f" providerId="LiveId" clId="{A6339E56-8272-42D6-9D95-12E1A8284411}" dt="2026-07-03T12:17:12.336" v="79" actId="21"/>
@@ -480,6 +569,74 @@
             <ac:picMk id="7" creationId="{BADC532B-33D3-D4C5-8D4E-1052EEA3C666}"/>
           </ac:picMkLst>
         </pc:picChg>
+      </pc:sldChg>
+      <pc:sldChg chg="addSp delSp modSp new mod">
+        <pc:chgData name="헌정 임" userId="eb9ca9bd79f0560f" providerId="LiveId" clId="{A6339E56-8272-42D6-9D95-12E1A8284411}" dt="2026-07-03T12:37:16.613" v="104" actId="693"/>
+        <pc:sldMkLst>
+          <pc:docMk/>
+          <pc:sldMk cId="2676242124" sldId="390"/>
+        </pc:sldMkLst>
+        <pc:spChg chg="del">
+          <ac:chgData name="헌정 임" userId="eb9ca9bd79f0560f" providerId="LiveId" clId="{A6339E56-8272-42D6-9D95-12E1A8284411}" dt="2026-07-03T12:31:39.175" v="89" actId="478"/>
+          <ac:spMkLst>
+            <pc:docMk/>
+            <pc:sldMk cId="2676242124" sldId="390"/>
+            <ac:spMk id="2" creationId="{4726A28A-587D-1072-ECE7-D1561D324FD2}"/>
+          </ac:spMkLst>
+        </pc:spChg>
+        <pc:spChg chg="del">
+          <ac:chgData name="헌정 임" userId="eb9ca9bd79f0560f" providerId="LiveId" clId="{A6339E56-8272-42D6-9D95-12E1A8284411}" dt="2026-07-03T12:31:39.175" v="89" actId="478"/>
+          <ac:spMkLst>
+            <pc:docMk/>
+            <pc:sldMk cId="2676242124" sldId="390"/>
+            <ac:spMk id="3" creationId="{2B24658C-4118-C4B8-3884-17B949343351}"/>
+          </ac:spMkLst>
+        </pc:spChg>
+        <pc:spChg chg="add mod">
+          <ac:chgData name="헌정 임" userId="eb9ca9bd79f0560f" providerId="LiveId" clId="{A6339E56-8272-42D6-9D95-12E1A8284411}" dt="2026-07-03T12:37:16.613" v="104" actId="693"/>
+          <ac:spMkLst>
+            <pc:docMk/>
+            <pc:sldMk cId="2676242124" sldId="390"/>
+            <ac:spMk id="6" creationId="{9B7B9073-8606-D0C1-8750-0AE40BAD927A}"/>
+          </ac:spMkLst>
+        </pc:spChg>
+        <pc:picChg chg="add mod">
+          <ac:chgData name="헌정 임" userId="eb9ca9bd79f0560f" providerId="LiveId" clId="{A6339E56-8272-42D6-9D95-12E1A8284411}" dt="2026-07-03T12:36:52.928" v="102" actId="208"/>
+          <ac:picMkLst>
+            <pc:docMk/>
+            <pc:sldMk cId="2676242124" sldId="390"/>
+            <ac:picMk id="5" creationId="{C75BFF21-2AA7-77DF-62B2-D05B186ED8D0}"/>
+          </ac:picMkLst>
+        </pc:picChg>
+      </pc:sldChg>
+      <pc:sldChg chg="addSp new mod">
+        <pc:chgData name="헌정 임" userId="eb9ca9bd79f0560f" providerId="LiveId" clId="{A6339E56-8272-42D6-9D95-12E1A8284411}" dt="2026-07-03T12:35:57.979" v="92" actId="22"/>
+        <pc:sldMkLst>
+          <pc:docMk/>
+          <pc:sldMk cId="1772083265" sldId="391"/>
+        </pc:sldMkLst>
+        <pc:picChg chg="add">
+          <ac:chgData name="헌정 임" userId="eb9ca9bd79f0560f" providerId="LiveId" clId="{A6339E56-8272-42D6-9D95-12E1A8284411}" dt="2026-07-03T12:35:57.979" v="92" actId="22"/>
+          <ac:picMkLst>
+            <pc:docMk/>
+            <pc:sldMk cId="1772083265" sldId="391"/>
+            <ac:picMk id="5" creationId="{6589C82B-76C7-FFFE-F8A8-EBE625E776D5}"/>
+          </ac:picMkLst>
+        </pc:picChg>
+      </pc:sldChg>
+      <pc:sldChg chg="new">
+        <pc:chgData name="헌정 임" userId="eb9ca9bd79f0560f" providerId="LiveId" clId="{A6339E56-8272-42D6-9D95-12E1A8284411}" dt="2026-07-03T12:36:21.600" v="98" actId="680"/>
+        <pc:sldMkLst>
+          <pc:docMk/>
+          <pc:sldMk cId="4061806259" sldId="392"/>
+        </pc:sldMkLst>
+      </pc:sldChg>
+      <pc:sldChg chg="new">
+        <pc:chgData name="헌정 임" userId="eb9ca9bd79f0560f" providerId="LiveId" clId="{A6339E56-8272-42D6-9D95-12E1A8284411}" dt="2026-07-03T12:36:21.768" v="99" actId="680"/>
+        <pc:sldMkLst>
+          <pc:docMk/>
+          <pc:sldMk cId="1862866235" sldId="393"/>
+        </pc:sldMkLst>
       </pc:sldChg>
     </pc:docChg>
   </pc:docChgLst>
@@ -3709,6 +3866,179 @@
           <a:chExt cx="0" cy="0"/>
         </a:xfrm>
       </p:grpSpPr>
+      <p:pic>
+        <p:nvPicPr>
+          <p:cNvPr id="5" name="그림 4">
+            <a:extLst>
+              <a:ext uri="{FF2B5EF4-FFF2-40B4-BE49-F238E27FC236}">
+                <a16:creationId xmlns:a16="http://schemas.microsoft.com/office/drawing/2014/main" id="{C75BFF21-2AA7-77DF-62B2-D05B186ED8D0}"/>
+              </a:ext>
+            </a:extLst>
+          </p:cNvPr>
+          <p:cNvPicPr>
+            <a:picLocks noChangeAspect="1"/>
+          </p:cNvPicPr>
+          <p:nvPr/>
+        </p:nvPicPr>
+        <p:blipFill>
+          <a:blip r:embed="rId2"/>
+          <a:stretch>
+            <a:fillRect/>
+          </a:stretch>
+        </p:blipFill>
+        <p:spPr>
+          <a:xfrm>
+            <a:off x="1166776" y="438128"/>
+            <a:ext cx="9858447" cy="5981744"/>
+          </a:xfrm>
+          <a:prstGeom prst="rect">
+            <a:avLst/>
+          </a:prstGeom>
+          <a:ln>
+            <a:solidFill>
+              <a:srgbClr val="FFFF00"/>
+            </a:solidFill>
+          </a:ln>
+        </p:spPr>
+      </p:pic>
+      <p:sp>
+        <p:nvSpPr>
+          <p:cNvPr id="6" name="직사각형 5">
+            <a:extLst>
+              <a:ext uri="{FF2B5EF4-FFF2-40B4-BE49-F238E27FC236}">
+                <a16:creationId xmlns:a16="http://schemas.microsoft.com/office/drawing/2014/main" id="{9B7B9073-8606-D0C1-8750-0AE40BAD927A}"/>
+              </a:ext>
+            </a:extLst>
+          </p:cNvPr>
+          <p:cNvSpPr/>
+          <p:nvPr/>
+        </p:nvSpPr>
+        <p:spPr>
+          <a:xfrm>
+            <a:off x="6045200" y="3689350"/>
+            <a:ext cx="2641600" cy="774700"/>
+          </a:xfrm>
+          <a:prstGeom prst="rect">
+            <a:avLst/>
+          </a:prstGeom>
+          <a:noFill/>
+          <a:ln>
+            <a:solidFill>
+              <a:srgbClr val="FFFF00"/>
+            </a:solidFill>
+            <a:prstDash val="sysDash"/>
+          </a:ln>
+        </p:spPr>
+        <p:style>
+          <a:lnRef idx="2">
+            <a:schemeClr val="accent1">
+              <a:shade val="15000"/>
+            </a:schemeClr>
+          </a:lnRef>
+          <a:fillRef idx="1">
+            <a:schemeClr val="accent1"/>
+          </a:fillRef>
+          <a:effectRef idx="0">
+            <a:schemeClr val="accent1"/>
+          </a:effectRef>
+          <a:fontRef idx="minor">
+            <a:schemeClr val="lt1"/>
+          </a:fontRef>
+        </p:style>
+        <p:txBody>
+          <a:bodyPr rtlCol="0" anchor="ctr"/>
+          <a:lstStyle/>
+          <a:p>
+            <a:pPr algn="ctr"/>
+            <a:endParaRPr lang="ko-KR" altLang="en-US" dirty="0"/>
+          </a:p>
+        </p:txBody>
+      </p:sp>
+    </p:spTree>
+    <p:extLst>
+      <p:ext uri="{BB962C8B-B14F-4D97-AF65-F5344CB8AC3E}">
+        <p14:creationId xmlns:p14="http://schemas.microsoft.com/office/powerpoint/2010/main" val="2676242124"/>
+      </p:ext>
+    </p:extLst>
+  </p:cSld>
+  <p:clrMapOvr>
+    <a:masterClrMapping/>
+  </p:clrMapOvr>
+</p:sld>
+</file>
+
+<file path=ppt/slides/slide10.xml><?xml version="1.0" encoding="utf-8"?>
+<p:sld xmlns:a="http://schemas.openxmlformats.org/drawingml/2006/main" xmlns:r="http://schemas.openxmlformats.org/officeDocument/2006/relationships" xmlns:p="http://schemas.openxmlformats.org/presentationml/2006/main">
+  <p:cSld>
+    <p:spTree>
+      <p:nvGrpSpPr>
+        <p:cNvPr id="1" name=""/>
+        <p:cNvGrpSpPr/>
+        <p:nvPr/>
+      </p:nvGrpSpPr>
+      <p:grpSpPr>
+        <a:xfrm>
+          <a:off x="0" y="0"/>
+          <a:ext cx="0" cy="0"/>
+          <a:chOff x="0" y="0"/>
+          <a:chExt cx="0" cy="0"/>
+        </a:xfrm>
+      </p:grpSpPr>
+      <p:sp>
+        <p:nvSpPr>
+          <p:cNvPr id="2" name="제목 1">
+            <a:extLst>
+              <a:ext uri="{FF2B5EF4-FFF2-40B4-BE49-F238E27FC236}">
+                <a16:creationId xmlns:a16="http://schemas.microsoft.com/office/drawing/2014/main" id="{59705BC9-4FD3-8553-71FF-489C2E19D408}"/>
+              </a:ext>
+            </a:extLst>
+          </p:cNvPr>
+          <p:cNvSpPr>
+            <a:spLocks noGrp="1"/>
+          </p:cNvSpPr>
+          <p:nvPr>
+            <p:ph type="title"/>
+          </p:nvPr>
+        </p:nvSpPr>
+        <p:spPr/>
+        <p:txBody>
+          <a:bodyPr/>
+          <a:lstStyle/>
+          <a:p>
+            <a:endParaRPr lang="ko-KR" altLang="en-US"/>
+          </a:p>
+        </p:txBody>
+      </p:sp>
+    </p:spTree>
+    <p:extLst>
+      <p:ext uri="{BB962C8B-B14F-4D97-AF65-F5344CB8AC3E}">
+        <p14:creationId xmlns:p14="http://schemas.microsoft.com/office/powerpoint/2010/main" val="1862866235"/>
+      </p:ext>
+    </p:extLst>
+  </p:cSld>
+  <p:clrMapOvr>
+    <a:masterClrMapping/>
+  </p:clrMapOvr>
+</p:sld>
+</file>
+
+<file path=ppt/slides/slide11.xml><?xml version="1.0" encoding="utf-8"?>
+<p:sld xmlns:a="http://schemas.openxmlformats.org/drawingml/2006/main" xmlns:r="http://schemas.openxmlformats.org/officeDocument/2006/relationships" xmlns:p="http://schemas.openxmlformats.org/presentationml/2006/main">
+  <p:cSld>
+    <p:spTree>
+      <p:nvGrpSpPr>
+        <p:cNvPr id="1" name=""/>
+        <p:cNvGrpSpPr/>
+        <p:nvPr/>
+      </p:nvGrpSpPr>
+      <p:grpSpPr>
+        <a:xfrm>
+          <a:off x="0" y="0"/>
+          <a:ext cx="0" cy="0"/>
+          <a:chOff x="0" y="0"/>
+          <a:chExt cx="0" cy="0"/>
+        </a:xfrm>
+      </p:grpSpPr>
       <p:sp>
         <p:nvSpPr>
           <p:cNvPr id="41" name="제목 40">
@@ -3890,443 +4220,7 @@
     </p:spTree>
     <p:extLst>
       <p:ext uri="{BB962C8B-B14F-4D97-AF65-F5344CB8AC3E}">
-        <p14:creationId xmlns:p14="http://schemas.microsoft.com/office/powerpoint/2010/main" val="2282982365"/>
-      </p:ext>
-    </p:extLst>
-  </p:cSld>
-  <p:clrMapOvr>
-    <a:masterClrMapping/>
-  </p:clrMapOvr>
-</p:sld>
-</file>
-
-<file path=ppt/slides/slide10.xml><?xml version="1.0" encoding="utf-8"?>
-<p:sld xmlns:a="http://schemas.openxmlformats.org/drawingml/2006/main" xmlns:r="http://schemas.openxmlformats.org/officeDocument/2006/relationships" xmlns:p="http://schemas.openxmlformats.org/presentationml/2006/main">
-  <p:cSld>
-    <p:spTree>
-      <p:nvGrpSpPr>
-        <p:cNvPr id="1" name=""/>
-        <p:cNvGrpSpPr/>
-        <p:nvPr/>
-      </p:nvGrpSpPr>
-      <p:grpSpPr>
-        <a:xfrm>
-          <a:off x="0" y="0"/>
-          <a:ext cx="0" cy="0"/>
-          <a:chOff x="0" y="0"/>
-          <a:chExt cx="0" cy="0"/>
-        </a:xfrm>
-      </p:grpSpPr>
-      <p:sp>
-        <p:nvSpPr>
-          <p:cNvPr id="2" name="제목 1">
-            <a:extLst>
-              <a:ext uri="{FF2B5EF4-FFF2-40B4-BE49-F238E27FC236}">
-                <a16:creationId xmlns:a16="http://schemas.microsoft.com/office/drawing/2014/main" id="{DA0C604D-4898-FB68-B7A1-BA45C421C029}"/>
-              </a:ext>
-            </a:extLst>
-          </p:cNvPr>
-          <p:cNvSpPr>
-            <a:spLocks noGrp="1"/>
-          </p:cNvSpPr>
-          <p:nvPr>
-            <p:ph type="title"/>
-          </p:nvPr>
-        </p:nvSpPr>
-        <p:spPr/>
-        <p:txBody>
-          <a:bodyPr/>
-          <a:lstStyle/>
-          <a:p>
-            <a:endParaRPr lang="ko-KR" altLang="en-US"/>
-          </a:p>
-        </p:txBody>
-      </p:sp>
-      <p:pic>
-        <p:nvPicPr>
-          <p:cNvPr id="4" name="그림 3">
-            <a:extLst>
-              <a:ext uri="{FF2B5EF4-FFF2-40B4-BE49-F238E27FC236}">
-                <a16:creationId xmlns:a16="http://schemas.microsoft.com/office/drawing/2014/main" id="{D46C9835-FBA8-76FF-19E1-17A22C19FE4D}"/>
-              </a:ext>
-            </a:extLst>
-          </p:cNvPr>
-          <p:cNvPicPr>
-            <a:picLocks noChangeAspect="1"/>
-          </p:cNvPicPr>
-          <p:nvPr/>
-        </p:nvPicPr>
-        <p:blipFill>
-          <a:blip r:embed="rId2"/>
-          <a:srcRect t="53795" b="23331"/>
-          <a:stretch>
-            <a:fillRect/>
-          </a:stretch>
-        </p:blipFill>
-        <p:spPr>
-          <a:xfrm>
-            <a:off x="207650" y="4657603"/>
-            <a:ext cx="4333907" cy="1544782"/>
-          </a:xfrm>
-          <a:prstGeom prst="rect">
-            <a:avLst/>
-          </a:prstGeom>
-        </p:spPr>
-      </p:pic>
-      <p:pic>
-        <p:nvPicPr>
-          <p:cNvPr id="6" name="그림 5">
-            <a:extLst>
-              <a:ext uri="{FF2B5EF4-FFF2-40B4-BE49-F238E27FC236}">
-                <a16:creationId xmlns:a16="http://schemas.microsoft.com/office/drawing/2014/main" id="{FC127FFB-6F9B-41DE-A499-C39EB3281D17}"/>
-              </a:ext>
-            </a:extLst>
-          </p:cNvPr>
-          <p:cNvPicPr>
-            <a:picLocks noChangeAspect="1"/>
-          </p:cNvPicPr>
-          <p:nvPr/>
-        </p:nvPicPr>
-        <p:blipFill>
-          <a:blip r:embed="rId3"/>
-          <a:srcRect t="48199"/>
-          <a:stretch>
-            <a:fillRect/>
-          </a:stretch>
-        </p:blipFill>
-        <p:spPr>
-          <a:xfrm>
-            <a:off x="4541557" y="4087092"/>
-            <a:ext cx="4248181" cy="3187434"/>
-          </a:xfrm>
-          <a:prstGeom prst="rect">
-            <a:avLst/>
-          </a:prstGeom>
-        </p:spPr>
-      </p:pic>
-      <p:pic>
-        <p:nvPicPr>
-          <p:cNvPr id="8" name="그림 7">
-            <a:extLst>
-              <a:ext uri="{FF2B5EF4-FFF2-40B4-BE49-F238E27FC236}">
-                <a16:creationId xmlns:a16="http://schemas.microsoft.com/office/drawing/2014/main" id="{5FE4F172-8AD1-5C42-0140-DA4A2BE3DD96}"/>
-              </a:ext>
-            </a:extLst>
-          </p:cNvPr>
-          <p:cNvPicPr>
-            <a:picLocks noChangeAspect="1"/>
-          </p:cNvPicPr>
-          <p:nvPr/>
-        </p:nvPicPr>
-        <p:blipFill>
-          <a:blip r:embed="rId4"/>
-          <a:stretch>
-            <a:fillRect/>
-          </a:stretch>
-        </p:blipFill>
-        <p:spPr>
-          <a:xfrm>
-            <a:off x="4570133" y="6967971"/>
-            <a:ext cx="4305331" cy="2209816"/>
-          </a:xfrm>
-          <a:prstGeom prst="rect">
-            <a:avLst/>
-          </a:prstGeom>
-        </p:spPr>
-      </p:pic>
-      <p:pic>
-        <p:nvPicPr>
-          <p:cNvPr id="10" name="그림 9">
-            <a:extLst>
-              <a:ext uri="{FF2B5EF4-FFF2-40B4-BE49-F238E27FC236}">
-                <a16:creationId xmlns:a16="http://schemas.microsoft.com/office/drawing/2014/main" id="{92735DA8-5C9C-348D-FD57-450DE0508F74}"/>
-              </a:ext>
-            </a:extLst>
-          </p:cNvPr>
-          <p:cNvPicPr>
-            <a:picLocks noChangeAspect="1"/>
-          </p:cNvPicPr>
-          <p:nvPr/>
-        </p:nvPicPr>
-        <p:blipFill>
-          <a:blip r:embed="rId5"/>
-          <a:stretch>
-            <a:fillRect/>
-          </a:stretch>
-        </p:blipFill>
-        <p:spPr>
-          <a:xfrm>
-            <a:off x="7905719" y="180933"/>
-            <a:ext cx="4286281" cy="5581691"/>
-          </a:xfrm>
-          <a:prstGeom prst="rect">
-            <a:avLst/>
-          </a:prstGeom>
-        </p:spPr>
-      </p:pic>
-      <p:pic>
-        <p:nvPicPr>
-          <p:cNvPr id="11" name="그림 10">
-            <a:extLst>
-              <a:ext uri="{FF2B5EF4-FFF2-40B4-BE49-F238E27FC236}">
-                <a16:creationId xmlns:a16="http://schemas.microsoft.com/office/drawing/2014/main" id="{190B6743-2176-3074-22CE-7C8BCB59873C}"/>
-              </a:ext>
-            </a:extLst>
-          </p:cNvPr>
-          <p:cNvPicPr>
-            <a:picLocks noChangeAspect="1"/>
-          </p:cNvPicPr>
-          <p:nvPr/>
-        </p:nvPicPr>
-        <p:blipFill>
-          <a:blip r:embed="rId2"/>
-          <a:srcRect b="45959"/>
-          <a:stretch>
-            <a:fillRect/>
-          </a:stretch>
-        </p:blipFill>
-        <p:spPr>
-          <a:xfrm>
-            <a:off x="207650" y="946318"/>
-            <a:ext cx="4333907" cy="3649503"/>
-          </a:xfrm>
-          <a:prstGeom prst="rect">
-            <a:avLst/>
-          </a:prstGeom>
-        </p:spPr>
-      </p:pic>
-      <p:pic>
-        <p:nvPicPr>
-          <p:cNvPr id="12" name="그림 11">
-            <a:extLst>
-              <a:ext uri="{FF2B5EF4-FFF2-40B4-BE49-F238E27FC236}">
-                <a16:creationId xmlns:a16="http://schemas.microsoft.com/office/drawing/2014/main" id="{8A1E3112-45E3-0CB1-E1B4-6F0256BAF1E3}"/>
-              </a:ext>
-            </a:extLst>
-          </p:cNvPr>
-          <p:cNvPicPr>
-            <a:picLocks noChangeAspect="1"/>
-          </p:cNvPicPr>
-          <p:nvPr/>
-        </p:nvPicPr>
-        <p:blipFill>
-          <a:blip r:embed="rId2"/>
-          <a:srcRect t="76233"/>
-          <a:stretch>
-            <a:fillRect/>
-          </a:stretch>
-        </p:blipFill>
-        <p:spPr>
-          <a:xfrm>
-            <a:off x="207650" y="6624832"/>
-            <a:ext cx="4333907" cy="1605032"/>
-          </a:xfrm>
-          <a:prstGeom prst="rect">
-            <a:avLst/>
-          </a:prstGeom>
-        </p:spPr>
-      </p:pic>
-      <p:pic>
-        <p:nvPicPr>
-          <p:cNvPr id="13" name="그림 12">
-            <a:extLst>
-              <a:ext uri="{FF2B5EF4-FFF2-40B4-BE49-F238E27FC236}">
-                <a16:creationId xmlns:a16="http://schemas.microsoft.com/office/drawing/2014/main" id="{1C9043BD-C001-5B13-4D1A-9C757CE0088D}"/>
-              </a:ext>
-            </a:extLst>
-          </p:cNvPr>
-          <p:cNvPicPr>
-            <a:picLocks noChangeAspect="1"/>
-          </p:cNvPicPr>
-          <p:nvPr/>
-        </p:nvPicPr>
-        <p:blipFill>
-          <a:blip r:embed="rId3"/>
-          <a:srcRect b="51379"/>
-          <a:stretch>
-            <a:fillRect/>
-          </a:stretch>
-        </p:blipFill>
-        <p:spPr>
-          <a:xfrm>
-            <a:off x="4541557" y="1095376"/>
-            <a:ext cx="4248181" cy="2991716"/>
-          </a:xfrm>
-          <a:prstGeom prst="rect">
-            <a:avLst/>
-          </a:prstGeom>
-        </p:spPr>
-      </p:pic>
-    </p:spTree>
-    <p:extLst>
-      <p:ext uri="{BB962C8B-B14F-4D97-AF65-F5344CB8AC3E}">
-        <p14:creationId xmlns:p14="http://schemas.microsoft.com/office/powerpoint/2010/main" val="1983847626"/>
-      </p:ext>
-    </p:extLst>
-  </p:cSld>
-  <p:clrMapOvr>
-    <a:masterClrMapping/>
-  </p:clrMapOvr>
-</p:sld>
-</file>
-
-<file path=ppt/slides/slide11.xml><?xml version="1.0" encoding="utf-8"?>
-<p:sld xmlns:a="http://schemas.openxmlformats.org/drawingml/2006/main" xmlns:r="http://schemas.openxmlformats.org/officeDocument/2006/relationships" xmlns:p="http://schemas.openxmlformats.org/presentationml/2006/main">
-  <p:cSld>
-    <p:spTree>
-      <p:nvGrpSpPr>
-        <p:cNvPr id="1" name=""/>
-        <p:cNvGrpSpPr/>
-        <p:nvPr/>
-      </p:nvGrpSpPr>
-      <p:grpSpPr>
-        <a:xfrm>
-          <a:off x="0" y="0"/>
-          <a:ext cx="0" cy="0"/>
-          <a:chOff x="0" y="0"/>
-          <a:chExt cx="0" cy="0"/>
-        </a:xfrm>
-      </p:grpSpPr>
-      <p:sp>
-        <p:nvSpPr>
-          <p:cNvPr id="2" name="제목 1">
-            <a:extLst>
-              <a:ext uri="{FF2B5EF4-FFF2-40B4-BE49-F238E27FC236}">
-                <a16:creationId xmlns:a16="http://schemas.microsoft.com/office/drawing/2014/main" id="{D5A1BA7F-CD92-ACF2-5B13-F456190790AC}"/>
-              </a:ext>
-            </a:extLst>
-          </p:cNvPr>
-          <p:cNvSpPr>
-            <a:spLocks noGrp="1"/>
-          </p:cNvSpPr>
-          <p:nvPr>
-            <p:ph type="title"/>
-          </p:nvPr>
-        </p:nvSpPr>
-        <p:spPr/>
-        <p:txBody>
-          <a:bodyPr/>
-          <a:lstStyle/>
-          <a:p>
-            <a:endParaRPr lang="ko-KR" altLang="en-US"/>
-          </a:p>
-        </p:txBody>
-      </p:sp>
-      <p:pic>
-        <p:nvPicPr>
-          <p:cNvPr id="4" name="그림 3">
-            <a:extLst>
-              <a:ext uri="{FF2B5EF4-FFF2-40B4-BE49-F238E27FC236}">
-                <a16:creationId xmlns:a16="http://schemas.microsoft.com/office/drawing/2014/main" id="{E8B297AB-20D8-0B14-8D8A-CAAF32A032DE}"/>
-              </a:ext>
-            </a:extLst>
-          </p:cNvPr>
-          <p:cNvPicPr>
-            <a:picLocks noChangeAspect="1"/>
-          </p:cNvPicPr>
-          <p:nvPr/>
-        </p:nvPicPr>
-        <p:blipFill>
-          <a:blip r:embed="rId2"/>
-          <a:stretch>
-            <a:fillRect/>
-          </a:stretch>
-        </p:blipFill>
-        <p:spPr>
-          <a:xfrm>
-            <a:off x="0" y="28163"/>
-            <a:ext cx="12192000" cy="6801674"/>
-          </a:xfrm>
-          <a:prstGeom prst="rect">
-            <a:avLst/>
-          </a:prstGeom>
-        </p:spPr>
-      </p:pic>
-      <p:sp>
-        <p:nvSpPr>
-          <p:cNvPr id="5" name="직사각형 4">
-            <a:extLst>
-              <a:ext uri="{FF2B5EF4-FFF2-40B4-BE49-F238E27FC236}">
-                <a16:creationId xmlns:a16="http://schemas.microsoft.com/office/drawing/2014/main" id="{87597391-AF5F-C774-31F8-B1E520AE5465}"/>
-              </a:ext>
-            </a:extLst>
-          </p:cNvPr>
-          <p:cNvSpPr/>
-          <p:nvPr/>
-        </p:nvSpPr>
-        <p:spPr>
-          <a:xfrm>
-            <a:off x="10655687" y="147241"/>
-            <a:ext cx="1159847" cy="297260"/>
-          </a:xfrm>
-          <a:prstGeom prst="rect">
-            <a:avLst/>
-          </a:prstGeom>
-          <a:solidFill>
-            <a:srgbClr val="F2F2F2"/>
-          </a:solidFill>
-          <a:ln>
-            <a:noFill/>
-          </a:ln>
-        </p:spPr>
-        <p:style>
-          <a:lnRef idx="2">
-            <a:schemeClr val="accent1">
-              <a:shade val="50000"/>
-            </a:schemeClr>
-          </a:lnRef>
-          <a:fillRef idx="1">
-            <a:schemeClr val="accent1"/>
-          </a:fillRef>
-          <a:effectRef idx="0">
-            <a:schemeClr val="accent1"/>
-          </a:effectRef>
-          <a:fontRef idx="minor">
-            <a:schemeClr val="lt1"/>
-          </a:fontRef>
-        </p:style>
-        <p:txBody>
-          <a:bodyPr rtlCol="0" anchor="ctr"/>
-          <a:lstStyle/>
-          <a:p>
-            <a:pPr marL="0" marR="0" lvl="0" indent="0" algn="ctr" defTabSz="914400" rtl="0" eaLnBrk="1" fontAlgn="auto" latinLnBrk="1" hangingPunct="1">
-              <a:lnSpc>
-                <a:spcPct val="100000"/>
-              </a:lnSpc>
-              <a:spcBef>
-                <a:spcPts val="0"/>
-              </a:spcBef>
-              <a:spcAft>
-                <a:spcPts val="0"/>
-              </a:spcAft>
-              <a:buClrTx/>
-              <a:buSzTx/>
-              <a:buFontTx/>
-              <a:buNone/>
-              <a:tabLst/>
-              <a:defRPr/>
-            </a:pPr>
-            <a:endParaRPr kumimoji="0" lang="ko-KR" altLang="en-US" sz="1800" b="0" i="0" u="none" strike="noStrike" kern="1200" cap="none" spc="0" normalizeH="0" baseline="0" noProof="0">
-              <a:ln>
-                <a:noFill/>
-              </a:ln>
-              <a:solidFill>
-                <a:prstClr val="white"/>
-              </a:solidFill>
-              <a:effectLst/>
-              <a:uLnTx/>
-              <a:uFillTx/>
-              <a:latin typeface="Montserrat" pitchFamily="2" charset="0"/>
-              <a:ea typeface="맑은 고딕" panose="020B0503020000020004" pitchFamily="50" charset="-127"/>
-              <a:cs typeface="+mn-cs"/>
-            </a:endParaRPr>
-          </a:p>
-        </p:txBody>
-      </p:sp>
-    </p:spTree>
-    <p:extLst>
-      <p:ext uri="{BB962C8B-B14F-4D97-AF65-F5344CB8AC3E}">
-        <p14:creationId xmlns:p14="http://schemas.microsoft.com/office/powerpoint/2010/main" val="333529903"/>
+        <p14:creationId xmlns:p14="http://schemas.microsoft.com/office/powerpoint/2010/main" val="3589339983"/>
       </p:ext>
     </p:extLst>
   </p:cSld>
@@ -4337,172 +4231,6 @@
 </file>
 
 <file path=ppt/slides/slide12.xml><?xml version="1.0" encoding="utf-8"?>
-<p:sld xmlns:a="http://schemas.openxmlformats.org/drawingml/2006/main" xmlns:r="http://schemas.openxmlformats.org/officeDocument/2006/relationships" xmlns:p="http://schemas.openxmlformats.org/presentationml/2006/main">
-  <p:cSld>
-    <p:spTree>
-      <p:nvGrpSpPr>
-        <p:cNvPr id="1" name=""/>
-        <p:cNvGrpSpPr/>
-        <p:nvPr/>
-      </p:nvGrpSpPr>
-      <p:grpSpPr>
-        <a:xfrm>
-          <a:off x="0" y="0"/>
-          <a:ext cx="0" cy="0"/>
-          <a:chOff x="0" y="0"/>
-          <a:chExt cx="0" cy="0"/>
-        </a:xfrm>
-      </p:grpSpPr>
-      <p:sp>
-        <p:nvSpPr>
-          <p:cNvPr id="2" name="제목 1">
-            <a:extLst>
-              <a:ext uri="{FF2B5EF4-FFF2-40B4-BE49-F238E27FC236}">
-                <a16:creationId xmlns:a16="http://schemas.microsoft.com/office/drawing/2014/main" id="{C806619F-2430-DB69-E007-F8C44168B1F1}"/>
-              </a:ext>
-            </a:extLst>
-          </p:cNvPr>
-          <p:cNvSpPr>
-            <a:spLocks noGrp="1"/>
-          </p:cNvSpPr>
-          <p:nvPr>
-            <p:ph type="title"/>
-          </p:nvPr>
-        </p:nvSpPr>
-        <p:spPr/>
-        <p:txBody>
-          <a:bodyPr/>
-          <a:lstStyle/>
-          <a:p>
-            <a:endParaRPr lang="ko-KR" altLang="en-US"/>
-          </a:p>
-        </p:txBody>
-      </p:sp>
-      <p:pic>
-        <p:nvPicPr>
-          <p:cNvPr id="6" name="그림 5">
-            <a:extLst>
-              <a:ext uri="{FF2B5EF4-FFF2-40B4-BE49-F238E27FC236}">
-                <a16:creationId xmlns:a16="http://schemas.microsoft.com/office/drawing/2014/main" id="{48EF2E57-901F-B412-D2ED-829178775CF8}"/>
-              </a:ext>
-            </a:extLst>
-          </p:cNvPr>
-          <p:cNvPicPr>
-            <a:picLocks noChangeAspect="1"/>
-          </p:cNvPicPr>
-          <p:nvPr/>
-        </p:nvPicPr>
-        <p:blipFill>
-          <a:blip r:embed="rId2"/>
-          <a:stretch>
-            <a:fillRect/>
-          </a:stretch>
-        </p:blipFill>
-        <p:spPr>
-          <a:xfrm>
-            <a:off x="0" y="55194"/>
-            <a:ext cx="12192000" cy="6747612"/>
-          </a:xfrm>
-          <a:prstGeom prst="rect">
-            <a:avLst/>
-          </a:prstGeom>
-        </p:spPr>
-      </p:pic>
-      <p:sp>
-        <p:nvSpPr>
-          <p:cNvPr id="7" name="직사각형 6">
-            <a:extLst>
-              <a:ext uri="{FF2B5EF4-FFF2-40B4-BE49-F238E27FC236}">
-                <a16:creationId xmlns:a16="http://schemas.microsoft.com/office/drawing/2014/main" id="{14B85EC4-8F40-3159-DBE0-117F5C1C36A2}"/>
-              </a:ext>
-            </a:extLst>
-          </p:cNvPr>
-          <p:cNvSpPr/>
-          <p:nvPr/>
-        </p:nvSpPr>
-        <p:spPr>
-          <a:xfrm>
-            <a:off x="10655687" y="147241"/>
-            <a:ext cx="1159847" cy="297260"/>
-          </a:xfrm>
-          <a:prstGeom prst="rect">
-            <a:avLst/>
-          </a:prstGeom>
-          <a:solidFill>
-            <a:srgbClr val="F2F2F2"/>
-          </a:solidFill>
-          <a:ln>
-            <a:noFill/>
-          </a:ln>
-        </p:spPr>
-        <p:style>
-          <a:lnRef idx="2">
-            <a:schemeClr val="accent1">
-              <a:shade val="50000"/>
-            </a:schemeClr>
-          </a:lnRef>
-          <a:fillRef idx="1">
-            <a:schemeClr val="accent1"/>
-          </a:fillRef>
-          <a:effectRef idx="0">
-            <a:schemeClr val="accent1"/>
-          </a:effectRef>
-          <a:fontRef idx="minor">
-            <a:schemeClr val="lt1"/>
-          </a:fontRef>
-        </p:style>
-        <p:txBody>
-          <a:bodyPr rtlCol="0" anchor="ctr"/>
-          <a:lstStyle/>
-          <a:p>
-            <a:pPr marL="0" marR="0" lvl="0" indent="0" algn="ctr" defTabSz="914400" rtl="0" eaLnBrk="1" fontAlgn="auto" latinLnBrk="1" hangingPunct="1">
-              <a:lnSpc>
-                <a:spcPct val="100000"/>
-              </a:lnSpc>
-              <a:spcBef>
-                <a:spcPts val="0"/>
-              </a:spcBef>
-              <a:spcAft>
-                <a:spcPts val="0"/>
-              </a:spcAft>
-              <a:buClrTx/>
-              <a:buSzTx/>
-              <a:buFontTx/>
-              <a:buNone/>
-              <a:tabLst/>
-              <a:defRPr/>
-            </a:pPr>
-            <a:endParaRPr kumimoji="0" lang="ko-KR" altLang="en-US" sz="1800" b="0" i="0" u="none" strike="noStrike" kern="1200" cap="none" spc="0" normalizeH="0" baseline="0" noProof="0">
-              <a:ln>
-                <a:noFill/>
-              </a:ln>
-              <a:solidFill>
-                <a:prstClr val="white"/>
-              </a:solidFill>
-              <a:effectLst/>
-              <a:uLnTx/>
-              <a:uFillTx/>
-              <a:latin typeface="Montserrat" pitchFamily="2" charset="0"/>
-              <a:ea typeface="맑은 고딕" panose="020B0503020000020004" pitchFamily="50" charset="-127"/>
-              <a:cs typeface="+mn-cs"/>
-            </a:endParaRPr>
-          </a:p>
-        </p:txBody>
-      </p:sp>
-    </p:spTree>
-    <p:extLst>
-      <p:ext uri="{BB962C8B-B14F-4D97-AF65-F5344CB8AC3E}">
-        <p14:creationId xmlns:p14="http://schemas.microsoft.com/office/powerpoint/2010/main" val="1109579226"/>
-      </p:ext>
-    </p:extLst>
-  </p:cSld>
-  <p:clrMapOvr>
-    <a:masterClrMapping/>
-  </p:clrMapOvr>
-</p:sld>
-</file>
-
-<file path=ppt/slides/slide2.xml><?xml version="1.0" encoding="utf-8"?>
 <p:sld xmlns:a="http://schemas.openxmlformats.org/drawingml/2006/main" xmlns:r="http://schemas.openxmlformats.org/officeDocument/2006/relationships" xmlns:p="http://schemas.openxmlformats.org/presentationml/2006/main">
   <p:cSld>
     <p:spTree>
@@ -29874,7 +29602,7 @@
     </p:spTree>
     <p:extLst>
       <p:ext uri="{BB962C8B-B14F-4D97-AF65-F5344CB8AC3E}">
-        <p14:creationId xmlns:p14="http://schemas.microsoft.com/office/powerpoint/2010/main" val="1331024538"/>
+        <p14:creationId xmlns:p14="http://schemas.microsoft.com/office/powerpoint/2010/main" val="4276870801"/>
       </p:ext>
     </p:extLst>
   </p:cSld>
@@ -29884,7 +29612,7 @@
 </p:sld>
 </file>
 
-<file path=ppt/slides/slide3.xml><?xml version="1.0" encoding="utf-8"?>
+<file path=ppt/slides/slide13.xml><?xml version="1.0" encoding="utf-8"?>
 <p:sld xmlns:a="http://schemas.openxmlformats.org/drawingml/2006/main" xmlns:r="http://schemas.openxmlformats.org/officeDocument/2006/relationships" xmlns:p="http://schemas.openxmlformats.org/presentationml/2006/main">
   <p:cSld>
     <p:spTree>
@@ -33252,7 +32980,7 @@
     </p:spTree>
     <p:extLst>
       <p:ext uri="{BB962C8B-B14F-4D97-AF65-F5344CB8AC3E}">
-        <p14:creationId xmlns:p14="http://schemas.microsoft.com/office/powerpoint/2010/main" val="3313299812"/>
+        <p14:creationId xmlns:p14="http://schemas.microsoft.com/office/powerpoint/2010/main" val="580931778"/>
       </p:ext>
     </p:extLst>
   </p:cSld>
@@ -33262,7 +32990,7 @@
 </p:sld>
 </file>
 
-<file path=ppt/slides/slide4.xml><?xml version="1.0" encoding="utf-8"?>
+<file path=ppt/slides/slide14.xml><?xml version="1.0" encoding="utf-8"?>
 <p:sld xmlns:a="http://schemas.openxmlformats.org/drawingml/2006/main" xmlns:r="http://schemas.openxmlformats.org/officeDocument/2006/relationships" xmlns:p="http://schemas.openxmlformats.org/presentationml/2006/main">
   <p:cSld>
     <p:spTree>
@@ -36633,7 +36361,7 @@
     </p:spTree>
     <p:extLst>
       <p:ext uri="{BB962C8B-B14F-4D97-AF65-F5344CB8AC3E}">
-        <p14:creationId xmlns:p14="http://schemas.microsoft.com/office/powerpoint/2010/main" val="1040387894"/>
+        <p14:creationId xmlns:p14="http://schemas.microsoft.com/office/powerpoint/2010/main" val="1992724321"/>
       </p:ext>
     </p:extLst>
   </p:cSld>
@@ -36643,7 +36371,7 @@
 </p:sld>
 </file>
 
-<file path=ppt/slides/slide5.xml><?xml version="1.0" encoding="utf-8"?>
+<file path=ppt/slides/slide15.xml><?xml version="1.0" encoding="utf-8"?>
 <p:sld xmlns:a="http://schemas.openxmlformats.org/drawingml/2006/main" xmlns:r="http://schemas.openxmlformats.org/officeDocument/2006/relationships" xmlns:p="http://schemas.openxmlformats.org/presentationml/2006/main">
   <p:cSld>
     <p:spTree>
@@ -40010,7 +39738,7 @@
     </p:spTree>
     <p:extLst>
       <p:ext uri="{BB962C8B-B14F-4D97-AF65-F5344CB8AC3E}">
-        <p14:creationId xmlns:p14="http://schemas.microsoft.com/office/powerpoint/2010/main" val="2534719469"/>
+        <p14:creationId xmlns:p14="http://schemas.microsoft.com/office/powerpoint/2010/main" val="1595150386"/>
       </p:ext>
     </p:extLst>
   </p:cSld>
@@ -40020,7 +39748,7 @@
 </p:sld>
 </file>
 
-<file path=ppt/slides/slide6.xml><?xml version="1.0" encoding="utf-8"?>
+<file path=ppt/slides/slide16.xml><?xml version="1.0" encoding="utf-8"?>
 <p:sld xmlns:a="http://schemas.openxmlformats.org/drawingml/2006/main" xmlns:r="http://schemas.openxmlformats.org/officeDocument/2006/relationships" xmlns:p="http://schemas.openxmlformats.org/presentationml/2006/main">
   <p:cSld>
     <p:spTree>
@@ -41515,7 +41243,7 @@
     </p:spTree>
     <p:extLst>
       <p:ext uri="{BB962C8B-B14F-4D97-AF65-F5344CB8AC3E}">
-        <p14:creationId xmlns:p14="http://schemas.microsoft.com/office/powerpoint/2010/main" val="2705008494"/>
+        <p14:creationId xmlns:p14="http://schemas.microsoft.com/office/powerpoint/2010/main" val="3383271283"/>
       </p:ext>
     </p:extLst>
   </p:cSld>
@@ -41525,7 +41253,117 @@
 </p:sld>
 </file>
 
-<file path=ppt/slides/slide7.xml><?xml version="1.0" encoding="utf-8"?>
+<file path=ppt/slides/slide2.xml><?xml version="1.0" encoding="utf-8"?>
+<p:sld xmlns:a="http://schemas.openxmlformats.org/drawingml/2006/main" xmlns:r="http://schemas.openxmlformats.org/officeDocument/2006/relationships" xmlns:p="http://schemas.openxmlformats.org/presentationml/2006/main">
+  <p:cSld>
+    <p:spTree>
+      <p:nvGrpSpPr>
+        <p:cNvPr id="1" name=""/>
+        <p:cNvGrpSpPr/>
+        <p:nvPr/>
+      </p:nvGrpSpPr>
+      <p:grpSpPr>
+        <a:xfrm>
+          <a:off x="0" y="0"/>
+          <a:ext cx="0" cy="0"/>
+          <a:chOff x="0" y="0"/>
+          <a:chExt cx="0" cy="0"/>
+        </a:xfrm>
+      </p:grpSpPr>
+      <p:sp>
+        <p:nvSpPr>
+          <p:cNvPr id="2" name="제목 1">
+            <a:extLst>
+              <a:ext uri="{FF2B5EF4-FFF2-40B4-BE49-F238E27FC236}">
+                <a16:creationId xmlns:a16="http://schemas.microsoft.com/office/drawing/2014/main" id="{6B72C4B6-F596-F78E-3A8C-23BCA79F7F76}"/>
+              </a:ext>
+            </a:extLst>
+          </p:cNvPr>
+          <p:cNvSpPr>
+            <a:spLocks noGrp="1"/>
+          </p:cNvSpPr>
+          <p:nvPr>
+            <p:ph type="title"/>
+          </p:nvPr>
+        </p:nvSpPr>
+        <p:spPr/>
+        <p:txBody>
+          <a:bodyPr/>
+          <a:lstStyle/>
+          <a:p>
+            <a:endParaRPr lang="ko-KR" altLang="en-US"/>
+          </a:p>
+        </p:txBody>
+      </p:sp>
+      <p:sp>
+        <p:nvSpPr>
+          <p:cNvPr id="3" name="내용 개체 틀 2">
+            <a:extLst>
+              <a:ext uri="{FF2B5EF4-FFF2-40B4-BE49-F238E27FC236}">
+                <a16:creationId xmlns:a16="http://schemas.microsoft.com/office/drawing/2014/main" id="{461B4D87-F7B2-AB98-E8DD-ED3981191125}"/>
+              </a:ext>
+            </a:extLst>
+          </p:cNvPr>
+          <p:cNvSpPr>
+            <a:spLocks noGrp="1"/>
+          </p:cNvSpPr>
+          <p:nvPr>
+            <p:ph idx="1"/>
+          </p:nvPr>
+        </p:nvSpPr>
+        <p:spPr/>
+        <p:txBody>
+          <a:bodyPr/>
+          <a:lstStyle/>
+          <a:p>
+            <a:endParaRPr lang="ko-KR" altLang="en-US"/>
+          </a:p>
+        </p:txBody>
+      </p:sp>
+      <p:pic>
+        <p:nvPicPr>
+          <p:cNvPr id="5" name="그림 4">
+            <a:extLst>
+              <a:ext uri="{FF2B5EF4-FFF2-40B4-BE49-F238E27FC236}">
+                <a16:creationId xmlns:a16="http://schemas.microsoft.com/office/drawing/2014/main" id="{6589C82B-76C7-FFFE-F8A8-EBE625E776D5}"/>
+              </a:ext>
+            </a:extLst>
+          </p:cNvPr>
+          <p:cNvPicPr>
+            <a:picLocks noChangeAspect="1"/>
+          </p:cNvPicPr>
+          <p:nvPr/>
+        </p:nvPicPr>
+        <p:blipFill>
+          <a:blip r:embed="rId2"/>
+          <a:stretch>
+            <a:fillRect/>
+          </a:stretch>
+        </p:blipFill>
+        <p:spPr>
+          <a:xfrm>
+            <a:off x="3300392" y="2967034"/>
+            <a:ext cx="5591216" cy="923932"/>
+          </a:xfrm>
+          <a:prstGeom prst="rect">
+            <a:avLst/>
+          </a:prstGeom>
+        </p:spPr>
+      </p:pic>
+    </p:spTree>
+    <p:extLst>
+      <p:ext uri="{BB962C8B-B14F-4D97-AF65-F5344CB8AC3E}">
+        <p14:creationId xmlns:p14="http://schemas.microsoft.com/office/powerpoint/2010/main" val="1772083265"/>
+      </p:ext>
+    </p:extLst>
+  </p:cSld>
+  <p:clrMapOvr>
+    <a:masterClrMapping/>
+  </p:clrMapOvr>
+</p:sld>
+</file>
+
+<file path=ppt/slides/slide3.xml><?xml version="1.0" encoding="utf-8"?>
 <p:sld xmlns:a="http://schemas.openxmlformats.org/drawingml/2006/main" xmlns:r="http://schemas.openxmlformats.org/officeDocument/2006/relationships" xmlns:p="http://schemas.openxmlformats.org/presentationml/2006/main">
   <p:cSld>
     <p:spTree>
@@ -41666,7 +41504,7 @@
 </p:sld>
 </file>
 
-<file path=ppt/slides/slide8.xml><?xml version="1.0" encoding="utf-8"?>
+<file path=ppt/slides/slide4.xml><?xml version="1.0" encoding="utf-8"?>
 <p:sld xmlns:a="http://schemas.openxmlformats.org/drawingml/2006/main" xmlns:r="http://schemas.openxmlformats.org/officeDocument/2006/relationships" xmlns:p="http://schemas.openxmlformats.org/presentationml/2006/main">
   <p:cSld>
     <p:spTree>
@@ -41832,7 +41670,7 @@
 </p:sld>
 </file>
 
-<file path=ppt/slides/slide9.xml><?xml version="1.0" encoding="utf-8"?>
+<file path=ppt/slides/slide5.xml><?xml version="1.0" encoding="utf-8"?>
 <p:sld xmlns:a="http://schemas.openxmlformats.org/drawingml/2006/main" xmlns:r="http://schemas.openxmlformats.org/officeDocument/2006/relationships" xmlns:p="http://schemas.openxmlformats.org/presentationml/2006/main">
   <p:cSld>
     <p:spTree>
@@ -41909,6 +41747,663 @@
     <p:extLst>
       <p:ext uri="{BB962C8B-B14F-4D97-AF65-F5344CB8AC3E}">
         <p14:creationId xmlns:p14="http://schemas.microsoft.com/office/powerpoint/2010/main" val="2716414540"/>
+      </p:ext>
+    </p:extLst>
+  </p:cSld>
+  <p:clrMapOvr>
+    <a:masterClrMapping/>
+  </p:clrMapOvr>
+</p:sld>
+</file>
+
+<file path=ppt/slides/slide6.xml><?xml version="1.0" encoding="utf-8"?>
+<p:sld xmlns:a="http://schemas.openxmlformats.org/drawingml/2006/main" xmlns:r="http://schemas.openxmlformats.org/officeDocument/2006/relationships" xmlns:p="http://schemas.openxmlformats.org/presentationml/2006/main">
+  <p:cSld>
+    <p:spTree>
+      <p:nvGrpSpPr>
+        <p:cNvPr id="1" name=""/>
+        <p:cNvGrpSpPr/>
+        <p:nvPr/>
+      </p:nvGrpSpPr>
+      <p:grpSpPr>
+        <a:xfrm>
+          <a:off x="0" y="0"/>
+          <a:ext cx="0" cy="0"/>
+          <a:chOff x="0" y="0"/>
+          <a:chExt cx="0" cy="0"/>
+        </a:xfrm>
+      </p:grpSpPr>
+      <p:sp>
+        <p:nvSpPr>
+          <p:cNvPr id="2" name="제목 1">
+            <a:extLst>
+              <a:ext uri="{FF2B5EF4-FFF2-40B4-BE49-F238E27FC236}">
+                <a16:creationId xmlns:a16="http://schemas.microsoft.com/office/drawing/2014/main" id="{DA0C604D-4898-FB68-B7A1-BA45C421C029}"/>
+              </a:ext>
+            </a:extLst>
+          </p:cNvPr>
+          <p:cNvSpPr>
+            <a:spLocks noGrp="1"/>
+          </p:cNvSpPr>
+          <p:nvPr>
+            <p:ph type="title"/>
+          </p:nvPr>
+        </p:nvSpPr>
+        <p:spPr/>
+        <p:txBody>
+          <a:bodyPr/>
+          <a:lstStyle/>
+          <a:p>
+            <a:endParaRPr lang="ko-KR" altLang="en-US"/>
+          </a:p>
+        </p:txBody>
+      </p:sp>
+      <p:pic>
+        <p:nvPicPr>
+          <p:cNvPr id="4" name="그림 3">
+            <a:extLst>
+              <a:ext uri="{FF2B5EF4-FFF2-40B4-BE49-F238E27FC236}">
+                <a16:creationId xmlns:a16="http://schemas.microsoft.com/office/drawing/2014/main" id="{D46C9835-FBA8-76FF-19E1-17A22C19FE4D}"/>
+              </a:ext>
+            </a:extLst>
+          </p:cNvPr>
+          <p:cNvPicPr>
+            <a:picLocks noChangeAspect="1"/>
+          </p:cNvPicPr>
+          <p:nvPr/>
+        </p:nvPicPr>
+        <p:blipFill>
+          <a:blip r:embed="rId2"/>
+          <a:srcRect t="53795" b="23331"/>
+          <a:stretch>
+            <a:fillRect/>
+          </a:stretch>
+        </p:blipFill>
+        <p:spPr>
+          <a:xfrm>
+            <a:off x="207650" y="4657603"/>
+            <a:ext cx="4333907" cy="1544782"/>
+          </a:xfrm>
+          <a:prstGeom prst="rect">
+            <a:avLst/>
+          </a:prstGeom>
+        </p:spPr>
+      </p:pic>
+      <p:pic>
+        <p:nvPicPr>
+          <p:cNvPr id="6" name="그림 5">
+            <a:extLst>
+              <a:ext uri="{FF2B5EF4-FFF2-40B4-BE49-F238E27FC236}">
+                <a16:creationId xmlns:a16="http://schemas.microsoft.com/office/drawing/2014/main" id="{FC127FFB-6F9B-41DE-A499-C39EB3281D17}"/>
+              </a:ext>
+            </a:extLst>
+          </p:cNvPr>
+          <p:cNvPicPr>
+            <a:picLocks noChangeAspect="1"/>
+          </p:cNvPicPr>
+          <p:nvPr/>
+        </p:nvPicPr>
+        <p:blipFill>
+          <a:blip r:embed="rId3"/>
+          <a:srcRect t="48199"/>
+          <a:stretch>
+            <a:fillRect/>
+          </a:stretch>
+        </p:blipFill>
+        <p:spPr>
+          <a:xfrm>
+            <a:off x="4541557" y="4087092"/>
+            <a:ext cx="4248181" cy="3187434"/>
+          </a:xfrm>
+          <a:prstGeom prst="rect">
+            <a:avLst/>
+          </a:prstGeom>
+        </p:spPr>
+      </p:pic>
+      <p:pic>
+        <p:nvPicPr>
+          <p:cNvPr id="8" name="그림 7">
+            <a:extLst>
+              <a:ext uri="{FF2B5EF4-FFF2-40B4-BE49-F238E27FC236}">
+                <a16:creationId xmlns:a16="http://schemas.microsoft.com/office/drawing/2014/main" id="{5FE4F172-8AD1-5C42-0140-DA4A2BE3DD96}"/>
+              </a:ext>
+            </a:extLst>
+          </p:cNvPr>
+          <p:cNvPicPr>
+            <a:picLocks noChangeAspect="1"/>
+          </p:cNvPicPr>
+          <p:nvPr/>
+        </p:nvPicPr>
+        <p:blipFill>
+          <a:blip r:embed="rId4"/>
+          <a:stretch>
+            <a:fillRect/>
+          </a:stretch>
+        </p:blipFill>
+        <p:spPr>
+          <a:xfrm>
+            <a:off x="4570133" y="6967971"/>
+            <a:ext cx="4305331" cy="2209816"/>
+          </a:xfrm>
+          <a:prstGeom prst="rect">
+            <a:avLst/>
+          </a:prstGeom>
+        </p:spPr>
+      </p:pic>
+      <p:pic>
+        <p:nvPicPr>
+          <p:cNvPr id="10" name="그림 9">
+            <a:extLst>
+              <a:ext uri="{FF2B5EF4-FFF2-40B4-BE49-F238E27FC236}">
+                <a16:creationId xmlns:a16="http://schemas.microsoft.com/office/drawing/2014/main" id="{92735DA8-5C9C-348D-FD57-450DE0508F74}"/>
+              </a:ext>
+            </a:extLst>
+          </p:cNvPr>
+          <p:cNvPicPr>
+            <a:picLocks noChangeAspect="1"/>
+          </p:cNvPicPr>
+          <p:nvPr/>
+        </p:nvPicPr>
+        <p:blipFill>
+          <a:blip r:embed="rId5"/>
+          <a:stretch>
+            <a:fillRect/>
+          </a:stretch>
+        </p:blipFill>
+        <p:spPr>
+          <a:xfrm>
+            <a:off x="7905719" y="180933"/>
+            <a:ext cx="4286281" cy="5581691"/>
+          </a:xfrm>
+          <a:prstGeom prst="rect">
+            <a:avLst/>
+          </a:prstGeom>
+        </p:spPr>
+      </p:pic>
+      <p:pic>
+        <p:nvPicPr>
+          <p:cNvPr id="11" name="그림 10">
+            <a:extLst>
+              <a:ext uri="{FF2B5EF4-FFF2-40B4-BE49-F238E27FC236}">
+                <a16:creationId xmlns:a16="http://schemas.microsoft.com/office/drawing/2014/main" id="{190B6743-2176-3074-22CE-7C8BCB59873C}"/>
+              </a:ext>
+            </a:extLst>
+          </p:cNvPr>
+          <p:cNvPicPr>
+            <a:picLocks noChangeAspect="1"/>
+          </p:cNvPicPr>
+          <p:nvPr/>
+        </p:nvPicPr>
+        <p:blipFill>
+          <a:blip r:embed="rId2"/>
+          <a:srcRect b="45959"/>
+          <a:stretch>
+            <a:fillRect/>
+          </a:stretch>
+        </p:blipFill>
+        <p:spPr>
+          <a:xfrm>
+            <a:off x="207650" y="946318"/>
+            <a:ext cx="4333907" cy="3649503"/>
+          </a:xfrm>
+          <a:prstGeom prst="rect">
+            <a:avLst/>
+          </a:prstGeom>
+        </p:spPr>
+      </p:pic>
+      <p:pic>
+        <p:nvPicPr>
+          <p:cNvPr id="12" name="그림 11">
+            <a:extLst>
+              <a:ext uri="{FF2B5EF4-FFF2-40B4-BE49-F238E27FC236}">
+                <a16:creationId xmlns:a16="http://schemas.microsoft.com/office/drawing/2014/main" id="{8A1E3112-45E3-0CB1-E1B4-6F0256BAF1E3}"/>
+              </a:ext>
+            </a:extLst>
+          </p:cNvPr>
+          <p:cNvPicPr>
+            <a:picLocks noChangeAspect="1"/>
+          </p:cNvPicPr>
+          <p:nvPr/>
+        </p:nvPicPr>
+        <p:blipFill>
+          <a:blip r:embed="rId2"/>
+          <a:srcRect t="76233"/>
+          <a:stretch>
+            <a:fillRect/>
+          </a:stretch>
+        </p:blipFill>
+        <p:spPr>
+          <a:xfrm>
+            <a:off x="207650" y="6624832"/>
+            <a:ext cx="4333907" cy="1605032"/>
+          </a:xfrm>
+          <a:prstGeom prst="rect">
+            <a:avLst/>
+          </a:prstGeom>
+        </p:spPr>
+      </p:pic>
+      <p:pic>
+        <p:nvPicPr>
+          <p:cNvPr id="13" name="그림 12">
+            <a:extLst>
+              <a:ext uri="{FF2B5EF4-FFF2-40B4-BE49-F238E27FC236}">
+                <a16:creationId xmlns:a16="http://schemas.microsoft.com/office/drawing/2014/main" id="{1C9043BD-C001-5B13-4D1A-9C757CE0088D}"/>
+              </a:ext>
+            </a:extLst>
+          </p:cNvPr>
+          <p:cNvPicPr>
+            <a:picLocks noChangeAspect="1"/>
+          </p:cNvPicPr>
+          <p:nvPr/>
+        </p:nvPicPr>
+        <p:blipFill>
+          <a:blip r:embed="rId3"/>
+          <a:srcRect b="51379"/>
+          <a:stretch>
+            <a:fillRect/>
+          </a:stretch>
+        </p:blipFill>
+        <p:spPr>
+          <a:xfrm>
+            <a:off x="4541557" y="1095376"/>
+            <a:ext cx="4248181" cy="2991716"/>
+          </a:xfrm>
+          <a:prstGeom prst="rect">
+            <a:avLst/>
+          </a:prstGeom>
+        </p:spPr>
+      </p:pic>
+    </p:spTree>
+    <p:extLst>
+      <p:ext uri="{BB962C8B-B14F-4D97-AF65-F5344CB8AC3E}">
+        <p14:creationId xmlns:p14="http://schemas.microsoft.com/office/powerpoint/2010/main" val="1983847626"/>
+      </p:ext>
+    </p:extLst>
+  </p:cSld>
+  <p:clrMapOvr>
+    <a:masterClrMapping/>
+  </p:clrMapOvr>
+</p:sld>
+</file>
+
+<file path=ppt/slides/slide7.xml><?xml version="1.0" encoding="utf-8"?>
+<p:sld xmlns:a="http://schemas.openxmlformats.org/drawingml/2006/main" xmlns:r="http://schemas.openxmlformats.org/officeDocument/2006/relationships" xmlns:p="http://schemas.openxmlformats.org/presentationml/2006/main">
+  <p:cSld>
+    <p:spTree>
+      <p:nvGrpSpPr>
+        <p:cNvPr id="1" name=""/>
+        <p:cNvGrpSpPr/>
+        <p:nvPr/>
+      </p:nvGrpSpPr>
+      <p:grpSpPr>
+        <a:xfrm>
+          <a:off x="0" y="0"/>
+          <a:ext cx="0" cy="0"/>
+          <a:chOff x="0" y="0"/>
+          <a:chExt cx="0" cy="0"/>
+        </a:xfrm>
+      </p:grpSpPr>
+      <p:sp>
+        <p:nvSpPr>
+          <p:cNvPr id="2" name="제목 1">
+            <a:extLst>
+              <a:ext uri="{FF2B5EF4-FFF2-40B4-BE49-F238E27FC236}">
+                <a16:creationId xmlns:a16="http://schemas.microsoft.com/office/drawing/2014/main" id="{D5A1BA7F-CD92-ACF2-5B13-F456190790AC}"/>
+              </a:ext>
+            </a:extLst>
+          </p:cNvPr>
+          <p:cNvSpPr>
+            <a:spLocks noGrp="1"/>
+          </p:cNvSpPr>
+          <p:nvPr>
+            <p:ph type="title"/>
+          </p:nvPr>
+        </p:nvSpPr>
+        <p:spPr/>
+        <p:txBody>
+          <a:bodyPr/>
+          <a:lstStyle/>
+          <a:p>
+            <a:endParaRPr lang="ko-KR" altLang="en-US"/>
+          </a:p>
+        </p:txBody>
+      </p:sp>
+      <p:pic>
+        <p:nvPicPr>
+          <p:cNvPr id="4" name="그림 3">
+            <a:extLst>
+              <a:ext uri="{FF2B5EF4-FFF2-40B4-BE49-F238E27FC236}">
+                <a16:creationId xmlns:a16="http://schemas.microsoft.com/office/drawing/2014/main" id="{E8B297AB-20D8-0B14-8D8A-CAAF32A032DE}"/>
+              </a:ext>
+            </a:extLst>
+          </p:cNvPr>
+          <p:cNvPicPr>
+            <a:picLocks noChangeAspect="1"/>
+          </p:cNvPicPr>
+          <p:nvPr/>
+        </p:nvPicPr>
+        <p:blipFill>
+          <a:blip r:embed="rId2"/>
+          <a:stretch>
+            <a:fillRect/>
+          </a:stretch>
+        </p:blipFill>
+        <p:spPr>
+          <a:xfrm>
+            <a:off x="0" y="28163"/>
+            <a:ext cx="12192000" cy="6801674"/>
+          </a:xfrm>
+          <a:prstGeom prst="rect">
+            <a:avLst/>
+          </a:prstGeom>
+        </p:spPr>
+      </p:pic>
+      <p:sp>
+        <p:nvSpPr>
+          <p:cNvPr id="5" name="직사각형 4">
+            <a:extLst>
+              <a:ext uri="{FF2B5EF4-FFF2-40B4-BE49-F238E27FC236}">
+                <a16:creationId xmlns:a16="http://schemas.microsoft.com/office/drawing/2014/main" id="{87597391-AF5F-C774-31F8-B1E520AE5465}"/>
+              </a:ext>
+            </a:extLst>
+          </p:cNvPr>
+          <p:cNvSpPr/>
+          <p:nvPr/>
+        </p:nvSpPr>
+        <p:spPr>
+          <a:xfrm>
+            <a:off x="10655687" y="147241"/>
+            <a:ext cx="1159847" cy="297260"/>
+          </a:xfrm>
+          <a:prstGeom prst="rect">
+            <a:avLst/>
+          </a:prstGeom>
+          <a:solidFill>
+            <a:srgbClr val="F2F2F2"/>
+          </a:solidFill>
+          <a:ln>
+            <a:noFill/>
+          </a:ln>
+        </p:spPr>
+        <p:style>
+          <a:lnRef idx="2">
+            <a:schemeClr val="accent1">
+              <a:shade val="50000"/>
+            </a:schemeClr>
+          </a:lnRef>
+          <a:fillRef idx="1">
+            <a:schemeClr val="accent1"/>
+          </a:fillRef>
+          <a:effectRef idx="0">
+            <a:schemeClr val="accent1"/>
+          </a:effectRef>
+          <a:fontRef idx="minor">
+            <a:schemeClr val="lt1"/>
+          </a:fontRef>
+        </p:style>
+        <p:txBody>
+          <a:bodyPr rtlCol="0" anchor="ctr"/>
+          <a:lstStyle/>
+          <a:p>
+            <a:pPr marL="0" marR="0" lvl="0" indent="0" algn="ctr" defTabSz="914400" rtl="0" eaLnBrk="1" fontAlgn="auto" latinLnBrk="1" hangingPunct="1">
+              <a:lnSpc>
+                <a:spcPct val="100000"/>
+              </a:lnSpc>
+              <a:spcBef>
+                <a:spcPts val="0"/>
+              </a:spcBef>
+              <a:spcAft>
+                <a:spcPts val="0"/>
+              </a:spcAft>
+              <a:buClrTx/>
+              <a:buSzTx/>
+              <a:buFontTx/>
+              <a:buNone/>
+              <a:tabLst/>
+              <a:defRPr/>
+            </a:pPr>
+            <a:endParaRPr kumimoji="0" lang="ko-KR" altLang="en-US" sz="1800" b="0" i="0" u="none" strike="noStrike" kern="1200" cap="none" spc="0" normalizeH="0" baseline="0" noProof="0">
+              <a:ln>
+                <a:noFill/>
+              </a:ln>
+              <a:solidFill>
+                <a:prstClr val="white"/>
+              </a:solidFill>
+              <a:effectLst/>
+              <a:uLnTx/>
+              <a:uFillTx/>
+              <a:latin typeface="Montserrat" pitchFamily="2" charset="0"/>
+              <a:ea typeface="맑은 고딕" panose="020B0503020000020004" pitchFamily="50" charset="-127"/>
+              <a:cs typeface="+mn-cs"/>
+            </a:endParaRPr>
+          </a:p>
+        </p:txBody>
+      </p:sp>
+    </p:spTree>
+    <p:extLst>
+      <p:ext uri="{BB962C8B-B14F-4D97-AF65-F5344CB8AC3E}">
+        <p14:creationId xmlns:p14="http://schemas.microsoft.com/office/powerpoint/2010/main" val="333529903"/>
+      </p:ext>
+    </p:extLst>
+  </p:cSld>
+  <p:clrMapOvr>
+    <a:masterClrMapping/>
+  </p:clrMapOvr>
+</p:sld>
+</file>
+
+<file path=ppt/slides/slide8.xml><?xml version="1.0" encoding="utf-8"?>
+<p:sld xmlns:a="http://schemas.openxmlformats.org/drawingml/2006/main" xmlns:r="http://schemas.openxmlformats.org/officeDocument/2006/relationships" xmlns:p="http://schemas.openxmlformats.org/presentationml/2006/main">
+  <p:cSld>
+    <p:spTree>
+      <p:nvGrpSpPr>
+        <p:cNvPr id="1" name=""/>
+        <p:cNvGrpSpPr/>
+        <p:nvPr/>
+      </p:nvGrpSpPr>
+      <p:grpSpPr>
+        <a:xfrm>
+          <a:off x="0" y="0"/>
+          <a:ext cx="0" cy="0"/>
+          <a:chOff x="0" y="0"/>
+          <a:chExt cx="0" cy="0"/>
+        </a:xfrm>
+      </p:grpSpPr>
+      <p:sp>
+        <p:nvSpPr>
+          <p:cNvPr id="2" name="제목 1">
+            <a:extLst>
+              <a:ext uri="{FF2B5EF4-FFF2-40B4-BE49-F238E27FC236}">
+                <a16:creationId xmlns:a16="http://schemas.microsoft.com/office/drawing/2014/main" id="{C806619F-2430-DB69-E007-F8C44168B1F1}"/>
+              </a:ext>
+            </a:extLst>
+          </p:cNvPr>
+          <p:cNvSpPr>
+            <a:spLocks noGrp="1"/>
+          </p:cNvSpPr>
+          <p:nvPr>
+            <p:ph type="title"/>
+          </p:nvPr>
+        </p:nvSpPr>
+        <p:spPr/>
+        <p:txBody>
+          <a:bodyPr/>
+          <a:lstStyle/>
+          <a:p>
+            <a:endParaRPr lang="ko-KR" altLang="en-US"/>
+          </a:p>
+        </p:txBody>
+      </p:sp>
+      <p:pic>
+        <p:nvPicPr>
+          <p:cNvPr id="6" name="그림 5">
+            <a:extLst>
+              <a:ext uri="{FF2B5EF4-FFF2-40B4-BE49-F238E27FC236}">
+                <a16:creationId xmlns:a16="http://schemas.microsoft.com/office/drawing/2014/main" id="{48EF2E57-901F-B412-D2ED-829178775CF8}"/>
+              </a:ext>
+            </a:extLst>
+          </p:cNvPr>
+          <p:cNvPicPr>
+            <a:picLocks noChangeAspect="1"/>
+          </p:cNvPicPr>
+          <p:nvPr/>
+        </p:nvPicPr>
+        <p:blipFill>
+          <a:blip r:embed="rId2"/>
+          <a:stretch>
+            <a:fillRect/>
+          </a:stretch>
+        </p:blipFill>
+        <p:spPr>
+          <a:xfrm>
+            <a:off x="0" y="55194"/>
+            <a:ext cx="12192000" cy="6747612"/>
+          </a:xfrm>
+          <a:prstGeom prst="rect">
+            <a:avLst/>
+          </a:prstGeom>
+        </p:spPr>
+      </p:pic>
+      <p:sp>
+        <p:nvSpPr>
+          <p:cNvPr id="7" name="직사각형 6">
+            <a:extLst>
+              <a:ext uri="{FF2B5EF4-FFF2-40B4-BE49-F238E27FC236}">
+                <a16:creationId xmlns:a16="http://schemas.microsoft.com/office/drawing/2014/main" id="{14B85EC4-8F40-3159-DBE0-117F5C1C36A2}"/>
+              </a:ext>
+            </a:extLst>
+          </p:cNvPr>
+          <p:cNvSpPr/>
+          <p:nvPr/>
+        </p:nvSpPr>
+        <p:spPr>
+          <a:xfrm>
+            <a:off x="10655687" y="147241"/>
+            <a:ext cx="1159847" cy="297260"/>
+          </a:xfrm>
+          <a:prstGeom prst="rect">
+            <a:avLst/>
+          </a:prstGeom>
+          <a:solidFill>
+            <a:srgbClr val="F2F2F2"/>
+          </a:solidFill>
+          <a:ln>
+            <a:noFill/>
+          </a:ln>
+        </p:spPr>
+        <p:style>
+          <a:lnRef idx="2">
+            <a:schemeClr val="accent1">
+              <a:shade val="50000"/>
+            </a:schemeClr>
+          </a:lnRef>
+          <a:fillRef idx="1">
+            <a:schemeClr val="accent1"/>
+          </a:fillRef>
+          <a:effectRef idx="0">
+            <a:schemeClr val="accent1"/>
+          </a:effectRef>
+          <a:fontRef idx="minor">
+            <a:schemeClr val="lt1"/>
+          </a:fontRef>
+        </p:style>
+        <p:txBody>
+          <a:bodyPr rtlCol="0" anchor="ctr"/>
+          <a:lstStyle/>
+          <a:p>
+            <a:pPr marL="0" marR="0" lvl="0" indent="0" algn="ctr" defTabSz="914400" rtl="0" eaLnBrk="1" fontAlgn="auto" latinLnBrk="1" hangingPunct="1">
+              <a:lnSpc>
+                <a:spcPct val="100000"/>
+              </a:lnSpc>
+              <a:spcBef>
+                <a:spcPts val="0"/>
+              </a:spcBef>
+              <a:spcAft>
+                <a:spcPts val="0"/>
+              </a:spcAft>
+              <a:buClrTx/>
+              <a:buSzTx/>
+              <a:buFontTx/>
+              <a:buNone/>
+              <a:tabLst/>
+              <a:defRPr/>
+            </a:pPr>
+            <a:endParaRPr kumimoji="0" lang="ko-KR" altLang="en-US" sz="1800" b="0" i="0" u="none" strike="noStrike" kern="1200" cap="none" spc="0" normalizeH="0" baseline="0" noProof="0">
+              <a:ln>
+                <a:noFill/>
+              </a:ln>
+              <a:solidFill>
+                <a:prstClr val="white"/>
+              </a:solidFill>
+              <a:effectLst/>
+              <a:uLnTx/>
+              <a:uFillTx/>
+              <a:latin typeface="Montserrat" pitchFamily="2" charset="0"/>
+              <a:ea typeface="맑은 고딕" panose="020B0503020000020004" pitchFamily="50" charset="-127"/>
+              <a:cs typeface="+mn-cs"/>
+            </a:endParaRPr>
+          </a:p>
+        </p:txBody>
+      </p:sp>
+    </p:spTree>
+    <p:extLst>
+      <p:ext uri="{BB962C8B-B14F-4D97-AF65-F5344CB8AC3E}">
+        <p14:creationId xmlns:p14="http://schemas.microsoft.com/office/powerpoint/2010/main" val="1109579226"/>
+      </p:ext>
+    </p:extLst>
+  </p:cSld>
+  <p:clrMapOvr>
+    <a:masterClrMapping/>
+  </p:clrMapOvr>
+</p:sld>
+</file>
+
+<file path=ppt/slides/slide9.xml><?xml version="1.0" encoding="utf-8"?>
+<p:sld xmlns:a="http://schemas.openxmlformats.org/drawingml/2006/main" xmlns:r="http://schemas.openxmlformats.org/officeDocument/2006/relationships" xmlns:p="http://schemas.openxmlformats.org/presentationml/2006/main">
+  <p:cSld>
+    <p:spTree>
+      <p:nvGrpSpPr>
+        <p:cNvPr id="1" name=""/>
+        <p:cNvGrpSpPr/>
+        <p:nvPr/>
+      </p:nvGrpSpPr>
+      <p:grpSpPr>
+        <a:xfrm>
+          <a:off x="0" y="0"/>
+          <a:ext cx="0" cy="0"/>
+          <a:chOff x="0" y="0"/>
+          <a:chExt cx="0" cy="0"/>
+        </a:xfrm>
+      </p:grpSpPr>
+      <p:sp>
+        <p:nvSpPr>
+          <p:cNvPr id="2" name="제목 1">
+            <a:extLst>
+              <a:ext uri="{FF2B5EF4-FFF2-40B4-BE49-F238E27FC236}">
+                <a16:creationId xmlns:a16="http://schemas.microsoft.com/office/drawing/2014/main" id="{20F68881-C95D-985B-7896-422ED4C2EE47}"/>
+              </a:ext>
+            </a:extLst>
+          </p:cNvPr>
+          <p:cNvSpPr>
+            <a:spLocks noGrp="1"/>
+          </p:cNvSpPr>
+          <p:nvPr>
+            <p:ph type="title"/>
+          </p:nvPr>
+        </p:nvSpPr>
+        <p:spPr/>
+        <p:txBody>
+          <a:bodyPr/>
+          <a:lstStyle/>
+          <a:p>
+            <a:endParaRPr lang="ko-KR" altLang="en-US"/>
+          </a:p>
+        </p:txBody>
+      </p:sp>
+    </p:spTree>
+    <p:extLst>
+      <p:ext uri="{BB962C8B-B14F-4D97-AF65-F5344CB8AC3E}">
+        <p14:creationId xmlns:p14="http://schemas.microsoft.com/office/powerpoint/2010/main" val="4061806259"/>
       </p:ext>
     </p:extLst>
   </p:cSld>

</xml_diff>

<commit_message>
vault backup: 2026-07-03 21:37:42
</commit_message>
<xml_diff>
--- a/assets/06-dataspace/image.pptx
+++ b/assets/06-dataspace/image.pptx
@@ -130,7 +130,7 @@
 <file path=ppt/revisionInfo.xml><?xml version="1.0" encoding="utf-8"?>
 <p1510:revInfo xmlns:a="http://schemas.openxmlformats.org/drawingml/2006/main" xmlns:r="http://schemas.openxmlformats.org/officeDocument/2006/relationships" xmlns:p1510="http://schemas.microsoft.com/office/powerpoint/2015/10/main">
   <p1510:revLst>
-    <p1510:client id="{77AFA03C-ADB3-48E7-9DEE-EC77C33AF38A}" v="10" dt="2026-07-03T12:36:22.062"/>
+    <p1510:client id="{77AFA03C-ADB3-48E7-9DEE-EC77C33AF38A}" v="11" dt="2026-07-03T12:37:39.492"/>
   </p1510:revLst>
 </p1510:revInfo>
 </file>
@@ -140,7 +140,7 @@
   <pc:docChgLst>
     <pc:chgData name="헌정 임" userId="eb9ca9bd79f0560f" providerId="LiveId" clId="{A6339E56-8272-42D6-9D95-12E1A8284411}"/>
     <pc:docChg chg="undo custSel addSld delSld modSld">
-      <pc:chgData name="헌정 임" userId="eb9ca9bd79f0560f" providerId="LiveId" clId="{A6339E56-8272-42D6-9D95-12E1A8284411}" dt="2026-07-03T12:37:16.613" v="104" actId="693"/>
+      <pc:chgData name="헌정 임" userId="eb9ca9bd79f0560f" providerId="LiveId" clId="{A6339E56-8272-42D6-9D95-12E1A8284411}" dt="2026-07-03T12:37:39.486" v="109" actId="571"/>
       <pc:docMkLst>
         <pc:docMk/>
       </pc:docMkLst>
@@ -571,7 +571,7 @@
         </pc:picChg>
       </pc:sldChg>
       <pc:sldChg chg="addSp delSp modSp new mod">
-        <pc:chgData name="헌정 임" userId="eb9ca9bd79f0560f" providerId="LiveId" clId="{A6339E56-8272-42D6-9D95-12E1A8284411}" dt="2026-07-03T12:37:16.613" v="104" actId="693"/>
+        <pc:chgData name="헌정 임" userId="eb9ca9bd79f0560f" providerId="LiveId" clId="{A6339E56-8272-42D6-9D95-12E1A8284411}" dt="2026-07-03T12:37:39.486" v="109" actId="571"/>
         <pc:sldMkLst>
           <pc:docMk/>
           <pc:sldMk cId="2676242124" sldId="390"/>
@@ -593,15 +593,23 @@
           </ac:spMkLst>
         </pc:spChg>
         <pc:spChg chg="add mod">
-          <ac:chgData name="헌정 임" userId="eb9ca9bd79f0560f" providerId="LiveId" clId="{A6339E56-8272-42D6-9D95-12E1A8284411}" dt="2026-07-03T12:37:16.613" v="104" actId="693"/>
+          <ac:chgData name="헌정 임" userId="eb9ca9bd79f0560f" providerId="LiveId" clId="{A6339E56-8272-42D6-9D95-12E1A8284411}" dt="2026-07-03T12:37:35.687" v="108" actId="14100"/>
           <ac:spMkLst>
             <pc:docMk/>
             <pc:sldMk cId="2676242124" sldId="390"/>
             <ac:spMk id="6" creationId="{9B7B9073-8606-D0C1-8750-0AE40BAD927A}"/>
           </ac:spMkLst>
         </pc:spChg>
-        <pc:picChg chg="add mod">
-          <ac:chgData name="헌정 임" userId="eb9ca9bd79f0560f" providerId="LiveId" clId="{A6339E56-8272-42D6-9D95-12E1A8284411}" dt="2026-07-03T12:36:52.928" v="102" actId="208"/>
+        <pc:spChg chg="add mod">
+          <ac:chgData name="헌정 임" userId="eb9ca9bd79f0560f" providerId="LiveId" clId="{A6339E56-8272-42D6-9D95-12E1A8284411}" dt="2026-07-03T12:37:39.486" v="109" actId="571"/>
+          <ac:spMkLst>
+            <pc:docMk/>
+            <pc:sldMk cId="2676242124" sldId="390"/>
+            <ac:spMk id="7" creationId="{9201944A-EB55-153D-FDE1-69F50483C688}"/>
+          </ac:spMkLst>
+        </pc:spChg>
+        <pc:picChg chg="add mod ord">
+          <ac:chgData name="헌정 임" userId="eb9ca9bd79f0560f" providerId="LiveId" clId="{A6339E56-8272-42D6-9D95-12E1A8284411}" dt="2026-07-03T12:37:28.655" v="106" actId="167"/>
           <ac:picMkLst>
             <pc:docMk/>
             <pc:sldMk cId="2676242124" sldId="390"/>
@@ -3888,7 +3896,7 @@
         </p:blipFill>
         <p:spPr>
           <a:xfrm>
-            <a:off x="1166776" y="438128"/>
+            <a:off x="1166776" y="298428"/>
             <a:ext cx="9858447" cy="5981744"/>
           </a:xfrm>
           <a:prstGeom prst="rect">
@@ -3915,8 +3923,61 @@
         </p:nvSpPr>
         <p:spPr>
           <a:xfrm>
-            <a:off x="6045200" y="3689350"/>
-            <a:ext cx="2641600" cy="774700"/>
+            <a:off x="3073400" y="4527550"/>
+            <a:ext cx="2641600" cy="323850"/>
+          </a:xfrm>
+          <a:prstGeom prst="rect">
+            <a:avLst/>
+          </a:prstGeom>
+          <a:noFill/>
+          <a:ln>
+            <a:solidFill>
+              <a:srgbClr val="FFFF00"/>
+            </a:solidFill>
+            <a:prstDash val="sysDash"/>
+          </a:ln>
+        </p:spPr>
+        <p:style>
+          <a:lnRef idx="2">
+            <a:schemeClr val="accent1">
+              <a:shade val="15000"/>
+            </a:schemeClr>
+          </a:lnRef>
+          <a:fillRef idx="1">
+            <a:schemeClr val="accent1"/>
+          </a:fillRef>
+          <a:effectRef idx="0">
+            <a:schemeClr val="accent1"/>
+          </a:effectRef>
+          <a:fontRef idx="minor">
+            <a:schemeClr val="lt1"/>
+          </a:fontRef>
+        </p:style>
+        <p:txBody>
+          <a:bodyPr rtlCol="0" anchor="ctr"/>
+          <a:lstStyle/>
+          <a:p>
+            <a:pPr algn="ctr"/>
+            <a:endParaRPr lang="ko-KR" altLang="en-US" dirty="0"/>
+          </a:p>
+        </p:txBody>
+      </p:sp>
+      <p:sp>
+        <p:nvSpPr>
+          <p:cNvPr id="7" name="직사각형 6">
+            <a:extLst>
+              <a:ext uri="{FF2B5EF4-FFF2-40B4-BE49-F238E27FC236}">
+                <a16:creationId xmlns:a16="http://schemas.microsoft.com/office/drawing/2014/main" id="{9201944A-EB55-153D-FDE1-69F50483C688}"/>
+              </a:ext>
+            </a:extLst>
+          </p:cNvPr>
+          <p:cNvSpPr/>
+          <p:nvPr/>
+        </p:nvSpPr>
+        <p:spPr>
+          <a:xfrm>
+            <a:off x="4394200" y="5403861"/>
+            <a:ext cx="2641600" cy="323850"/>
           </a:xfrm>
           <a:prstGeom prst="rect">
             <a:avLst/>

</xml_diff>

<commit_message>
vault backup: 2026-07-03 21:47:35
</commit_message>
<xml_diff>
--- a/assets/06-dataspace/image.pptx
+++ b/assets/06-dataspace/image.pptx
@@ -7,20 +7,23 @@
   <p:sldIdLst>
     <p:sldId id="390" r:id="rId2"/>
     <p:sldId id="391" r:id="rId3"/>
-    <p:sldId id="261" r:id="rId4"/>
-    <p:sldId id="389" r:id="rId5"/>
-    <p:sldId id="384" r:id="rId6"/>
-    <p:sldId id="385" r:id="rId7"/>
-    <p:sldId id="387" r:id="rId8"/>
-    <p:sldId id="388" r:id="rId9"/>
-    <p:sldId id="392" r:id="rId10"/>
-    <p:sldId id="393" r:id="rId11"/>
-    <p:sldId id="256" r:id="rId12"/>
-    <p:sldId id="257" r:id="rId13"/>
-    <p:sldId id="259" r:id="rId14"/>
-    <p:sldId id="258" r:id="rId15"/>
-    <p:sldId id="260" r:id="rId16"/>
-    <p:sldId id="380" r:id="rId17"/>
+    <p:sldId id="394" r:id="rId4"/>
+    <p:sldId id="261" r:id="rId5"/>
+    <p:sldId id="389" r:id="rId6"/>
+    <p:sldId id="384" r:id="rId7"/>
+    <p:sldId id="385" r:id="rId8"/>
+    <p:sldId id="395" r:id="rId9"/>
+    <p:sldId id="396" r:id="rId10"/>
+    <p:sldId id="387" r:id="rId11"/>
+    <p:sldId id="388" r:id="rId12"/>
+    <p:sldId id="392" r:id="rId13"/>
+    <p:sldId id="393" r:id="rId14"/>
+    <p:sldId id="256" r:id="rId15"/>
+    <p:sldId id="257" r:id="rId16"/>
+    <p:sldId id="259" r:id="rId17"/>
+    <p:sldId id="258" r:id="rId18"/>
+    <p:sldId id="260" r:id="rId19"/>
+    <p:sldId id="380" r:id="rId20"/>
   </p:sldIdLst>
   <p:sldSz cx="12192000" cy="6858000"/>
   <p:notesSz cx="6858000" cy="9144000"/>
@@ -130,7 +133,7 @@
 <file path=ppt/revisionInfo.xml><?xml version="1.0" encoding="utf-8"?>
 <p1510:revInfo xmlns:a="http://schemas.openxmlformats.org/drawingml/2006/main" xmlns:r="http://schemas.openxmlformats.org/officeDocument/2006/relationships" xmlns:p1510="http://schemas.microsoft.com/office/powerpoint/2015/10/main">
   <p1510:revLst>
-    <p1510:client id="{77AFA03C-ADB3-48E7-9DEE-EC77C33AF38A}" v="11" dt="2026-07-03T12:37:39.492"/>
+    <p1510:client id="{77AFA03C-ADB3-48E7-9DEE-EC77C33AF38A}" v="84" dt="2026-07-03T12:47:18.216"/>
   </p1510:revLst>
 </p1510:revInfo>
 </file>
@@ -140,7 +143,7 @@
   <pc:docChgLst>
     <pc:chgData name="헌정 임" userId="eb9ca9bd79f0560f" providerId="LiveId" clId="{A6339E56-8272-42D6-9D95-12E1A8284411}"/>
     <pc:docChg chg="undo custSel addSld delSld modSld">
-      <pc:chgData name="헌정 임" userId="eb9ca9bd79f0560f" providerId="LiveId" clId="{A6339E56-8272-42D6-9D95-12E1A8284411}" dt="2026-07-03T12:37:39.486" v="109" actId="571"/>
+      <pc:chgData name="헌정 임" userId="eb9ca9bd79f0560f" providerId="LiveId" clId="{A6339E56-8272-42D6-9D95-12E1A8284411}" dt="2026-07-03T12:47:18.216" v="896"/>
       <pc:docMkLst>
         <pc:docMk/>
       </pc:docMkLst>
@@ -376,12 +379,28 @@
           <pc:sldMk cId="1773760154" sldId="383"/>
         </pc:sldMkLst>
       </pc:sldChg>
-      <pc:sldChg chg="addSp modSp new mod">
-        <pc:chgData name="헌정 임" userId="eb9ca9bd79f0560f" providerId="LiveId" clId="{A6339E56-8272-42D6-9D95-12E1A8284411}" dt="2026-07-03T12:15:52.502" v="73" actId="732"/>
+      <pc:sldChg chg="addSp delSp modSp new mod">
+        <pc:chgData name="헌정 임" userId="eb9ca9bd79f0560f" providerId="LiveId" clId="{A6339E56-8272-42D6-9D95-12E1A8284411}" dt="2026-07-03T12:45:32.954" v="783" actId="21"/>
         <pc:sldMkLst>
           <pc:docMk/>
           <pc:sldMk cId="2716414540" sldId="384"/>
         </pc:sldMkLst>
+        <pc:spChg chg="add del mod">
+          <ac:chgData name="헌정 임" userId="eb9ca9bd79f0560f" providerId="LiveId" clId="{A6339E56-8272-42D6-9D95-12E1A8284411}" dt="2026-07-03T12:45:28.623" v="782" actId="478"/>
+          <ac:spMkLst>
+            <pc:docMk/>
+            <pc:sldMk cId="2716414540" sldId="384"/>
+            <ac:spMk id="5" creationId="{93660AE3-B082-3249-8639-640915DF9573}"/>
+          </ac:spMkLst>
+        </pc:spChg>
+        <pc:spChg chg="add del mod">
+          <ac:chgData name="헌정 임" userId="eb9ca9bd79f0560f" providerId="LiveId" clId="{A6339E56-8272-42D6-9D95-12E1A8284411}" dt="2026-07-03T12:45:32.954" v="783" actId="21"/>
+          <ac:spMkLst>
+            <pc:docMk/>
+            <pc:sldMk cId="2716414540" sldId="384"/>
+            <ac:spMk id="6" creationId="{AFECB066-6B82-9680-532F-47556D50ECA3}"/>
+          </ac:spMkLst>
+        </pc:spChg>
         <pc:picChg chg="add mod modCrop">
           <ac:chgData name="헌정 임" userId="eb9ca9bd79f0560f" providerId="LiveId" clId="{A6339E56-8272-42D6-9D95-12E1A8284411}" dt="2026-07-03T12:15:52.502" v="73" actId="732"/>
           <ac:picMkLst>
@@ -392,37 +411,61 @@
         </pc:picChg>
       </pc:sldChg>
       <pc:sldChg chg="addSp delSp modSp new mod">
-        <pc:chgData name="헌정 임" userId="eb9ca9bd79f0560f" providerId="LiveId" clId="{A6339E56-8272-42D6-9D95-12E1A8284411}" dt="2026-07-03T12:05:19.726" v="55" actId="21"/>
+        <pc:chgData name="헌정 임" userId="eb9ca9bd79f0560f" providerId="LiveId" clId="{A6339E56-8272-42D6-9D95-12E1A8284411}" dt="2026-07-03T12:45:50.985" v="788" actId="20577"/>
         <pc:sldMkLst>
           <pc:docMk/>
           <pc:sldMk cId="1983847626" sldId="385"/>
         </pc:sldMkLst>
+        <pc:spChg chg="add mod">
+          <ac:chgData name="헌정 임" userId="eb9ca9bd79f0560f" providerId="LiveId" clId="{A6339E56-8272-42D6-9D95-12E1A8284411}" dt="2026-07-03T12:45:01.808" v="781" actId="1076"/>
+          <ac:spMkLst>
+            <pc:docMk/>
+            <pc:sldMk cId="1983847626" sldId="385"/>
+            <ac:spMk id="14" creationId="{98207C3C-D8DE-0B0B-7F9C-F476F538AE47}"/>
+          </ac:spMkLst>
+        </pc:spChg>
+        <pc:spChg chg="add mod">
+          <ac:chgData name="헌정 임" userId="eb9ca9bd79f0560f" providerId="LiveId" clId="{A6339E56-8272-42D6-9D95-12E1A8284411}" dt="2026-07-03T12:45:37.609" v="785" actId="1076"/>
+          <ac:spMkLst>
+            <pc:docMk/>
+            <pc:sldMk cId="1983847626" sldId="385"/>
+            <ac:spMk id="15" creationId="{AFECB066-6B82-9680-532F-47556D50ECA3}"/>
+          </ac:spMkLst>
+        </pc:spChg>
+        <pc:spChg chg="add mod">
+          <ac:chgData name="헌정 임" userId="eb9ca9bd79f0560f" providerId="LiveId" clId="{A6339E56-8272-42D6-9D95-12E1A8284411}" dt="2026-07-03T12:45:50.985" v="788" actId="20577"/>
+          <ac:spMkLst>
+            <pc:docMk/>
+            <pc:sldMk cId="1983847626" sldId="385"/>
+            <ac:spMk id="16" creationId="{9B6F4B20-A4A0-A12D-B811-C2B2E05E12EC}"/>
+          </ac:spMkLst>
+        </pc:spChg>
         <pc:picChg chg="add mod modCrop">
-          <ac:chgData name="헌정 임" userId="eb9ca9bd79f0560f" providerId="LiveId" clId="{A6339E56-8272-42D6-9D95-12E1A8284411}" dt="2026-07-03T11:57:29.577" v="38" actId="1076"/>
+          <ac:chgData name="헌정 임" userId="eb9ca9bd79f0560f" providerId="LiveId" clId="{A6339E56-8272-42D6-9D95-12E1A8284411}" dt="2026-07-03T12:43:54.723" v="669" actId="1076"/>
           <ac:picMkLst>
             <pc:docMk/>
             <pc:sldMk cId="1983847626" sldId="385"/>
             <ac:picMk id="4" creationId="{D46C9835-FBA8-76FF-19E1-17A22C19FE4D}"/>
           </ac:picMkLst>
         </pc:picChg>
-        <pc:picChg chg="add mod modCrop">
-          <ac:chgData name="헌정 임" userId="eb9ca9bd79f0560f" providerId="LiveId" clId="{A6339E56-8272-42D6-9D95-12E1A8284411}" dt="2026-07-03T11:57:58.895" v="45" actId="1076"/>
+        <pc:picChg chg="add del mod modCrop">
+          <ac:chgData name="헌정 임" userId="eb9ca9bd79f0560f" providerId="LiveId" clId="{A6339E56-8272-42D6-9D95-12E1A8284411}" dt="2026-07-03T12:43:33.894" v="657" actId="478"/>
           <ac:picMkLst>
             <pc:docMk/>
             <pc:sldMk cId="1983847626" sldId="385"/>
             <ac:picMk id="6" creationId="{FC127FFB-6F9B-41DE-A499-C39EB3281D17}"/>
           </ac:picMkLst>
         </pc:picChg>
-        <pc:picChg chg="add mod">
-          <ac:chgData name="헌정 임" userId="eb9ca9bd79f0560f" providerId="LiveId" clId="{A6339E56-8272-42D6-9D95-12E1A8284411}" dt="2026-07-03T11:57:57.423" v="44" actId="1076"/>
+        <pc:picChg chg="add del mod">
+          <ac:chgData name="헌정 임" userId="eb9ca9bd79f0560f" providerId="LiveId" clId="{A6339E56-8272-42D6-9D95-12E1A8284411}" dt="2026-07-03T12:43:34.539" v="658" actId="478"/>
           <ac:picMkLst>
             <pc:docMk/>
             <pc:sldMk cId="1983847626" sldId="385"/>
             <ac:picMk id="8" creationId="{5FE4F172-8AD1-5C42-0140-DA4A2BE3DD96}"/>
           </ac:picMkLst>
         </pc:picChg>
-        <pc:picChg chg="add mod">
-          <ac:chgData name="헌정 임" userId="eb9ca9bd79f0560f" providerId="LiveId" clId="{A6339E56-8272-42D6-9D95-12E1A8284411}" dt="2026-07-03T11:58:00.547" v="46" actId="1076"/>
+        <pc:picChg chg="add del mod">
+          <ac:chgData name="헌정 임" userId="eb9ca9bd79f0560f" providerId="LiveId" clId="{A6339E56-8272-42D6-9D95-12E1A8284411}" dt="2026-07-03T12:43:32.547" v="655" actId="478"/>
           <ac:picMkLst>
             <pc:docMk/>
             <pc:sldMk cId="1983847626" sldId="385"/>
@@ -438,15 +481,15 @@
           </ac:picMkLst>
         </pc:picChg>
         <pc:picChg chg="add del mod modCrop">
-          <ac:chgData name="헌정 임" userId="eb9ca9bd79f0560f" providerId="LiveId" clId="{A6339E56-8272-42D6-9D95-12E1A8284411}" dt="2026-07-03T12:05:19.726" v="55" actId="21"/>
+          <ac:chgData name="헌정 임" userId="eb9ca9bd79f0560f" providerId="LiveId" clId="{A6339E56-8272-42D6-9D95-12E1A8284411}" dt="2026-07-03T12:43:57.231" v="670" actId="1076"/>
           <ac:picMkLst>
             <pc:docMk/>
             <pc:sldMk cId="1983847626" sldId="385"/>
             <ac:picMk id="12" creationId="{8A1E3112-45E3-0CB1-E1B4-6F0256BAF1E3}"/>
           </ac:picMkLst>
         </pc:picChg>
-        <pc:picChg chg="add mod modCrop">
-          <ac:chgData name="헌정 임" userId="eb9ca9bd79f0560f" providerId="LiveId" clId="{A6339E56-8272-42D6-9D95-12E1A8284411}" dt="2026-07-03T11:57:44.864" v="41" actId="732"/>
+        <pc:picChg chg="add del mod modCrop">
+          <ac:chgData name="헌정 임" userId="eb9ca9bd79f0560f" providerId="LiveId" clId="{A6339E56-8272-42D6-9D95-12E1A8284411}" dt="2026-07-03T12:43:33.456" v="656" actId="478"/>
           <ac:picMkLst>
             <pc:docMk/>
             <pc:sldMk cId="1983847626" sldId="385"/>
@@ -571,7 +614,7 @@
         </pc:picChg>
       </pc:sldChg>
       <pc:sldChg chg="addSp delSp modSp new mod">
-        <pc:chgData name="헌정 임" userId="eb9ca9bd79f0560f" providerId="LiveId" clId="{A6339E56-8272-42D6-9D95-12E1A8284411}" dt="2026-07-03T12:37:39.486" v="109" actId="571"/>
+        <pc:chgData name="헌정 임" userId="eb9ca9bd79f0560f" providerId="LiveId" clId="{A6339E56-8272-42D6-9D95-12E1A8284411}" dt="2026-07-03T12:41:42.894" v="431" actId="1076"/>
         <pc:sldMkLst>
           <pc:docMk/>
           <pc:sldMk cId="2676242124" sldId="390"/>
@@ -601,30 +644,62 @@
           </ac:spMkLst>
         </pc:spChg>
         <pc:spChg chg="add mod">
-          <ac:chgData name="헌정 임" userId="eb9ca9bd79f0560f" providerId="LiveId" clId="{A6339E56-8272-42D6-9D95-12E1A8284411}" dt="2026-07-03T12:37:39.486" v="109" actId="571"/>
+          <ac:chgData name="헌정 임" userId="eb9ca9bd79f0560f" providerId="LiveId" clId="{A6339E56-8272-42D6-9D95-12E1A8284411}" dt="2026-07-03T12:38:39.820" v="172" actId="14100"/>
           <ac:spMkLst>
             <pc:docMk/>
             <pc:sldMk cId="2676242124" sldId="390"/>
             <ac:spMk id="7" creationId="{9201944A-EB55-153D-FDE1-69F50483C688}"/>
           </ac:spMkLst>
         </pc:spChg>
+        <pc:spChg chg="add mod">
+          <ac:chgData name="헌정 임" userId="eb9ca9bd79f0560f" providerId="LiveId" clId="{A6339E56-8272-42D6-9D95-12E1A8284411}" dt="2026-07-03T12:38:34.601" v="171" actId="1076"/>
+          <ac:spMkLst>
+            <pc:docMk/>
+            <pc:sldMk cId="2676242124" sldId="390"/>
+            <ac:spMk id="11" creationId="{4249A169-15EF-2110-4375-3EB6008B6866}"/>
+          </ac:spMkLst>
+        </pc:spChg>
+        <pc:spChg chg="add mod">
+          <ac:chgData name="헌정 임" userId="eb9ca9bd79f0560f" providerId="LiveId" clId="{A6339E56-8272-42D6-9D95-12E1A8284411}" dt="2026-07-03T12:38:50.153" v="173" actId="571"/>
+          <ac:spMkLst>
+            <pc:docMk/>
+            <pc:sldMk cId="2676242124" sldId="390"/>
+            <ac:spMk id="14" creationId="{5DF8D435-254C-F3B1-32A8-6D5E176BE51E}"/>
+          </ac:spMkLst>
+        </pc:spChg>
+        <pc:spChg chg="add mod">
+          <ac:chgData name="헌정 임" userId="eb9ca9bd79f0560f" providerId="LiveId" clId="{A6339E56-8272-42D6-9D95-12E1A8284411}" dt="2026-07-03T12:39:22.166" v="296" actId="14100"/>
+          <ac:spMkLst>
+            <pc:docMk/>
+            <pc:sldMk cId="2676242124" sldId="390"/>
+            <ac:spMk id="15" creationId="{6AD0FD0E-D4CB-76D6-559B-263C57FDEE31}"/>
+          </ac:spMkLst>
+        </pc:spChg>
         <pc:picChg chg="add mod ord">
-          <ac:chgData name="헌정 임" userId="eb9ca9bd79f0560f" providerId="LiveId" clId="{A6339E56-8272-42D6-9D95-12E1A8284411}" dt="2026-07-03T12:37:28.655" v="106" actId="167"/>
+          <ac:chgData name="헌정 임" userId="eb9ca9bd79f0560f" providerId="LiveId" clId="{A6339E56-8272-42D6-9D95-12E1A8284411}" dt="2026-07-03T12:41:42.894" v="431" actId="1076"/>
           <ac:picMkLst>
             <pc:docMk/>
             <pc:sldMk cId="2676242124" sldId="390"/>
             <ac:picMk id="5" creationId="{C75BFF21-2AA7-77DF-62B2-D05B186ED8D0}"/>
           </ac:picMkLst>
         </pc:picChg>
+        <pc:cxnChg chg="add mod">
+          <ac:chgData name="헌정 임" userId="eb9ca9bd79f0560f" providerId="LiveId" clId="{A6339E56-8272-42D6-9D95-12E1A8284411}" dt="2026-07-03T12:38:39.820" v="172" actId="14100"/>
+          <ac:cxnSpMkLst>
+            <pc:docMk/>
+            <pc:sldMk cId="2676242124" sldId="390"/>
+            <ac:cxnSpMk id="9" creationId="{C13D8F2B-9FD2-3033-68A4-F11D17392FF0}"/>
+          </ac:cxnSpMkLst>
+        </pc:cxnChg>
       </pc:sldChg>
-      <pc:sldChg chg="addSp new mod">
-        <pc:chgData name="헌정 임" userId="eb9ca9bd79f0560f" providerId="LiveId" clId="{A6339E56-8272-42D6-9D95-12E1A8284411}" dt="2026-07-03T12:35:57.979" v="92" actId="22"/>
+      <pc:sldChg chg="addSp delSp new mod">
+        <pc:chgData name="헌정 임" userId="eb9ca9bd79f0560f" providerId="LiveId" clId="{A6339E56-8272-42D6-9D95-12E1A8284411}" dt="2026-07-03T12:39:46.153" v="301" actId="21"/>
         <pc:sldMkLst>
           <pc:docMk/>
           <pc:sldMk cId="1772083265" sldId="391"/>
         </pc:sldMkLst>
-        <pc:picChg chg="add">
-          <ac:chgData name="헌정 임" userId="eb9ca9bd79f0560f" providerId="LiveId" clId="{A6339E56-8272-42D6-9D95-12E1A8284411}" dt="2026-07-03T12:35:57.979" v="92" actId="22"/>
+        <pc:picChg chg="add del">
+          <ac:chgData name="헌정 임" userId="eb9ca9bd79f0560f" providerId="LiveId" clId="{A6339E56-8272-42D6-9D95-12E1A8284411}" dt="2026-07-03T12:39:46.153" v="301" actId="21"/>
           <ac:picMkLst>
             <pc:docMk/>
             <pc:sldMk cId="1772083265" sldId="391"/>
@@ -644,6 +719,163 @@
         <pc:sldMkLst>
           <pc:docMk/>
           <pc:sldMk cId="1862866235" sldId="393"/>
+        </pc:sldMkLst>
+      </pc:sldChg>
+      <pc:sldChg chg="addSp delSp modSp add mod">
+        <pc:chgData name="헌정 임" userId="eb9ca9bd79f0560f" providerId="LiveId" clId="{A6339E56-8272-42D6-9D95-12E1A8284411}" dt="2026-07-03T12:40:48.957" v="429" actId="20577"/>
+        <pc:sldMkLst>
+          <pc:docMk/>
+          <pc:sldMk cId="4202351708" sldId="394"/>
+        </pc:sldMkLst>
+        <pc:spChg chg="add mod">
+          <ac:chgData name="헌정 임" userId="eb9ca9bd79f0560f" providerId="LiveId" clId="{A6339E56-8272-42D6-9D95-12E1A8284411}" dt="2026-07-03T12:40:48.957" v="429" actId="20577"/>
+          <ac:spMkLst>
+            <pc:docMk/>
+            <pc:sldMk cId="4202351708" sldId="394"/>
+            <ac:spMk id="3" creationId="{BEFB24E2-E246-886E-894B-8B4933F952B2}"/>
+          </ac:spMkLst>
+        </pc:spChg>
+        <pc:spChg chg="del">
+          <ac:chgData name="헌정 임" userId="eb9ca9bd79f0560f" providerId="LiveId" clId="{A6339E56-8272-42D6-9D95-12E1A8284411}" dt="2026-07-03T12:40:06.058" v="309" actId="478"/>
+          <ac:spMkLst>
+            <pc:docMk/>
+            <pc:sldMk cId="4202351708" sldId="394"/>
+            <ac:spMk id="6" creationId="{13BF2556-CF82-9DA8-2680-3B0C94ECB2A6}"/>
+          </ac:spMkLst>
+        </pc:spChg>
+        <pc:spChg chg="del">
+          <ac:chgData name="헌정 임" userId="eb9ca9bd79f0560f" providerId="LiveId" clId="{A6339E56-8272-42D6-9D95-12E1A8284411}" dt="2026-07-03T12:40:06.058" v="309" actId="478"/>
+          <ac:spMkLst>
+            <pc:docMk/>
+            <pc:sldMk cId="4202351708" sldId="394"/>
+            <ac:spMk id="7" creationId="{7EF4D5A0-28EE-C05D-BB74-427A40A5C62A}"/>
+          </ac:spMkLst>
+        </pc:spChg>
+        <pc:spChg chg="del">
+          <ac:chgData name="헌정 임" userId="eb9ca9bd79f0560f" providerId="LiveId" clId="{A6339E56-8272-42D6-9D95-12E1A8284411}" dt="2026-07-03T12:40:06.058" v="309" actId="478"/>
+          <ac:spMkLst>
+            <pc:docMk/>
+            <pc:sldMk cId="4202351708" sldId="394"/>
+            <ac:spMk id="11" creationId="{663B606D-ADCC-5F2C-63C2-B82D98DACAB5}"/>
+          </ac:spMkLst>
+        </pc:spChg>
+        <pc:spChg chg="del">
+          <ac:chgData name="헌정 임" userId="eb9ca9bd79f0560f" providerId="LiveId" clId="{A6339E56-8272-42D6-9D95-12E1A8284411}" dt="2026-07-03T12:40:06.058" v="309" actId="478"/>
+          <ac:spMkLst>
+            <pc:docMk/>
+            <pc:sldMk cId="4202351708" sldId="394"/>
+            <ac:spMk id="14" creationId="{AF120610-61FC-7D52-54B6-608776059934}"/>
+          </ac:spMkLst>
+        </pc:spChg>
+        <pc:spChg chg="del">
+          <ac:chgData name="헌정 임" userId="eb9ca9bd79f0560f" providerId="LiveId" clId="{A6339E56-8272-42D6-9D95-12E1A8284411}" dt="2026-07-03T12:40:06.058" v="309" actId="478"/>
+          <ac:spMkLst>
+            <pc:docMk/>
+            <pc:sldMk cId="4202351708" sldId="394"/>
+            <ac:spMk id="15" creationId="{F037BA75-8225-EC42-A705-20419514FED9}"/>
+          </ac:spMkLst>
+        </pc:spChg>
+        <pc:picChg chg="add mod">
+          <ac:chgData name="헌정 임" userId="eb9ca9bd79f0560f" providerId="LiveId" clId="{A6339E56-8272-42D6-9D95-12E1A8284411}" dt="2026-07-03T12:39:58.948" v="308" actId="1035"/>
+          <ac:picMkLst>
+            <pc:docMk/>
+            <pc:sldMk cId="4202351708" sldId="394"/>
+            <ac:picMk id="2" creationId="{6589C82B-76C7-FFFE-F8A8-EBE625E776D5}"/>
+          </ac:picMkLst>
+        </pc:picChg>
+        <pc:picChg chg="mod modCrop">
+          <ac:chgData name="헌정 임" userId="eb9ca9bd79f0560f" providerId="LiveId" clId="{A6339E56-8272-42D6-9D95-12E1A8284411}" dt="2026-07-03T12:39:43.296" v="300" actId="732"/>
+          <ac:picMkLst>
+            <pc:docMk/>
+            <pc:sldMk cId="4202351708" sldId="394"/>
+            <ac:picMk id="5" creationId="{8E542F6A-4A10-00D0-732A-2F668532FFAD}"/>
+          </ac:picMkLst>
+        </pc:picChg>
+        <pc:cxnChg chg="del mod">
+          <ac:chgData name="헌정 임" userId="eb9ca9bd79f0560f" providerId="LiveId" clId="{A6339E56-8272-42D6-9D95-12E1A8284411}" dt="2026-07-03T12:40:06.058" v="309" actId="478"/>
+          <ac:cxnSpMkLst>
+            <pc:docMk/>
+            <pc:sldMk cId="4202351708" sldId="394"/>
+            <ac:cxnSpMk id="9" creationId="{643E5BAD-0D5B-7B77-6FEF-903720F3B008}"/>
+          </ac:cxnSpMkLst>
+        </pc:cxnChg>
+      </pc:sldChg>
+      <pc:sldChg chg="addSp delSp modSp add mod">
+        <pc:chgData name="헌정 임" userId="eb9ca9bd79f0560f" providerId="LiveId" clId="{A6339E56-8272-42D6-9D95-12E1A8284411}" dt="2026-07-03T12:47:18.216" v="896"/>
+        <pc:sldMkLst>
+          <pc:docMk/>
+          <pc:sldMk cId="3863440157" sldId="395"/>
+        </pc:sldMkLst>
+        <pc:spChg chg="add mod">
+          <ac:chgData name="헌정 임" userId="eb9ca9bd79f0560f" providerId="LiveId" clId="{A6339E56-8272-42D6-9D95-12E1A8284411}" dt="2026-07-03T12:47:18.216" v="896"/>
+          <ac:spMkLst>
+            <pc:docMk/>
+            <pc:sldMk cId="3863440157" sldId="395"/>
+            <ac:spMk id="3" creationId="{60232472-F08E-ABF8-CCA6-ADC50821946D}"/>
+          </ac:spMkLst>
+        </pc:spChg>
+        <pc:picChg chg="del">
+          <ac:chgData name="헌정 임" userId="eb9ca9bd79f0560f" providerId="LiveId" clId="{A6339E56-8272-42D6-9D95-12E1A8284411}" dt="2026-07-03T12:43:36.678" v="660" actId="478"/>
+          <ac:picMkLst>
+            <pc:docMk/>
+            <pc:sldMk cId="3863440157" sldId="395"/>
+            <ac:picMk id="4" creationId="{8AAA649E-9899-0EC2-C6AD-154A0B8848D3}"/>
+          </ac:picMkLst>
+        </pc:picChg>
+        <pc:picChg chg="mod">
+          <ac:chgData name="헌정 임" userId="eb9ca9bd79f0560f" providerId="LiveId" clId="{A6339E56-8272-42D6-9D95-12E1A8284411}" dt="2026-07-03T12:46:07.986" v="791" actId="1076"/>
+          <ac:picMkLst>
+            <pc:docMk/>
+            <pc:sldMk cId="3863440157" sldId="395"/>
+            <ac:picMk id="6" creationId="{B845D697-C236-3D8B-C60C-A557E44532D6}"/>
+          </ac:picMkLst>
+        </pc:picChg>
+        <pc:picChg chg="mod">
+          <ac:chgData name="헌정 임" userId="eb9ca9bd79f0560f" providerId="LiveId" clId="{A6339E56-8272-42D6-9D95-12E1A8284411}" dt="2026-07-03T12:43:50.522" v="668" actId="1076"/>
+          <ac:picMkLst>
+            <pc:docMk/>
+            <pc:sldMk cId="3863440157" sldId="395"/>
+            <ac:picMk id="8" creationId="{7C0EF117-428F-9EDD-E27F-AA9FBB041137}"/>
+          </ac:picMkLst>
+        </pc:picChg>
+        <pc:picChg chg="del">
+          <ac:chgData name="헌정 임" userId="eb9ca9bd79f0560f" providerId="LiveId" clId="{A6339E56-8272-42D6-9D95-12E1A8284411}" dt="2026-07-03T12:43:38.158" v="662" actId="478"/>
+          <ac:picMkLst>
+            <pc:docMk/>
+            <pc:sldMk cId="3863440157" sldId="395"/>
+            <ac:picMk id="10" creationId="{5AA652DF-AC7B-4044-376E-1954AAD2738E}"/>
+          </ac:picMkLst>
+        </pc:picChg>
+        <pc:picChg chg="del">
+          <ac:chgData name="헌정 임" userId="eb9ca9bd79f0560f" providerId="LiveId" clId="{A6339E56-8272-42D6-9D95-12E1A8284411}" dt="2026-07-03T12:43:36.152" v="659" actId="478"/>
+          <ac:picMkLst>
+            <pc:docMk/>
+            <pc:sldMk cId="3863440157" sldId="395"/>
+            <ac:picMk id="11" creationId="{ADF74D7C-6615-BF02-4C30-A6CBC31D14C6}"/>
+          </ac:picMkLst>
+        </pc:picChg>
+        <pc:picChg chg="del">
+          <ac:chgData name="헌정 임" userId="eb9ca9bd79f0560f" providerId="LiveId" clId="{A6339E56-8272-42D6-9D95-12E1A8284411}" dt="2026-07-03T12:43:37.360" v="661" actId="478"/>
+          <ac:picMkLst>
+            <pc:docMk/>
+            <pc:sldMk cId="3863440157" sldId="395"/>
+            <ac:picMk id="12" creationId="{B04BEF68-A559-2595-C4FF-21F78E78934C}"/>
+          </ac:picMkLst>
+        </pc:picChg>
+        <pc:picChg chg="mod">
+          <ac:chgData name="헌정 임" userId="eb9ca9bd79f0560f" providerId="LiveId" clId="{A6339E56-8272-42D6-9D95-12E1A8284411}" dt="2026-07-03T12:43:47.612" v="666" actId="1076"/>
+          <ac:picMkLst>
+            <pc:docMk/>
+            <pc:sldMk cId="3863440157" sldId="395"/>
+            <ac:picMk id="13" creationId="{354B6CF4-6333-8CF0-DFD3-6D7C39B090C5}"/>
+          </ac:picMkLst>
+        </pc:picChg>
+      </pc:sldChg>
+      <pc:sldChg chg="add">
+        <pc:chgData name="헌정 임" userId="eb9ca9bd79f0560f" providerId="LiveId" clId="{A6339E56-8272-42D6-9D95-12E1A8284411}" dt="2026-07-03T12:43:29.324" v="654"/>
+        <pc:sldMkLst>
+          <pc:docMk/>
+          <pc:sldMk cId="2184797597" sldId="396"/>
         </pc:sldMkLst>
       </pc:sldChg>
     </pc:docChg>
@@ -3977,7 +4209,7 @@
         <p:spPr>
           <a:xfrm>
             <a:off x="4394200" y="5403861"/>
-            <a:ext cx="2641600" cy="323850"/>
+            <a:ext cx="2641600" cy="260339"/>
           </a:xfrm>
           <a:prstGeom prst="rect">
             <a:avLst/>
@@ -4015,6 +4247,240 @@
           </a:p>
         </p:txBody>
       </p:sp>
+      <p:cxnSp>
+        <p:nvCxnSpPr>
+          <p:cNvPr id="9" name="연결선: 꺾임 8">
+            <a:extLst>
+              <a:ext uri="{FF2B5EF4-FFF2-40B4-BE49-F238E27FC236}">
+                <a16:creationId xmlns:a16="http://schemas.microsoft.com/office/drawing/2014/main" id="{C13D8F2B-9FD2-3033-68A4-F11D17392FF0}"/>
+              </a:ext>
+            </a:extLst>
+          </p:cNvPr>
+          <p:cNvCxnSpPr>
+            <a:cxnSpLocks/>
+            <a:stCxn id="6" idx="3"/>
+            <a:endCxn id="7" idx="3"/>
+          </p:cNvCxnSpPr>
+          <p:nvPr/>
+        </p:nvCxnSpPr>
+        <p:spPr>
+          <a:xfrm>
+            <a:off x="5715000" y="4689475"/>
+            <a:ext cx="1320800" cy="844556"/>
+          </a:xfrm>
+          <a:prstGeom prst="bentConnector3">
+            <a:avLst>
+              <a:gd name="adj1" fmla="val 117308"/>
+            </a:avLst>
+          </a:prstGeom>
+          <a:ln>
+            <a:solidFill>
+              <a:srgbClr val="FFFF00"/>
+            </a:solidFill>
+          </a:ln>
+        </p:spPr>
+        <p:style>
+          <a:lnRef idx="2">
+            <a:schemeClr val="accent1"/>
+          </a:lnRef>
+          <a:fillRef idx="0">
+            <a:schemeClr val="accent1"/>
+          </a:fillRef>
+          <a:effectRef idx="1">
+            <a:schemeClr val="accent1"/>
+          </a:effectRef>
+          <a:fontRef idx="minor">
+            <a:schemeClr val="tx1"/>
+          </a:fontRef>
+        </p:style>
+      </p:cxnSp>
+      <p:sp>
+        <p:nvSpPr>
+          <p:cNvPr id="11" name="TextBox 10">
+            <a:extLst>
+              <a:ext uri="{FF2B5EF4-FFF2-40B4-BE49-F238E27FC236}">
+                <a16:creationId xmlns:a16="http://schemas.microsoft.com/office/drawing/2014/main" id="{4249A169-15EF-2110-4375-3EB6008B6866}"/>
+              </a:ext>
+            </a:extLst>
+          </p:cNvPr>
+          <p:cNvSpPr txBox="1"/>
+          <p:nvPr/>
+        </p:nvSpPr>
+        <p:spPr>
+          <a:xfrm>
+            <a:off x="7873999" y="4889500"/>
+            <a:ext cx="4140201" cy="369332"/>
+          </a:xfrm>
+          <a:prstGeom prst="rect">
+            <a:avLst/>
+          </a:prstGeom>
+          <a:noFill/>
+        </p:spPr>
+        <p:txBody>
+          <a:bodyPr wrap="square" rtlCol="0">
+            <a:spAutoFit/>
+          </a:bodyPr>
+          <a:lstStyle/>
+          <a:p>
+            <a:r>
+              <a:rPr lang="ko-KR" altLang="en-US" dirty="0">
+                <a:highlight>
+                  <a:srgbClr val="FFFF00"/>
+                </a:highlight>
+              </a:rPr>
+              <a:t>파일 명</a:t>
+            </a:r>
+            <a:r>
+              <a:rPr lang="en-US" altLang="ko-KR" dirty="0">
+                <a:highlight>
+                  <a:srgbClr val="FFFF00"/>
+                </a:highlight>
+              </a:rPr>
+              <a:t>(.</a:t>
+            </a:r>
+            <a:r>
+              <a:rPr lang="en-US" altLang="ko-KR" dirty="0" err="1">
+                <a:highlight>
+                  <a:srgbClr val="FFFF00"/>
+                </a:highlight>
+              </a:rPr>
+              <a:t>yaml</a:t>
+            </a:r>
+            <a:r>
+              <a:rPr lang="en-US" altLang="ko-KR" dirty="0">
+                <a:highlight>
+                  <a:srgbClr val="FFFF00"/>
+                </a:highlight>
+              </a:rPr>
+              <a:t>)</a:t>
+            </a:r>
+            <a:r>
+              <a:rPr lang="ko-KR" altLang="en-US" dirty="0">
+                <a:highlight>
+                  <a:srgbClr val="FFFF00"/>
+                </a:highlight>
+              </a:rPr>
+              <a:t>을 바꾸어도 반영 안됨 </a:t>
+            </a:r>
+          </a:p>
+        </p:txBody>
+      </p:sp>
+      <p:sp>
+        <p:nvSpPr>
+          <p:cNvPr id="14" name="직사각형 13">
+            <a:extLst>
+              <a:ext uri="{FF2B5EF4-FFF2-40B4-BE49-F238E27FC236}">
+                <a16:creationId xmlns:a16="http://schemas.microsoft.com/office/drawing/2014/main" id="{5DF8D435-254C-F3B1-32A8-6D5E176BE51E}"/>
+              </a:ext>
+            </a:extLst>
+          </p:cNvPr>
+          <p:cNvSpPr/>
+          <p:nvPr/>
+        </p:nvSpPr>
+        <p:spPr>
+          <a:xfrm>
+            <a:off x="1231900" y="5664200"/>
+            <a:ext cx="2641600" cy="260339"/>
+          </a:xfrm>
+          <a:prstGeom prst="rect">
+            <a:avLst/>
+          </a:prstGeom>
+          <a:noFill/>
+          <a:ln>
+            <a:solidFill>
+              <a:srgbClr val="FFFF00"/>
+            </a:solidFill>
+            <a:prstDash val="sysDash"/>
+          </a:ln>
+        </p:spPr>
+        <p:style>
+          <a:lnRef idx="2">
+            <a:schemeClr val="accent1">
+              <a:shade val="15000"/>
+            </a:schemeClr>
+          </a:lnRef>
+          <a:fillRef idx="1">
+            <a:schemeClr val="accent1"/>
+          </a:fillRef>
+          <a:effectRef idx="0">
+            <a:schemeClr val="accent1"/>
+          </a:effectRef>
+          <a:fontRef idx="minor">
+            <a:schemeClr val="lt1"/>
+          </a:fontRef>
+        </p:style>
+        <p:txBody>
+          <a:bodyPr rtlCol="0" anchor="ctr"/>
+          <a:lstStyle/>
+          <a:p>
+            <a:pPr algn="ctr"/>
+            <a:endParaRPr lang="ko-KR" altLang="en-US" dirty="0"/>
+          </a:p>
+        </p:txBody>
+      </p:sp>
+      <p:sp>
+        <p:nvSpPr>
+          <p:cNvPr id="15" name="TextBox 14">
+            <a:extLst>
+              <a:ext uri="{FF2B5EF4-FFF2-40B4-BE49-F238E27FC236}">
+                <a16:creationId xmlns:a16="http://schemas.microsoft.com/office/drawing/2014/main" id="{6AD0FD0E-D4CB-76D6-559B-263C57FDEE31}"/>
+              </a:ext>
+            </a:extLst>
+          </p:cNvPr>
+          <p:cNvSpPr txBox="1"/>
+          <p:nvPr/>
+        </p:nvSpPr>
+        <p:spPr>
+          <a:xfrm>
+            <a:off x="1282699" y="6002404"/>
+            <a:ext cx="6134101" cy="369332"/>
+          </a:xfrm>
+          <a:prstGeom prst="rect">
+            <a:avLst/>
+          </a:prstGeom>
+          <a:noFill/>
+        </p:spPr>
+        <p:txBody>
+          <a:bodyPr wrap="square" rtlCol="0">
+            <a:spAutoFit/>
+          </a:bodyPr>
+          <a:lstStyle/>
+          <a:p>
+            <a:r>
+              <a:rPr lang="en-US" altLang="ko-KR" dirty="0">
+                <a:highlight>
+                  <a:srgbClr val="FFFF00"/>
+                </a:highlight>
+              </a:rPr>
+              <a:t>(</a:t>
+            </a:r>
+            <a:r>
+              <a:rPr lang="ko-KR" altLang="en-US" dirty="0">
+                <a:highlight>
+                  <a:srgbClr val="FFFF00"/>
+                </a:highlight>
+              </a:rPr>
+              <a:t>읽기 권한이 없어서 인지</a:t>
+            </a:r>
+            <a:r>
+              <a:rPr lang="en-US" altLang="ko-KR" dirty="0">
+                <a:highlight>
+                  <a:srgbClr val="FFFF00"/>
+                </a:highlight>
+              </a:rPr>
+              <a:t>, </a:t>
+            </a:r>
+            <a:r>
+              <a:rPr lang="ko-KR" altLang="en-US" dirty="0">
+                <a:highlight>
+                  <a:srgbClr val="FFFF00"/>
+                </a:highlight>
+              </a:rPr>
+              <a:t>업로드 하여도 인식 못함</a:t>
+            </a:r>
+          </a:p>
+        </p:txBody>
+      </p:sp>
     </p:spTree>
     <p:extLst>
       <p:ext uri="{BB962C8B-B14F-4D97-AF65-F5344CB8AC3E}">
@@ -4029,6 +4495,393 @@
 </file>
 
 <file path=ppt/slides/slide10.xml><?xml version="1.0" encoding="utf-8"?>
+<p:sld xmlns:a="http://schemas.openxmlformats.org/drawingml/2006/main" xmlns:r="http://schemas.openxmlformats.org/officeDocument/2006/relationships" xmlns:p="http://schemas.openxmlformats.org/presentationml/2006/main">
+  <p:cSld>
+    <p:spTree>
+      <p:nvGrpSpPr>
+        <p:cNvPr id="1" name=""/>
+        <p:cNvGrpSpPr/>
+        <p:nvPr/>
+      </p:nvGrpSpPr>
+      <p:grpSpPr>
+        <a:xfrm>
+          <a:off x="0" y="0"/>
+          <a:ext cx="0" cy="0"/>
+          <a:chOff x="0" y="0"/>
+          <a:chExt cx="0" cy="0"/>
+        </a:xfrm>
+      </p:grpSpPr>
+      <p:sp>
+        <p:nvSpPr>
+          <p:cNvPr id="2" name="제목 1">
+            <a:extLst>
+              <a:ext uri="{FF2B5EF4-FFF2-40B4-BE49-F238E27FC236}">
+                <a16:creationId xmlns:a16="http://schemas.microsoft.com/office/drawing/2014/main" id="{D5A1BA7F-CD92-ACF2-5B13-F456190790AC}"/>
+              </a:ext>
+            </a:extLst>
+          </p:cNvPr>
+          <p:cNvSpPr>
+            <a:spLocks noGrp="1"/>
+          </p:cNvSpPr>
+          <p:nvPr>
+            <p:ph type="title"/>
+          </p:nvPr>
+        </p:nvSpPr>
+        <p:spPr/>
+        <p:txBody>
+          <a:bodyPr/>
+          <a:lstStyle/>
+          <a:p>
+            <a:endParaRPr lang="ko-KR" altLang="en-US"/>
+          </a:p>
+        </p:txBody>
+      </p:sp>
+      <p:pic>
+        <p:nvPicPr>
+          <p:cNvPr id="4" name="그림 3">
+            <a:extLst>
+              <a:ext uri="{FF2B5EF4-FFF2-40B4-BE49-F238E27FC236}">
+                <a16:creationId xmlns:a16="http://schemas.microsoft.com/office/drawing/2014/main" id="{E8B297AB-20D8-0B14-8D8A-CAAF32A032DE}"/>
+              </a:ext>
+            </a:extLst>
+          </p:cNvPr>
+          <p:cNvPicPr>
+            <a:picLocks noChangeAspect="1"/>
+          </p:cNvPicPr>
+          <p:nvPr/>
+        </p:nvPicPr>
+        <p:blipFill>
+          <a:blip r:embed="rId2"/>
+          <a:stretch>
+            <a:fillRect/>
+          </a:stretch>
+        </p:blipFill>
+        <p:spPr>
+          <a:xfrm>
+            <a:off x="0" y="28163"/>
+            <a:ext cx="12192000" cy="6801674"/>
+          </a:xfrm>
+          <a:prstGeom prst="rect">
+            <a:avLst/>
+          </a:prstGeom>
+        </p:spPr>
+      </p:pic>
+      <p:sp>
+        <p:nvSpPr>
+          <p:cNvPr id="5" name="직사각형 4">
+            <a:extLst>
+              <a:ext uri="{FF2B5EF4-FFF2-40B4-BE49-F238E27FC236}">
+                <a16:creationId xmlns:a16="http://schemas.microsoft.com/office/drawing/2014/main" id="{87597391-AF5F-C774-31F8-B1E520AE5465}"/>
+              </a:ext>
+            </a:extLst>
+          </p:cNvPr>
+          <p:cNvSpPr/>
+          <p:nvPr/>
+        </p:nvSpPr>
+        <p:spPr>
+          <a:xfrm>
+            <a:off x="10655687" y="147241"/>
+            <a:ext cx="1159847" cy="297260"/>
+          </a:xfrm>
+          <a:prstGeom prst="rect">
+            <a:avLst/>
+          </a:prstGeom>
+          <a:solidFill>
+            <a:srgbClr val="F2F2F2"/>
+          </a:solidFill>
+          <a:ln>
+            <a:noFill/>
+          </a:ln>
+        </p:spPr>
+        <p:style>
+          <a:lnRef idx="2">
+            <a:schemeClr val="accent1">
+              <a:shade val="50000"/>
+            </a:schemeClr>
+          </a:lnRef>
+          <a:fillRef idx="1">
+            <a:schemeClr val="accent1"/>
+          </a:fillRef>
+          <a:effectRef idx="0">
+            <a:schemeClr val="accent1"/>
+          </a:effectRef>
+          <a:fontRef idx="minor">
+            <a:schemeClr val="lt1"/>
+          </a:fontRef>
+        </p:style>
+        <p:txBody>
+          <a:bodyPr rtlCol="0" anchor="ctr"/>
+          <a:lstStyle/>
+          <a:p>
+            <a:pPr marL="0" marR="0" lvl="0" indent="0" algn="ctr" defTabSz="914400" rtl="0" eaLnBrk="1" fontAlgn="auto" latinLnBrk="1" hangingPunct="1">
+              <a:lnSpc>
+                <a:spcPct val="100000"/>
+              </a:lnSpc>
+              <a:spcBef>
+                <a:spcPts val="0"/>
+              </a:spcBef>
+              <a:spcAft>
+                <a:spcPts val="0"/>
+              </a:spcAft>
+              <a:buClrTx/>
+              <a:buSzTx/>
+              <a:buFontTx/>
+              <a:buNone/>
+              <a:tabLst/>
+              <a:defRPr/>
+            </a:pPr>
+            <a:endParaRPr kumimoji="0" lang="ko-KR" altLang="en-US" sz="1800" b="0" i="0" u="none" strike="noStrike" kern="1200" cap="none" spc="0" normalizeH="0" baseline="0" noProof="0">
+              <a:ln>
+                <a:noFill/>
+              </a:ln>
+              <a:solidFill>
+                <a:prstClr val="white"/>
+              </a:solidFill>
+              <a:effectLst/>
+              <a:uLnTx/>
+              <a:uFillTx/>
+              <a:latin typeface="Montserrat" pitchFamily="2" charset="0"/>
+              <a:ea typeface="맑은 고딕" panose="020B0503020000020004" pitchFamily="50" charset="-127"/>
+              <a:cs typeface="+mn-cs"/>
+            </a:endParaRPr>
+          </a:p>
+        </p:txBody>
+      </p:sp>
+    </p:spTree>
+    <p:extLst>
+      <p:ext uri="{BB962C8B-B14F-4D97-AF65-F5344CB8AC3E}">
+        <p14:creationId xmlns:p14="http://schemas.microsoft.com/office/powerpoint/2010/main" val="333529903"/>
+      </p:ext>
+    </p:extLst>
+  </p:cSld>
+  <p:clrMapOvr>
+    <a:masterClrMapping/>
+  </p:clrMapOvr>
+</p:sld>
+</file>
+
+<file path=ppt/slides/slide11.xml><?xml version="1.0" encoding="utf-8"?>
+<p:sld xmlns:a="http://schemas.openxmlformats.org/drawingml/2006/main" xmlns:r="http://schemas.openxmlformats.org/officeDocument/2006/relationships" xmlns:p="http://schemas.openxmlformats.org/presentationml/2006/main">
+  <p:cSld>
+    <p:spTree>
+      <p:nvGrpSpPr>
+        <p:cNvPr id="1" name=""/>
+        <p:cNvGrpSpPr/>
+        <p:nvPr/>
+      </p:nvGrpSpPr>
+      <p:grpSpPr>
+        <a:xfrm>
+          <a:off x="0" y="0"/>
+          <a:ext cx="0" cy="0"/>
+          <a:chOff x="0" y="0"/>
+          <a:chExt cx="0" cy="0"/>
+        </a:xfrm>
+      </p:grpSpPr>
+      <p:sp>
+        <p:nvSpPr>
+          <p:cNvPr id="2" name="제목 1">
+            <a:extLst>
+              <a:ext uri="{FF2B5EF4-FFF2-40B4-BE49-F238E27FC236}">
+                <a16:creationId xmlns:a16="http://schemas.microsoft.com/office/drawing/2014/main" id="{C806619F-2430-DB69-E007-F8C44168B1F1}"/>
+              </a:ext>
+            </a:extLst>
+          </p:cNvPr>
+          <p:cNvSpPr>
+            <a:spLocks noGrp="1"/>
+          </p:cNvSpPr>
+          <p:nvPr>
+            <p:ph type="title"/>
+          </p:nvPr>
+        </p:nvSpPr>
+        <p:spPr/>
+        <p:txBody>
+          <a:bodyPr/>
+          <a:lstStyle/>
+          <a:p>
+            <a:endParaRPr lang="ko-KR" altLang="en-US"/>
+          </a:p>
+        </p:txBody>
+      </p:sp>
+      <p:pic>
+        <p:nvPicPr>
+          <p:cNvPr id="6" name="그림 5">
+            <a:extLst>
+              <a:ext uri="{FF2B5EF4-FFF2-40B4-BE49-F238E27FC236}">
+                <a16:creationId xmlns:a16="http://schemas.microsoft.com/office/drawing/2014/main" id="{48EF2E57-901F-B412-D2ED-829178775CF8}"/>
+              </a:ext>
+            </a:extLst>
+          </p:cNvPr>
+          <p:cNvPicPr>
+            <a:picLocks noChangeAspect="1"/>
+          </p:cNvPicPr>
+          <p:nvPr/>
+        </p:nvPicPr>
+        <p:blipFill>
+          <a:blip r:embed="rId2"/>
+          <a:stretch>
+            <a:fillRect/>
+          </a:stretch>
+        </p:blipFill>
+        <p:spPr>
+          <a:xfrm>
+            <a:off x="0" y="55194"/>
+            <a:ext cx="12192000" cy="6747612"/>
+          </a:xfrm>
+          <a:prstGeom prst="rect">
+            <a:avLst/>
+          </a:prstGeom>
+        </p:spPr>
+      </p:pic>
+      <p:sp>
+        <p:nvSpPr>
+          <p:cNvPr id="7" name="직사각형 6">
+            <a:extLst>
+              <a:ext uri="{FF2B5EF4-FFF2-40B4-BE49-F238E27FC236}">
+                <a16:creationId xmlns:a16="http://schemas.microsoft.com/office/drawing/2014/main" id="{14B85EC4-8F40-3159-DBE0-117F5C1C36A2}"/>
+              </a:ext>
+            </a:extLst>
+          </p:cNvPr>
+          <p:cNvSpPr/>
+          <p:nvPr/>
+        </p:nvSpPr>
+        <p:spPr>
+          <a:xfrm>
+            <a:off x="10655687" y="147241"/>
+            <a:ext cx="1159847" cy="297260"/>
+          </a:xfrm>
+          <a:prstGeom prst="rect">
+            <a:avLst/>
+          </a:prstGeom>
+          <a:solidFill>
+            <a:srgbClr val="F2F2F2"/>
+          </a:solidFill>
+          <a:ln>
+            <a:noFill/>
+          </a:ln>
+        </p:spPr>
+        <p:style>
+          <a:lnRef idx="2">
+            <a:schemeClr val="accent1">
+              <a:shade val="50000"/>
+            </a:schemeClr>
+          </a:lnRef>
+          <a:fillRef idx="1">
+            <a:schemeClr val="accent1"/>
+          </a:fillRef>
+          <a:effectRef idx="0">
+            <a:schemeClr val="accent1"/>
+          </a:effectRef>
+          <a:fontRef idx="minor">
+            <a:schemeClr val="lt1"/>
+          </a:fontRef>
+        </p:style>
+        <p:txBody>
+          <a:bodyPr rtlCol="0" anchor="ctr"/>
+          <a:lstStyle/>
+          <a:p>
+            <a:pPr marL="0" marR="0" lvl="0" indent="0" algn="ctr" defTabSz="914400" rtl="0" eaLnBrk="1" fontAlgn="auto" latinLnBrk="1" hangingPunct="1">
+              <a:lnSpc>
+                <a:spcPct val="100000"/>
+              </a:lnSpc>
+              <a:spcBef>
+                <a:spcPts val="0"/>
+              </a:spcBef>
+              <a:spcAft>
+                <a:spcPts val="0"/>
+              </a:spcAft>
+              <a:buClrTx/>
+              <a:buSzTx/>
+              <a:buFontTx/>
+              <a:buNone/>
+              <a:tabLst/>
+              <a:defRPr/>
+            </a:pPr>
+            <a:endParaRPr kumimoji="0" lang="ko-KR" altLang="en-US" sz="1800" b="0" i="0" u="none" strike="noStrike" kern="1200" cap="none" spc="0" normalizeH="0" baseline="0" noProof="0">
+              <a:ln>
+                <a:noFill/>
+              </a:ln>
+              <a:solidFill>
+                <a:prstClr val="white"/>
+              </a:solidFill>
+              <a:effectLst/>
+              <a:uLnTx/>
+              <a:uFillTx/>
+              <a:latin typeface="Montserrat" pitchFamily="2" charset="0"/>
+              <a:ea typeface="맑은 고딕" panose="020B0503020000020004" pitchFamily="50" charset="-127"/>
+              <a:cs typeface="+mn-cs"/>
+            </a:endParaRPr>
+          </a:p>
+        </p:txBody>
+      </p:sp>
+    </p:spTree>
+    <p:extLst>
+      <p:ext uri="{BB962C8B-B14F-4D97-AF65-F5344CB8AC3E}">
+        <p14:creationId xmlns:p14="http://schemas.microsoft.com/office/powerpoint/2010/main" val="1109579226"/>
+      </p:ext>
+    </p:extLst>
+  </p:cSld>
+  <p:clrMapOvr>
+    <a:masterClrMapping/>
+  </p:clrMapOvr>
+</p:sld>
+</file>
+
+<file path=ppt/slides/slide12.xml><?xml version="1.0" encoding="utf-8"?>
+<p:sld xmlns:a="http://schemas.openxmlformats.org/drawingml/2006/main" xmlns:r="http://schemas.openxmlformats.org/officeDocument/2006/relationships" xmlns:p="http://schemas.openxmlformats.org/presentationml/2006/main">
+  <p:cSld>
+    <p:spTree>
+      <p:nvGrpSpPr>
+        <p:cNvPr id="1" name=""/>
+        <p:cNvGrpSpPr/>
+        <p:nvPr/>
+      </p:nvGrpSpPr>
+      <p:grpSpPr>
+        <a:xfrm>
+          <a:off x="0" y="0"/>
+          <a:ext cx="0" cy="0"/>
+          <a:chOff x="0" y="0"/>
+          <a:chExt cx="0" cy="0"/>
+        </a:xfrm>
+      </p:grpSpPr>
+      <p:sp>
+        <p:nvSpPr>
+          <p:cNvPr id="2" name="제목 1">
+            <a:extLst>
+              <a:ext uri="{FF2B5EF4-FFF2-40B4-BE49-F238E27FC236}">
+                <a16:creationId xmlns:a16="http://schemas.microsoft.com/office/drawing/2014/main" id="{20F68881-C95D-985B-7896-422ED4C2EE47}"/>
+              </a:ext>
+            </a:extLst>
+          </p:cNvPr>
+          <p:cNvSpPr>
+            <a:spLocks noGrp="1"/>
+          </p:cNvSpPr>
+          <p:nvPr>
+            <p:ph type="title"/>
+          </p:nvPr>
+        </p:nvSpPr>
+        <p:spPr/>
+        <p:txBody>
+          <a:bodyPr/>
+          <a:lstStyle/>
+          <a:p>
+            <a:endParaRPr lang="ko-KR" altLang="en-US"/>
+          </a:p>
+        </p:txBody>
+      </p:sp>
+    </p:spTree>
+    <p:extLst>
+      <p:ext uri="{BB962C8B-B14F-4D97-AF65-F5344CB8AC3E}">
+        <p14:creationId xmlns:p14="http://schemas.microsoft.com/office/powerpoint/2010/main" val="4061806259"/>
+      </p:ext>
+    </p:extLst>
+  </p:cSld>
+  <p:clrMapOvr>
+    <a:masterClrMapping/>
+  </p:clrMapOvr>
+</p:sld>
+</file>
+
+<file path=ppt/slides/slide13.xml><?xml version="1.0" encoding="utf-8"?>
 <p:sld xmlns:a="http://schemas.openxmlformats.org/drawingml/2006/main" xmlns:r="http://schemas.openxmlformats.org/officeDocument/2006/relationships" xmlns:p="http://schemas.openxmlformats.org/presentationml/2006/main">
   <p:cSld>
     <p:spTree>
@@ -4083,7 +4936,7 @@
 </p:sld>
 </file>
 
-<file path=ppt/slides/slide11.xml><?xml version="1.0" encoding="utf-8"?>
+<file path=ppt/slides/slide14.xml><?xml version="1.0" encoding="utf-8"?>
 <p:sld xmlns:a="http://schemas.openxmlformats.org/drawingml/2006/main" xmlns:r="http://schemas.openxmlformats.org/officeDocument/2006/relationships" xmlns:p="http://schemas.openxmlformats.org/presentationml/2006/main">
   <p:cSld>
     <p:spTree>
@@ -4291,7 +5144,7 @@
 </p:sld>
 </file>
 
-<file path=ppt/slides/slide12.xml><?xml version="1.0" encoding="utf-8"?>
+<file path=ppt/slides/slide15.xml><?xml version="1.0" encoding="utf-8"?>
 <p:sld xmlns:a="http://schemas.openxmlformats.org/drawingml/2006/main" xmlns:r="http://schemas.openxmlformats.org/officeDocument/2006/relationships" xmlns:p="http://schemas.openxmlformats.org/presentationml/2006/main">
   <p:cSld>
     <p:spTree>
@@ -29673,7 +30526,7 @@
 </p:sld>
 </file>
 
-<file path=ppt/slides/slide13.xml><?xml version="1.0" encoding="utf-8"?>
+<file path=ppt/slides/slide16.xml><?xml version="1.0" encoding="utf-8"?>
 <p:sld xmlns:a="http://schemas.openxmlformats.org/drawingml/2006/main" xmlns:r="http://schemas.openxmlformats.org/officeDocument/2006/relationships" xmlns:p="http://schemas.openxmlformats.org/presentationml/2006/main">
   <p:cSld>
     <p:spTree>
@@ -33051,7 +33904,7 @@
 </p:sld>
 </file>
 
-<file path=ppt/slides/slide14.xml><?xml version="1.0" encoding="utf-8"?>
+<file path=ppt/slides/slide17.xml><?xml version="1.0" encoding="utf-8"?>
 <p:sld xmlns:a="http://schemas.openxmlformats.org/drawingml/2006/main" xmlns:r="http://schemas.openxmlformats.org/officeDocument/2006/relationships" xmlns:p="http://schemas.openxmlformats.org/presentationml/2006/main">
   <p:cSld>
     <p:spTree>
@@ -36432,7 +37285,7 @@
 </p:sld>
 </file>
 
-<file path=ppt/slides/slide15.xml><?xml version="1.0" encoding="utf-8"?>
+<file path=ppt/slides/slide18.xml><?xml version="1.0" encoding="utf-8"?>
 <p:sld xmlns:a="http://schemas.openxmlformats.org/drawingml/2006/main" xmlns:r="http://schemas.openxmlformats.org/officeDocument/2006/relationships" xmlns:p="http://schemas.openxmlformats.org/presentationml/2006/main">
   <p:cSld>
     <p:spTree>
@@ -39809,7 +40662,7 @@
 </p:sld>
 </file>
 
-<file path=ppt/slides/slide16.xml><?xml version="1.0" encoding="utf-8"?>
+<file path=ppt/slides/slide19.xml><?xml version="1.0" encoding="utf-8"?>
 <p:sld xmlns:a="http://schemas.openxmlformats.org/drawingml/2006/main" xmlns:r="http://schemas.openxmlformats.org/officeDocument/2006/relationships" xmlns:p="http://schemas.openxmlformats.org/presentationml/2006/main">
   <p:cSld>
     <p:spTree>
@@ -41381,36 +42234,6 @@
           </a:p>
         </p:txBody>
       </p:sp>
-      <p:pic>
-        <p:nvPicPr>
-          <p:cNvPr id="5" name="그림 4">
-            <a:extLst>
-              <a:ext uri="{FF2B5EF4-FFF2-40B4-BE49-F238E27FC236}">
-                <a16:creationId xmlns:a16="http://schemas.microsoft.com/office/drawing/2014/main" id="{6589C82B-76C7-FFFE-F8A8-EBE625E776D5}"/>
-              </a:ext>
-            </a:extLst>
-          </p:cNvPr>
-          <p:cNvPicPr>
-            <a:picLocks noChangeAspect="1"/>
-          </p:cNvPicPr>
-          <p:nvPr/>
-        </p:nvPicPr>
-        <p:blipFill>
-          <a:blip r:embed="rId2"/>
-          <a:stretch>
-            <a:fillRect/>
-          </a:stretch>
-        </p:blipFill>
-        <p:spPr>
-          <a:xfrm>
-            <a:off x="3300392" y="2967034"/>
-            <a:ext cx="5591216" cy="923932"/>
-          </a:xfrm>
-          <a:prstGeom prst="rect">
-            <a:avLst/>
-          </a:prstGeom>
-        </p:spPr>
-      </p:pic>
     </p:spTree>
     <p:extLst>
       <p:ext uri="{BB962C8B-B14F-4D97-AF65-F5344CB8AC3E}">
@@ -41425,6 +42248,173 @@
 </file>
 
 <file path=ppt/slides/slide3.xml><?xml version="1.0" encoding="utf-8"?>
+<p:sld xmlns:a="http://schemas.openxmlformats.org/drawingml/2006/main" xmlns:r="http://schemas.openxmlformats.org/officeDocument/2006/relationships" xmlns:p="http://schemas.openxmlformats.org/presentationml/2006/main">
+  <p:cSld>
+    <p:spTree>
+      <p:nvGrpSpPr>
+        <p:cNvPr id="1" name="">
+          <a:extLst>
+            <a:ext uri="{FF2B5EF4-FFF2-40B4-BE49-F238E27FC236}">
+              <a16:creationId xmlns:a16="http://schemas.microsoft.com/office/drawing/2014/main" id="{045E6A8D-16EE-AA51-6E86-E1580084E2C5}"/>
+            </a:ext>
+          </a:extLst>
+        </p:cNvPr>
+        <p:cNvGrpSpPr/>
+        <p:nvPr/>
+      </p:nvGrpSpPr>
+      <p:grpSpPr>
+        <a:xfrm>
+          <a:off x="0" y="0"/>
+          <a:ext cx="0" cy="0"/>
+          <a:chOff x="0" y="0"/>
+          <a:chExt cx="0" cy="0"/>
+        </a:xfrm>
+      </p:grpSpPr>
+      <p:pic>
+        <p:nvPicPr>
+          <p:cNvPr id="5" name="그림 4">
+            <a:extLst>
+              <a:ext uri="{FF2B5EF4-FFF2-40B4-BE49-F238E27FC236}">
+                <a16:creationId xmlns:a16="http://schemas.microsoft.com/office/drawing/2014/main" id="{8E542F6A-4A10-00D0-732A-2F668532FFAD}"/>
+              </a:ext>
+            </a:extLst>
+          </p:cNvPr>
+          <p:cNvPicPr>
+            <a:picLocks noChangeAspect="1"/>
+          </p:cNvPicPr>
+          <p:nvPr/>
+        </p:nvPicPr>
+        <p:blipFill>
+          <a:blip r:embed="rId2"/>
+          <a:srcRect b="75478"/>
+          <a:stretch>
+            <a:fillRect/>
+          </a:stretch>
+        </p:blipFill>
+        <p:spPr>
+          <a:xfrm>
+            <a:off x="1166776" y="298428"/>
+            <a:ext cx="9858447" cy="1466872"/>
+          </a:xfrm>
+          <a:prstGeom prst="rect">
+            <a:avLst/>
+          </a:prstGeom>
+          <a:ln>
+            <a:solidFill>
+              <a:srgbClr val="FFFF00"/>
+            </a:solidFill>
+          </a:ln>
+        </p:spPr>
+      </p:pic>
+      <p:pic>
+        <p:nvPicPr>
+          <p:cNvPr id="2" name="그림 1">
+            <a:extLst>
+              <a:ext uri="{FF2B5EF4-FFF2-40B4-BE49-F238E27FC236}">
+                <a16:creationId xmlns:a16="http://schemas.microsoft.com/office/drawing/2014/main" id="{6589C82B-76C7-FFFE-F8A8-EBE625E776D5}"/>
+              </a:ext>
+            </a:extLst>
+          </p:cNvPr>
+          <p:cNvPicPr>
+            <a:picLocks noChangeAspect="1"/>
+          </p:cNvPicPr>
+          <p:nvPr/>
+        </p:nvPicPr>
+        <p:blipFill>
+          <a:blip r:embed="rId3"/>
+          <a:stretch>
+            <a:fillRect/>
+          </a:stretch>
+        </p:blipFill>
+        <p:spPr>
+          <a:xfrm>
+            <a:off x="1166776" y="1766877"/>
+            <a:ext cx="5591216" cy="923932"/>
+          </a:xfrm>
+          <a:prstGeom prst="rect">
+            <a:avLst/>
+          </a:prstGeom>
+        </p:spPr>
+      </p:pic>
+      <p:sp>
+        <p:nvSpPr>
+          <p:cNvPr id="3" name="TextBox 2">
+            <a:extLst>
+              <a:ext uri="{FF2B5EF4-FFF2-40B4-BE49-F238E27FC236}">
+                <a16:creationId xmlns:a16="http://schemas.microsoft.com/office/drawing/2014/main" id="{BEFB24E2-E246-886E-894B-8B4933F952B2}"/>
+              </a:ext>
+            </a:extLst>
+          </p:cNvPr>
+          <p:cNvSpPr txBox="1"/>
+          <p:nvPr/>
+        </p:nvSpPr>
+        <p:spPr>
+          <a:xfrm>
+            <a:off x="6721515" y="2044177"/>
+            <a:ext cx="5664200" cy="646331"/>
+          </a:xfrm>
+          <a:prstGeom prst="rect">
+            <a:avLst/>
+          </a:prstGeom>
+          <a:noFill/>
+        </p:spPr>
+        <p:txBody>
+          <a:bodyPr wrap="square" rtlCol="0">
+            <a:spAutoFit/>
+          </a:bodyPr>
+          <a:lstStyle/>
+          <a:p>
+            <a:pPr marL="285750" indent="-285750">
+              <a:buFont typeface="Wingdings" panose="05000000000000000000" pitchFamily="2" charset="2"/>
+              <a:buChar char="ß"/>
+            </a:pPr>
+            <a:r>
+              <a:rPr lang="ko-KR" altLang="en-US" dirty="0">
+                <a:sym typeface="Wingdings" panose="05000000000000000000" pitchFamily="2" charset="2"/>
+              </a:rPr>
+              <a:t>설정 파일 생성 알림 추가 표현 </a:t>
+            </a:r>
+            <a:endParaRPr lang="en-US" altLang="ko-KR" dirty="0">
+              <a:sym typeface="Wingdings" panose="05000000000000000000" pitchFamily="2" charset="2"/>
+            </a:endParaRPr>
+          </a:p>
+          <a:p>
+            <a:r>
+              <a:rPr lang="en-US" altLang="ko-KR" dirty="0">
+                <a:sym typeface="Wingdings" panose="05000000000000000000" pitchFamily="2" charset="2"/>
+              </a:rPr>
+              <a:t>    (</a:t>
+            </a:r>
+            <a:r>
+              <a:rPr lang="ko-KR" altLang="en-US" dirty="0">
+                <a:sym typeface="Wingdings" panose="05000000000000000000" pitchFamily="2" charset="2"/>
+              </a:rPr>
+              <a:t>박스 표시로 강조</a:t>
+            </a:r>
+            <a:r>
+              <a:rPr lang="en-US" altLang="ko-KR" dirty="0">
+                <a:sym typeface="Wingdings" panose="05000000000000000000" pitchFamily="2" charset="2"/>
+              </a:rPr>
+              <a:t>) </a:t>
+            </a:r>
+            <a:endParaRPr lang="ko-KR" altLang="en-US" dirty="0"/>
+          </a:p>
+        </p:txBody>
+      </p:sp>
+    </p:spTree>
+    <p:extLst>
+      <p:ext uri="{BB962C8B-B14F-4D97-AF65-F5344CB8AC3E}">
+        <p14:creationId xmlns:p14="http://schemas.microsoft.com/office/powerpoint/2010/main" val="4202351708"/>
+      </p:ext>
+    </p:extLst>
+  </p:cSld>
+  <p:clrMapOvr>
+    <a:masterClrMapping/>
+  </p:clrMapOvr>
+</p:sld>
+</file>
+
+<file path=ppt/slides/slide4.xml><?xml version="1.0" encoding="utf-8"?>
 <p:sld xmlns:a="http://schemas.openxmlformats.org/drawingml/2006/main" xmlns:r="http://schemas.openxmlformats.org/officeDocument/2006/relationships" xmlns:p="http://schemas.openxmlformats.org/presentationml/2006/main">
   <p:cSld>
     <p:spTree>
@@ -41565,7 +42555,7 @@
 </p:sld>
 </file>
 
-<file path=ppt/slides/slide4.xml><?xml version="1.0" encoding="utf-8"?>
+<file path=ppt/slides/slide5.xml><?xml version="1.0" encoding="utf-8"?>
 <p:sld xmlns:a="http://schemas.openxmlformats.org/drawingml/2006/main" xmlns:r="http://schemas.openxmlformats.org/officeDocument/2006/relationships" xmlns:p="http://schemas.openxmlformats.org/presentationml/2006/main">
   <p:cSld>
     <p:spTree>
@@ -41731,7 +42721,7 @@
 </p:sld>
 </file>
 
-<file path=ppt/slides/slide5.xml><?xml version="1.0" encoding="utf-8"?>
+<file path=ppt/slides/slide6.xml><?xml version="1.0" encoding="utf-8"?>
 <p:sld xmlns:a="http://schemas.openxmlformats.org/drawingml/2006/main" xmlns:r="http://schemas.openxmlformats.org/officeDocument/2006/relationships" xmlns:p="http://schemas.openxmlformats.org/presentationml/2006/main">
   <p:cSld>
     <p:spTree>
@@ -41817,7 +42807,7 @@
 </p:sld>
 </file>
 
-<file path=ppt/slides/slide6.xml><?xml version="1.0" encoding="utf-8"?>
+<file path=ppt/slides/slide7.xml><?xml version="1.0" encoding="utf-8"?>
 <p:sld xmlns:a="http://schemas.openxmlformats.org/drawingml/2006/main" xmlns:r="http://schemas.openxmlformats.org/officeDocument/2006/relationships" xmlns:p="http://schemas.openxmlformats.org/presentationml/2006/main">
   <p:cSld>
     <p:spTree>
@@ -41882,99 +42872,8 @@
         </p:blipFill>
         <p:spPr>
           <a:xfrm>
-            <a:off x="207650" y="4657603"/>
+            <a:off x="4716150" y="1025403"/>
             <a:ext cx="4333907" cy="1544782"/>
-          </a:xfrm>
-          <a:prstGeom prst="rect">
-            <a:avLst/>
-          </a:prstGeom>
-        </p:spPr>
-      </p:pic>
-      <p:pic>
-        <p:nvPicPr>
-          <p:cNvPr id="6" name="그림 5">
-            <a:extLst>
-              <a:ext uri="{FF2B5EF4-FFF2-40B4-BE49-F238E27FC236}">
-                <a16:creationId xmlns:a16="http://schemas.microsoft.com/office/drawing/2014/main" id="{FC127FFB-6F9B-41DE-A499-C39EB3281D17}"/>
-              </a:ext>
-            </a:extLst>
-          </p:cNvPr>
-          <p:cNvPicPr>
-            <a:picLocks noChangeAspect="1"/>
-          </p:cNvPicPr>
-          <p:nvPr/>
-        </p:nvPicPr>
-        <p:blipFill>
-          <a:blip r:embed="rId3"/>
-          <a:srcRect t="48199"/>
-          <a:stretch>
-            <a:fillRect/>
-          </a:stretch>
-        </p:blipFill>
-        <p:spPr>
-          <a:xfrm>
-            <a:off x="4541557" y="4087092"/>
-            <a:ext cx="4248181" cy="3187434"/>
-          </a:xfrm>
-          <a:prstGeom prst="rect">
-            <a:avLst/>
-          </a:prstGeom>
-        </p:spPr>
-      </p:pic>
-      <p:pic>
-        <p:nvPicPr>
-          <p:cNvPr id="8" name="그림 7">
-            <a:extLst>
-              <a:ext uri="{FF2B5EF4-FFF2-40B4-BE49-F238E27FC236}">
-                <a16:creationId xmlns:a16="http://schemas.microsoft.com/office/drawing/2014/main" id="{5FE4F172-8AD1-5C42-0140-DA4A2BE3DD96}"/>
-              </a:ext>
-            </a:extLst>
-          </p:cNvPr>
-          <p:cNvPicPr>
-            <a:picLocks noChangeAspect="1"/>
-          </p:cNvPicPr>
-          <p:nvPr/>
-        </p:nvPicPr>
-        <p:blipFill>
-          <a:blip r:embed="rId4"/>
-          <a:stretch>
-            <a:fillRect/>
-          </a:stretch>
-        </p:blipFill>
-        <p:spPr>
-          <a:xfrm>
-            <a:off x="4570133" y="6967971"/>
-            <a:ext cx="4305331" cy="2209816"/>
-          </a:xfrm>
-          <a:prstGeom prst="rect">
-            <a:avLst/>
-          </a:prstGeom>
-        </p:spPr>
-      </p:pic>
-      <p:pic>
-        <p:nvPicPr>
-          <p:cNvPr id="10" name="그림 9">
-            <a:extLst>
-              <a:ext uri="{FF2B5EF4-FFF2-40B4-BE49-F238E27FC236}">
-                <a16:creationId xmlns:a16="http://schemas.microsoft.com/office/drawing/2014/main" id="{92735DA8-5C9C-348D-FD57-450DE0508F74}"/>
-              </a:ext>
-            </a:extLst>
-          </p:cNvPr>
-          <p:cNvPicPr>
-            <a:picLocks noChangeAspect="1"/>
-          </p:cNvPicPr>
-          <p:nvPr/>
-        </p:nvPicPr>
-        <p:blipFill>
-          <a:blip r:embed="rId5"/>
-          <a:stretch>
-            <a:fillRect/>
-          </a:stretch>
-        </p:blipFill>
-        <p:spPr>
-          <a:xfrm>
-            <a:off x="7905719" y="180933"/>
-            <a:ext cx="4286281" cy="5581691"/>
           </a:xfrm>
           <a:prstGeom prst="rect">
             <a:avLst/>
@@ -42035,6 +42934,832 @@
         </p:blipFill>
         <p:spPr>
           <a:xfrm>
+            <a:off x="9186846" y="1001101"/>
+            <a:ext cx="4333907" cy="1605032"/>
+          </a:xfrm>
+          <a:prstGeom prst="rect">
+            <a:avLst/>
+          </a:prstGeom>
+        </p:spPr>
+      </p:pic>
+      <p:sp>
+        <p:nvSpPr>
+          <p:cNvPr id="14" name="TextBox 13">
+            <a:extLst>
+              <a:ext uri="{FF2B5EF4-FFF2-40B4-BE49-F238E27FC236}">
+                <a16:creationId xmlns:a16="http://schemas.microsoft.com/office/drawing/2014/main" id="{98207C3C-D8DE-0B0B-7F9C-F476F538AE47}"/>
+              </a:ext>
+            </a:extLst>
+          </p:cNvPr>
+          <p:cNvSpPr txBox="1"/>
+          <p:nvPr/>
+        </p:nvSpPr>
+        <p:spPr>
+          <a:xfrm>
+            <a:off x="4762499" y="2771069"/>
+            <a:ext cx="4730751" cy="1754326"/>
+          </a:xfrm>
+          <a:prstGeom prst="rect">
+            <a:avLst/>
+          </a:prstGeom>
+          <a:noFill/>
+        </p:spPr>
+        <p:txBody>
+          <a:bodyPr wrap="square" rtlCol="0">
+            <a:spAutoFit/>
+          </a:bodyPr>
+          <a:lstStyle/>
+          <a:p>
+            <a:r>
+              <a:rPr lang="en-US" altLang="ko-KR" dirty="0">
+                <a:highlight>
+                  <a:srgbClr val="FFFF00"/>
+                </a:highlight>
+              </a:rPr>
+              <a:t>(</a:t>
+            </a:r>
+            <a:r>
+              <a:rPr lang="ko-KR" altLang="en-US" dirty="0">
+                <a:highlight>
+                  <a:srgbClr val="FFFF00"/>
+                </a:highlight>
+              </a:rPr>
+              <a:t>문의</a:t>
+            </a:r>
+            <a:r>
+              <a:rPr lang="en-US" altLang="ko-KR" dirty="0">
+                <a:highlight>
+                  <a:srgbClr val="FFFF00"/>
+                </a:highlight>
+              </a:rPr>
+              <a:t>) </a:t>
+            </a:r>
+            <a:r>
+              <a:rPr lang="ko-KR" altLang="en-US" dirty="0">
+                <a:highlight>
+                  <a:srgbClr val="FFFF00"/>
+                </a:highlight>
+              </a:rPr>
+              <a:t>선택에 따라 </a:t>
+            </a:r>
+            <a:r>
+              <a:rPr lang="ko-KR" altLang="en-US" dirty="0" err="1">
+                <a:highlight>
+                  <a:srgbClr val="FFFF00"/>
+                </a:highlight>
+              </a:rPr>
+              <a:t>달라지는점은</a:t>
+            </a:r>
+            <a:br>
+              <a:rPr lang="en-US" altLang="ko-KR" dirty="0">
+                <a:highlight>
+                  <a:srgbClr val="FFFF00"/>
+                </a:highlight>
+              </a:rPr>
+            </a:br>
+            <a:r>
+              <a:rPr lang="en-US" altLang="ko-KR" dirty="0">
+                <a:highlight>
+                  <a:srgbClr val="FFFF00"/>
+                </a:highlight>
+              </a:rPr>
+              <a:t>- </a:t>
+            </a:r>
+            <a:r>
+              <a:rPr lang="ko-KR" altLang="en-US" dirty="0">
+                <a:highlight>
+                  <a:srgbClr val="FFFF00"/>
+                </a:highlight>
+              </a:rPr>
+              <a:t>차량 데이터 수집 </a:t>
+            </a:r>
+            <a:r>
+              <a:rPr lang="en-US" altLang="ko-KR" dirty="0">
+                <a:highlight>
+                  <a:srgbClr val="FFFF00"/>
+                </a:highlight>
+              </a:rPr>
+              <a:t>= CAN  viewer</a:t>
+            </a:r>
+          </a:p>
+          <a:p>
+            <a:r>
+              <a:rPr lang="en-US" altLang="ko-KR" dirty="0">
+                <a:highlight>
+                  <a:srgbClr val="FFFF00"/>
+                </a:highlight>
+              </a:rPr>
+              <a:t>- </a:t>
+            </a:r>
+            <a:r>
+              <a:rPr lang="ko-KR" altLang="en-US" dirty="0" err="1">
+                <a:highlight>
+                  <a:srgbClr val="FFFF00"/>
+                </a:highlight>
+              </a:rPr>
+              <a:t>레포지</a:t>
+            </a:r>
+            <a:r>
+              <a:rPr lang="ko-KR" altLang="en-US" dirty="0">
+                <a:highlight>
+                  <a:srgbClr val="FFFF00"/>
+                </a:highlight>
+              </a:rPr>
+              <a:t> 토리에서 보여 지는 항목이 다르게 하였었나요</a:t>
+            </a:r>
+            <a:r>
+              <a:rPr lang="en-US" altLang="ko-KR" dirty="0">
+                <a:highlight>
+                  <a:srgbClr val="FFFF00"/>
+                </a:highlight>
+              </a:rPr>
+              <a:t>?</a:t>
+            </a:r>
+            <a:br>
+              <a:rPr lang="en-US" altLang="ko-KR" dirty="0">
+                <a:highlight>
+                  <a:srgbClr val="FFFF00"/>
+                </a:highlight>
+              </a:rPr>
+            </a:br>
+            <a:br>
+              <a:rPr lang="en-US" altLang="ko-KR" dirty="0">
+                <a:highlight>
+                  <a:srgbClr val="FFFF00"/>
+                </a:highlight>
+              </a:rPr>
+            </a:br>
+            <a:r>
+              <a:rPr lang="en-US" altLang="ko-KR" dirty="0">
+                <a:highlight>
+                  <a:srgbClr val="FFFF00"/>
+                </a:highlight>
+              </a:rPr>
+              <a:t>* </a:t>
+            </a:r>
+            <a:r>
+              <a:rPr lang="ko-KR" altLang="en-US" dirty="0">
+                <a:highlight>
+                  <a:srgbClr val="FFFF00"/>
+                </a:highlight>
+              </a:rPr>
+              <a:t>파악 후 설명 문구 전달 드리겠습니다</a:t>
+            </a:r>
+            <a:r>
+              <a:rPr lang="en-US" altLang="ko-KR" dirty="0">
+                <a:highlight>
+                  <a:srgbClr val="FFFF00"/>
+                </a:highlight>
+              </a:rPr>
+              <a:t>.</a:t>
+            </a:r>
+          </a:p>
+        </p:txBody>
+      </p:sp>
+      <p:sp>
+        <p:nvSpPr>
+          <p:cNvPr id="15" name="직사각형 14">
+            <a:extLst>
+              <a:ext uri="{FF2B5EF4-FFF2-40B4-BE49-F238E27FC236}">
+                <a16:creationId xmlns:a16="http://schemas.microsoft.com/office/drawing/2014/main" id="{AFECB066-6B82-9680-532F-47556D50ECA3}"/>
+              </a:ext>
+            </a:extLst>
+          </p:cNvPr>
+          <p:cNvSpPr/>
+          <p:nvPr/>
+        </p:nvSpPr>
+        <p:spPr>
+          <a:xfrm>
+            <a:off x="5021034" y="1570200"/>
+            <a:ext cx="3449866" cy="180459"/>
+          </a:xfrm>
+          <a:prstGeom prst="rect">
+            <a:avLst/>
+          </a:prstGeom>
+          <a:noFill/>
+          <a:ln>
+            <a:solidFill>
+              <a:srgbClr val="C00000"/>
+            </a:solidFill>
+            <a:prstDash val="sysDash"/>
+          </a:ln>
+        </p:spPr>
+        <p:style>
+          <a:lnRef idx="2">
+            <a:schemeClr val="accent1">
+              <a:shade val="15000"/>
+            </a:schemeClr>
+          </a:lnRef>
+          <a:fillRef idx="1">
+            <a:schemeClr val="accent1"/>
+          </a:fillRef>
+          <a:effectRef idx="0">
+            <a:schemeClr val="accent1"/>
+          </a:effectRef>
+          <a:fontRef idx="minor">
+            <a:schemeClr val="lt1"/>
+          </a:fontRef>
+        </p:style>
+        <p:txBody>
+          <a:bodyPr rtlCol="0" anchor="ctr"/>
+          <a:lstStyle/>
+          <a:p>
+            <a:pPr algn="ctr"/>
+            <a:endParaRPr lang="ko-KR" altLang="en-US" dirty="0"/>
+          </a:p>
+        </p:txBody>
+      </p:sp>
+      <p:sp>
+        <p:nvSpPr>
+          <p:cNvPr id="16" name="TextBox 15">
+            <a:extLst>
+              <a:ext uri="{FF2B5EF4-FFF2-40B4-BE49-F238E27FC236}">
+                <a16:creationId xmlns:a16="http://schemas.microsoft.com/office/drawing/2014/main" id="{9B6F4B20-A4A0-A12D-B811-C2B2E05E12EC}"/>
+              </a:ext>
+            </a:extLst>
+          </p:cNvPr>
+          <p:cNvSpPr txBox="1"/>
+          <p:nvPr/>
+        </p:nvSpPr>
+        <p:spPr>
+          <a:xfrm>
+            <a:off x="9493250" y="2771069"/>
+            <a:ext cx="4730751" cy="1200329"/>
+          </a:xfrm>
+          <a:prstGeom prst="rect">
+            <a:avLst/>
+          </a:prstGeom>
+          <a:noFill/>
+        </p:spPr>
+        <p:txBody>
+          <a:bodyPr wrap="square" rtlCol="0">
+            <a:spAutoFit/>
+          </a:bodyPr>
+          <a:lstStyle/>
+          <a:p>
+            <a:r>
+              <a:rPr lang="en-US" altLang="ko-KR" dirty="0">
+                <a:highlight>
+                  <a:srgbClr val="FFFF00"/>
+                </a:highlight>
+              </a:rPr>
+              <a:t>(</a:t>
+            </a:r>
+            <a:r>
+              <a:rPr lang="ko-KR" altLang="en-US" dirty="0">
+                <a:highlight>
+                  <a:srgbClr val="FFFF00"/>
+                </a:highlight>
+              </a:rPr>
+              <a:t>문의</a:t>
+            </a:r>
+            <a:r>
+              <a:rPr lang="en-US" altLang="ko-KR" dirty="0">
+                <a:highlight>
+                  <a:srgbClr val="FFFF00"/>
+                </a:highlight>
+              </a:rPr>
+              <a:t>) </a:t>
+            </a:r>
+            <a:r>
+              <a:rPr lang="ko-KR" altLang="en-US" dirty="0">
+                <a:highlight>
+                  <a:srgbClr val="FFFF00"/>
+                </a:highlight>
+              </a:rPr>
+              <a:t>선택에 따라 </a:t>
+            </a:r>
+            <a:r>
+              <a:rPr lang="ko-KR" altLang="en-US" dirty="0" err="1">
+                <a:highlight>
+                  <a:srgbClr val="FFFF00"/>
+                </a:highlight>
+              </a:rPr>
+              <a:t>달라지는점은</a:t>
+            </a:r>
+            <a:br>
+              <a:rPr lang="en-US" altLang="ko-KR" dirty="0">
+                <a:highlight>
+                  <a:srgbClr val="FFFF00"/>
+                </a:highlight>
+              </a:rPr>
+            </a:br>
+            <a:r>
+              <a:rPr lang="en-US" altLang="ko-KR" dirty="0">
+                <a:highlight>
+                  <a:srgbClr val="FFFF00"/>
+                </a:highlight>
+              </a:rPr>
+              <a:t>- </a:t>
+            </a:r>
+            <a:r>
+              <a:rPr lang="ko-KR" altLang="en-US" dirty="0" err="1">
+                <a:highlight>
+                  <a:srgbClr val="FFFF00"/>
+                </a:highlight>
+              </a:rPr>
+              <a:t>레포지</a:t>
+            </a:r>
+            <a:r>
+              <a:rPr lang="ko-KR" altLang="en-US" dirty="0">
+                <a:highlight>
+                  <a:srgbClr val="FFFF00"/>
+                </a:highlight>
+              </a:rPr>
+              <a:t> 토리에서 보여 지는 항목이 다르게 하였었나요</a:t>
+            </a:r>
+            <a:r>
+              <a:rPr lang="en-US" altLang="ko-KR" dirty="0">
+                <a:highlight>
+                  <a:srgbClr val="FFFF00"/>
+                </a:highlight>
+              </a:rPr>
+              <a:t>?</a:t>
+            </a:r>
+            <a:br>
+              <a:rPr lang="en-US" altLang="ko-KR" dirty="0">
+                <a:highlight>
+                  <a:srgbClr val="FFFF00"/>
+                </a:highlight>
+              </a:rPr>
+            </a:br>
+            <a:endParaRPr lang="en-US" altLang="ko-KR" dirty="0">
+              <a:highlight>
+                <a:srgbClr val="FFFF00"/>
+              </a:highlight>
+            </a:endParaRPr>
+          </a:p>
+        </p:txBody>
+      </p:sp>
+    </p:spTree>
+    <p:extLst>
+      <p:ext uri="{BB962C8B-B14F-4D97-AF65-F5344CB8AC3E}">
+        <p14:creationId xmlns:p14="http://schemas.microsoft.com/office/powerpoint/2010/main" val="1983847626"/>
+      </p:ext>
+    </p:extLst>
+  </p:cSld>
+  <p:clrMapOvr>
+    <a:masterClrMapping/>
+  </p:clrMapOvr>
+</p:sld>
+</file>
+
+<file path=ppt/slides/slide8.xml><?xml version="1.0" encoding="utf-8"?>
+<p:sld xmlns:a="http://schemas.openxmlformats.org/drawingml/2006/main" xmlns:r="http://schemas.openxmlformats.org/officeDocument/2006/relationships" xmlns:p="http://schemas.openxmlformats.org/presentationml/2006/main">
+  <p:cSld>
+    <p:spTree>
+      <p:nvGrpSpPr>
+        <p:cNvPr id="1" name="">
+          <a:extLst>
+            <a:ext uri="{FF2B5EF4-FFF2-40B4-BE49-F238E27FC236}">
+              <a16:creationId xmlns:a16="http://schemas.microsoft.com/office/drawing/2014/main" id="{43526000-5925-50CD-1F11-95E1FDB5F8BF}"/>
+            </a:ext>
+          </a:extLst>
+        </p:cNvPr>
+        <p:cNvGrpSpPr/>
+        <p:nvPr/>
+      </p:nvGrpSpPr>
+      <p:grpSpPr>
+        <a:xfrm>
+          <a:off x="0" y="0"/>
+          <a:ext cx="0" cy="0"/>
+          <a:chOff x="0" y="0"/>
+          <a:chExt cx="0" cy="0"/>
+        </a:xfrm>
+      </p:grpSpPr>
+      <p:sp>
+        <p:nvSpPr>
+          <p:cNvPr id="2" name="제목 1">
+            <a:extLst>
+              <a:ext uri="{FF2B5EF4-FFF2-40B4-BE49-F238E27FC236}">
+                <a16:creationId xmlns:a16="http://schemas.microsoft.com/office/drawing/2014/main" id="{D4AA3A61-216E-AE8E-B4F6-9DC84106F158}"/>
+              </a:ext>
+            </a:extLst>
+          </p:cNvPr>
+          <p:cNvSpPr>
+            <a:spLocks noGrp="1"/>
+          </p:cNvSpPr>
+          <p:nvPr>
+            <p:ph type="title"/>
+          </p:nvPr>
+        </p:nvSpPr>
+        <p:spPr/>
+        <p:txBody>
+          <a:bodyPr/>
+          <a:lstStyle/>
+          <a:p>
+            <a:endParaRPr lang="ko-KR" altLang="en-US"/>
+          </a:p>
+        </p:txBody>
+      </p:sp>
+      <p:pic>
+        <p:nvPicPr>
+          <p:cNvPr id="6" name="그림 5">
+            <a:extLst>
+              <a:ext uri="{FF2B5EF4-FFF2-40B4-BE49-F238E27FC236}">
+                <a16:creationId xmlns:a16="http://schemas.microsoft.com/office/drawing/2014/main" id="{B845D697-C236-3D8B-C60C-A557E44532D6}"/>
+              </a:ext>
+            </a:extLst>
+          </p:cNvPr>
+          <p:cNvPicPr>
+            <a:picLocks noChangeAspect="1"/>
+          </p:cNvPicPr>
+          <p:nvPr/>
+        </p:nvPicPr>
+        <p:blipFill>
+          <a:blip r:embed="rId2"/>
+          <a:srcRect t="48199"/>
+          <a:stretch>
+            <a:fillRect/>
+          </a:stretch>
+        </p:blipFill>
+        <p:spPr>
+          <a:xfrm>
+            <a:off x="4528857" y="997517"/>
+            <a:ext cx="4248181" cy="3187434"/>
+          </a:xfrm>
+          <a:prstGeom prst="rect">
+            <a:avLst/>
+          </a:prstGeom>
+        </p:spPr>
+      </p:pic>
+      <p:pic>
+        <p:nvPicPr>
+          <p:cNvPr id="8" name="그림 7">
+            <a:extLst>
+              <a:ext uri="{FF2B5EF4-FFF2-40B4-BE49-F238E27FC236}">
+                <a16:creationId xmlns:a16="http://schemas.microsoft.com/office/drawing/2014/main" id="{7C0EF117-428F-9EDD-E27F-AA9FBB041137}"/>
+              </a:ext>
+            </a:extLst>
+          </p:cNvPr>
+          <p:cNvPicPr>
+            <a:picLocks noChangeAspect="1"/>
+          </p:cNvPicPr>
+          <p:nvPr/>
+        </p:nvPicPr>
+        <p:blipFill>
+          <a:blip r:embed="rId3"/>
+          <a:stretch>
+            <a:fillRect/>
+          </a:stretch>
+        </p:blipFill>
+        <p:spPr>
+          <a:xfrm>
+            <a:off x="8926233" y="997517"/>
+            <a:ext cx="4305331" cy="2209816"/>
+          </a:xfrm>
+          <a:prstGeom prst="rect">
+            <a:avLst/>
+          </a:prstGeom>
+        </p:spPr>
+      </p:pic>
+      <p:pic>
+        <p:nvPicPr>
+          <p:cNvPr id="13" name="그림 12">
+            <a:extLst>
+              <a:ext uri="{FF2B5EF4-FFF2-40B4-BE49-F238E27FC236}">
+                <a16:creationId xmlns:a16="http://schemas.microsoft.com/office/drawing/2014/main" id="{354B6CF4-6333-8CF0-DFD3-6D7C39B090C5}"/>
+              </a:ext>
+            </a:extLst>
+          </p:cNvPr>
+          <p:cNvPicPr>
+            <a:picLocks noChangeAspect="1"/>
+          </p:cNvPicPr>
+          <p:nvPr/>
+        </p:nvPicPr>
+        <p:blipFill>
+          <a:blip r:embed="rId2"/>
+          <a:srcRect b="51379"/>
+          <a:stretch>
+            <a:fillRect/>
+          </a:stretch>
+        </p:blipFill>
+        <p:spPr>
+          <a:xfrm>
+            <a:off x="83857" y="1095376"/>
+            <a:ext cx="4248181" cy="2991716"/>
+          </a:xfrm>
+          <a:prstGeom prst="rect">
+            <a:avLst/>
+          </a:prstGeom>
+        </p:spPr>
+      </p:pic>
+      <p:sp>
+        <p:nvSpPr>
+          <p:cNvPr id="3" name="직사각형 2">
+            <a:extLst>
+              <a:ext uri="{FF2B5EF4-FFF2-40B4-BE49-F238E27FC236}">
+                <a16:creationId xmlns:a16="http://schemas.microsoft.com/office/drawing/2014/main" id="{60232472-F08E-ABF8-CCA6-ADC50821946D}"/>
+              </a:ext>
+            </a:extLst>
+          </p:cNvPr>
+          <p:cNvSpPr/>
+          <p:nvPr/>
+        </p:nvSpPr>
+        <p:spPr>
+          <a:xfrm>
+            <a:off x="882172" y="4948400"/>
+            <a:ext cx="4305778" cy="474500"/>
+          </a:xfrm>
+          <a:prstGeom prst="rect">
+            <a:avLst/>
+          </a:prstGeom>
+          <a:noFill/>
+          <a:ln>
+            <a:solidFill>
+              <a:srgbClr val="C00000"/>
+            </a:solidFill>
+            <a:prstDash val="sysDash"/>
+          </a:ln>
+        </p:spPr>
+        <p:style>
+          <a:lnRef idx="2">
+            <a:schemeClr val="accent1">
+              <a:shade val="15000"/>
+            </a:schemeClr>
+          </a:lnRef>
+          <a:fillRef idx="1">
+            <a:schemeClr val="accent1"/>
+          </a:fillRef>
+          <a:effectRef idx="0">
+            <a:schemeClr val="accent1"/>
+          </a:effectRef>
+          <a:fontRef idx="minor">
+            <a:schemeClr val="lt1"/>
+          </a:fontRef>
+        </p:style>
+        <p:txBody>
+          <a:bodyPr rtlCol="0" anchor="ctr"/>
+          <a:lstStyle/>
+          <a:p>
+            <a:pPr algn="ctr"/>
+            <a:r>
+              <a:rPr lang="ko-KR" altLang="en-US" dirty="0">
+                <a:solidFill>
+                  <a:schemeClr val="bg1">
+                    <a:lumMod val="50000"/>
+                  </a:schemeClr>
+                </a:solidFill>
+              </a:rPr>
+              <a:t>장비내 파일 탐색기 활용 됩니다</a:t>
+            </a:r>
+            <a:r>
+              <a:rPr lang="en-US" altLang="ko-KR" dirty="0">
+                <a:solidFill>
+                  <a:schemeClr val="bg1">
+                    <a:lumMod val="50000"/>
+                  </a:schemeClr>
+                </a:solidFill>
+              </a:rPr>
+              <a:t>. </a:t>
+            </a:r>
+            <a:endParaRPr lang="ko-KR" altLang="en-US" dirty="0">
+              <a:solidFill>
+                <a:schemeClr val="bg1">
+                  <a:lumMod val="50000"/>
+                </a:schemeClr>
+              </a:solidFill>
+            </a:endParaRPr>
+          </a:p>
+        </p:txBody>
+      </p:sp>
+    </p:spTree>
+    <p:extLst>
+      <p:ext uri="{BB962C8B-B14F-4D97-AF65-F5344CB8AC3E}">
+        <p14:creationId xmlns:p14="http://schemas.microsoft.com/office/powerpoint/2010/main" val="3863440157"/>
+      </p:ext>
+    </p:extLst>
+  </p:cSld>
+  <p:clrMapOvr>
+    <a:masterClrMapping/>
+  </p:clrMapOvr>
+</p:sld>
+</file>
+
+<file path=ppt/slides/slide9.xml><?xml version="1.0" encoding="utf-8"?>
+<p:sld xmlns:a="http://schemas.openxmlformats.org/drawingml/2006/main" xmlns:r="http://schemas.openxmlformats.org/officeDocument/2006/relationships" xmlns:p="http://schemas.openxmlformats.org/presentationml/2006/main">
+  <p:cSld>
+    <p:spTree>
+      <p:nvGrpSpPr>
+        <p:cNvPr id="1" name="">
+          <a:extLst>
+            <a:ext uri="{FF2B5EF4-FFF2-40B4-BE49-F238E27FC236}">
+              <a16:creationId xmlns:a16="http://schemas.microsoft.com/office/drawing/2014/main" id="{D2F59DA8-6EB5-D1DF-F3F2-863231B123D3}"/>
+            </a:ext>
+          </a:extLst>
+        </p:cNvPr>
+        <p:cNvGrpSpPr/>
+        <p:nvPr/>
+      </p:nvGrpSpPr>
+      <p:grpSpPr>
+        <a:xfrm>
+          <a:off x="0" y="0"/>
+          <a:ext cx="0" cy="0"/>
+          <a:chOff x="0" y="0"/>
+          <a:chExt cx="0" cy="0"/>
+        </a:xfrm>
+      </p:grpSpPr>
+      <p:sp>
+        <p:nvSpPr>
+          <p:cNvPr id="2" name="제목 1">
+            <a:extLst>
+              <a:ext uri="{FF2B5EF4-FFF2-40B4-BE49-F238E27FC236}">
+                <a16:creationId xmlns:a16="http://schemas.microsoft.com/office/drawing/2014/main" id="{695C423C-55EB-11F0-6F2C-E759A1DE9565}"/>
+              </a:ext>
+            </a:extLst>
+          </p:cNvPr>
+          <p:cNvSpPr>
+            <a:spLocks noGrp="1"/>
+          </p:cNvSpPr>
+          <p:nvPr>
+            <p:ph type="title"/>
+          </p:nvPr>
+        </p:nvSpPr>
+        <p:spPr/>
+        <p:txBody>
+          <a:bodyPr/>
+          <a:lstStyle/>
+          <a:p>
+            <a:endParaRPr lang="ko-KR" altLang="en-US"/>
+          </a:p>
+        </p:txBody>
+      </p:sp>
+      <p:pic>
+        <p:nvPicPr>
+          <p:cNvPr id="4" name="그림 3">
+            <a:extLst>
+              <a:ext uri="{FF2B5EF4-FFF2-40B4-BE49-F238E27FC236}">
+                <a16:creationId xmlns:a16="http://schemas.microsoft.com/office/drawing/2014/main" id="{7C6C6874-D593-7ADA-8954-ED08CC6AAAAC}"/>
+              </a:ext>
+            </a:extLst>
+          </p:cNvPr>
+          <p:cNvPicPr>
+            <a:picLocks noChangeAspect="1"/>
+          </p:cNvPicPr>
+          <p:nvPr/>
+        </p:nvPicPr>
+        <p:blipFill>
+          <a:blip r:embed="rId2"/>
+          <a:srcRect t="53795" b="23331"/>
+          <a:stretch>
+            <a:fillRect/>
+          </a:stretch>
+        </p:blipFill>
+        <p:spPr>
+          <a:xfrm>
+            <a:off x="207650" y="4657603"/>
+            <a:ext cx="4333907" cy="1544782"/>
+          </a:xfrm>
+          <a:prstGeom prst="rect">
+            <a:avLst/>
+          </a:prstGeom>
+        </p:spPr>
+      </p:pic>
+      <p:pic>
+        <p:nvPicPr>
+          <p:cNvPr id="6" name="그림 5">
+            <a:extLst>
+              <a:ext uri="{FF2B5EF4-FFF2-40B4-BE49-F238E27FC236}">
+                <a16:creationId xmlns:a16="http://schemas.microsoft.com/office/drawing/2014/main" id="{3FA6B0C8-97A8-2EF8-0BC3-A89525CC46CB}"/>
+              </a:ext>
+            </a:extLst>
+          </p:cNvPr>
+          <p:cNvPicPr>
+            <a:picLocks noChangeAspect="1"/>
+          </p:cNvPicPr>
+          <p:nvPr/>
+        </p:nvPicPr>
+        <p:blipFill>
+          <a:blip r:embed="rId3"/>
+          <a:srcRect t="48199"/>
+          <a:stretch>
+            <a:fillRect/>
+          </a:stretch>
+        </p:blipFill>
+        <p:spPr>
+          <a:xfrm>
+            <a:off x="4541557" y="4087092"/>
+            <a:ext cx="4248181" cy="3187434"/>
+          </a:xfrm>
+          <a:prstGeom prst="rect">
+            <a:avLst/>
+          </a:prstGeom>
+        </p:spPr>
+      </p:pic>
+      <p:pic>
+        <p:nvPicPr>
+          <p:cNvPr id="8" name="그림 7">
+            <a:extLst>
+              <a:ext uri="{FF2B5EF4-FFF2-40B4-BE49-F238E27FC236}">
+                <a16:creationId xmlns:a16="http://schemas.microsoft.com/office/drawing/2014/main" id="{2701C9C8-E61E-2E12-D266-F2A8CEB4FD77}"/>
+              </a:ext>
+            </a:extLst>
+          </p:cNvPr>
+          <p:cNvPicPr>
+            <a:picLocks noChangeAspect="1"/>
+          </p:cNvPicPr>
+          <p:nvPr/>
+        </p:nvPicPr>
+        <p:blipFill>
+          <a:blip r:embed="rId4"/>
+          <a:stretch>
+            <a:fillRect/>
+          </a:stretch>
+        </p:blipFill>
+        <p:spPr>
+          <a:xfrm>
+            <a:off x="4570133" y="6967971"/>
+            <a:ext cx="4305331" cy="2209816"/>
+          </a:xfrm>
+          <a:prstGeom prst="rect">
+            <a:avLst/>
+          </a:prstGeom>
+        </p:spPr>
+      </p:pic>
+      <p:pic>
+        <p:nvPicPr>
+          <p:cNvPr id="10" name="그림 9">
+            <a:extLst>
+              <a:ext uri="{FF2B5EF4-FFF2-40B4-BE49-F238E27FC236}">
+                <a16:creationId xmlns:a16="http://schemas.microsoft.com/office/drawing/2014/main" id="{C1D47F4E-42E2-8C2C-5C7F-01E5F29AA422}"/>
+              </a:ext>
+            </a:extLst>
+          </p:cNvPr>
+          <p:cNvPicPr>
+            <a:picLocks noChangeAspect="1"/>
+          </p:cNvPicPr>
+          <p:nvPr/>
+        </p:nvPicPr>
+        <p:blipFill>
+          <a:blip r:embed="rId5"/>
+          <a:stretch>
+            <a:fillRect/>
+          </a:stretch>
+        </p:blipFill>
+        <p:spPr>
+          <a:xfrm>
+            <a:off x="7905719" y="180933"/>
+            <a:ext cx="4286281" cy="5581691"/>
+          </a:xfrm>
+          <a:prstGeom prst="rect">
+            <a:avLst/>
+          </a:prstGeom>
+        </p:spPr>
+      </p:pic>
+      <p:pic>
+        <p:nvPicPr>
+          <p:cNvPr id="11" name="그림 10">
+            <a:extLst>
+              <a:ext uri="{FF2B5EF4-FFF2-40B4-BE49-F238E27FC236}">
+                <a16:creationId xmlns:a16="http://schemas.microsoft.com/office/drawing/2014/main" id="{268C36DC-72E7-DE21-BB45-CC921BE2AB29}"/>
+              </a:ext>
+            </a:extLst>
+          </p:cNvPr>
+          <p:cNvPicPr>
+            <a:picLocks noChangeAspect="1"/>
+          </p:cNvPicPr>
+          <p:nvPr/>
+        </p:nvPicPr>
+        <p:blipFill>
+          <a:blip r:embed="rId2"/>
+          <a:srcRect b="45959"/>
+          <a:stretch>
+            <a:fillRect/>
+          </a:stretch>
+        </p:blipFill>
+        <p:spPr>
+          <a:xfrm>
+            <a:off x="207650" y="946318"/>
+            <a:ext cx="4333907" cy="3649503"/>
+          </a:xfrm>
+          <a:prstGeom prst="rect">
+            <a:avLst/>
+          </a:prstGeom>
+        </p:spPr>
+      </p:pic>
+      <p:pic>
+        <p:nvPicPr>
+          <p:cNvPr id="12" name="그림 11">
+            <a:extLst>
+              <a:ext uri="{FF2B5EF4-FFF2-40B4-BE49-F238E27FC236}">
+                <a16:creationId xmlns:a16="http://schemas.microsoft.com/office/drawing/2014/main" id="{AC550799-BF56-449B-43FB-0642AB0EE9BB}"/>
+              </a:ext>
+            </a:extLst>
+          </p:cNvPr>
+          <p:cNvPicPr>
+            <a:picLocks noChangeAspect="1"/>
+          </p:cNvPicPr>
+          <p:nvPr/>
+        </p:nvPicPr>
+        <p:blipFill>
+          <a:blip r:embed="rId2"/>
+          <a:srcRect t="76233"/>
+          <a:stretch>
+            <a:fillRect/>
+          </a:stretch>
+        </p:blipFill>
+        <p:spPr>
+          <a:xfrm>
             <a:off x="207650" y="6624832"/>
             <a:ext cx="4333907" cy="1605032"/>
           </a:xfrm>
@@ -42048,7 +43773,7 @@
           <p:cNvPr id="13" name="그림 12">
             <a:extLst>
               <a:ext uri="{FF2B5EF4-FFF2-40B4-BE49-F238E27FC236}">
-                <a16:creationId xmlns:a16="http://schemas.microsoft.com/office/drawing/2014/main" id="{1C9043BD-C001-5B13-4D1A-9C757CE0088D}"/>
+                <a16:creationId xmlns:a16="http://schemas.microsoft.com/office/drawing/2014/main" id="{D5A8B3AC-E6FE-EBF6-EB2B-1EA6814161EF}"/>
               </a:ext>
             </a:extLst>
           </p:cNvPr>
@@ -42077,394 +43802,7 @@
     </p:spTree>
     <p:extLst>
       <p:ext uri="{BB962C8B-B14F-4D97-AF65-F5344CB8AC3E}">
-        <p14:creationId xmlns:p14="http://schemas.microsoft.com/office/powerpoint/2010/main" val="1983847626"/>
-      </p:ext>
-    </p:extLst>
-  </p:cSld>
-  <p:clrMapOvr>
-    <a:masterClrMapping/>
-  </p:clrMapOvr>
-</p:sld>
-</file>
-
-<file path=ppt/slides/slide7.xml><?xml version="1.0" encoding="utf-8"?>
-<p:sld xmlns:a="http://schemas.openxmlformats.org/drawingml/2006/main" xmlns:r="http://schemas.openxmlformats.org/officeDocument/2006/relationships" xmlns:p="http://schemas.openxmlformats.org/presentationml/2006/main">
-  <p:cSld>
-    <p:spTree>
-      <p:nvGrpSpPr>
-        <p:cNvPr id="1" name=""/>
-        <p:cNvGrpSpPr/>
-        <p:nvPr/>
-      </p:nvGrpSpPr>
-      <p:grpSpPr>
-        <a:xfrm>
-          <a:off x="0" y="0"/>
-          <a:ext cx="0" cy="0"/>
-          <a:chOff x="0" y="0"/>
-          <a:chExt cx="0" cy="0"/>
-        </a:xfrm>
-      </p:grpSpPr>
-      <p:sp>
-        <p:nvSpPr>
-          <p:cNvPr id="2" name="제목 1">
-            <a:extLst>
-              <a:ext uri="{FF2B5EF4-FFF2-40B4-BE49-F238E27FC236}">
-                <a16:creationId xmlns:a16="http://schemas.microsoft.com/office/drawing/2014/main" id="{D5A1BA7F-CD92-ACF2-5B13-F456190790AC}"/>
-              </a:ext>
-            </a:extLst>
-          </p:cNvPr>
-          <p:cNvSpPr>
-            <a:spLocks noGrp="1"/>
-          </p:cNvSpPr>
-          <p:nvPr>
-            <p:ph type="title"/>
-          </p:nvPr>
-        </p:nvSpPr>
-        <p:spPr/>
-        <p:txBody>
-          <a:bodyPr/>
-          <a:lstStyle/>
-          <a:p>
-            <a:endParaRPr lang="ko-KR" altLang="en-US"/>
-          </a:p>
-        </p:txBody>
-      </p:sp>
-      <p:pic>
-        <p:nvPicPr>
-          <p:cNvPr id="4" name="그림 3">
-            <a:extLst>
-              <a:ext uri="{FF2B5EF4-FFF2-40B4-BE49-F238E27FC236}">
-                <a16:creationId xmlns:a16="http://schemas.microsoft.com/office/drawing/2014/main" id="{E8B297AB-20D8-0B14-8D8A-CAAF32A032DE}"/>
-              </a:ext>
-            </a:extLst>
-          </p:cNvPr>
-          <p:cNvPicPr>
-            <a:picLocks noChangeAspect="1"/>
-          </p:cNvPicPr>
-          <p:nvPr/>
-        </p:nvPicPr>
-        <p:blipFill>
-          <a:blip r:embed="rId2"/>
-          <a:stretch>
-            <a:fillRect/>
-          </a:stretch>
-        </p:blipFill>
-        <p:spPr>
-          <a:xfrm>
-            <a:off x="0" y="28163"/>
-            <a:ext cx="12192000" cy="6801674"/>
-          </a:xfrm>
-          <a:prstGeom prst="rect">
-            <a:avLst/>
-          </a:prstGeom>
-        </p:spPr>
-      </p:pic>
-      <p:sp>
-        <p:nvSpPr>
-          <p:cNvPr id="5" name="직사각형 4">
-            <a:extLst>
-              <a:ext uri="{FF2B5EF4-FFF2-40B4-BE49-F238E27FC236}">
-                <a16:creationId xmlns:a16="http://schemas.microsoft.com/office/drawing/2014/main" id="{87597391-AF5F-C774-31F8-B1E520AE5465}"/>
-              </a:ext>
-            </a:extLst>
-          </p:cNvPr>
-          <p:cNvSpPr/>
-          <p:nvPr/>
-        </p:nvSpPr>
-        <p:spPr>
-          <a:xfrm>
-            <a:off x="10655687" y="147241"/>
-            <a:ext cx="1159847" cy="297260"/>
-          </a:xfrm>
-          <a:prstGeom prst="rect">
-            <a:avLst/>
-          </a:prstGeom>
-          <a:solidFill>
-            <a:srgbClr val="F2F2F2"/>
-          </a:solidFill>
-          <a:ln>
-            <a:noFill/>
-          </a:ln>
-        </p:spPr>
-        <p:style>
-          <a:lnRef idx="2">
-            <a:schemeClr val="accent1">
-              <a:shade val="50000"/>
-            </a:schemeClr>
-          </a:lnRef>
-          <a:fillRef idx="1">
-            <a:schemeClr val="accent1"/>
-          </a:fillRef>
-          <a:effectRef idx="0">
-            <a:schemeClr val="accent1"/>
-          </a:effectRef>
-          <a:fontRef idx="minor">
-            <a:schemeClr val="lt1"/>
-          </a:fontRef>
-        </p:style>
-        <p:txBody>
-          <a:bodyPr rtlCol="0" anchor="ctr"/>
-          <a:lstStyle/>
-          <a:p>
-            <a:pPr marL="0" marR="0" lvl="0" indent="0" algn="ctr" defTabSz="914400" rtl="0" eaLnBrk="1" fontAlgn="auto" latinLnBrk="1" hangingPunct="1">
-              <a:lnSpc>
-                <a:spcPct val="100000"/>
-              </a:lnSpc>
-              <a:spcBef>
-                <a:spcPts val="0"/>
-              </a:spcBef>
-              <a:spcAft>
-                <a:spcPts val="0"/>
-              </a:spcAft>
-              <a:buClrTx/>
-              <a:buSzTx/>
-              <a:buFontTx/>
-              <a:buNone/>
-              <a:tabLst/>
-              <a:defRPr/>
-            </a:pPr>
-            <a:endParaRPr kumimoji="0" lang="ko-KR" altLang="en-US" sz="1800" b="0" i="0" u="none" strike="noStrike" kern="1200" cap="none" spc="0" normalizeH="0" baseline="0" noProof="0">
-              <a:ln>
-                <a:noFill/>
-              </a:ln>
-              <a:solidFill>
-                <a:prstClr val="white"/>
-              </a:solidFill>
-              <a:effectLst/>
-              <a:uLnTx/>
-              <a:uFillTx/>
-              <a:latin typeface="Montserrat" pitchFamily="2" charset="0"/>
-              <a:ea typeface="맑은 고딕" panose="020B0503020000020004" pitchFamily="50" charset="-127"/>
-              <a:cs typeface="+mn-cs"/>
-            </a:endParaRPr>
-          </a:p>
-        </p:txBody>
-      </p:sp>
-    </p:spTree>
-    <p:extLst>
-      <p:ext uri="{BB962C8B-B14F-4D97-AF65-F5344CB8AC3E}">
-        <p14:creationId xmlns:p14="http://schemas.microsoft.com/office/powerpoint/2010/main" val="333529903"/>
-      </p:ext>
-    </p:extLst>
-  </p:cSld>
-  <p:clrMapOvr>
-    <a:masterClrMapping/>
-  </p:clrMapOvr>
-</p:sld>
-</file>
-
-<file path=ppt/slides/slide8.xml><?xml version="1.0" encoding="utf-8"?>
-<p:sld xmlns:a="http://schemas.openxmlformats.org/drawingml/2006/main" xmlns:r="http://schemas.openxmlformats.org/officeDocument/2006/relationships" xmlns:p="http://schemas.openxmlformats.org/presentationml/2006/main">
-  <p:cSld>
-    <p:spTree>
-      <p:nvGrpSpPr>
-        <p:cNvPr id="1" name=""/>
-        <p:cNvGrpSpPr/>
-        <p:nvPr/>
-      </p:nvGrpSpPr>
-      <p:grpSpPr>
-        <a:xfrm>
-          <a:off x="0" y="0"/>
-          <a:ext cx="0" cy="0"/>
-          <a:chOff x="0" y="0"/>
-          <a:chExt cx="0" cy="0"/>
-        </a:xfrm>
-      </p:grpSpPr>
-      <p:sp>
-        <p:nvSpPr>
-          <p:cNvPr id="2" name="제목 1">
-            <a:extLst>
-              <a:ext uri="{FF2B5EF4-FFF2-40B4-BE49-F238E27FC236}">
-                <a16:creationId xmlns:a16="http://schemas.microsoft.com/office/drawing/2014/main" id="{C806619F-2430-DB69-E007-F8C44168B1F1}"/>
-              </a:ext>
-            </a:extLst>
-          </p:cNvPr>
-          <p:cNvSpPr>
-            <a:spLocks noGrp="1"/>
-          </p:cNvSpPr>
-          <p:nvPr>
-            <p:ph type="title"/>
-          </p:nvPr>
-        </p:nvSpPr>
-        <p:spPr/>
-        <p:txBody>
-          <a:bodyPr/>
-          <a:lstStyle/>
-          <a:p>
-            <a:endParaRPr lang="ko-KR" altLang="en-US"/>
-          </a:p>
-        </p:txBody>
-      </p:sp>
-      <p:pic>
-        <p:nvPicPr>
-          <p:cNvPr id="6" name="그림 5">
-            <a:extLst>
-              <a:ext uri="{FF2B5EF4-FFF2-40B4-BE49-F238E27FC236}">
-                <a16:creationId xmlns:a16="http://schemas.microsoft.com/office/drawing/2014/main" id="{48EF2E57-901F-B412-D2ED-829178775CF8}"/>
-              </a:ext>
-            </a:extLst>
-          </p:cNvPr>
-          <p:cNvPicPr>
-            <a:picLocks noChangeAspect="1"/>
-          </p:cNvPicPr>
-          <p:nvPr/>
-        </p:nvPicPr>
-        <p:blipFill>
-          <a:blip r:embed="rId2"/>
-          <a:stretch>
-            <a:fillRect/>
-          </a:stretch>
-        </p:blipFill>
-        <p:spPr>
-          <a:xfrm>
-            <a:off x="0" y="55194"/>
-            <a:ext cx="12192000" cy="6747612"/>
-          </a:xfrm>
-          <a:prstGeom prst="rect">
-            <a:avLst/>
-          </a:prstGeom>
-        </p:spPr>
-      </p:pic>
-      <p:sp>
-        <p:nvSpPr>
-          <p:cNvPr id="7" name="직사각형 6">
-            <a:extLst>
-              <a:ext uri="{FF2B5EF4-FFF2-40B4-BE49-F238E27FC236}">
-                <a16:creationId xmlns:a16="http://schemas.microsoft.com/office/drawing/2014/main" id="{14B85EC4-8F40-3159-DBE0-117F5C1C36A2}"/>
-              </a:ext>
-            </a:extLst>
-          </p:cNvPr>
-          <p:cNvSpPr/>
-          <p:nvPr/>
-        </p:nvSpPr>
-        <p:spPr>
-          <a:xfrm>
-            <a:off x="10655687" y="147241"/>
-            <a:ext cx="1159847" cy="297260"/>
-          </a:xfrm>
-          <a:prstGeom prst="rect">
-            <a:avLst/>
-          </a:prstGeom>
-          <a:solidFill>
-            <a:srgbClr val="F2F2F2"/>
-          </a:solidFill>
-          <a:ln>
-            <a:noFill/>
-          </a:ln>
-        </p:spPr>
-        <p:style>
-          <a:lnRef idx="2">
-            <a:schemeClr val="accent1">
-              <a:shade val="50000"/>
-            </a:schemeClr>
-          </a:lnRef>
-          <a:fillRef idx="1">
-            <a:schemeClr val="accent1"/>
-          </a:fillRef>
-          <a:effectRef idx="0">
-            <a:schemeClr val="accent1"/>
-          </a:effectRef>
-          <a:fontRef idx="minor">
-            <a:schemeClr val="lt1"/>
-          </a:fontRef>
-        </p:style>
-        <p:txBody>
-          <a:bodyPr rtlCol="0" anchor="ctr"/>
-          <a:lstStyle/>
-          <a:p>
-            <a:pPr marL="0" marR="0" lvl="0" indent="0" algn="ctr" defTabSz="914400" rtl="0" eaLnBrk="1" fontAlgn="auto" latinLnBrk="1" hangingPunct="1">
-              <a:lnSpc>
-                <a:spcPct val="100000"/>
-              </a:lnSpc>
-              <a:spcBef>
-                <a:spcPts val="0"/>
-              </a:spcBef>
-              <a:spcAft>
-                <a:spcPts val="0"/>
-              </a:spcAft>
-              <a:buClrTx/>
-              <a:buSzTx/>
-              <a:buFontTx/>
-              <a:buNone/>
-              <a:tabLst/>
-              <a:defRPr/>
-            </a:pPr>
-            <a:endParaRPr kumimoji="0" lang="ko-KR" altLang="en-US" sz="1800" b="0" i="0" u="none" strike="noStrike" kern="1200" cap="none" spc="0" normalizeH="0" baseline="0" noProof="0">
-              <a:ln>
-                <a:noFill/>
-              </a:ln>
-              <a:solidFill>
-                <a:prstClr val="white"/>
-              </a:solidFill>
-              <a:effectLst/>
-              <a:uLnTx/>
-              <a:uFillTx/>
-              <a:latin typeface="Montserrat" pitchFamily="2" charset="0"/>
-              <a:ea typeface="맑은 고딕" panose="020B0503020000020004" pitchFamily="50" charset="-127"/>
-              <a:cs typeface="+mn-cs"/>
-            </a:endParaRPr>
-          </a:p>
-        </p:txBody>
-      </p:sp>
-    </p:spTree>
-    <p:extLst>
-      <p:ext uri="{BB962C8B-B14F-4D97-AF65-F5344CB8AC3E}">
-        <p14:creationId xmlns:p14="http://schemas.microsoft.com/office/powerpoint/2010/main" val="1109579226"/>
-      </p:ext>
-    </p:extLst>
-  </p:cSld>
-  <p:clrMapOvr>
-    <a:masterClrMapping/>
-  </p:clrMapOvr>
-</p:sld>
-</file>
-
-<file path=ppt/slides/slide9.xml><?xml version="1.0" encoding="utf-8"?>
-<p:sld xmlns:a="http://schemas.openxmlformats.org/drawingml/2006/main" xmlns:r="http://schemas.openxmlformats.org/officeDocument/2006/relationships" xmlns:p="http://schemas.openxmlformats.org/presentationml/2006/main">
-  <p:cSld>
-    <p:spTree>
-      <p:nvGrpSpPr>
-        <p:cNvPr id="1" name=""/>
-        <p:cNvGrpSpPr/>
-        <p:nvPr/>
-      </p:nvGrpSpPr>
-      <p:grpSpPr>
-        <a:xfrm>
-          <a:off x="0" y="0"/>
-          <a:ext cx="0" cy="0"/>
-          <a:chOff x="0" y="0"/>
-          <a:chExt cx="0" cy="0"/>
-        </a:xfrm>
-      </p:grpSpPr>
-      <p:sp>
-        <p:nvSpPr>
-          <p:cNvPr id="2" name="제목 1">
-            <a:extLst>
-              <a:ext uri="{FF2B5EF4-FFF2-40B4-BE49-F238E27FC236}">
-                <a16:creationId xmlns:a16="http://schemas.microsoft.com/office/drawing/2014/main" id="{20F68881-C95D-985B-7896-422ED4C2EE47}"/>
-              </a:ext>
-            </a:extLst>
-          </p:cNvPr>
-          <p:cNvSpPr>
-            <a:spLocks noGrp="1"/>
-          </p:cNvSpPr>
-          <p:nvPr>
-            <p:ph type="title"/>
-          </p:nvPr>
-        </p:nvSpPr>
-        <p:spPr/>
-        <p:txBody>
-          <a:bodyPr/>
-          <a:lstStyle/>
-          <a:p>
-            <a:endParaRPr lang="ko-KR" altLang="en-US"/>
-          </a:p>
-        </p:txBody>
-      </p:sp>
-    </p:spTree>
-    <p:extLst>
-      <p:ext uri="{BB962C8B-B14F-4D97-AF65-F5344CB8AC3E}">
-        <p14:creationId xmlns:p14="http://schemas.microsoft.com/office/powerpoint/2010/main" val="4061806259"/>
+        <p14:creationId xmlns:p14="http://schemas.microsoft.com/office/powerpoint/2010/main" val="2184797597"/>
       </p:ext>
     </p:extLst>
   </p:cSld>

</xml_diff>

<commit_message>
vault backup: 2026-07-03 21:57:42
</commit_message>
<xml_diff>
--- a/assets/06-dataspace/image.pptx
+++ b/assets/06-dataspace/image.pptx
@@ -14,16 +14,18 @@
     <p:sldId id="385" r:id="rId8"/>
     <p:sldId id="395" r:id="rId9"/>
     <p:sldId id="396" r:id="rId10"/>
-    <p:sldId id="387" r:id="rId11"/>
-    <p:sldId id="388" r:id="rId12"/>
-    <p:sldId id="392" r:id="rId13"/>
-    <p:sldId id="393" r:id="rId14"/>
-    <p:sldId id="256" r:id="rId15"/>
-    <p:sldId id="257" r:id="rId16"/>
-    <p:sldId id="259" r:id="rId17"/>
-    <p:sldId id="258" r:id="rId18"/>
-    <p:sldId id="260" r:id="rId19"/>
-    <p:sldId id="380" r:id="rId20"/>
+    <p:sldId id="397" r:id="rId11"/>
+    <p:sldId id="387" r:id="rId12"/>
+    <p:sldId id="388" r:id="rId13"/>
+    <p:sldId id="392" r:id="rId14"/>
+    <p:sldId id="398" r:id="rId15"/>
+    <p:sldId id="393" r:id="rId16"/>
+    <p:sldId id="256" r:id="rId17"/>
+    <p:sldId id="257" r:id="rId18"/>
+    <p:sldId id="259" r:id="rId19"/>
+    <p:sldId id="258" r:id="rId20"/>
+    <p:sldId id="260" r:id="rId21"/>
+    <p:sldId id="380" r:id="rId22"/>
   </p:sldIdLst>
   <p:sldSz cx="12192000" cy="6858000"/>
   <p:notesSz cx="6858000" cy="9144000"/>
@@ -133,7 +135,7 @@
 <file path=ppt/revisionInfo.xml><?xml version="1.0" encoding="utf-8"?>
 <p1510:revInfo xmlns:a="http://schemas.openxmlformats.org/drawingml/2006/main" xmlns:r="http://schemas.openxmlformats.org/officeDocument/2006/relationships" xmlns:p1510="http://schemas.microsoft.com/office/powerpoint/2015/10/main">
   <p1510:revLst>
-    <p1510:client id="{77AFA03C-ADB3-48E7-9DEE-EC77C33AF38A}" v="84" dt="2026-07-03T12:47:18.216"/>
+    <p1510:client id="{77AFA03C-ADB3-48E7-9DEE-EC77C33AF38A}" v="110" dt="2026-07-03T12:57:22.740"/>
   </p1510:revLst>
 </p1510:revInfo>
 </file>
@@ -143,7 +145,7 @@
   <pc:docChgLst>
     <pc:chgData name="헌정 임" userId="eb9ca9bd79f0560f" providerId="LiveId" clId="{A6339E56-8272-42D6-9D95-12E1A8284411}"/>
     <pc:docChg chg="undo custSel addSld delSld modSld">
-      <pc:chgData name="헌정 임" userId="eb9ca9bd79f0560f" providerId="LiveId" clId="{A6339E56-8272-42D6-9D95-12E1A8284411}" dt="2026-07-03T12:47:18.216" v="896"/>
+      <pc:chgData name="헌정 임" userId="eb9ca9bd79f0560f" providerId="LiveId" clId="{A6339E56-8272-42D6-9D95-12E1A8284411}" dt="2026-07-03T12:57:22.740" v="1172"/>
       <pc:docMkLst>
         <pc:docMk/>
       </pc:docMkLst>
@@ -411,13 +413,13 @@
         </pc:picChg>
       </pc:sldChg>
       <pc:sldChg chg="addSp delSp modSp new mod">
-        <pc:chgData name="헌정 임" userId="eb9ca9bd79f0560f" providerId="LiveId" clId="{A6339E56-8272-42D6-9D95-12E1A8284411}" dt="2026-07-03T12:45:50.985" v="788" actId="20577"/>
+        <pc:chgData name="헌정 임" userId="eb9ca9bd79f0560f" providerId="LiveId" clId="{A6339E56-8272-42D6-9D95-12E1A8284411}" dt="2026-07-03T12:53:26.125" v="1043" actId="571"/>
         <pc:sldMkLst>
           <pc:docMk/>
           <pc:sldMk cId="1983847626" sldId="385"/>
         </pc:sldMkLst>
         <pc:spChg chg="add mod">
-          <ac:chgData name="헌정 임" userId="eb9ca9bd79f0560f" providerId="LiveId" clId="{A6339E56-8272-42D6-9D95-12E1A8284411}" dt="2026-07-03T12:45:01.808" v="781" actId="1076"/>
+          <ac:chgData name="헌정 임" userId="eb9ca9bd79f0560f" providerId="LiveId" clId="{A6339E56-8272-42D6-9D95-12E1A8284411}" dt="2026-07-03T12:53:19.549" v="1042" actId="20577"/>
           <ac:spMkLst>
             <pc:docMk/>
             <pc:sldMk cId="1983847626" sldId="385"/>
@@ -433,11 +435,19 @@
           </ac:spMkLst>
         </pc:spChg>
         <pc:spChg chg="add mod">
-          <ac:chgData name="헌정 임" userId="eb9ca9bd79f0560f" providerId="LiveId" clId="{A6339E56-8272-42D6-9D95-12E1A8284411}" dt="2026-07-03T12:45:50.985" v="788" actId="20577"/>
+          <ac:chgData name="헌정 임" userId="eb9ca9bd79f0560f" providerId="LiveId" clId="{A6339E56-8272-42D6-9D95-12E1A8284411}" dt="2026-07-03T12:53:17.190" v="1041" actId="20577"/>
           <ac:spMkLst>
             <pc:docMk/>
             <pc:sldMk cId="1983847626" sldId="385"/>
             <ac:spMk id="16" creationId="{9B6F4B20-A4A0-A12D-B811-C2B2E05E12EC}"/>
+          </ac:spMkLst>
+        </pc:spChg>
+        <pc:spChg chg="add mod">
+          <ac:chgData name="헌정 임" userId="eb9ca9bd79f0560f" providerId="LiveId" clId="{A6339E56-8272-42D6-9D95-12E1A8284411}" dt="2026-07-03T12:53:26.125" v="1043" actId="571"/>
+          <ac:spMkLst>
+            <pc:docMk/>
+            <pc:sldMk cId="1983847626" sldId="385"/>
+            <ac:spMk id="17" creationId="{B141E512-2EF8-ECDB-1647-A8ABC5977C29}"/>
           </ac:spMkLst>
         </pc:spChg>
         <pc:picChg chg="add mod modCrop">
@@ -614,7 +624,7 @@
         </pc:picChg>
       </pc:sldChg>
       <pc:sldChg chg="addSp delSp modSp new mod">
-        <pc:chgData name="헌정 임" userId="eb9ca9bd79f0560f" providerId="LiveId" clId="{A6339E56-8272-42D6-9D95-12E1A8284411}" dt="2026-07-03T12:41:42.894" v="431" actId="1076"/>
+        <pc:chgData name="헌정 임" userId="eb9ca9bd79f0560f" providerId="LiveId" clId="{A6339E56-8272-42D6-9D95-12E1A8284411}" dt="2026-07-03T12:53:05.307" v="1040" actId="113"/>
         <pc:sldMkLst>
           <pc:docMk/>
           <pc:sldMk cId="2676242124" sldId="390"/>
@@ -668,7 +678,7 @@
           </ac:spMkLst>
         </pc:spChg>
         <pc:spChg chg="add mod">
-          <ac:chgData name="헌정 임" userId="eb9ca9bd79f0560f" providerId="LiveId" clId="{A6339E56-8272-42D6-9D95-12E1A8284411}" dt="2026-07-03T12:39:22.166" v="296" actId="14100"/>
+          <ac:chgData name="헌정 임" userId="eb9ca9bd79f0560f" providerId="LiveId" clId="{A6339E56-8272-42D6-9D95-12E1A8284411}" dt="2026-07-03T12:53:05.307" v="1040" actId="113"/>
           <ac:spMkLst>
             <pc:docMk/>
             <pc:sldMk cId="2676242124" sldId="390"/>
@@ -681,6 +691,14 @@
             <pc:docMk/>
             <pc:sldMk cId="2676242124" sldId="390"/>
             <ac:picMk id="5" creationId="{C75BFF21-2AA7-77DF-62B2-D05B186ED8D0}"/>
+          </ac:picMkLst>
+        </pc:picChg>
+        <pc:picChg chg="add del">
+          <ac:chgData name="헌정 임" userId="eb9ca9bd79f0560f" providerId="LiveId" clId="{A6339E56-8272-42D6-9D95-12E1A8284411}" dt="2026-07-03T12:53:01.372" v="1039" actId="478"/>
+          <ac:picMkLst>
+            <pc:docMk/>
+            <pc:sldMk cId="2676242124" sldId="390"/>
+            <ac:picMk id="17" creationId="{4AE9F061-6028-4F87-D2B1-993AE8BE235A}"/>
           </ac:picMkLst>
         </pc:picChg>
         <pc:cxnChg chg="add mod">
@@ -707,12 +725,68 @@
           </ac:picMkLst>
         </pc:picChg>
       </pc:sldChg>
-      <pc:sldChg chg="new">
-        <pc:chgData name="헌정 임" userId="eb9ca9bd79f0560f" providerId="LiveId" clId="{A6339E56-8272-42D6-9D95-12E1A8284411}" dt="2026-07-03T12:36:21.600" v="98" actId="680"/>
+      <pc:sldChg chg="addSp modSp new mod">
+        <pc:chgData name="헌정 임" userId="eb9ca9bd79f0560f" providerId="LiveId" clId="{A6339E56-8272-42D6-9D95-12E1A8284411}" dt="2026-07-03T12:57:22.740" v="1172"/>
         <pc:sldMkLst>
           <pc:docMk/>
           <pc:sldMk cId="4061806259" sldId="392"/>
         </pc:sldMkLst>
+        <pc:spChg chg="add mod">
+          <ac:chgData name="헌정 임" userId="eb9ca9bd79f0560f" providerId="LiveId" clId="{A6339E56-8272-42D6-9D95-12E1A8284411}" dt="2026-07-03T12:56:23.586" v="1116" actId="14100"/>
+          <ac:spMkLst>
+            <pc:docMk/>
+            <pc:sldMk cId="4061806259" sldId="392"/>
+            <ac:spMk id="6" creationId="{A4C66587-2F99-2F32-4BE0-F4241EECA662}"/>
+          </ac:spMkLst>
+        </pc:spChg>
+        <pc:spChg chg="add mod">
+          <ac:chgData name="헌정 임" userId="eb9ca9bd79f0560f" providerId="LiveId" clId="{A6339E56-8272-42D6-9D95-12E1A8284411}" dt="2026-07-03T12:56:42.013" v="1121" actId="20577"/>
+          <ac:spMkLst>
+            <pc:docMk/>
+            <pc:sldMk cId="4061806259" sldId="392"/>
+            <ac:spMk id="8" creationId="{B442ED24-BD1F-0F8D-2EB3-9890BD2C6D6F}"/>
+          </ac:spMkLst>
+        </pc:spChg>
+        <pc:spChg chg="add mod">
+          <ac:chgData name="헌정 임" userId="eb9ca9bd79f0560f" providerId="LiveId" clId="{A6339E56-8272-42D6-9D95-12E1A8284411}" dt="2026-07-03T12:57:22.740" v="1172"/>
+          <ac:spMkLst>
+            <pc:docMk/>
+            <pc:sldMk cId="4061806259" sldId="392"/>
+            <ac:spMk id="11" creationId="{31053E93-66B7-018E-F9EC-0E101C8E2A84}"/>
+          </ac:spMkLst>
+        </pc:spChg>
+        <pc:picChg chg="add">
+          <ac:chgData name="헌정 임" userId="eb9ca9bd79f0560f" providerId="LiveId" clId="{A6339E56-8272-42D6-9D95-12E1A8284411}" dt="2026-07-03T12:55:08.722" v="1044" actId="22"/>
+          <ac:picMkLst>
+            <pc:docMk/>
+            <pc:sldMk cId="4061806259" sldId="392"/>
+            <ac:picMk id="4" creationId="{06F08584-1975-FEDC-2204-D3AB8D6EAE37}"/>
+          </ac:picMkLst>
+        </pc:picChg>
+        <pc:picChg chg="add mod">
+          <ac:chgData name="헌정 임" userId="eb9ca9bd79f0560f" providerId="LiveId" clId="{A6339E56-8272-42D6-9D95-12E1A8284411}" dt="2026-07-03T12:55:53.993" v="1052" actId="1440"/>
+          <ac:picMkLst>
+            <pc:docMk/>
+            <pc:sldMk cId="4061806259" sldId="392"/>
+            <ac:picMk id="5" creationId="{3DD657DB-9BF3-E3BF-6D87-A6AE803716DD}"/>
+          </ac:picMkLst>
+        </pc:picChg>
+        <pc:picChg chg="add mod">
+          <ac:chgData name="헌정 임" userId="eb9ca9bd79f0560f" providerId="LiveId" clId="{A6339E56-8272-42D6-9D95-12E1A8284411}" dt="2026-07-03T12:56:19.908" v="1114"/>
+          <ac:picMkLst>
+            <pc:docMk/>
+            <pc:sldMk cId="4061806259" sldId="392"/>
+            <ac:picMk id="7" creationId="{6B2783D0-2AFD-388E-76D0-440F4283A8B6}"/>
+          </ac:picMkLst>
+        </pc:picChg>
+        <pc:cxnChg chg="add mod">
+          <ac:chgData name="헌정 임" userId="eb9ca9bd79f0560f" providerId="LiveId" clId="{A6339E56-8272-42D6-9D95-12E1A8284411}" dt="2026-07-03T12:56:52.016" v="1123" actId="208"/>
+          <ac:cxnSpMkLst>
+            <pc:docMk/>
+            <pc:sldMk cId="4061806259" sldId="392"/>
+            <ac:cxnSpMk id="10" creationId="{8DB0ED0E-2808-3F95-B3EA-2285434A66C6}"/>
+          </ac:cxnSpMkLst>
+        </pc:cxnChg>
       </pc:sldChg>
       <pc:sldChg chg="new">
         <pc:chgData name="헌정 임" userId="eb9ca9bd79f0560f" providerId="LiveId" clId="{A6339E56-8272-42D6-9D95-12E1A8284411}" dt="2026-07-03T12:36:21.768" v="99" actId="680"/>
@@ -877,6 +951,36 @@
           <pc:docMk/>
           <pc:sldMk cId="2184797597" sldId="396"/>
         </pc:sldMkLst>
+      </pc:sldChg>
+      <pc:sldChg chg="addSp new mod">
+        <pc:chgData name="헌정 임" userId="eb9ca9bd79f0560f" providerId="LiveId" clId="{A6339E56-8272-42D6-9D95-12E1A8284411}" dt="2026-07-03T12:51:53.931" v="898" actId="22"/>
+        <pc:sldMkLst>
+          <pc:docMk/>
+          <pc:sldMk cId="3262085849" sldId="397"/>
+        </pc:sldMkLst>
+        <pc:picChg chg="add">
+          <ac:chgData name="헌정 임" userId="eb9ca9bd79f0560f" providerId="LiveId" clId="{A6339E56-8272-42D6-9D95-12E1A8284411}" dt="2026-07-03T12:51:53.931" v="898" actId="22"/>
+          <ac:picMkLst>
+            <pc:docMk/>
+            <pc:sldMk cId="3262085849" sldId="397"/>
+            <ac:picMk id="4" creationId="{75E236EC-2819-2011-E945-249F35B3FDBB}"/>
+          </ac:picMkLst>
+        </pc:picChg>
+      </pc:sldChg>
+      <pc:sldChg chg="delSp modSp add mod">
+        <pc:chgData name="헌정 임" userId="eb9ca9bd79f0560f" providerId="LiveId" clId="{A6339E56-8272-42D6-9D95-12E1A8284411}" dt="2026-07-03T12:55:29.342" v="1048" actId="21"/>
+        <pc:sldMkLst>
+          <pc:docMk/>
+          <pc:sldMk cId="1099443927" sldId="398"/>
+        </pc:sldMkLst>
+        <pc:picChg chg="del mod">
+          <ac:chgData name="헌정 임" userId="eb9ca9bd79f0560f" providerId="LiveId" clId="{A6339E56-8272-42D6-9D95-12E1A8284411}" dt="2026-07-03T12:55:29.342" v="1048" actId="21"/>
+          <ac:picMkLst>
+            <pc:docMk/>
+            <pc:sldMk cId="1099443927" sldId="398"/>
+            <ac:picMk id="4" creationId="{3DD657DB-9BF3-E3BF-6D87-A6AE803716DD}"/>
+          </ac:picMkLst>
+        </pc:picChg>
       </pc:sldChg>
     </pc:docChg>
   </pc:docChgLst>
@@ -4433,7 +4537,7 @@
         <p:spPr>
           <a:xfrm>
             <a:off x="1282699" y="6002404"/>
-            <a:ext cx="6134101" cy="369332"/>
+            <a:ext cx="9423401" cy="646331"/>
           </a:xfrm>
           <a:prstGeom prst="rect">
             <a:avLst/>
@@ -4478,6 +4582,56 @@
               </a:rPr>
               <a:t>업로드 하여도 인식 못함</a:t>
             </a:r>
+            <a:endParaRPr lang="en-US" altLang="ko-KR" dirty="0">
+              <a:highlight>
+                <a:srgbClr val="FFFF00"/>
+              </a:highlight>
+            </a:endParaRPr>
+          </a:p>
+          <a:p>
+            <a:r>
+              <a:rPr lang="en-US" altLang="ko-KR" dirty="0" err="1">
+                <a:highlight>
+                  <a:srgbClr val="FFFF00"/>
+                </a:highlight>
+              </a:rPr>
+              <a:t>chmod</a:t>
+            </a:r>
+            <a:r>
+              <a:rPr lang="en-US" altLang="ko-KR" dirty="0">
+                <a:highlight>
+                  <a:srgbClr val="FFFF00"/>
+                </a:highlight>
+              </a:rPr>
+              <a:t> </a:t>
+            </a:r>
+            <a:r>
+              <a:rPr lang="en-US" altLang="ko-KR" b="1" dirty="0">
+                <a:solidFill>
+                  <a:srgbClr val="C00000"/>
+                </a:solidFill>
+                <a:highlight>
+                  <a:srgbClr val="FFFF00"/>
+                </a:highlight>
+              </a:rPr>
+              <a:t>+r </a:t>
+            </a:r>
+            <a:r>
+              <a:rPr lang="en-US" altLang="ko-KR" dirty="0">
+                <a:highlight>
+                  <a:srgbClr val="FFFF00"/>
+                </a:highlight>
+              </a:rPr>
+              <a:t>edge5.kubeconfig </a:t>
+            </a:r>
+            <a:r>
+              <a:rPr lang="ko-KR" altLang="en-US" dirty="0">
+                <a:highlight>
+                  <a:srgbClr val="FFFF00"/>
+                </a:highlight>
+              </a:rPr>
+              <a:t>하면 다운로드 후 바로 업로드 하여도 인식 됨</a:t>
+            </a:r>
           </a:p>
         </p:txBody>
       </p:sp>
@@ -4495,6 +4649,91 @@
 </file>
 
 <file path=ppt/slides/slide10.xml><?xml version="1.0" encoding="utf-8"?>
+<p:sld xmlns:a="http://schemas.openxmlformats.org/drawingml/2006/main" xmlns:r="http://schemas.openxmlformats.org/officeDocument/2006/relationships" xmlns:p="http://schemas.openxmlformats.org/presentationml/2006/main">
+  <p:cSld>
+    <p:spTree>
+      <p:nvGrpSpPr>
+        <p:cNvPr id="1" name=""/>
+        <p:cNvGrpSpPr/>
+        <p:nvPr/>
+      </p:nvGrpSpPr>
+      <p:grpSpPr>
+        <a:xfrm>
+          <a:off x="0" y="0"/>
+          <a:ext cx="0" cy="0"/>
+          <a:chOff x="0" y="0"/>
+          <a:chExt cx="0" cy="0"/>
+        </a:xfrm>
+      </p:grpSpPr>
+      <p:sp>
+        <p:nvSpPr>
+          <p:cNvPr id="2" name="제목 1">
+            <a:extLst>
+              <a:ext uri="{FF2B5EF4-FFF2-40B4-BE49-F238E27FC236}">
+                <a16:creationId xmlns:a16="http://schemas.microsoft.com/office/drawing/2014/main" id="{D36E85DB-23E2-8AE2-7730-D2E6CFCBB814}"/>
+              </a:ext>
+            </a:extLst>
+          </p:cNvPr>
+          <p:cNvSpPr>
+            <a:spLocks noGrp="1"/>
+          </p:cNvSpPr>
+          <p:nvPr>
+            <p:ph type="title"/>
+          </p:nvPr>
+        </p:nvSpPr>
+        <p:spPr/>
+        <p:txBody>
+          <a:bodyPr/>
+          <a:lstStyle/>
+          <a:p>
+            <a:endParaRPr lang="ko-KR" altLang="en-US"/>
+          </a:p>
+        </p:txBody>
+      </p:sp>
+      <p:pic>
+        <p:nvPicPr>
+          <p:cNvPr id="4" name="그림 3">
+            <a:extLst>
+              <a:ext uri="{FF2B5EF4-FFF2-40B4-BE49-F238E27FC236}">
+                <a16:creationId xmlns:a16="http://schemas.microsoft.com/office/drawing/2014/main" id="{75E236EC-2819-2011-E945-249F35B3FDBB}"/>
+              </a:ext>
+            </a:extLst>
+          </p:cNvPr>
+          <p:cNvPicPr>
+            <a:picLocks noChangeAspect="1"/>
+          </p:cNvPicPr>
+          <p:nvPr/>
+        </p:nvPicPr>
+        <p:blipFill>
+          <a:blip r:embed="rId2"/>
+          <a:stretch>
+            <a:fillRect/>
+          </a:stretch>
+        </p:blipFill>
+        <p:spPr>
+          <a:xfrm>
+            <a:off x="395246" y="2214553"/>
+            <a:ext cx="11401508" cy="2428893"/>
+          </a:xfrm>
+          <a:prstGeom prst="rect">
+            <a:avLst/>
+          </a:prstGeom>
+        </p:spPr>
+      </p:pic>
+    </p:spTree>
+    <p:extLst>
+      <p:ext uri="{BB962C8B-B14F-4D97-AF65-F5344CB8AC3E}">
+        <p14:creationId xmlns:p14="http://schemas.microsoft.com/office/powerpoint/2010/main" val="3262085849"/>
+      </p:ext>
+    </p:extLst>
+  </p:cSld>
+  <p:clrMapOvr>
+    <a:masterClrMapping/>
+  </p:clrMapOvr>
+</p:sld>
+</file>
+
+<file path=ppt/slides/slide11.xml><?xml version="1.0" encoding="utf-8"?>
 <p:sld xmlns:a="http://schemas.openxmlformats.org/drawingml/2006/main" xmlns:r="http://schemas.openxmlformats.org/officeDocument/2006/relationships" xmlns:p="http://schemas.openxmlformats.org/presentationml/2006/main">
   <p:cSld>
     <p:spTree>
@@ -4660,7 +4899,7 @@
 </p:sld>
 </file>
 
-<file path=ppt/slides/slide11.xml><?xml version="1.0" encoding="utf-8"?>
+<file path=ppt/slides/slide12.xml><?xml version="1.0" encoding="utf-8"?>
 <p:sld xmlns:a="http://schemas.openxmlformats.org/drawingml/2006/main" xmlns:r="http://schemas.openxmlformats.org/officeDocument/2006/relationships" xmlns:p="http://schemas.openxmlformats.org/presentationml/2006/main">
   <p:cSld>
     <p:spTree>
@@ -4826,7 +5065,7 @@
 </p:sld>
 </file>
 
-<file path=ppt/slides/slide12.xml><?xml version="1.0" encoding="utf-8"?>
+<file path=ppt/slides/slide13.xml><?xml version="1.0" encoding="utf-8"?>
 <p:sld xmlns:a="http://schemas.openxmlformats.org/drawingml/2006/main" xmlns:r="http://schemas.openxmlformats.org/officeDocument/2006/relationships" xmlns:p="http://schemas.openxmlformats.org/presentationml/2006/main">
   <p:cSld>
     <p:spTree>
@@ -4868,6 +5107,286 @@
           </a:p>
         </p:txBody>
       </p:sp>
+      <p:pic>
+        <p:nvPicPr>
+          <p:cNvPr id="4" name="그림 3">
+            <a:extLst>
+              <a:ext uri="{FF2B5EF4-FFF2-40B4-BE49-F238E27FC236}">
+                <a16:creationId xmlns:a16="http://schemas.microsoft.com/office/drawing/2014/main" id="{06F08584-1975-FEDC-2204-D3AB8D6EAE37}"/>
+              </a:ext>
+            </a:extLst>
+          </p:cNvPr>
+          <p:cNvPicPr>
+            <a:picLocks noChangeAspect="1"/>
+          </p:cNvPicPr>
+          <p:nvPr/>
+        </p:nvPicPr>
+        <p:blipFill>
+          <a:blip r:embed="rId2"/>
+          <a:stretch>
+            <a:fillRect/>
+          </a:stretch>
+        </p:blipFill>
+        <p:spPr>
+          <a:xfrm>
+            <a:off x="0" y="77277"/>
+            <a:ext cx="12192000" cy="6703446"/>
+          </a:xfrm>
+          <a:prstGeom prst="rect">
+            <a:avLst/>
+          </a:prstGeom>
+        </p:spPr>
+      </p:pic>
+      <p:pic>
+        <p:nvPicPr>
+          <p:cNvPr id="5" name="그림 4">
+            <a:extLst>
+              <a:ext uri="{FF2B5EF4-FFF2-40B4-BE49-F238E27FC236}">
+                <a16:creationId xmlns:a16="http://schemas.microsoft.com/office/drawing/2014/main" id="{3DD657DB-9BF3-E3BF-6D87-A6AE803716DD}"/>
+              </a:ext>
+            </a:extLst>
+          </p:cNvPr>
+          <p:cNvPicPr>
+            <a:picLocks noChangeAspect="1"/>
+          </p:cNvPicPr>
+          <p:nvPr/>
+        </p:nvPicPr>
+        <p:blipFill>
+          <a:blip r:embed="rId3"/>
+          <a:stretch>
+            <a:fillRect/>
+          </a:stretch>
+        </p:blipFill>
+        <p:spPr>
+          <a:xfrm>
+            <a:off x="3848100" y="1018098"/>
+            <a:ext cx="6248400" cy="3456656"/>
+          </a:xfrm>
+          <a:prstGeom prst="rect">
+            <a:avLst/>
+          </a:prstGeom>
+          <a:ln>
+            <a:noFill/>
+          </a:ln>
+          <a:effectLst>
+            <a:outerShdw blurRad="292100" dist="139700" dir="2700000" algn="tl" rotWithShape="0">
+              <a:srgbClr val="333333">
+                <a:alpha val="65000"/>
+              </a:srgbClr>
+            </a:outerShdw>
+          </a:effectLst>
+        </p:spPr>
+      </p:pic>
+      <p:sp>
+        <p:nvSpPr>
+          <p:cNvPr id="6" name="TextBox 5">
+            <a:extLst>
+              <a:ext uri="{FF2B5EF4-FFF2-40B4-BE49-F238E27FC236}">
+                <a16:creationId xmlns:a16="http://schemas.microsoft.com/office/drawing/2014/main" id="{A4C66587-2F99-2F32-4BE0-F4241EECA662}"/>
+              </a:ext>
+            </a:extLst>
+          </p:cNvPr>
+          <p:cNvSpPr txBox="1"/>
+          <p:nvPr/>
+        </p:nvSpPr>
+        <p:spPr>
+          <a:xfrm>
+            <a:off x="5905500" y="2762250"/>
+            <a:ext cx="3733800" cy="369332"/>
+          </a:xfrm>
+          <a:prstGeom prst="rect">
+            <a:avLst/>
+          </a:prstGeom>
+          <a:noFill/>
+        </p:spPr>
+        <p:txBody>
+          <a:bodyPr wrap="square" rtlCol="0">
+            <a:spAutoFit/>
+          </a:bodyPr>
+          <a:lstStyle/>
+          <a:p>
+            <a:r>
+              <a:rPr lang="ko-KR" altLang="en-US" b="1" dirty="0">
+                <a:solidFill>
+                  <a:srgbClr val="C00000"/>
+                </a:solidFill>
+              </a:rPr>
+              <a:t>전 단계에서 장비 모두 삭제 </a:t>
+            </a:r>
+          </a:p>
+        </p:txBody>
+      </p:sp>
+      <p:sp>
+        <p:nvSpPr>
+          <p:cNvPr id="8" name="직사각형 7">
+            <a:extLst>
+              <a:ext uri="{FF2B5EF4-FFF2-40B4-BE49-F238E27FC236}">
+                <a16:creationId xmlns:a16="http://schemas.microsoft.com/office/drawing/2014/main" id="{B442ED24-BD1F-0F8D-2EB3-9890BD2C6D6F}"/>
+              </a:ext>
+            </a:extLst>
+          </p:cNvPr>
+          <p:cNvSpPr/>
+          <p:nvPr/>
+        </p:nvSpPr>
+        <p:spPr>
+          <a:xfrm>
+            <a:off x="2177572" y="5519900"/>
+            <a:ext cx="4070828" cy="699006"/>
+          </a:xfrm>
+          <a:prstGeom prst="rect">
+            <a:avLst/>
+          </a:prstGeom>
+          <a:noFill/>
+          <a:ln>
+            <a:solidFill>
+              <a:srgbClr val="C00000"/>
+            </a:solidFill>
+            <a:prstDash val="sysDash"/>
+          </a:ln>
+        </p:spPr>
+        <p:style>
+          <a:lnRef idx="2">
+            <a:schemeClr val="accent1">
+              <a:shade val="15000"/>
+            </a:schemeClr>
+          </a:lnRef>
+          <a:fillRef idx="1">
+            <a:schemeClr val="accent1"/>
+          </a:fillRef>
+          <a:effectRef idx="0">
+            <a:schemeClr val="accent1"/>
+          </a:effectRef>
+          <a:fontRef idx="minor">
+            <a:schemeClr val="lt1"/>
+          </a:fontRef>
+        </p:style>
+        <p:txBody>
+          <a:bodyPr rtlCol="0" anchor="ctr"/>
+          <a:lstStyle/>
+          <a:p>
+            <a:pPr algn="ctr"/>
+            <a:endParaRPr lang="ko-KR" altLang="en-US" dirty="0">
+              <a:solidFill>
+                <a:schemeClr val="bg1">
+                  <a:lumMod val="50000"/>
+                </a:schemeClr>
+              </a:solidFill>
+            </a:endParaRPr>
+          </a:p>
+        </p:txBody>
+      </p:sp>
+      <p:cxnSp>
+        <p:nvCxnSpPr>
+          <p:cNvPr id="10" name="연결선: 꺾임 9">
+            <a:extLst>
+              <a:ext uri="{FF2B5EF4-FFF2-40B4-BE49-F238E27FC236}">
+                <a16:creationId xmlns:a16="http://schemas.microsoft.com/office/drawing/2014/main" id="{8DB0ED0E-2808-3F95-B3EA-2285434A66C6}"/>
+              </a:ext>
+            </a:extLst>
+          </p:cNvPr>
+          <p:cNvCxnSpPr>
+            <a:stCxn id="6" idx="2"/>
+            <a:endCxn id="8" idx="3"/>
+          </p:cNvCxnSpPr>
+          <p:nvPr/>
+        </p:nvCxnSpPr>
+        <p:spPr>
+          <a:xfrm rot="5400000">
+            <a:off x="5641490" y="3738492"/>
+            <a:ext cx="2737821" cy="1524000"/>
+          </a:xfrm>
+          <a:prstGeom prst="bentConnector2">
+            <a:avLst/>
+          </a:prstGeom>
+          <a:ln>
+            <a:solidFill>
+              <a:srgbClr val="C00000"/>
+            </a:solidFill>
+          </a:ln>
+        </p:spPr>
+        <p:style>
+          <a:lnRef idx="2">
+            <a:schemeClr val="accent1"/>
+          </a:lnRef>
+          <a:fillRef idx="0">
+            <a:schemeClr val="accent1"/>
+          </a:fillRef>
+          <a:effectRef idx="1">
+            <a:schemeClr val="accent1"/>
+          </a:effectRef>
+          <a:fontRef idx="minor">
+            <a:schemeClr val="tx1"/>
+          </a:fontRef>
+        </p:style>
+      </p:cxnSp>
+      <p:sp>
+        <p:nvSpPr>
+          <p:cNvPr id="11" name="TextBox 10">
+            <a:extLst>
+              <a:ext uri="{FF2B5EF4-FFF2-40B4-BE49-F238E27FC236}">
+                <a16:creationId xmlns:a16="http://schemas.microsoft.com/office/drawing/2014/main" id="{31053E93-66B7-018E-F9EC-0E101C8E2A84}"/>
+              </a:ext>
+            </a:extLst>
+          </p:cNvPr>
+          <p:cNvSpPr txBox="1"/>
+          <p:nvPr/>
+        </p:nvSpPr>
+        <p:spPr>
+          <a:xfrm>
+            <a:off x="7874000" y="5580394"/>
+            <a:ext cx="4730751" cy="369332"/>
+          </a:xfrm>
+          <a:prstGeom prst="rect">
+            <a:avLst/>
+          </a:prstGeom>
+          <a:noFill/>
+        </p:spPr>
+        <p:txBody>
+          <a:bodyPr wrap="square" rtlCol="0">
+            <a:spAutoFit/>
+          </a:bodyPr>
+          <a:lstStyle/>
+          <a:p>
+            <a:r>
+              <a:rPr lang="ko-KR" altLang="en-US" dirty="0">
+                <a:highlight>
+                  <a:srgbClr val="FFFF00"/>
+                </a:highlight>
+              </a:rPr>
+              <a:t>깨진</a:t>
+            </a:r>
+            <a:r>
+              <a:rPr lang="en-US" altLang="ko-KR" dirty="0">
+                <a:highlight>
+                  <a:srgbClr val="FFFF00"/>
+                </a:highlight>
+              </a:rPr>
+              <a:t>(??) </a:t>
+            </a:r>
+            <a:r>
+              <a:rPr lang="ko-KR" altLang="en-US" dirty="0" err="1">
+                <a:highlight>
+                  <a:srgbClr val="FFFF00"/>
+                </a:highlight>
+              </a:rPr>
+              <a:t>장비명</a:t>
+            </a:r>
+            <a:r>
+              <a:rPr lang="ko-KR" altLang="en-US">
+                <a:highlight>
+                  <a:srgbClr val="FFFF00"/>
+                </a:highlight>
+              </a:rPr>
+              <a:t> 남아 있음</a:t>
+            </a:r>
+            <a:endParaRPr lang="en-US" altLang="ko-KR" dirty="0">
+              <a:highlight>
+                <a:srgbClr val="FFFF00"/>
+              </a:highlight>
+            </a:endParaRPr>
+          </a:p>
+        </p:txBody>
+      </p:sp>
     </p:spTree>
     <p:extLst>
       <p:ext uri="{BB962C8B-B14F-4D97-AF65-F5344CB8AC3E}">
@@ -4881,7 +5400,149 @@
 </p:sld>
 </file>
 
-<file path=ppt/slides/slide13.xml><?xml version="1.0" encoding="utf-8"?>
+<file path=ppt/slides/slide14.xml><?xml version="1.0" encoding="utf-8"?>
+<p:sld xmlns:a="http://schemas.openxmlformats.org/drawingml/2006/main" xmlns:r="http://schemas.openxmlformats.org/officeDocument/2006/relationships" xmlns:p="http://schemas.openxmlformats.org/presentationml/2006/main">
+  <p:cSld>
+    <p:spTree>
+      <p:nvGrpSpPr>
+        <p:cNvPr id="1" name="">
+          <a:extLst>
+            <a:ext uri="{FF2B5EF4-FFF2-40B4-BE49-F238E27FC236}">
+              <a16:creationId xmlns:a16="http://schemas.microsoft.com/office/drawing/2014/main" id="{EA02E9E1-A469-215B-8A86-08BF9114D417}"/>
+            </a:ext>
+          </a:extLst>
+        </p:cNvPr>
+        <p:cNvGrpSpPr/>
+        <p:nvPr/>
+      </p:nvGrpSpPr>
+      <p:grpSpPr>
+        <a:xfrm>
+          <a:off x="0" y="0"/>
+          <a:ext cx="0" cy="0"/>
+          <a:chOff x="0" y="0"/>
+          <a:chExt cx="0" cy="0"/>
+        </a:xfrm>
+      </p:grpSpPr>
+      <p:sp>
+        <p:nvSpPr>
+          <p:cNvPr id="2" name="제목 1">
+            <a:extLst>
+              <a:ext uri="{FF2B5EF4-FFF2-40B4-BE49-F238E27FC236}">
+                <a16:creationId xmlns:a16="http://schemas.microsoft.com/office/drawing/2014/main" id="{96983AA7-57FC-7A6E-7159-D66E15BE2BEC}"/>
+              </a:ext>
+            </a:extLst>
+          </p:cNvPr>
+          <p:cNvSpPr>
+            <a:spLocks noGrp="1"/>
+          </p:cNvSpPr>
+          <p:nvPr>
+            <p:ph type="title"/>
+          </p:nvPr>
+        </p:nvSpPr>
+        <p:spPr/>
+        <p:txBody>
+          <a:bodyPr/>
+          <a:lstStyle/>
+          <a:p>
+            <a:endParaRPr lang="ko-KR" altLang="en-US"/>
+          </a:p>
+        </p:txBody>
+      </p:sp>
+      <p:sp>
+        <p:nvSpPr>
+          <p:cNvPr id="5" name="직사각형 4">
+            <a:extLst>
+              <a:ext uri="{FF2B5EF4-FFF2-40B4-BE49-F238E27FC236}">
+                <a16:creationId xmlns:a16="http://schemas.microsoft.com/office/drawing/2014/main" id="{9331254A-5503-4C53-B301-6E63F85404BC}"/>
+              </a:ext>
+            </a:extLst>
+          </p:cNvPr>
+          <p:cNvSpPr/>
+          <p:nvPr/>
+        </p:nvSpPr>
+        <p:spPr>
+          <a:xfrm>
+            <a:off x="10682902" y="109140"/>
+            <a:ext cx="1159847" cy="297260"/>
+          </a:xfrm>
+          <a:prstGeom prst="rect">
+            <a:avLst/>
+          </a:prstGeom>
+          <a:solidFill>
+            <a:srgbClr val="F2F2F2"/>
+          </a:solidFill>
+          <a:ln>
+            <a:noFill/>
+          </a:ln>
+        </p:spPr>
+        <p:style>
+          <a:lnRef idx="2">
+            <a:schemeClr val="accent1">
+              <a:shade val="50000"/>
+            </a:schemeClr>
+          </a:lnRef>
+          <a:fillRef idx="1">
+            <a:schemeClr val="accent1"/>
+          </a:fillRef>
+          <a:effectRef idx="0">
+            <a:schemeClr val="accent1"/>
+          </a:effectRef>
+          <a:fontRef idx="minor">
+            <a:schemeClr val="lt1"/>
+          </a:fontRef>
+        </p:style>
+        <p:txBody>
+          <a:bodyPr rtlCol="0" anchor="ctr"/>
+          <a:lstStyle/>
+          <a:p>
+            <a:pPr marL="0" marR="0" lvl="0" indent="0" algn="ctr" defTabSz="914400" rtl="0" eaLnBrk="1" fontAlgn="auto" latinLnBrk="1" hangingPunct="1">
+              <a:lnSpc>
+                <a:spcPct val="100000"/>
+              </a:lnSpc>
+              <a:spcBef>
+                <a:spcPts val="0"/>
+              </a:spcBef>
+              <a:spcAft>
+                <a:spcPts val="0"/>
+              </a:spcAft>
+              <a:buClrTx/>
+              <a:buSzTx/>
+              <a:buFontTx/>
+              <a:buNone/>
+              <a:tabLst/>
+              <a:defRPr/>
+            </a:pPr>
+            <a:endParaRPr kumimoji="0" lang="ko-KR" altLang="en-US" sz="1800" b="0" i="0" u="none" strike="noStrike" kern="1200" cap="none" spc="0" normalizeH="0" baseline="0" noProof="0">
+              <a:ln>
+                <a:noFill/>
+              </a:ln>
+              <a:solidFill>
+                <a:prstClr val="white"/>
+              </a:solidFill>
+              <a:effectLst/>
+              <a:uLnTx/>
+              <a:uFillTx/>
+              <a:latin typeface="Montserrat" pitchFamily="2" charset="0"/>
+              <a:ea typeface="맑은 고딕" panose="020B0503020000020004" pitchFamily="50" charset="-127"/>
+              <a:cs typeface="+mn-cs"/>
+            </a:endParaRPr>
+          </a:p>
+        </p:txBody>
+      </p:sp>
+    </p:spTree>
+    <p:extLst>
+      <p:ext uri="{BB962C8B-B14F-4D97-AF65-F5344CB8AC3E}">
+        <p14:creationId xmlns:p14="http://schemas.microsoft.com/office/powerpoint/2010/main" val="1099443927"/>
+      </p:ext>
+    </p:extLst>
+  </p:cSld>
+  <p:clrMapOvr>
+    <a:masterClrMapping/>
+  </p:clrMapOvr>
+</p:sld>
+</file>
+
+<file path=ppt/slides/slide15.xml><?xml version="1.0" encoding="utf-8"?>
 <p:sld xmlns:a="http://schemas.openxmlformats.org/drawingml/2006/main" xmlns:r="http://schemas.openxmlformats.org/officeDocument/2006/relationships" xmlns:p="http://schemas.openxmlformats.org/presentationml/2006/main">
   <p:cSld>
     <p:spTree>
@@ -4936,7 +5597,7 @@
 </p:sld>
 </file>
 
-<file path=ppt/slides/slide14.xml><?xml version="1.0" encoding="utf-8"?>
+<file path=ppt/slides/slide16.xml><?xml version="1.0" encoding="utf-8"?>
 <p:sld xmlns:a="http://schemas.openxmlformats.org/drawingml/2006/main" xmlns:r="http://schemas.openxmlformats.org/officeDocument/2006/relationships" xmlns:p="http://schemas.openxmlformats.org/presentationml/2006/main">
   <p:cSld>
     <p:spTree>
@@ -5144,7 +5805,7 @@
 </p:sld>
 </file>
 
-<file path=ppt/slides/slide15.xml><?xml version="1.0" encoding="utf-8"?>
+<file path=ppt/slides/slide17.xml><?xml version="1.0" encoding="utf-8"?>
 <p:sld xmlns:a="http://schemas.openxmlformats.org/drawingml/2006/main" xmlns:r="http://schemas.openxmlformats.org/officeDocument/2006/relationships" xmlns:p="http://schemas.openxmlformats.org/presentationml/2006/main">
   <p:cSld>
     <p:spTree>
@@ -30526,7 +31187,7 @@
 </p:sld>
 </file>
 
-<file path=ppt/slides/slide16.xml><?xml version="1.0" encoding="utf-8"?>
+<file path=ppt/slides/slide18.xml><?xml version="1.0" encoding="utf-8"?>
 <p:sld xmlns:a="http://schemas.openxmlformats.org/drawingml/2006/main" xmlns:r="http://schemas.openxmlformats.org/officeDocument/2006/relationships" xmlns:p="http://schemas.openxmlformats.org/presentationml/2006/main">
   <p:cSld>
     <p:spTree>
@@ -33904,7 +34565,7 @@
 </p:sld>
 </file>
 
-<file path=ppt/slides/slide17.xml><?xml version="1.0" encoding="utf-8"?>
+<file path=ppt/slides/slide19.xml><?xml version="1.0" encoding="utf-8"?>
 <p:sld xmlns:a="http://schemas.openxmlformats.org/drawingml/2006/main" xmlns:r="http://schemas.openxmlformats.org/officeDocument/2006/relationships" xmlns:p="http://schemas.openxmlformats.org/presentationml/2006/main">
   <p:cSld>
     <p:spTree>
@@ -37285,7 +37946,87 @@
 </p:sld>
 </file>
 
-<file path=ppt/slides/slide18.xml><?xml version="1.0" encoding="utf-8"?>
+<file path=ppt/slides/slide2.xml><?xml version="1.0" encoding="utf-8"?>
+<p:sld xmlns:a="http://schemas.openxmlformats.org/drawingml/2006/main" xmlns:r="http://schemas.openxmlformats.org/officeDocument/2006/relationships" xmlns:p="http://schemas.openxmlformats.org/presentationml/2006/main">
+  <p:cSld>
+    <p:spTree>
+      <p:nvGrpSpPr>
+        <p:cNvPr id="1" name=""/>
+        <p:cNvGrpSpPr/>
+        <p:nvPr/>
+      </p:nvGrpSpPr>
+      <p:grpSpPr>
+        <a:xfrm>
+          <a:off x="0" y="0"/>
+          <a:ext cx="0" cy="0"/>
+          <a:chOff x="0" y="0"/>
+          <a:chExt cx="0" cy="0"/>
+        </a:xfrm>
+      </p:grpSpPr>
+      <p:sp>
+        <p:nvSpPr>
+          <p:cNvPr id="2" name="제목 1">
+            <a:extLst>
+              <a:ext uri="{FF2B5EF4-FFF2-40B4-BE49-F238E27FC236}">
+                <a16:creationId xmlns:a16="http://schemas.microsoft.com/office/drawing/2014/main" id="{6B72C4B6-F596-F78E-3A8C-23BCA79F7F76}"/>
+              </a:ext>
+            </a:extLst>
+          </p:cNvPr>
+          <p:cNvSpPr>
+            <a:spLocks noGrp="1"/>
+          </p:cNvSpPr>
+          <p:nvPr>
+            <p:ph type="title"/>
+          </p:nvPr>
+        </p:nvSpPr>
+        <p:spPr/>
+        <p:txBody>
+          <a:bodyPr/>
+          <a:lstStyle/>
+          <a:p>
+            <a:endParaRPr lang="ko-KR" altLang="en-US"/>
+          </a:p>
+        </p:txBody>
+      </p:sp>
+      <p:sp>
+        <p:nvSpPr>
+          <p:cNvPr id="3" name="내용 개체 틀 2">
+            <a:extLst>
+              <a:ext uri="{FF2B5EF4-FFF2-40B4-BE49-F238E27FC236}">
+                <a16:creationId xmlns:a16="http://schemas.microsoft.com/office/drawing/2014/main" id="{461B4D87-F7B2-AB98-E8DD-ED3981191125}"/>
+              </a:ext>
+            </a:extLst>
+          </p:cNvPr>
+          <p:cNvSpPr>
+            <a:spLocks noGrp="1"/>
+          </p:cNvSpPr>
+          <p:nvPr>
+            <p:ph idx="1"/>
+          </p:nvPr>
+        </p:nvSpPr>
+        <p:spPr/>
+        <p:txBody>
+          <a:bodyPr/>
+          <a:lstStyle/>
+          <a:p>
+            <a:endParaRPr lang="ko-KR" altLang="en-US"/>
+          </a:p>
+        </p:txBody>
+      </p:sp>
+    </p:spTree>
+    <p:extLst>
+      <p:ext uri="{BB962C8B-B14F-4D97-AF65-F5344CB8AC3E}">
+        <p14:creationId xmlns:p14="http://schemas.microsoft.com/office/powerpoint/2010/main" val="1772083265"/>
+      </p:ext>
+    </p:extLst>
+  </p:cSld>
+  <p:clrMapOvr>
+    <a:masterClrMapping/>
+  </p:clrMapOvr>
+</p:sld>
+</file>
+
+<file path=ppt/slides/slide20.xml><?xml version="1.0" encoding="utf-8"?>
 <p:sld xmlns:a="http://schemas.openxmlformats.org/drawingml/2006/main" xmlns:r="http://schemas.openxmlformats.org/officeDocument/2006/relationships" xmlns:p="http://schemas.openxmlformats.org/presentationml/2006/main">
   <p:cSld>
     <p:spTree>
@@ -40662,7 +41403,7 @@
 </p:sld>
 </file>
 
-<file path=ppt/slides/slide19.xml><?xml version="1.0" encoding="utf-8"?>
+<file path=ppt/slides/slide21.xml><?xml version="1.0" encoding="utf-8"?>
 <p:sld xmlns:a="http://schemas.openxmlformats.org/drawingml/2006/main" xmlns:r="http://schemas.openxmlformats.org/officeDocument/2006/relationships" xmlns:p="http://schemas.openxmlformats.org/presentationml/2006/main">
   <p:cSld>
     <p:spTree>
@@ -42167,86 +42908,6 @@
 </p:sld>
 </file>
 
-<file path=ppt/slides/slide2.xml><?xml version="1.0" encoding="utf-8"?>
-<p:sld xmlns:a="http://schemas.openxmlformats.org/drawingml/2006/main" xmlns:r="http://schemas.openxmlformats.org/officeDocument/2006/relationships" xmlns:p="http://schemas.openxmlformats.org/presentationml/2006/main">
-  <p:cSld>
-    <p:spTree>
-      <p:nvGrpSpPr>
-        <p:cNvPr id="1" name=""/>
-        <p:cNvGrpSpPr/>
-        <p:nvPr/>
-      </p:nvGrpSpPr>
-      <p:grpSpPr>
-        <a:xfrm>
-          <a:off x="0" y="0"/>
-          <a:ext cx="0" cy="0"/>
-          <a:chOff x="0" y="0"/>
-          <a:chExt cx="0" cy="0"/>
-        </a:xfrm>
-      </p:grpSpPr>
-      <p:sp>
-        <p:nvSpPr>
-          <p:cNvPr id="2" name="제목 1">
-            <a:extLst>
-              <a:ext uri="{FF2B5EF4-FFF2-40B4-BE49-F238E27FC236}">
-                <a16:creationId xmlns:a16="http://schemas.microsoft.com/office/drawing/2014/main" id="{6B72C4B6-F596-F78E-3A8C-23BCA79F7F76}"/>
-              </a:ext>
-            </a:extLst>
-          </p:cNvPr>
-          <p:cNvSpPr>
-            <a:spLocks noGrp="1"/>
-          </p:cNvSpPr>
-          <p:nvPr>
-            <p:ph type="title"/>
-          </p:nvPr>
-        </p:nvSpPr>
-        <p:spPr/>
-        <p:txBody>
-          <a:bodyPr/>
-          <a:lstStyle/>
-          <a:p>
-            <a:endParaRPr lang="ko-KR" altLang="en-US"/>
-          </a:p>
-        </p:txBody>
-      </p:sp>
-      <p:sp>
-        <p:nvSpPr>
-          <p:cNvPr id="3" name="내용 개체 틀 2">
-            <a:extLst>
-              <a:ext uri="{FF2B5EF4-FFF2-40B4-BE49-F238E27FC236}">
-                <a16:creationId xmlns:a16="http://schemas.microsoft.com/office/drawing/2014/main" id="{461B4D87-F7B2-AB98-E8DD-ED3981191125}"/>
-              </a:ext>
-            </a:extLst>
-          </p:cNvPr>
-          <p:cNvSpPr>
-            <a:spLocks noGrp="1"/>
-          </p:cNvSpPr>
-          <p:nvPr>
-            <p:ph idx="1"/>
-          </p:nvPr>
-        </p:nvSpPr>
-        <p:spPr/>
-        <p:txBody>
-          <a:bodyPr/>
-          <a:lstStyle/>
-          <a:p>
-            <a:endParaRPr lang="ko-KR" altLang="en-US"/>
-          </a:p>
-        </p:txBody>
-      </p:sp>
-    </p:spTree>
-    <p:extLst>
-      <p:ext uri="{BB962C8B-B14F-4D97-AF65-F5344CB8AC3E}">
-        <p14:creationId xmlns:p14="http://schemas.microsoft.com/office/powerpoint/2010/main" val="1772083265"/>
-      </p:ext>
-    </p:extLst>
-  </p:cSld>
-  <p:clrMapOvr>
-    <a:masterClrMapping/>
-  </p:clrMapOvr>
-</p:sld>
-</file>
-
 <file path=ppt/slides/slide3.xml><?xml version="1.0" encoding="utf-8"?>
 <p:sld xmlns:a="http://schemas.openxmlformats.org/drawingml/2006/main" xmlns:r="http://schemas.openxmlformats.org/officeDocument/2006/relationships" xmlns:p="http://schemas.openxmlformats.org/presentationml/2006/main">
   <p:cSld>
@@ -43008,7 +43669,7 @@
                   <a:srgbClr val="FFFF00"/>
                 </a:highlight>
               </a:rPr>
-              <a:t>달라지는점은</a:t>
+              <a:t>달라지는점</a:t>
             </a:r>
             <a:br>
               <a:rPr lang="en-US" altLang="ko-KR" dirty="0">
@@ -43235,7 +43896,7 @@
                   <a:srgbClr val="FFFF00"/>
                 </a:highlight>
               </a:rPr>
-              <a:t>달라지는점은</a:t>
+              <a:t>달라지는점</a:t>
             </a:r>
             <a:br>
               <a:rPr lang="en-US" altLang="ko-KR" dirty="0">
@@ -43288,6 +43949,59 @@
                 <a:srgbClr val="FFFF00"/>
               </a:highlight>
             </a:endParaRPr>
+          </a:p>
+        </p:txBody>
+      </p:sp>
+      <p:sp>
+        <p:nvSpPr>
+          <p:cNvPr id="17" name="직사각형 16">
+            <a:extLst>
+              <a:ext uri="{FF2B5EF4-FFF2-40B4-BE49-F238E27FC236}">
+                <a16:creationId xmlns:a16="http://schemas.microsoft.com/office/drawing/2014/main" id="{B141E512-2EF8-ECDB-1647-A8ABC5977C29}"/>
+              </a:ext>
+            </a:extLst>
+          </p:cNvPr>
+          <p:cNvSpPr/>
+          <p:nvPr/>
+        </p:nvSpPr>
+        <p:spPr>
+          <a:xfrm>
+            <a:off x="9542234" y="1570200"/>
+            <a:ext cx="3449866" cy="180459"/>
+          </a:xfrm>
+          <a:prstGeom prst="rect">
+            <a:avLst/>
+          </a:prstGeom>
+          <a:noFill/>
+          <a:ln>
+            <a:solidFill>
+              <a:srgbClr val="C00000"/>
+            </a:solidFill>
+            <a:prstDash val="sysDash"/>
+          </a:ln>
+        </p:spPr>
+        <p:style>
+          <a:lnRef idx="2">
+            <a:schemeClr val="accent1">
+              <a:shade val="15000"/>
+            </a:schemeClr>
+          </a:lnRef>
+          <a:fillRef idx="1">
+            <a:schemeClr val="accent1"/>
+          </a:fillRef>
+          <a:effectRef idx="0">
+            <a:schemeClr val="accent1"/>
+          </a:effectRef>
+          <a:fontRef idx="minor">
+            <a:schemeClr val="lt1"/>
+          </a:fontRef>
+        </p:style>
+        <p:txBody>
+          <a:bodyPr rtlCol="0" anchor="ctr"/>
+          <a:lstStyle/>
+          <a:p>
+            <a:pPr algn="ctr"/>
+            <a:endParaRPr lang="ko-KR" altLang="en-US" dirty="0"/>
           </a:p>
         </p:txBody>
       </p:sp>

</xml_diff>

<commit_message>
vault backup: 2026-07-03 22:12:32
</commit_message>
<xml_diff>
--- a/assets/06-dataspace/image.pptx
+++ b/assets/06-dataspace/image.pptx
@@ -135,7 +135,7 @@
 <file path=ppt/revisionInfo.xml><?xml version="1.0" encoding="utf-8"?>
 <p1510:revInfo xmlns:a="http://schemas.openxmlformats.org/drawingml/2006/main" xmlns:r="http://schemas.openxmlformats.org/officeDocument/2006/relationships" xmlns:p1510="http://schemas.microsoft.com/office/powerpoint/2015/10/main">
   <p1510:revLst>
-    <p1510:client id="{77AFA03C-ADB3-48E7-9DEE-EC77C33AF38A}" v="110" dt="2026-07-03T12:57:22.740"/>
+    <p1510:client id="{77AFA03C-ADB3-48E7-9DEE-EC77C33AF38A}" v="120" dt="2026-07-03T13:03:58.318"/>
   </p1510:revLst>
 </p1510:revInfo>
 </file>
@@ -145,7 +145,7 @@
   <pc:docChgLst>
     <pc:chgData name="헌정 임" userId="eb9ca9bd79f0560f" providerId="LiveId" clId="{A6339E56-8272-42D6-9D95-12E1A8284411}"/>
     <pc:docChg chg="undo custSel addSld delSld modSld">
-      <pc:chgData name="헌정 임" userId="eb9ca9bd79f0560f" providerId="LiveId" clId="{A6339E56-8272-42D6-9D95-12E1A8284411}" dt="2026-07-03T12:57:22.740" v="1172"/>
+      <pc:chgData name="헌정 임" userId="eb9ca9bd79f0560f" providerId="LiveId" clId="{A6339E56-8272-42D6-9D95-12E1A8284411}" dt="2026-07-03T13:04:19.379" v="1326" actId="1037"/>
       <pc:docMkLst>
         <pc:docMk/>
       </pc:docMkLst>
@@ -875,17 +875,25 @@
         </pc:cxnChg>
       </pc:sldChg>
       <pc:sldChg chg="addSp delSp modSp add mod">
-        <pc:chgData name="헌정 임" userId="eb9ca9bd79f0560f" providerId="LiveId" clId="{A6339E56-8272-42D6-9D95-12E1A8284411}" dt="2026-07-03T12:47:18.216" v="896"/>
+        <pc:chgData name="헌정 임" userId="eb9ca9bd79f0560f" providerId="LiveId" clId="{A6339E56-8272-42D6-9D95-12E1A8284411}" dt="2026-07-03T13:04:19.379" v="1326" actId="1037"/>
         <pc:sldMkLst>
           <pc:docMk/>
           <pc:sldMk cId="3863440157" sldId="395"/>
         </pc:sldMkLst>
         <pc:spChg chg="add mod">
-          <ac:chgData name="헌정 임" userId="eb9ca9bd79f0560f" providerId="LiveId" clId="{A6339E56-8272-42D6-9D95-12E1A8284411}" dt="2026-07-03T12:47:18.216" v="896"/>
+          <ac:chgData name="헌정 임" userId="eb9ca9bd79f0560f" providerId="LiveId" clId="{A6339E56-8272-42D6-9D95-12E1A8284411}" dt="2026-07-03T13:04:19.379" v="1326" actId="1037"/>
           <ac:spMkLst>
             <pc:docMk/>
             <pc:sldMk cId="3863440157" sldId="395"/>
             <ac:spMk id="3" creationId="{60232472-F08E-ABF8-CCA6-ADC50821946D}"/>
+          </ac:spMkLst>
+        </pc:spChg>
+        <pc:spChg chg="add mod">
+          <ac:chgData name="헌정 임" userId="eb9ca9bd79f0560f" providerId="LiveId" clId="{A6339E56-8272-42D6-9D95-12E1A8284411}" dt="2026-07-03T13:04:13.215" v="1317" actId="13926"/>
+          <ac:spMkLst>
+            <pc:docMk/>
+            <pc:sldMk cId="3863440157" sldId="395"/>
+            <ac:spMk id="5" creationId="{E5FFBD18-5489-51B0-7198-77957871EC26}"/>
           </ac:spMkLst>
         </pc:spChg>
         <pc:picChg chg="del">
@@ -937,7 +945,7 @@
           </ac:picMkLst>
         </pc:picChg>
         <pc:picChg chg="mod">
-          <ac:chgData name="헌정 임" userId="eb9ca9bd79f0560f" providerId="LiveId" clId="{A6339E56-8272-42D6-9D95-12E1A8284411}" dt="2026-07-03T12:43:47.612" v="666" actId="1076"/>
+          <ac:chgData name="헌정 임" userId="eb9ca9bd79f0560f" providerId="LiveId" clId="{A6339E56-8272-42D6-9D95-12E1A8284411}" dt="2026-07-03T13:03:25.375" v="1280" actId="1076"/>
           <ac:picMkLst>
             <pc:docMk/>
             <pc:sldMk cId="3863440157" sldId="395"/>
@@ -5372,7 +5380,7 @@
               <a:t>장비명</a:t>
             </a:r>
             <a:r>
-              <a:rPr lang="ko-KR" altLang="en-US">
+              <a:rPr lang="ko-KR" altLang="en-US" dirty="0">
                 <a:highlight>
                   <a:srgbClr val="FFFF00"/>
                 </a:highlight>
@@ -44150,7 +44158,7 @@
         </p:blipFill>
         <p:spPr>
           <a:xfrm>
-            <a:off x="83857" y="1095376"/>
+            <a:off x="131481" y="1193235"/>
             <a:ext cx="4248181" cy="2991716"/>
           </a:xfrm>
           <a:prstGeom prst="rect">
@@ -44172,17 +44180,17 @@
         </p:nvSpPr>
         <p:spPr>
           <a:xfrm>
-            <a:off x="882172" y="4948400"/>
-            <a:ext cx="4305778" cy="474500"/>
+            <a:off x="265946" y="1720667"/>
+            <a:ext cx="2927828" cy="223675"/>
           </a:xfrm>
           <a:prstGeom prst="rect">
             <a:avLst/>
           </a:prstGeom>
-          <a:noFill/>
+          <a:solidFill>
+            <a:schemeClr val="bg1"/>
+          </a:solidFill>
           <a:ln>
-            <a:solidFill>
-              <a:srgbClr val="C00000"/>
-            </a:solidFill>
+            <a:noFill/>
             <a:prstDash val="sysDash"/>
           </a:ln>
         </p:spPr>
@@ -44203,37 +44211,119 @@
           </a:fontRef>
         </p:style>
         <p:txBody>
-          <a:bodyPr rtlCol="0" anchor="ctr"/>
+          <a:bodyPr lIns="0" tIns="0" rIns="0" bIns="0" rtlCol="0" anchor="ctr"/>
           <a:lstStyle/>
           <a:p>
             <a:pPr algn="ctr"/>
             <a:r>
-              <a:rPr lang="ko-KR" altLang="en-US" dirty="0">
+              <a:rPr lang="ko-KR" altLang="en-US" sz="1400" dirty="0">
                 <a:solidFill>
                   <a:schemeClr val="bg1">
                     <a:lumMod val="50000"/>
                   </a:schemeClr>
                 </a:solidFill>
+                <a:highlight>
+                  <a:srgbClr val="FFFF00"/>
+                </a:highlight>
               </a:rPr>
-              <a:t>장비내 파일 탐색기 활용 됩니다</a:t>
+              <a:t>장치 파일관리에서 활용 됩니다</a:t>
             </a:r>
             <a:r>
-              <a:rPr lang="en-US" altLang="ko-KR" dirty="0">
+              <a:rPr lang="en-US" altLang="ko-KR" sz="1400" dirty="0">
                 <a:solidFill>
                   <a:schemeClr val="bg1">
                     <a:lumMod val="50000"/>
                   </a:schemeClr>
                 </a:solidFill>
+                <a:highlight>
+                  <a:srgbClr val="FFFF00"/>
+                </a:highlight>
               </a:rPr>
-              <a:t>. </a:t>
+              <a:t>.</a:t>
             </a:r>
-            <a:endParaRPr lang="ko-KR" altLang="en-US" dirty="0">
+            <a:endParaRPr lang="ko-KR" altLang="en-US" sz="1400" dirty="0">
               <a:solidFill>
                 <a:schemeClr val="bg1">
                   <a:lumMod val="50000"/>
                 </a:schemeClr>
               </a:solidFill>
+              <a:highlight>
+                <a:srgbClr val="FFFF00"/>
+              </a:highlight>
             </a:endParaRPr>
+          </a:p>
+        </p:txBody>
+      </p:sp>
+      <p:sp>
+        <p:nvSpPr>
+          <p:cNvPr id="5" name="직사각형 4">
+            <a:extLst>
+              <a:ext uri="{FF2B5EF4-FFF2-40B4-BE49-F238E27FC236}">
+                <a16:creationId xmlns:a16="http://schemas.microsoft.com/office/drawing/2014/main" id="{E5FFBD18-5489-51B0-7198-77957871EC26}"/>
+              </a:ext>
+            </a:extLst>
+          </p:cNvPr>
+          <p:cNvSpPr/>
+          <p:nvPr/>
+        </p:nvSpPr>
+        <p:spPr>
+          <a:xfrm>
+            <a:off x="435019" y="1445292"/>
+            <a:ext cx="2927828" cy="223675"/>
+          </a:xfrm>
+          <a:prstGeom prst="rect">
+            <a:avLst/>
+          </a:prstGeom>
+          <a:solidFill>
+            <a:schemeClr val="bg1"/>
+          </a:solidFill>
+          <a:ln>
+            <a:noFill/>
+            <a:prstDash val="sysDash"/>
+          </a:ln>
+        </p:spPr>
+        <p:style>
+          <a:lnRef idx="2">
+            <a:schemeClr val="accent1">
+              <a:shade val="15000"/>
+            </a:schemeClr>
+          </a:lnRef>
+          <a:fillRef idx="1">
+            <a:schemeClr val="accent1"/>
+          </a:fillRef>
+          <a:effectRef idx="0">
+            <a:schemeClr val="accent1"/>
+          </a:effectRef>
+          <a:fontRef idx="minor">
+            <a:schemeClr val="lt1"/>
+          </a:fontRef>
+        </p:style>
+        <p:txBody>
+          <a:bodyPr lIns="0" tIns="0" rIns="0" bIns="0" rtlCol="0" anchor="ctr"/>
+          <a:lstStyle/>
+          <a:p>
+            <a:r>
+              <a:rPr lang="en-US" altLang="ko-KR" sz="1400" dirty="0">
+                <a:solidFill>
+                  <a:schemeClr val="tx1"/>
+                </a:solidFill>
+                <a:highlight>
+                  <a:srgbClr val="FFFF00"/>
+                </a:highlight>
+              </a:rPr>
+              <a:t>SFTP(SSH) </a:t>
+            </a:r>
+            <a:r>
+              <a:rPr lang="ko-KR" altLang="en-US" sz="1400" dirty="0">
+                <a:solidFill>
+                  <a:schemeClr val="tx1"/>
+                </a:solidFill>
+                <a:highlight>
+                  <a:srgbClr val="FFFF00"/>
+                </a:highlight>
+              </a:rPr>
+              <a:t>접속 정보</a:t>
+            </a:r>
           </a:p>
         </p:txBody>
       </p:sp>

</xml_diff>

<commit_message>
vault backup: 2026-07-04 08:50:53
</commit_message>
<xml_diff>
--- a/assets/06-dataspace/image.pptx
+++ b/assets/06-dataspace/image.pptx
@@ -13,19 +13,20 @@
     <p:sldId id="384" r:id="rId7"/>
     <p:sldId id="385" r:id="rId8"/>
     <p:sldId id="395" r:id="rId9"/>
-    <p:sldId id="396" r:id="rId10"/>
+    <p:sldId id="399" r:id="rId10"/>
     <p:sldId id="397" r:id="rId11"/>
     <p:sldId id="387" r:id="rId12"/>
     <p:sldId id="388" r:id="rId13"/>
     <p:sldId id="392" r:id="rId14"/>
     <p:sldId id="398" r:id="rId15"/>
     <p:sldId id="393" r:id="rId16"/>
-    <p:sldId id="256" r:id="rId17"/>
-    <p:sldId id="257" r:id="rId18"/>
-    <p:sldId id="259" r:id="rId19"/>
-    <p:sldId id="258" r:id="rId20"/>
-    <p:sldId id="260" r:id="rId21"/>
-    <p:sldId id="380" r:id="rId22"/>
+    <p:sldId id="396" r:id="rId17"/>
+    <p:sldId id="256" r:id="rId18"/>
+    <p:sldId id="257" r:id="rId19"/>
+    <p:sldId id="259" r:id="rId20"/>
+    <p:sldId id="258" r:id="rId21"/>
+    <p:sldId id="260" r:id="rId22"/>
+    <p:sldId id="380" r:id="rId23"/>
   </p:sldIdLst>
   <p:sldSz cx="12192000" cy="6858000"/>
   <p:notesSz cx="6858000" cy="9144000"/>
@@ -135,7 +136,7 @@
 <file path=ppt/revisionInfo.xml><?xml version="1.0" encoding="utf-8"?>
 <p1510:revInfo xmlns:a="http://schemas.openxmlformats.org/drawingml/2006/main" xmlns:r="http://schemas.openxmlformats.org/officeDocument/2006/relationships" xmlns:p1510="http://schemas.microsoft.com/office/powerpoint/2015/10/main">
   <p1510:revLst>
-    <p1510:client id="{77AFA03C-ADB3-48E7-9DEE-EC77C33AF38A}" v="120" dt="2026-07-03T13:03:58.318"/>
+    <p1510:client id="{77AFA03C-ADB3-48E7-9DEE-EC77C33AF38A}" v="187" dt="2026-07-03T23:50:31.260"/>
   </p1510:revLst>
 </p1510:revInfo>
 </file>
@@ -144,8 +145,8 @@
 <pc:chgInfo xmlns:a="http://schemas.openxmlformats.org/drawingml/2006/main" xmlns:r="http://schemas.openxmlformats.org/officeDocument/2006/relationships" xmlns:ac="http://schemas.microsoft.com/office/drawing/2013/main/command" xmlns:pc="http://schemas.microsoft.com/office/powerpoint/2013/main/command">
   <pc:docChgLst>
     <pc:chgData name="헌정 임" userId="eb9ca9bd79f0560f" providerId="LiveId" clId="{A6339E56-8272-42D6-9D95-12E1A8284411}"/>
-    <pc:docChg chg="undo custSel addSld delSld modSld">
-      <pc:chgData name="헌정 임" userId="eb9ca9bd79f0560f" providerId="LiveId" clId="{A6339E56-8272-42D6-9D95-12E1A8284411}" dt="2026-07-03T13:04:19.379" v="1326" actId="1037"/>
+    <pc:docChg chg="undo custSel addSld delSld modSld sldOrd">
+      <pc:chgData name="헌정 임" userId="eb9ca9bd79f0560f" providerId="LiveId" clId="{A6339E56-8272-42D6-9D95-12E1A8284411}" dt="2026-07-03T23:50:31.260" v="2101"/>
       <pc:docMkLst>
         <pc:docMk/>
       </pc:docMkLst>
@@ -875,7 +876,7 @@
         </pc:cxnChg>
       </pc:sldChg>
       <pc:sldChg chg="addSp delSp modSp add mod">
-        <pc:chgData name="헌정 임" userId="eb9ca9bd79f0560f" providerId="LiveId" clId="{A6339E56-8272-42D6-9D95-12E1A8284411}" dt="2026-07-03T13:04:19.379" v="1326" actId="1037"/>
+        <pc:chgData name="헌정 임" userId="eb9ca9bd79f0560f" providerId="LiveId" clId="{A6339E56-8272-42D6-9D95-12E1A8284411}" dt="2026-07-03T23:50:31.260" v="2101"/>
         <pc:sldMkLst>
           <pc:docMk/>
           <pc:sldMk cId="3863440157" sldId="395"/>
@@ -889,11 +890,43 @@
           </ac:spMkLst>
         </pc:spChg>
         <pc:spChg chg="add mod">
-          <ac:chgData name="헌정 임" userId="eb9ca9bd79f0560f" providerId="LiveId" clId="{A6339E56-8272-42D6-9D95-12E1A8284411}" dt="2026-07-03T13:04:13.215" v="1317" actId="13926"/>
+          <ac:chgData name="헌정 임" userId="eb9ca9bd79f0560f" providerId="LiveId" clId="{A6339E56-8272-42D6-9D95-12E1A8284411}" dt="2026-07-03T23:48:33.677" v="1827" actId="20577"/>
           <ac:spMkLst>
             <pc:docMk/>
             <pc:sldMk cId="3863440157" sldId="395"/>
             <ac:spMk id="5" creationId="{E5FFBD18-5489-51B0-7198-77957871EC26}"/>
+          </ac:spMkLst>
+        </pc:spChg>
+        <pc:spChg chg="add mod">
+          <ac:chgData name="헌정 임" userId="eb9ca9bd79f0560f" providerId="LiveId" clId="{A6339E56-8272-42D6-9D95-12E1A8284411}" dt="2026-07-03T23:43:12.833" v="1341" actId="20577"/>
+          <ac:spMkLst>
+            <pc:docMk/>
+            <pc:sldMk cId="3863440157" sldId="395"/>
+            <ac:spMk id="7" creationId="{7B2D9C4B-1C6A-D66B-A659-8DAB53D06786}"/>
+          </ac:spMkLst>
+        </pc:spChg>
+        <pc:spChg chg="add mod">
+          <ac:chgData name="헌정 임" userId="eb9ca9bd79f0560f" providerId="LiveId" clId="{A6339E56-8272-42D6-9D95-12E1A8284411}" dt="2026-07-03T23:43:34.604" v="1359" actId="20577"/>
+          <ac:spMkLst>
+            <pc:docMk/>
+            <pc:sldMk cId="3863440157" sldId="395"/>
+            <ac:spMk id="9" creationId="{382888A0-6698-4471-AE02-8C20BC1C3953}"/>
+          </ac:spMkLst>
+        </pc:spChg>
+        <pc:spChg chg="add mod">
+          <ac:chgData name="헌정 임" userId="eb9ca9bd79f0560f" providerId="LiveId" clId="{A6339E56-8272-42D6-9D95-12E1A8284411}" dt="2026-07-03T23:44:05.816" v="1418"/>
+          <ac:spMkLst>
+            <pc:docMk/>
+            <pc:sldMk cId="3863440157" sldId="395"/>
+            <ac:spMk id="14" creationId="{BF7CC288-6D57-C8AD-55BD-B81F3786A2ED}"/>
+          </ac:spMkLst>
+        </pc:spChg>
+        <pc:spChg chg="add mod">
+          <ac:chgData name="헌정 임" userId="eb9ca9bd79f0560f" providerId="LiveId" clId="{A6339E56-8272-42D6-9D95-12E1A8284411}" dt="2026-07-03T23:50:31.260" v="2101"/>
+          <ac:spMkLst>
+            <pc:docMk/>
+            <pc:sldMk cId="3863440157" sldId="395"/>
+            <ac:spMk id="15" creationId="{B9DD7709-7813-C69F-69A9-15152D4504E0}"/>
           </ac:spMkLst>
         </pc:spChg>
         <pc:picChg chg="del">
@@ -905,15 +938,15 @@
           </ac:picMkLst>
         </pc:picChg>
         <pc:picChg chg="mod">
-          <ac:chgData name="헌정 임" userId="eb9ca9bd79f0560f" providerId="LiveId" clId="{A6339E56-8272-42D6-9D95-12E1A8284411}" dt="2026-07-03T12:46:07.986" v="791" actId="1076"/>
+          <ac:chgData name="헌정 임" userId="eb9ca9bd79f0560f" providerId="LiveId" clId="{A6339E56-8272-42D6-9D95-12E1A8284411}" dt="2026-07-03T23:48:19.882" v="1798" actId="1037"/>
           <ac:picMkLst>
             <pc:docMk/>
             <pc:sldMk cId="3863440157" sldId="395"/>
             <ac:picMk id="6" creationId="{B845D697-C236-3D8B-C60C-A557E44532D6}"/>
           </ac:picMkLst>
         </pc:picChg>
-        <pc:picChg chg="mod">
-          <ac:chgData name="헌정 임" userId="eb9ca9bd79f0560f" providerId="LiveId" clId="{A6339E56-8272-42D6-9D95-12E1A8284411}" dt="2026-07-03T12:43:50.522" v="668" actId="1076"/>
+        <pc:picChg chg="del mod">
+          <ac:chgData name="헌정 임" userId="eb9ca9bd79f0560f" providerId="LiveId" clId="{A6339E56-8272-42D6-9D95-12E1A8284411}" dt="2026-07-03T23:44:22.569" v="1420" actId="21"/>
           <ac:picMkLst>
             <pc:docMk/>
             <pc:sldMk cId="3863440157" sldId="395"/>
@@ -953,8 +986,8 @@
           </ac:picMkLst>
         </pc:picChg>
       </pc:sldChg>
-      <pc:sldChg chg="add">
-        <pc:chgData name="헌정 임" userId="eb9ca9bd79f0560f" providerId="LiveId" clId="{A6339E56-8272-42D6-9D95-12E1A8284411}" dt="2026-07-03T12:43:29.324" v="654"/>
+      <pc:sldChg chg="add ord">
+        <pc:chgData name="헌정 임" userId="eb9ca9bd79f0560f" providerId="LiveId" clId="{A6339E56-8272-42D6-9D95-12E1A8284411}" dt="2026-07-03T23:45:03.051" v="1426"/>
         <pc:sldMkLst>
           <pc:docMk/>
           <pc:sldMk cId="2184797597" sldId="396"/>
@@ -987,6 +1020,61 @@
             <pc:docMk/>
             <pc:sldMk cId="1099443927" sldId="398"/>
             <ac:picMk id="4" creationId="{3DD657DB-9BF3-E3BF-6D87-A6AE803716DD}"/>
+          </ac:picMkLst>
+        </pc:picChg>
+      </pc:sldChg>
+      <pc:sldChg chg="addSp delSp modSp new mod">
+        <pc:chgData name="헌정 임" userId="eb9ca9bd79f0560f" providerId="LiveId" clId="{A6339E56-8272-42D6-9D95-12E1A8284411}" dt="2026-07-03T23:49:18.103" v="1942" actId="20577"/>
+        <pc:sldMkLst>
+          <pc:docMk/>
+          <pc:sldMk cId="3010018706" sldId="399"/>
+        </pc:sldMkLst>
+        <pc:spChg chg="del">
+          <ac:chgData name="헌정 임" userId="eb9ca9bd79f0560f" providerId="LiveId" clId="{A6339E56-8272-42D6-9D95-12E1A8284411}" dt="2026-07-03T23:44:25.811" v="1422" actId="478"/>
+          <ac:spMkLst>
+            <pc:docMk/>
+            <pc:sldMk cId="3010018706" sldId="399"/>
+            <ac:spMk id="2" creationId="{C1C8F3FC-C2E0-3D02-A7B9-938AE0828F65}"/>
+          </ac:spMkLst>
+        </pc:spChg>
+        <pc:spChg chg="add mod">
+          <ac:chgData name="헌정 임" userId="eb9ca9bd79f0560f" providerId="LiveId" clId="{A6339E56-8272-42D6-9D95-12E1A8284411}" dt="2026-07-03T23:47:07.707" v="1650" actId="1076"/>
+          <ac:spMkLst>
+            <pc:docMk/>
+            <pc:sldMk cId="3010018706" sldId="399"/>
+            <ac:spMk id="3" creationId="{35BD330A-F750-BC0A-59DE-8C17077501E7}"/>
+          </ac:spMkLst>
+        </pc:spChg>
+        <pc:spChg chg="add mod">
+          <ac:chgData name="헌정 임" userId="eb9ca9bd79f0560f" providerId="LiveId" clId="{A6339E56-8272-42D6-9D95-12E1A8284411}" dt="2026-07-03T23:47:24.897" v="1673" actId="20577"/>
+          <ac:spMkLst>
+            <pc:docMk/>
+            <pc:sldMk cId="3010018706" sldId="399"/>
+            <ac:spMk id="4" creationId="{B5B606E5-D90C-0996-E172-7A5EC51A7C1D}"/>
+          </ac:spMkLst>
+        </pc:spChg>
+        <pc:spChg chg="add del mod">
+          <ac:chgData name="헌정 임" userId="eb9ca9bd79f0560f" providerId="LiveId" clId="{A6339E56-8272-42D6-9D95-12E1A8284411}" dt="2026-07-03T23:47:26.164" v="1675"/>
+          <ac:spMkLst>
+            <pc:docMk/>
+            <pc:sldMk cId="3010018706" sldId="399"/>
+            <ac:spMk id="5" creationId="{F2CA44A0-EC79-B970-161F-9F71530DE3EB}"/>
+          </ac:spMkLst>
+        </pc:spChg>
+        <pc:spChg chg="add mod">
+          <ac:chgData name="헌정 임" userId="eb9ca9bd79f0560f" providerId="LiveId" clId="{A6339E56-8272-42D6-9D95-12E1A8284411}" dt="2026-07-03T23:49:18.103" v="1942" actId="20577"/>
+          <ac:spMkLst>
+            <pc:docMk/>
+            <pc:sldMk cId="3010018706" sldId="399"/>
+            <ac:spMk id="6" creationId="{8CBAADC2-493A-A8EC-B12E-55DE5B08C5B5}"/>
+          </ac:spMkLst>
+        </pc:spChg>
+        <pc:picChg chg="add mod">
+          <ac:chgData name="헌정 임" userId="eb9ca9bd79f0560f" providerId="LiveId" clId="{A6339E56-8272-42D6-9D95-12E1A8284411}" dt="2026-07-03T23:45:12.504" v="1427" actId="1076"/>
+          <ac:picMkLst>
+            <pc:docMk/>
+            <pc:sldMk cId="3010018706" sldId="399"/>
+            <ac:picMk id="8" creationId="{7C0EF117-428F-9EDD-E27F-AA9FBB041137}"/>
           </ac:picMkLst>
         </pc:picChg>
       </pc:sldChg>
@@ -5610,6 +5698,282 @@
   <p:cSld>
     <p:spTree>
       <p:nvGrpSpPr>
+        <p:cNvPr id="1" name="">
+          <a:extLst>
+            <a:ext uri="{FF2B5EF4-FFF2-40B4-BE49-F238E27FC236}">
+              <a16:creationId xmlns:a16="http://schemas.microsoft.com/office/drawing/2014/main" id="{D2F59DA8-6EB5-D1DF-F3F2-863231B123D3}"/>
+            </a:ext>
+          </a:extLst>
+        </p:cNvPr>
+        <p:cNvGrpSpPr/>
+        <p:nvPr/>
+      </p:nvGrpSpPr>
+      <p:grpSpPr>
+        <a:xfrm>
+          <a:off x="0" y="0"/>
+          <a:ext cx="0" cy="0"/>
+          <a:chOff x="0" y="0"/>
+          <a:chExt cx="0" cy="0"/>
+        </a:xfrm>
+      </p:grpSpPr>
+      <p:sp>
+        <p:nvSpPr>
+          <p:cNvPr id="2" name="제목 1">
+            <a:extLst>
+              <a:ext uri="{FF2B5EF4-FFF2-40B4-BE49-F238E27FC236}">
+                <a16:creationId xmlns:a16="http://schemas.microsoft.com/office/drawing/2014/main" id="{695C423C-55EB-11F0-6F2C-E759A1DE9565}"/>
+              </a:ext>
+            </a:extLst>
+          </p:cNvPr>
+          <p:cNvSpPr>
+            <a:spLocks noGrp="1"/>
+          </p:cNvSpPr>
+          <p:nvPr>
+            <p:ph type="title"/>
+          </p:nvPr>
+        </p:nvSpPr>
+        <p:spPr/>
+        <p:txBody>
+          <a:bodyPr/>
+          <a:lstStyle/>
+          <a:p>
+            <a:endParaRPr lang="ko-KR" altLang="en-US"/>
+          </a:p>
+        </p:txBody>
+      </p:sp>
+      <p:pic>
+        <p:nvPicPr>
+          <p:cNvPr id="4" name="그림 3">
+            <a:extLst>
+              <a:ext uri="{FF2B5EF4-FFF2-40B4-BE49-F238E27FC236}">
+                <a16:creationId xmlns:a16="http://schemas.microsoft.com/office/drawing/2014/main" id="{7C6C6874-D593-7ADA-8954-ED08CC6AAAAC}"/>
+              </a:ext>
+            </a:extLst>
+          </p:cNvPr>
+          <p:cNvPicPr>
+            <a:picLocks noChangeAspect="1"/>
+          </p:cNvPicPr>
+          <p:nvPr/>
+        </p:nvPicPr>
+        <p:blipFill>
+          <a:blip r:embed="rId2"/>
+          <a:srcRect t="53795" b="23331"/>
+          <a:stretch>
+            <a:fillRect/>
+          </a:stretch>
+        </p:blipFill>
+        <p:spPr>
+          <a:xfrm>
+            <a:off x="207650" y="4657603"/>
+            <a:ext cx="4333907" cy="1544782"/>
+          </a:xfrm>
+          <a:prstGeom prst="rect">
+            <a:avLst/>
+          </a:prstGeom>
+        </p:spPr>
+      </p:pic>
+      <p:pic>
+        <p:nvPicPr>
+          <p:cNvPr id="6" name="그림 5">
+            <a:extLst>
+              <a:ext uri="{FF2B5EF4-FFF2-40B4-BE49-F238E27FC236}">
+                <a16:creationId xmlns:a16="http://schemas.microsoft.com/office/drawing/2014/main" id="{3FA6B0C8-97A8-2EF8-0BC3-A89525CC46CB}"/>
+              </a:ext>
+            </a:extLst>
+          </p:cNvPr>
+          <p:cNvPicPr>
+            <a:picLocks noChangeAspect="1"/>
+          </p:cNvPicPr>
+          <p:nvPr/>
+        </p:nvPicPr>
+        <p:blipFill>
+          <a:blip r:embed="rId3"/>
+          <a:srcRect t="48199"/>
+          <a:stretch>
+            <a:fillRect/>
+          </a:stretch>
+        </p:blipFill>
+        <p:spPr>
+          <a:xfrm>
+            <a:off x="4541557" y="4087092"/>
+            <a:ext cx="4248181" cy="3187434"/>
+          </a:xfrm>
+          <a:prstGeom prst="rect">
+            <a:avLst/>
+          </a:prstGeom>
+        </p:spPr>
+      </p:pic>
+      <p:pic>
+        <p:nvPicPr>
+          <p:cNvPr id="8" name="그림 7">
+            <a:extLst>
+              <a:ext uri="{FF2B5EF4-FFF2-40B4-BE49-F238E27FC236}">
+                <a16:creationId xmlns:a16="http://schemas.microsoft.com/office/drawing/2014/main" id="{2701C9C8-E61E-2E12-D266-F2A8CEB4FD77}"/>
+              </a:ext>
+            </a:extLst>
+          </p:cNvPr>
+          <p:cNvPicPr>
+            <a:picLocks noChangeAspect="1"/>
+          </p:cNvPicPr>
+          <p:nvPr/>
+        </p:nvPicPr>
+        <p:blipFill>
+          <a:blip r:embed="rId4"/>
+          <a:stretch>
+            <a:fillRect/>
+          </a:stretch>
+        </p:blipFill>
+        <p:spPr>
+          <a:xfrm>
+            <a:off x="4570133" y="6967971"/>
+            <a:ext cx="4305331" cy="2209816"/>
+          </a:xfrm>
+          <a:prstGeom prst="rect">
+            <a:avLst/>
+          </a:prstGeom>
+        </p:spPr>
+      </p:pic>
+      <p:pic>
+        <p:nvPicPr>
+          <p:cNvPr id="10" name="그림 9">
+            <a:extLst>
+              <a:ext uri="{FF2B5EF4-FFF2-40B4-BE49-F238E27FC236}">
+                <a16:creationId xmlns:a16="http://schemas.microsoft.com/office/drawing/2014/main" id="{C1D47F4E-42E2-8C2C-5C7F-01E5F29AA422}"/>
+              </a:ext>
+            </a:extLst>
+          </p:cNvPr>
+          <p:cNvPicPr>
+            <a:picLocks noChangeAspect="1"/>
+          </p:cNvPicPr>
+          <p:nvPr/>
+        </p:nvPicPr>
+        <p:blipFill>
+          <a:blip r:embed="rId5"/>
+          <a:stretch>
+            <a:fillRect/>
+          </a:stretch>
+        </p:blipFill>
+        <p:spPr>
+          <a:xfrm>
+            <a:off x="7905719" y="180933"/>
+            <a:ext cx="4286281" cy="5581691"/>
+          </a:xfrm>
+          <a:prstGeom prst="rect">
+            <a:avLst/>
+          </a:prstGeom>
+        </p:spPr>
+      </p:pic>
+      <p:pic>
+        <p:nvPicPr>
+          <p:cNvPr id="11" name="그림 10">
+            <a:extLst>
+              <a:ext uri="{FF2B5EF4-FFF2-40B4-BE49-F238E27FC236}">
+                <a16:creationId xmlns:a16="http://schemas.microsoft.com/office/drawing/2014/main" id="{268C36DC-72E7-DE21-BB45-CC921BE2AB29}"/>
+              </a:ext>
+            </a:extLst>
+          </p:cNvPr>
+          <p:cNvPicPr>
+            <a:picLocks noChangeAspect="1"/>
+          </p:cNvPicPr>
+          <p:nvPr/>
+        </p:nvPicPr>
+        <p:blipFill>
+          <a:blip r:embed="rId2"/>
+          <a:srcRect b="45959"/>
+          <a:stretch>
+            <a:fillRect/>
+          </a:stretch>
+        </p:blipFill>
+        <p:spPr>
+          <a:xfrm>
+            <a:off x="207650" y="946318"/>
+            <a:ext cx="4333907" cy="3649503"/>
+          </a:xfrm>
+          <a:prstGeom prst="rect">
+            <a:avLst/>
+          </a:prstGeom>
+        </p:spPr>
+      </p:pic>
+      <p:pic>
+        <p:nvPicPr>
+          <p:cNvPr id="12" name="그림 11">
+            <a:extLst>
+              <a:ext uri="{FF2B5EF4-FFF2-40B4-BE49-F238E27FC236}">
+                <a16:creationId xmlns:a16="http://schemas.microsoft.com/office/drawing/2014/main" id="{AC550799-BF56-449B-43FB-0642AB0EE9BB}"/>
+              </a:ext>
+            </a:extLst>
+          </p:cNvPr>
+          <p:cNvPicPr>
+            <a:picLocks noChangeAspect="1"/>
+          </p:cNvPicPr>
+          <p:nvPr/>
+        </p:nvPicPr>
+        <p:blipFill>
+          <a:blip r:embed="rId2"/>
+          <a:srcRect t="76233"/>
+          <a:stretch>
+            <a:fillRect/>
+          </a:stretch>
+        </p:blipFill>
+        <p:spPr>
+          <a:xfrm>
+            <a:off x="207650" y="6624832"/>
+            <a:ext cx="4333907" cy="1605032"/>
+          </a:xfrm>
+          <a:prstGeom prst="rect">
+            <a:avLst/>
+          </a:prstGeom>
+        </p:spPr>
+      </p:pic>
+      <p:pic>
+        <p:nvPicPr>
+          <p:cNvPr id="13" name="그림 12">
+            <a:extLst>
+              <a:ext uri="{FF2B5EF4-FFF2-40B4-BE49-F238E27FC236}">
+                <a16:creationId xmlns:a16="http://schemas.microsoft.com/office/drawing/2014/main" id="{D5A8B3AC-E6FE-EBF6-EB2B-1EA6814161EF}"/>
+              </a:ext>
+            </a:extLst>
+          </p:cNvPr>
+          <p:cNvPicPr>
+            <a:picLocks noChangeAspect="1"/>
+          </p:cNvPicPr>
+          <p:nvPr/>
+        </p:nvPicPr>
+        <p:blipFill>
+          <a:blip r:embed="rId3"/>
+          <a:srcRect b="51379"/>
+          <a:stretch>
+            <a:fillRect/>
+          </a:stretch>
+        </p:blipFill>
+        <p:spPr>
+          <a:xfrm>
+            <a:off x="4541557" y="1095376"/>
+            <a:ext cx="4248181" cy="2991716"/>
+          </a:xfrm>
+          <a:prstGeom prst="rect">
+            <a:avLst/>
+          </a:prstGeom>
+        </p:spPr>
+      </p:pic>
+    </p:spTree>
+    <p:extLst>
+      <p:ext uri="{BB962C8B-B14F-4D97-AF65-F5344CB8AC3E}">
+        <p14:creationId xmlns:p14="http://schemas.microsoft.com/office/powerpoint/2010/main" val="2184797597"/>
+      </p:ext>
+    </p:extLst>
+  </p:cSld>
+  <p:clrMapOvr>
+    <a:masterClrMapping/>
+  </p:clrMapOvr>
+</p:sld>
+</file>
+
+<file path=ppt/slides/slide17.xml><?xml version="1.0" encoding="utf-8"?>
+<p:sld xmlns:a="http://schemas.openxmlformats.org/drawingml/2006/main" xmlns:r="http://schemas.openxmlformats.org/officeDocument/2006/relationships" xmlns:p="http://schemas.openxmlformats.org/presentationml/2006/main">
+  <p:cSld>
+    <p:spTree>
+      <p:nvGrpSpPr>
         <p:cNvPr id="1" name=""/>
         <p:cNvGrpSpPr/>
         <p:nvPr/>
@@ -5813,7 +6177,7 @@
 </p:sld>
 </file>
 
-<file path=ppt/slides/slide17.xml><?xml version="1.0" encoding="utf-8"?>
+<file path=ppt/slides/slide18.xml><?xml version="1.0" encoding="utf-8"?>
 <p:sld xmlns:a="http://schemas.openxmlformats.org/drawingml/2006/main" xmlns:r="http://schemas.openxmlformats.org/officeDocument/2006/relationships" xmlns:p="http://schemas.openxmlformats.org/presentationml/2006/main">
   <p:cSld>
     <p:spTree>
@@ -31195,7 +31559,7 @@
 </p:sld>
 </file>
 
-<file path=ppt/slides/slide18.xml><?xml version="1.0" encoding="utf-8"?>
+<file path=ppt/slides/slide19.xml><?xml version="1.0" encoding="utf-8"?>
 <p:sld xmlns:a="http://schemas.openxmlformats.org/drawingml/2006/main" xmlns:r="http://schemas.openxmlformats.org/officeDocument/2006/relationships" xmlns:p="http://schemas.openxmlformats.org/presentationml/2006/main">
   <p:cSld>
     <p:spTree>
@@ -34573,7 +34937,87 @@
 </p:sld>
 </file>
 
-<file path=ppt/slides/slide19.xml><?xml version="1.0" encoding="utf-8"?>
+<file path=ppt/slides/slide2.xml><?xml version="1.0" encoding="utf-8"?>
+<p:sld xmlns:a="http://schemas.openxmlformats.org/drawingml/2006/main" xmlns:r="http://schemas.openxmlformats.org/officeDocument/2006/relationships" xmlns:p="http://schemas.openxmlformats.org/presentationml/2006/main">
+  <p:cSld>
+    <p:spTree>
+      <p:nvGrpSpPr>
+        <p:cNvPr id="1" name=""/>
+        <p:cNvGrpSpPr/>
+        <p:nvPr/>
+      </p:nvGrpSpPr>
+      <p:grpSpPr>
+        <a:xfrm>
+          <a:off x="0" y="0"/>
+          <a:ext cx="0" cy="0"/>
+          <a:chOff x="0" y="0"/>
+          <a:chExt cx="0" cy="0"/>
+        </a:xfrm>
+      </p:grpSpPr>
+      <p:sp>
+        <p:nvSpPr>
+          <p:cNvPr id="2" name="제목 1">
+            <a:extLst>
+              <a:ext uri="{FF2B5EF4-FFF2-40B4-BE49-F238E27FC236}">
+                <a16:creationId xmlns:a16="http://schemas.microsoft.com/office/drawing/2014/main" id="{6B72C4B6-F596-F78E-3A8C-23BCA79F7F76}"/>
+              </a:ext>
+            </a:extLst>
+          </p:cNvPr>
+          <p:cNvSpPr>
+            <a:spLocks noGrp="1"/>
+          </p:cNvSpPr>
+          <p:nvPr>
+            <p:ph type="title"/>
+          </p:nvPr>
+        </p:nvSpPr>
+        <p:spPr/>
+        <p:txBody>
+          <a:bodyPr/>
+          <a:lstStyle/>
+          <a:p>
+            <a:endParaRPr lang="ko-KR" altLang="en-US"/>
+          </a:p>
+        </p:txBody>
+      </p:sp>
+      <p:sp>
+        <p:nvSpPr>
+          <p:cNvPr id="3" name="내용 개체 틀 2">
+            <a:extLst>
+              <a:ext uri="{FF2B5EF4-FFF2-40B4-BE49-F238E27FC236}">
+                <a16:creationId xmlns:a16="http://schemas.microsoft.com/office/drawing/2014/main" id="{461B4D87-F7B2-AB98-E8DD-ED3981191125}"/>
+              </a:ext>
+            </a:extLst>
+          </p:cNvPr>
+          <p:cNvSpPr>
+            <a:spLocks noGrp="1"/>
+          </p:cNvSpPr>
+          <p:nvPr>
+            <p:ph idx="1"/>
+          </p:nvPr>
+        </p:nvSpPr>
+        <p:spPr/>
+        <p:txBody>
+          <a:bodyPr/>
+          <a:lstStyle/>
+          <a:p>
+            <a:endParaRPr lang="ko-KR" altLang="en-US"/>
+          </a:p>
+        </p:txBody>
+      </p:sp>
+    </p:spTree>
+    <p:extLst>
+      <p:ext uri="{BB962C8B-B14F-4D97-AF65-F5344CB8AC3E}">
+        <p14:creationId xmlns:p14="http://schemas.microsoft.com/office/powerpoint/2010/main" val="1772083265"/>
+      </p:ext>
+    </p:extLst>
+  </p:cSld>
+  <p:clrMapOvr>
+    <a:masterClrMapping/>
+  </p:clrMapOvr>
+</p:sld>
+</file>
+
+<file path=ppt/slides/slide20.xml><?xml version="1.0" encoding="utf-8"?>
 <p:sld xmlns:a="http://schemas.openxmlformats.org/drawingml/2006/main" xmlns:r="http://schemas.openxmlformats.org/officeDocument/2006/relationships" xmlns:p="http://schemas.openxmlformats.org/presentationml/2006/main">
   <p:cSld>
     <p:spTree>
@@ -37954,87 +38398,7 @@
 </p:sld>
 </file>
 
-<file path=ppt/slides/slide2.xml><?xml version="1.0" encoding="utf-8"?>
-<p:sld xmlns:a="http://schemas.openxmlformats.org/drawingml/2006/main" xmlns:r="http://schemas.openxmlformats.org/officeDocument/2006/relationships" xmlns:p="http://schemas.openxmlformats.org/presentationml/2006/main">
-  <p:cSld>
-    <p:spTree>
-      <p:nvGrpSpPr>
-        <p:cNvPr id="1" name=""/>
-        <p:cNvGrpSpPr/>
-        <p:nvPr/>
-      </p:nvGrpSpPr>
-      <p:grpSpPr>
-        <a:xfrm>
-          <a:off x="0" y="0"/>
-          <a:ext cx="0" cy="0"/>
-          <a:chOff x="0" y="0"/>
-          <a:chExt cx="0" cy="0"/>
-        </a:xfrm>
-      </p:grpSpPr>
-      <p:sp>
-        <p:nvSpPr>
-          <p:cNvPr id="2" name="제목 1">
-            <a:extLst>
-              <a:ext uri="{FF2B5EF4-FFF2-40B4-BE49-F238E27FC236}">
-                <a16:creationId xmlns:a16="http://schemas.microsoft.com/office/drawing/2014/main" id="{6B72C4B6-F596-F78E-3A8C-23BCA79F7F76}"/>
-              </a:ext>
-            </a:extLst>
-          </p:cNvPr>
-          <p:cNvSpPr>
-            <a:spLocks noGrp="1"/>
-          </p:cNvSpPr>
-          <p:nvPr>
-            <p:ph type="title"/>
-          </p:nvPr>
-        </p:nvSpPr>
-        <p:spPr/>
-        <p:txBody>
-          <a:bodyPr/>
-          <a:lstStyle/>
-          <a:p>
-            <a:endParaRPr lang="ko-KR" altLang="en-US"/>
-          </a:p>
-        </p:txBody>
-      </p:sp>
-      <p:sp>
-        <p:nvSpPr>
-          <p:cNvPr id="3" name="내용 개체 틀 2">
-            <a:extLst>
-              <a:ext uri="{FF2B5EF4-FFF2-40B4-BE49-F238E27FC236}">
-                <a16:creationId xmlns:a16="http://schemas.microsoft.com/office/drawing/2014/main" id="{461B4D87-F7B2-AB98-E8DD-ED3981191125}"/>
-              </a:ext>
-            </a:extLst>
-          </p:cNvPr>
-          <p:cNvSpPr>
-            <a:spLocks noGrp="1"/>
-          </p:cNvSpPr>
-          <p:nvPr>
-            <p:ph idx="1"/>
-          </p:nvPr>
-        </p:nvSpPr>
-        <p:spPr/>
-        <p:txBody>
-          <a:bodyPr/>
-          <a:lstStyle/>
-          <a:p>
-            <a:endParaRPr lang="ko-KR" altLang="en-US"/>
-          </a:p>
-        </p:txBody>
-      </p:sp>
-    </p:spTree>
-    <p:extLst>
-      <p:ext uri="{BB962C8B-B14F-4D97-AF65-F5344CB8AC3E}">
-        <p14:creationId xmlns:p14="http://schemas.microsoft.com/office/powerpoint/2010/main" val="1772083265"/>
-      </p:ext>
-    </p:extLst>
-  </p:cSld>
-  <p:clrMapOvr>
-    <a:masterClrMapping/>
-  </p:clrMapOvr>
-</p:sld>
-</file>
-
-<file path=ppt/slides/slide20.xml><?xml version="1.0" encoding="utf-8"?>
+<file path=ppt/slides/slide21.xml><?xml version="1.0" encoding="utf-8"?>
 <p:sld xmlns:a="http://schemas.openxmlformats.org/drawingml/2006/main" xmlns:r="http://schemas.openxmlformats.org/officeDocument/2006/relationships" xmlns:p="http://schemas.openxmlformats.org/presentationml/2006/main">
   <p:cSld>
     <p:spTree>
@@ -41411,7 +41775,7 @@
 </p:sld>
 </file>
 
-<file path=ppt/slides/slide21.xml><?xml version="1.0" encoding="utf-8"?>
+<file path=ppt/slides/slide22.xml><?xml version="1.0" encoding="utf-8"?>
 <p:sld xmlns:a="http://schemas.openxmlformats.org/drawingml/2006/main" xmlns:r="http://schemas.openxmlformats.org/officeDocument/2006/relationships" xmlns:p="http://schemas.openxmlformats.org/presentationml/2006/main">
   <p:cSld>
     <p:spTree>
@@ -44097,38 +44461,8 @@
         </p:blipFill>
         <p:spPr>
           <a:xfrm>
-            <a:off x="4528857" y="997517"/>
+            <a:off x="4522231" y="997517"/>
             <a:ext cx="4248181" cy="3187434"/>
-          </a:xfrm>
-          <a:prstGeom prst="rect">
-            <a:avLst/>
-          </a:prstGeom>
-        </p:spPr>
-      </p:pic>
-      <p:pic>
-        <p:nvPicPr>
-          <p:cNvPr id="8" name="그림 7">
-            <a:extLst>
-              <a:ext uri="{FF2B5EF4-FFF2-40B4-BE49-F238E27FC236}">
-                <a16:creationId xmlns:a16="http://schemas.microsoft.com/office/drawing/2014/main" id="{7C0EF117-428F-9EDD-E27F-AA9FBB041137}"/>
-              </a:ext>
-            </a:extLst>
-          </p:cNvPr>
-          <p:cNvPicPr>
-            <a:picLocks noChangeAspect="1"/>
-          </p:cNvPicPr>
-          <p:nvPr/>
-        </p:nvPicPr>
-        <p:blipFill>
-          <a:blip r:embed="rId3"/>
-          <a:stretch>
-            <a:fillRect/>
-          </a:stretch>
-        </p:blipFill>
-        <p:spPr>
-          <a:xfrm>
-            <a:off x="8926233" y="997517"/>
-            <a:ext cx="4305331" cy="2209816"/>
           </a:xfrm>
           <a:prstGeom prst="rect">
             <a:avLst/>
@@ -44311,7 +44645,29 @@
                   <a:srgbClr val="FFFF00"/>
                 </a:highlight>
               </a:rPr>
-              <a:t>SFTP(SSH) </a:t>
+              <a:t>(</a:t>
+            </a:r>
+            <a:r>
+              <a:rPr lang="ko-KR" altLang="en-US" sz="1400" dirty="0">
+                <a:solidFill>
+                  <a:schemeClr val="tx1"/>
+                </a:solidFill>
+                <a:highlight>
+                  <a:srgbClr val="FFFF00"/>
+                </a:highlight>
+              </a:rPr>
+              <a:t>옵션</a:t>
+            </a:r>
+            <a:r>
+              <a:rPr lang="en-US" altLang="ko-KR" sz="1400" dirty="0">
+                <a:solidFill>
+                  <a:schemeClr val="tx1"/>
+                </a:solidFill>
+                <a:highlight>
+                  <a:srgbClr val="FFFF00"/>
+                </a:highlight>
+              </a:rPr>
+              <a:t>) SSH/SFTP </a:t>
             </a:r>
             <a:r>
               <a:rPr lang="ko-KR" altLang="en-US" sz="1400" dirty="0">
@@ -44323,6 +44679,370 @@
                 </a:highlight>
               </a:rPr>
               <a:t>접속 정보</a:t>
+            </a:r>
+            <a:r>
+              <a:rPr lang="en-US" altLang="ko-KR" sz="1400" dirty="0">
+                <a:solidFill>
+                  <a:schemeClr val="tx1"/>
+                </a:solidFill>
+                <a:highlight>
+                  <a:srgbClr val="FFFF00"/>
+                </a:highlight>
+              </a:rPr>
+              <a:t>(</a:t>
+            </a:r>
+            <a:r>
+              <a:rPr lang="ko-KR" altLang="en-US" sz="1400" dirty="0">
+                <a:solidFill>
+                  <a:schemeClr val="tx1"/>
+                </a:solidFill>
+                <a:highlight>
+                  <a:srgbClr val="FFFF00"/>
+                </a:highlight>
+              </a:rPr>
+              <a:t>옵션</a:t>
+            </a:r>
+            <a:r>
+              <a:rPr lang="en-US" altLang="ko-KR" sz="1400" dirty="0">
+                <a:solidFill>
+                  <a:schemeClr val="tx1"/>
+                </a:solidFill>
+                <a:highlight>
+                  <a:srgbClr val="FFFF00"/>
+                </a:highlight>
+              </a:rPr>
+              <a:t>)</a:t>
+            </a:r>
+            <a:endParaRPr lang="ko-KR" altLang="en-US" sz="1400" dirty="0">
+              <a:solidFill>
+                <a:schemeClr val="tx1"/>
+              </a:solidFill>
+              <a:highlight>
+                <a:srgbClr val="FFFF00"/>
+              </a:highlight>
+            </a:endParaRPr>
+          </a:p>
+        </p:txBody>
+      </p:sp>
+      <p:sp>
+        <p:nvSpPr>
+          <p:cNvPr id="7" name="직사각형 6">
+            <a:extLst>
+              <a:ext uri="{FF2B5EF4-FFF2-40B4-BE49-F238E27FC236}">
+                <a16:creationId xmlns:a16="http://schemas.microsoft.com/office/drawing/2014/main" id="{7B2D9C4B-1C6A-D66B-A659-8DAB53D06786}"/>
+              </a:ext>
+            </a:extLst>
+          </p:cNvPr>
+          <p:cNvSpPr/>
+          <p:nvPr/>
+        </p:nvSpPr>
+        <p:spPr>
+          <a:xfrm>
+            <a:off x="435019" y="2102425"/>
+            <a:ext cx="2927828" cy="223675"/>
+          </a:xfrm>
+          <a:prstGeom prst="rect">
+            <a:avLst/>
+          </a:prstGeom>
+          <a:solidFill>
+            <a:schemeClr val="bg1"/>
+          </a:solidFill>
+          <a:ln>
+            <a:noFill/>
+            <a:prstDash val="sysDash"/>
+          </a:ln>
+        </p:spPr>
+        <p:style>
+          <a:lnRef idx="2">
+            <a:schemeClr val="accent1">
+              <a:shade val="15000"/>
+            </a:schemeClr>
+          </a:lnRef>
+          <a:fillRef idx="1">
+            <a:schemeClr val="accent1"/>
+          </a:fillRef>
+          <a:effectRef idx="0">
+            <a:schemeClr val="accent1"/>
+          </a:effectRef>
+          <a:fontRef idx="minor">
+            <a:schemeClr val="lt1"/>
+          </a:fontRef>
+        </p:style>
+        <p:txBody>
+          <a:bodyPr lIns="0" tIns="0" rIns="0" bIns="0" rtlCol="0" anchor="ctr"/>
+          <a:lstStyle/>
+          <a:p>
+            <a:r>
+              <a:rPr lang="en-US" altLang="ko-KR" sz="1400" dirty="0">
+                <a:solidFill>
+                  <a:schemeClr val="tx1"/>
+                </a:solidFill>
+                <a:highlight>
+                  <a:srgbClr val="FFFF00"/>
+                </a:highlight>
+              </a:rPr>
+              <a:t>Port</a:t>
+            </a:r>
+            <a:endParaRPr lang="ko-KR" altLang="en-US" sz="1400" dirty="0">
+              <a:solidFill>
+                <a:schemeClr val="tx1"/>
+              </a:solidFill>
+              <a:highlight>
+                <a:srgbClr val="FFFF00"/>
+              </a:highlight>
+            </a:endParaRPr>
+          </a:p>
+        </p:txBody>
+      </p:sp>
+      <p:sp>
+        <p:nvSpPr>
+          <p:cNvPr id="9" name="직사각형 8">
+            <a:extLst>
+              <a:ext uri="{FF2B5EF4-FFF2-40B4-BE49-F238E27FC236}">
+                <a16:creationId xmlns:a16="http://schemas.microsoft.com/office/drawing/2014/main" id="{382888A0-6698-4471-AE02-8C20BC1C3953}"/>
+              </a:ext>
+            </a:extLst>
+          </p:cNvPr>
+          <p:cNvSpPr/>
+          <p:nvPr/>
+        </p:nvSpPr>
+        <p:spPr>
+          <a:xfrm>
+            <a:off x="435019" y="3303956"/>
+            <a:ext cx="2927828" cy="223675"/>
+          </a:xfrm>
+          <a:prstGeom prst="rect">
+            <a:avLst/>
+          </a:prstGeom>
+          <a:solidFill>
+            <a:schemeClr val="bg1"/>
+          </a:solidFill>
+          <a:ln>
+            <a:noFill/>
+            <a:prstDash val="sysDash"/>
+          </a:ln>
+        </p:spPr>
+        <p:style>
+          <a:lnRef idx="2">
+            <a:schemeClr val="accent1">
+              <a:shade val="15000"/>
+            </a:schemeClr>
+          </a:lnRef>
+          <a:fillRef idx="1">
+            <a:schemeClr val="accent1"/>
+          </a:fillRef>
+          <a:effectRef idx="0">
+            <a:schemeClr val="accent1"/>
+          </a:effectRef>
+          <a:fontRef idx="minor">
+            <a:schemeClr val="lt1"/>
+          </a:fontRef>
+        </p:style>
+        <p:txBody>
+          <a:bodyPr lIns="0" tIns="0" rIns="0" bIns="0" rtlCol="0" anchor="ctr"/>
+          <a:lstStyle/>
+          <a:p>
+            <a:r>
+              <a:rPr lang="en-US" altLang="ko-KR" sz="1400" dirty="0">
+                <a:solidFill>
+                  <a:schemeClr val="tx1"/>
+                </a:solidFill>
+                <a:highlight>
+                  <a:srgbClr val="FFFF00"/>
+                </a:highlight>
+              </a:rPr>
+              <a:t>Password</a:t>
+            </a:r>
+            <a:endParaRPr lang="ko-KR" altLang="en-US" sz="1400" dirty="0">
+              <a:solidFill>
+                <a:schemeClr val="tx1"/>
+              </a:solidFill>
+              <a:highlight>
+                <a:srgbClr val="FFFF00"/>
+              </a:highlight>
+            </a:endParaRPr>
+          </a:p>
+        </p:txBody>
+      </p:sp>
+      <p:sp>
+        <p:nvSpPr>
+          <p:cNvPr id="14" name="직사각형 13">
+            <a:extLst>
+              <a:ext uri="{FF2B5EF4-FFF2-40B4-BE49-F238E27FC236}">
+                <a16:creationId xmlns:a16="http://schemas.microsoft.com/office/drawing/2014/main" id="{BF7CC288-6D57-C8AD-55BD-B81F3786A2ED}"/>
+              </a:ext>
+            </a:extLst>
+          </p:cNvPr>
+          <p:cNvSpPr/>
+          <p:nvPr/>
+        </p:nvSpPr>
+        <p:spPr>
+          <a:xfrm>
+            <a:off x="4808236" y="1566308"/>
+            <a:ext cx="2927828" cy="223675"/>
+          </a:xfrm>
+          <a:prstGeom prst="rect">
+            <a:avLst/>
+          </a:prstGeom>
+          <a:solidFill>
+            <a:schemeClr val="bg1"/>
+          </a:solidFill>
+          <a:ln>
+            <a:noFill/>
+            <a:prstDash val="sysDash"/>
+          </a:ln>
+        </p:spPr>
+        <p:style>
+          <a:lnRef idx="2">
+            <a:schemeClr val="accent1">
+              <a:shade val="15000"/>
+            </a:schemeClr>
+          </a:lnRef>
+          <a:fillRef idx="1">
+            <a:schemeClr val="accent1"/>
+          </a:fillRef>
+          <a:effectRef idx="0">
+            <a:schemeClr val="accent1"/>
+          </a:effectRef>
+          <a:fontRef idx="minor">
+            <a:schemeClr val="lt1"/>
+          </a:fontRef>
+        </p:style>
+        <p:txBody>
+          <a:bodyPr lIns="0" tIns="0" rIns="0" bIns="0" rtlCol="0" anchor="ctr"/>
+          <a:lstStyle/>
+          <a:p>
+            <a:r>
+              <a:rPr lang="ko-KR" altLang="en-US" sz="1400" dirty="0">
+                <a:solidFill>
+                  <a:schemeClr val="tx1"/>
+                </a:solidFill>
+                <a:highlight>
+                  <a:srgbClr val="FFFF00"/>
+                </a:highlight>
+              </a:rPr>
+              <a:t>장치를 등록 할 때 활용 됩니다</a:t>
+            </a:r>
+            <a:r>
+              <a:rPr lang="en-US" altLang="ko-KR" sz="1400" dirty="0">
+                <a:solidFill>
+                  <a:schemeClr val="tx1"/>
+                </a:solidFill>
+                <a:highlight>
+                  <a:srgbClr val="FFFF00"/>
+                </a:highlight>
+              </a:rPr>
+              <a:t>.</a:t>
+            </a:r>
+            <a:endParaRPr lang="ko-KR" altLang="en-US" sz="1400" dirty="0">
+              <a:solidFill>
+                <a:schemeClr val="tx1"/>
+              </a:solidFill>
+              <a:highlight>
+                <a:srgbClr val="FFFF00"/>
+              </a:highlight>
+            </a:endParaRPr>
+          </a:p>
+        </p:txBody>
+      </p:sp>
+      <p:sp>
+        <p:nvSpPr>
+          <p:cNvPr id="15" name="TextBox 14">
+            <a:extLst>
+              <a:ext uri="{FF2B5EF4-FFF2-40B4-BE49-F238E27FC236}">
+                <a16:creationId xmlns:a16="http://schemas.microsoft.com/office/drawing/2014/main" id="{B9DD7709-7813-C69F-69A9-15152D4504E0}"/>
+              </a:ext>
+            </a:extLst>
+          </p:cNvPr>
+          <p:cNvSpPr txBox="1"/>
+          <p:nvPr/>
+        </p:nvSpPr>
+        <p:spPr>
+          <a:xfrm>
+            <a:off x="175699" y="4250718"/>
+            <a:ext cx="4005362" cy="2585323"/>
+          </a:xfrm>
+          <a:prstGeom prst="rect">
+            <a:avLst/>
+          </a:prstGeom>
+          <a:noFill/>
+        </p:spPr>
+        <p:txBody>
+          <a:bodyPr wrap="square" rtlCol="0">
+            <a:spAutoFit/>
+          </a:bodyPr>
+          <a:lstStyle/>
+          <a:p>
+            <a:r>
+              <a:rPr lang="ko-KR" altLang="en-US" dirty="0"/>
+              <a:t>외부서 데이터 접근을 원치 않는 곳이</a:t>
+            </a:r>
+            <a:r>
+              <a:rPr lang="en-US" altLang="ko-KR" dirty="0"/>
+              <a:t> </a:t>
+            </a:r>
+            <a:r>
+              <a:rPr lang="ko-KR" altLang="en-US" dirty="0"/>
+              <a:t>있습니다</a:t>
+            </a:r>
+            <a:r>
+              <a:rPr lang="en-US" altLang="ko-KR" dirty="0"/>
+              <a:t>.</a:t>
+            </a:r>
+          </a:p>
+          <a:p>
+            <a:endParaRPr lang="en-US" altLang="ko-KR" dirty="0"/>
+          </a:p>
+          <a:p>
+            <a:r>
+              <a:rPr lang="ko-KR" altLang="en-US" dirty="0"/>
+              <a:t>비 필수 항목으로 없어도 진행 되도록 </a:t>
+            </a:r>
+            <a:endParaRPr lang="en-US" altLang="ko-KR" dirty="0"/>
+          </a:p>
+          <a:p>
+            <a:endParaRPr lang="en-US" altLang="ko-KR" dirty="0"/>
+          </a:p>
+          <a:p>
+            <a:r>
+              <a:rPr lang="en-US" altLang="ko-KR" dirty="0"/>
+              <a:t>“</a:t>
+            </a:r>
+            <a:r>
+              <a:rPr lang="ko-KR" altLang="en-US" dirty="0"/>
+              <a:t>장치 파일 관리</a:t>
+            </a:r>
+            <a:r>
+              <a:rPr lang="en-US" altLang="ko-KR" dirty="0"/>
+              <a:t>”</a:t>
+            </a:r>
+            <a:r>
+              <a:rPr lang="ko-KR" altLang="en-US" dirty="0"/>
+              <a:t>창에서는 </a:t>
+            </a:r>
+            <a:r>
+              <a:rPr lang="en-US" altLang="ko-KR" dirty="0"/>
+              <a:t>SSH/SFTP</a:t>
+            </a:r>
+            <a:r>
+              <a:rPr lang="ko-KR" altLang="en-US" dirty="0"/>
+              <a:t>정보가 없습니다</a:t>
+            </a:r>
+            <a:r>
+              <a:rPr lang="en-US" altLang="ko-KR" dirty="0"/>
+              <a:t>. [</a:t>
+            </a:r>
+            <a:r>
+              <a:rPr lang="ko-KR" altLang="en-US" dirty="0"/>
+              <a:t>등록 이동</a:t>
+            </a:r>
+            <a:r>
+              <a:rPr lang="en-US" altLang="ko-KR" dirty="0"/>
+              <a:t>]” </a:t>
+            </a:r>
+            <a:r>
+              <a:rPr lang="ko-KR" altLang="en-US" dirty="0"/>
+              <a:t>등으로 알림</a:t>
             </a:r>
           </a:p>
         </p:txBody>
@@ -44345,13 +45065,7 @@
   <p:cSld>
     <p:spTree>
       <p:nvGrpSpPr>
-        <p:cNvPr id="1" name="">
-          <a:extLst>
-            <a:ext uri="{FF2B5EF4-FFF2-40B4-BE49-F238E27FC236}">
-              <a16:creationId xmlns:a16="http://schemas.microsoft.com/office/drawing/2014/main" id="{D2F59DA8-6EB5-D1DF-F3F2-863231B123D3}"/>
-            </a:ext>
-          </a:extLst>
-        </p:cNvPr>
+        <p:cNvPr id="1" name=""/>
         <p:cNvGrpSpPr/>
         <p:nvPr/>
       </p:nvGrpSpPr>
@@ -44363,37 +45077,12 @@
           <a:chExt cx="0" cy="0"/>
         </a:xfrm>
       </p:grpSpPr>
-      <p:sp>
-        <p:nvSpPr>
-          <p:cNvPr id="2" name="제목 1">
+      <p:pic>
+        <p:nvPicPr>
+          <p:cNvPr id="8" name="그림 7">
             <a:extLst>
               <a:ext uri="{FF2B5EF4-FFF2-40B4-BE49-F238E27FC236}">
-                <a16:creationId xmlns:a16="http://schemas.microsoft.com/office/drawing/2014/main" id="{695C423C-55EB-11F0-6F2C-E759A1DE9565}"/>
-              </a:ext>
-            </a:extLst>
-          </p:cNvPr>
-          <p:cNvSpPr>
-            <a:spLocks noGrp="1"/>
-          </p:cNvSpPr>
-          <p:nvPr>
-            <p:ph type="title"/>
-          </p:nvPr>
-        </p:nvSpPr>
-        <p:spPr/>
-        <p:txBody>
-          <a:bodyPr/>
-          <a:lstStyle/>
-          <a:p>
-            <a:endParaRPr lang="ko-KR" altLang="en-US"/>
-          </a:p>
-        </p:txBody>
-      </p:sp>
-      <p:pic>
-        <p:nvPicPr>
-          <p:cNvPr id="4" name="그림 3">
-            <a:extLst>
-              <a:ext uri="{FF2B5EF4-FFF2-40B4-BE49-F238E27FC236}">
-                <a16:creationId xmlns:a16="http://schemas.microsoft.com/office/drawing/2014/main" id="{7C6C6874-D593-7ADA-8954-ED08CC6AAAAC}"/>
+                <a16:creationId xmlns:a16="http://schemas.microsoft.com/office/drawing/2014/main" id="{7C0EF117-428F-9EDD-E27F-AA9FBB041137}"/>
               </a:ext>
             </a:extLst>
           </p:cNvPr>
@@ -44404,75 +45093,13 @@
         </p:nvPicPr>
         <p:blipFill>
           <a:blip r:embed="rId2"/>
-          <a:srcRect t="53795" b="23331"/>
           <a:stretch>
             <a:fillRect/>
           </a:stretch>
         </p:blipFill>
         <p:spPr>
           <a:xfrm>
-            <a:off x="207650" y="4657603"/>
-            <a:ext cx="4333907" cy="1544782"/>
-          </a:xfrm>
-          <a:prstGeom prst="rect">
-            <a:avLst/>
-          </a:prstGeom>
-        </p:spPr>
-      </p:pic>
-      <p:pic>
-        <p:nvPicPr>
-          <p:cNvPr id="6" name="그림 5">
-            <a:extLst>
-              <a:ext uri="{FF2B5EF4-FFF2-40B4-BE49-F238E27FC236}">
-                <a16:creationId xmlns:a16="http://schemas.microsoft.com/office/drawing/2014/main" id="{3FA6B0C8-97A8-2EF8-0BC3-A89525CC46CB}"/>
-              </a:ext>
-            </a:extLst>
-          </p:cNvPr>
-          <p:cNvPicPr>
-            <a:picLocks noChangeAspect="1"/>
-          </p:cNvPicPr>
-          <p:nvPr/>
-        </p:nvPicPr>
-        <p:blipFill>
-          <a:blip r:embed="rId3"/>
-          <a:srcRect t="48199"/>
-          <a:stretch>
-            <a:fillRect/>
-          </a:stretch>
-        </p:blipFill>
-        <p:spPr>
-          <a:xfrm>
-            <a:off x="4541557" y="4087092"/>
-            <a:ext cx="4248181" cy="3187434"/>
-          </a:xfrm>
-          <a:prstGeom prst="rect">
-            <a:avLst/>
-          </a:prstGeom>
-        </p:spPr>
-      </p:pic>
-      <p:pic>
-        <p:nvPicPr>
-          <p:cNvPr id="8" name="그림 7">
-            <a:extLst>
-              <a:ext uri="{FF2B5EF4-FFF2-40B4-BE49-F238E27FC236}">
-                <a16:creationId xmlns:a16="http://schemas.microsoft.com/office/drawing/2014/main" id="{2701C9C8-E61E-2E12-D266-F2A8CEB4FD77}"/>
-              </a:ext>
-            </a:extLst>
-          </p:cNvPr>
-          <p:cNvPicPr>
-            <a:picLocks noChangeAspect="1"/>
-          </p:cNvPicPr>
-          <p:nvPr/>
-        </p:nvPicPr>
-        <p:blipFill>
-          <a:blip r:embed="rId4"/>
-          <a:stretch>
-            <a:fillRect/>
-          </a:stretch>
-        </p:blipFill>
-        <p:spPr>
-          <a:xfrm>
-            <a:off x="4570133" y="6967971"/>
+            <a:off x="514258" y="546943"/>
             <a:ext cx="4305331" cy="2209816"/>
           </a:xfrm>
           <a:prstGeom prst="rect">
@@ -44480,133 +45107,249 @@
           </a:prstGeom>
         </p:spPr>
       </p:pic>
-      <p:pic>
-        <p:nvPicPr>
-          <p:cNvPr id="10" name="그림 9">
+      <p:sp>
+        <p:nvSpPr>
+          <p:cNvPr id="3" name="직사각형 2">
             <a:extLst>
               <a:ext uri="{FF2B5EF4-FFF2-40B4-BE49-F238E27FC236}">
-                <a16:creationId xmlns:a16="http://schemas.microsoft.com/office/drawing/2014/main" id="{C1D47F4E-42E2-8C2C-5C7F-01E5F29AA422}"/>
+                <a16:creationId xmlns:a16="http://schemas.microsoft.com/office/drawing/2014/main" id="{35BD330A-F750-BC0A-59DE-8C17077501E7}"/>
               </a:ext>
             </a:extLst>
           </p:cNvPr>
-          <p:cNvPicPr>
-            <a:picLocks noChangeAspect="1"/>
-          </p:cNvPicPr>
+          <p:cNvSpPr/>
           <p:nvPr/>
-        </p:nvPicPr>
-        <p:blipFill>
-          <a:blip r:embed="rId5"/>
-          <a:stretch>
-            <a:fillRect/>
-          </a:stretch>
-        </p:blipFill>
+        </p:nvSpPr>
         <p:spPr>
           <a:xfrm>
-            <a:off x="7905719" y="180933"/>
-            <a:ext cx="4286281" cy="5581691"/>
+            <a:off x="756276" y="991798"/>
+            <a:ext cx="3398280" cy="366551"/>
           </a:xfrm>
           <a:prstGeom prst="rect">
             <a:avLst/>
           </a:prstGeom>
+          <a:solidFill>
+            <a:schemeClr val="bg1"/>
+          </a:solidFill>
+          <a:ln>
+            <a:noFill/>
+            <a:prstDash val="sysDash"/>
+          </a:ln>
         </p:spPr>
-      </p:pic>
-      <p:pic>
-        <p:nvPicPr>
-          <p:cNvPr id="11" name="그림 10">
+        <p:style>
+          <a:lnRef idx="2">
+            <a:schemeClr val="accent1">
+              <a:shade val="15000"/>
+            </a:schemeClr>
+          </a:lnRef>
+          <a:fillRef idx="1">
+            <a:schemeClr val="accent1"/>
+          </a:fillRef>
+          <a:effectRef idx="0">
+            <a:schemeClr val="accent1"/>
+          </a:effectRef>
+          <a:fontRef idx="minor">
+            <a:schemeClr val="lt1"/>
+          </a:fontRef>
+        </p:style>
+        <p:txBody>
+          <a:bodyPr lIns="0" tIns="0" rIns="0" bIns="0" rtlCol="0" anchor="ctr"/>
+          <a:lstStyle/>
+          <a:p>
+            <a:pPr algn="ctr"/>
+            <a:r>
+              <a:rPr lang="ko-KR" altLang="en-US" sz="1400" dirty="0">
+                <a:solidFill>
+                  <a:schemeClr val="bg1">
+                    <a:lumMod val="50000"/>
+                  </a:schemeClr>
+                </a:solidFill>
+                <a:highlight>
+                  <a:srgbClr val="FFFF00"/>
+                </a:highlight>
+              </a:rPr>
+              <a:t>외부 데이터 저장소 정보를 입력 하세요</a:t>
+            </a:r>
+            <a:r>
+              <a:rPr lang="en-US" altLang="ko-KR" sz="1400" dirty="0">
+                <a:solidFill>
+                  <a:schemeClr val="bg1">
+                    <a:lumMod val="50000"/>
+                  </a:schemeClr>
+                </a:solidFill>
+                <a:highlight>
+                  <a:srgbClr val="FFFF00"/>
+                </a:highlight>
+              </a:rPr>
+              <a:t>. </a:t>
+            </a:r>
+            <a:endParaRPr lang="ko-KR" altLang="en-US" sz="1400" dirty="0">
+              <a:solidFill>
+                <a:schemeClr val="bg1">
+                  <a:lumMod val="50000"/>
+                </a:schemeClr>
+              </a:solidFill>
+              <a:highlight>
+                <a:srgbClr val="FFFF00"/>
+              </a:highlight>
+            </a:endParaRPr>
+          </a:p>
+        </p:txBody>
+      </p:sp>
+      <p:sp>
+        <p:nvSpPr>
+          <p:cNvPr id="4" name="직사각형 3">
             <a:extLst>
               <a:ext uri="{FF2B5EF4-FFF2-40B4-BE49-F238E27FC236}">
-                <a16:creationId xmlns:a16="http://schemas.microsoft.com/office/drawing/2014/main" id="{268C36DC-72E7-DE21-BB45-CC921BE2AB29}"/>
+                <a16:creationId xmlns:a16="http://schemas.microsoft.com/office/drawing/2014/main" id="{B5B606E5-D90C-0996-E172-7A5EC51A7C1D}"/>
               </a:ext>
             </a:extLst>
           </p:cNvPr>
-          <p:cNvPicPr>
-            <a:picLocks noChangeAspect="1"/>
-          </p:cNvPicPr>
+          <p:cNvSpPr/>
           <p:nvPr/>
-        </p:nvPicPr>
-        <p:blipFill>
-          <a:blip r:embed="rId2"/>
-          <a:srcRect b="45959"/>
-          <a:stretch>
-            <a:fillRect/>
-          </a:stretch>
-        </p:blipFill>
+        </p:nvSpPr>
         <p:spPr>
           <a:xfrm>
-            <a:off x="207650" y="946318"/>
-            <a:ext cx="4333907" cy="3649503"/>
+            <a:off x="925349" y="716423"/>
+            <a:ext cx="2927828" cy="223675"/>
           </a:xfrm>
           <a:prstGeom prst="rect">
             <a:avLst/>
           </a:prstGeom>
+          <a:solidFill>
+            <a:schemeClr val="bg1"/>
+          </a:solidFill>
+          <a:ln>
+            <a:noFill/>
+            <a:prstDash val="sysDash"/>
+          </a:ln>
         </p:spPr>
-      </p:pic>
-      <p:pic>
-        <p:nvPicPr>
-          <p:cNvPr id="12" name="그림 11">
+        <p:style>
+          <a:lnRef idx="2">
+            <a:schemeClr val="accent1">
+              <a:shade val="15000"/>
+            </a:schemeClr>
+          </a:lnRef>
+          <a:fillRef idx="1">
+            <a:schemeClr val="accent1"/>
+          </a:fillRef>
+          <a:effectRef idx="0">
+            <a:schemeClr val="accent1"/>
+          </a:effectRef>
+          <a:fontRef idx="minor">
+            <a:schemeClr val="lt1"/>
+          </a:fontRef>
+        </p:style>
+        <p:txBody>
+          <a:bodyPr lIns="0" tIns="0" rIns="0" bIns="0" rtlCol="0" anchor="ctr"/>
+          <a:lstStyle/>
+          <a:p>
+            <a:r>
+              <a:rPr lang="en-US" altLang="ko-KR" sz="1400" dirty="0">
+                <a:solidFill>
+                  <a:schemeClr val="tx1"/>
+                </a:solidFill>
+                <a:highlight>
+                  <a:srgbClr val="FFFF00"/>
+                </a:highlight>
+              </a:rPr>
+              <a:t>(</a:t>
+            </a:r>
+            <a:r>
+              <a:rPr lang="ko-KR" altLang="en-US" sz="1400" dirty="0">
+                <a:solidFill>
+                  <a:schemeClr val="tx1"/>
+                </a:solidFill>
+                <a:highlight>
+                  <a:srgbClr val="FFFF00"/>
+                </a:highlight>
+              </a:rPr>
+              <a:t>옵션</a:t>
+            </a:r>
+            <a:r>
+              <a:rPr lang="en-US" altLang="ko-KR" sz="1400" dirty="0">
+                <a:solidFill>
+                  <a:schemeClr val="tx1"/>
+                </a:solidFill>
+                <a:highlight>
+                  <a:srgbClr val="FFFF00"/>
+                </a:highlight>
+              </a:rPr>
+              <a:t>) </a:t>
+            </a:r>
+            <a:r>
+              <a:rPr lang="ko-KR" altLang="en-US" sz="1400" dirty="0">
+                <a:solidFill>
+                  <a:schemeClr val="tx1"/>
+                </a:solidFill>
+                <a:highlight>
+                  <a:srgbClr val="FFFF00"/>
+                </a:highlight>
+              </a:rPr>
+              <a:t>저장소 정보</a:t>
+            </a:r>
+          </a:p>
+        </p:txBody>
+      </p:sp>
+      <p:sp>
+        <p:nvSpPr>
+          <p:cNvPr id="6" name="TextBox 5">
             <a:extLst>
               <a:ext uri="{FF2B5EF4-FFF2-40B4-BE49-F238E27FC236}">
-                <a16:creationId xmlns:a16="http://schemas.microsoft.com/office/drawing/2014/main" id="{AC550799-BF56-449B-43FB-0642AB0EE9BB}"/>
+                <a16:creationId xmlns:a16="http://schemas.microsoft.com/office/drawing/2014/main" id="{8CBAADC2-493A-A8EC-B12E-55DE5B08C5B5}"/>
               </a:ext>
             </a:extLst>
           </p:cNvPr>
-          <p:cNvPicPr>
-            <a:picLocks noChangeAspect="1"/>
-          </p:cNvPicPr>
+          <p:cNvSpPr txBox="1"/>
           <p:nvPr/>
-        </p:nvPicPr>
-        <p:blipFill>
-          <a:blip r:embed="rId2"/>
-          <a:srcRect t="76233"/>
-          <a:stretch>
-            <a:fillRect/>
-          </a:stretch>
-        </p:blipFill>
+        </p:nvSpPr>
         <p:spPr>
           <a:xfrm>
-            <a:off x="207650" y="6624832"/>
-            <a:ext cx="4333907" cy="1605032"/>
+            <a:off x="5121965" y="755432"/>
+            <a:ext cx="6374296" cy="923330"/>
           </a:xfrm>
           <a:prstGeom prst="rect">
             <a:avLst/>
           </a:prstGeom>
+          <a:noFill/>
         </p:spPr>
-      </p:pic>
-      <p:pic>
-        <p:nvPicPr>
-          <p:cNvPr id="13" name="그림 12">
-            <a:extLst>
-              <a:ext uri="{FF2B5EF4-FFF2-40B4-BE49-F238E27FC236}">
-                <a16:creationId xmlns:a16="http://schemas.microsoft.com/office/drawing/2014/main" id="{D5A8B3AC-E6FE-EBF6-EB2B-1EA6814161EF}"/>
-              </a:ext>
-            </a:extLst>
-          </p:cNvPr>
-          <p:cNvPicPr>
-            <a:picLocks noChangeAspect="1"/>
-          </p:cNvPicPr>
-          <p:nvPr/>
-        </p:nvPicPr>
-        <p:blipFill>
-          <a:blip r:embed="rId3"/>
-          <a:srcRect b="51379"/>
-          <a:stretch>
-            <a:fillRect/>
-          </a:stretch>
-        </p:blipFill>
-        <p:spPr>
-          <a:xfrm>
-            <a:off x="4541557" y="1095376"/>
-            <a:ext cx="4248181" cy="2991716"/>
-          </a:xfrm>
-          <a:prstGeom prst="rect">
-            <a:avLst/>
-          </a:prstGeom>
-        </p:spPr>
-      </p:pic>
+        <p:txBody>
+          <a:bodyPr wrap="square" rtlCol="0">
+            <a:spAutoFit/>
+          </a:bodyPr>
+          <a:lstStyle/>
+          <a:p>
+            <a:r>
+              <a:rPr lang="ko-KR" altLang="en-US" dirty="0"/>
+              <a:t>외부에 데이터 저장을 원치 않는 곳이</a:t>
+            </a:r>
+            <a:r>
+              <a:rPr lang="en-US" altLang="ko-KR" dirty="0"/>
+              <a:t> </a:t>
+            </a:r>
+            <a:r>
+              <a:rPr lang="ko-KR" altLang="en-US" dirty="0"/>
+              <a:t>있습니다</a:t>
+            </a:r>
+            <a:r>
+              <a:rPr lang="en-US" altLang="ko-KR" dirty="0"/>
+              <a:t>.</a:t>
+            </a:r>
+          </a:p>
+          <a:p>
+            <a:endParaRPr lang="en-US" altLang="ko-KR" dirty="0"/>
+          </a:p>
+          <a:p>
+            <a:r>
+              <a:rPr lang="ko-KR" altLang="en-US" dirty="0"/>
+              <a:t>비 필수 항목으로 없어도 진행 되도록 </a:t>
+            </a:r>
+          </a:p>
+        </p:txBody>
+      </p:sp>
     </p:spTree>
     <p:extLst>
       <p:ext uri="{BB962C8B-B14F-4D97-AF65-F5344CB8AC3E}">
-        <p14:creationId xmlns:p14="http://schemas.microsoft.com/office/powerpoint/2010/main" val="2184797597"/>
+        <p14:creationId xmlns:p14="http://schemas.microsoft.com/office/powerpoint/2010/main" val="3010018706"/>
       </p:ext>
     </p:extLst>
   </p:cSld>

</xml_diff>

<commit_message>
vault backup: 2026-07-04 08:51:07
</commit_message>
<xml_diff>
--- a/assets/06-dataspace/image.pptx
+++ b/assets/06-dataspace/image.pptx
@@ -136,7 +136,7 @@
 <file path=ppt/revisionInfo.xml><?xml version="1.0" encoding="utf-8"?>
 <p1510:revInfo xmlns:a="http://schemas.openxmlformats.org/drawingml/2006/main" xmlns:r="http://schemas.openxmlformats.org/officeDocument/2006/relationships" xmlns:p1510="http://schemas.microsoft.com/office/powerpoint/2015/10/main">
   <p1510:revLst>
-    <p1510:client id="{77AFA03C-ADB3-48E7-9DEE-EC77C33AF38A}" v="187" dt="2026-07-03T23:50:31.260"/>
+    <p1510:client id="{77AFA03C-ADB3-48E7-9DEE-EC77C33AF38A}" v="188" dt="2026-07-03T23:50:49.459"/>
   </p1510:revLst>
 </p1510:revInfo>
 </file>
@@ -146,7 +146,7 @@
   <pc:docChgLst>
     <pc:chgData name="헌정 임" userId="eb9ca9bd79f0560f" providerId="LiveId" clId="{A6339E56-8272-42D6-9D95-12E1A8284411}"/>
     <pc:docChg chg="undo custSel addSld delSld modSld sldOrd">
-      <pc:chgData name="헌정 임" userId="eb9ca9bd79f0560f" providerId="LiveId" clId="{A6339E56-8272-42D6-9D95-12E1A8284411}" dt="2026-07-03T23:50:31.260" v="2101"/>
+      <pc:chgData name="헌정 임" userId="eb9ca9bd79f0560f" providerId="LiveId" clId="{A6339E56-8272-42D6-9D95-12E1A8284411}" dt="2026-07-03T23:50:52.908" v="2103" actId="1076"/>
       <pc:docMkLst>
         <pc:docMk/>
       </pc:docMkLst>
@@ -547,7 +547,7 @@
         </pc:picChg>
       </pc:sldChg>
       <pc:sldChg chg="addSp delSp modSp new mod">
-        <pc:chgData name="헌정 임" userId="eb9ca9bd79f0560f" providerId="LiveId" clId="{A6339E56-8272-42D6-9D95-12E1A8284411}" dt="2026-07-03T12:36:12.746" v="94" actId="22"/>
+        <pc:chgData name="헌정 임" userId="eb9ca9bd79f0560f" providerId="LiveId" clId="{A6339E56-8272-42D6-9D95-12E1A8284411}" dt="2026-07-03T23:50:52.908" v="2103" actId="1076"/>
         <pc:sldMkLst>
           <pc:docMk/>
           <pc:sldMk cId="1109579226" sldId="388"/>
@@ -558,6 +558,22 @@
             <pc:docMk/>
             <pc:sldMk cId="1109579226" sldId="388"/>
             <ac:spMk id="7" creationId="{14B85EC4-8F40-3159-DBE0-117F5C1C36A2}"/>
+          </ac:spMkLst>
+        </pc:spChg>
+        <pc:spChg chg="add mod">
+          <ac:chgData name="헌정 임" userId="eb9ca9bd79f0560f" providerId="LiveId" clId="{A6339E56-8272-42D6-9D95-12E1A8284411}" dt="2026-07-03T23:50:52.908" v="2103" actId="1076"/>
+          <ac:spMkLst>
+            <pc:docMk/>
+            <pc:sldMk cId="1109579226" sldId="388"/>
+            <ac:spMk id="12" creationId="{A3E2B3CB-B427-2FBE-557F-8229310BE264}"/>
+          </ac:spMkLst>
+        </pc:spChg>
+        <pc:spChg chg="add mod">
+          <ac:chgData name="헌정 임" userId="eb9ca9bd79f0560f" providerId="LiveId" clId="{A6339E56-8272-42D6-9D95-12E1A8284411}" dt="2026-07-03T23:50:52.908" v="2103" actId="1076"/>
+          <ac:spMkLst>
+            <pc:docMk/>
+            <pc:sldMk cId="1109579226" sldId="388"/>
+            <ac:spMk id="13" creationId="{1DAE601F-C90B-A461-45AE-F592AA3FA5D0}"/>
           </ac:spMkLst>
         </pc:spChg>
         <pc:picChg chg="add del mod modCrop">
@@ -5148,6 +5164,233 @@
           </a:p>
         </p:txBody>
       </p:sp>
+      <p:sp>
+        <p:nvSpPr>
+          <p:cNvPr id="12" name="TextBox 11">
+            <a:extLst>
+              <a:ext uri="{FF2B5EF4-FFF2-40B4-BE49-F238E27FC236}">
+                <a16:creationId xmlns:a16="http://schemas.microsoft.com/office/drawing/2014/main" id="{A3E2B3CB-B427-2FBE-557F-8229310BE264}"/>
+              </a:ext>
+            </a:extLst>
+          </p:cNvPr>
+          <p:cNvSpPr txBox="1"/>
+          <p:nvPr/>
+        </p:nvSpPr>
+        <p:spPr>
+          <a:xfrm>
+            <a:off x="7850256" y="2651800"/>
+            <a:ext cx="4730751" cy="1754326"/>
+          </a:xfrm>
+          <a:prstGeom prst="rect">
+            <a:avLst/>
+          </a:prstGeom>
+          <a:noFill/>
+        </p:spPr>
+        <p:txBody>
+          <a:bodyPr wrap="square" rtlCol="0">
+            <a:spAutoFit/>
+          </a:bodyPr>
+          <a:lstStyle/>
+          <a:p>
+            <a:r>
+              <a:rPr lang="en-US" altLang="ko-KR" dirty="0">
+                <a:highlight>
+                  <a:srgbClr val="FFFF00"/>
+                </a:highlight>
+              </a:rPr>
+              <a:t>(</a:t>
+            </a:r>
+            <a:r>
+              <a:rPr lang="ko-KR" altLang="en-US" dirty="0">
+                <a:highlight>
+                  <a:srgbClr val="FFFF00"/>
+                </a:highlight>
+              </a:rPr>
+              <a:t>문의</a:t>
+            </a:r>
+            <a:r>
+              <a:rPr lang="en-US" altLang="ko-KR" dirty="0">
+                <a:highlight>
+                  <a:srgbClr val="FFFF00"/>
+                </a:highlight>
+              </a:rPr>
+              <a:t>) </a:t>
+            </a:r>
+            <a:r>
+              <a:rPr lang="ko-KR" altLang="en-US" dirty="0">
+                <a:highlight>
+                  <a:srgbClr val="FFFF00"/>
+                </a:highlight>
+              </a:rPr>
+              <a:t>선택에 따라 </a:t>
+            </a:r>
+            <a:r>
+              <a:rPr lang="ko-KR" altLang="en-US" dirty="0" err="1">
+                <a:highlight>
+                  <a:srgbClr val="FFFF00"/>
+                </a:highlight>
+              </a:rPr>
+              <a:t>달라지는점</a:t>
+            </a:r>
+            <a:br>
+              <a:rPr lang="en-US" altLang="ko-KR" dirty="0">
+                <a:highlight>
+                  <a:srgbClr val="FFFF00"/>
+                </a:highlight>
+              </a:rPr>
+            </a:br>
+            <a:r>
+              <a:rPr lang="en-US" altLang="ko-KR" dirty="0">
+                <a:highlight>
+                  <a:srgbClr val="FFFF00"/>
+                </a:highlight>
+              </a:rPr>
+              <a:t>- </a:t>
+            </a:r>
+            <a:r>
+              <a:rPr lang="ko-KR" altLang="en-US" dirty="0">
+                <a:highlight>
+                  <a:srgbClr val="FFFF00"/>
+                </a:highlight>
+              </a:rPr>
+              <a:t>차량 데이터 수집 </a:t>
+            </a:r>
+            <a:r>
+              <a:rPr lang="en-US" altLang="ko-KR" dirty="0">
+                <a:highlight>
+                  <a:srgbClr val="FFFF00"/>
+                </a:highlight>
+              </a:rPr>
+              <a:t>= CAN  viewer</a:t>
+            </a:r>
+          </a:p>
+          <a:p>
+            <a:r>
+              <a:rPr lang="en-US" altLang="ko-KR" dirty="0">
+                <a:highlight>
+                  <a:srgbClr val="FFFF00"/>
+                </a:highlight>
+              </a:rPr>
+              <a:t>- </a:t>
+            </a:r>
+            <a:r>
+              <a:rPr lang="ko-KR" altLang="en-US" dirty="0" err="1">
+                <a:highlight>
+                  <a:srgbClr val="FFFF00"/>
+                </a:highlight>
+              </a:rPr>
+              <a:t>레포지</a:t>
+            </a:r>
+            <a:r>
+              <a:rPr lang="ko-KR" altLang="en-US" dirty="0">
+                <a:highlight>
+                  <a:srgbClr val="FFFF00"/>
+                </a:highlight>
+              </a:rPr>
+              <a:t> 토리에서 보여 지는 항목이 다르게 하였었나요</a:t>
+            </a:r>
+            <a:r>
+              <a:rPr lang="en-US" altLang="ko-KR" dirty="0">
+                <a:highlight>
+                  <a:srgbClr val="FFFF00"/>
+                </a:highlight>
+              </a:rPr>
+              <a:t>?</a:t>
+            </a:r>
+            <a:br>
+              <a:rPr lang="en-US" altLang="ko-KR" dirty="0">
+                <a:highlight>
+                  <a:srgbClr val="FFFF00"/>
+                </a:highlight>
+              </a:rPr>
+            </a:br>
+            <a:br>
+              <a:rPr lang="en-US" altLang="ko-KR" dirty="0">
+                <a:highlight>
+                  <a:srgbClr val="FFFF00"/>
+                </a:highlight>
+              </a:rPr>
+            </a:br>
+            <a:r>
+              <a:rPr lang="en-US" altLang="ko-KR" dirty="0">
+                <a:highlight>
+                  <a:srgbClr val="FFFF00"/>
+                </a:highlight>
+              </a:rPr>
+              <a:t>* </a:t>
+            </a:r>
+            <a:r>
+              <a:rPr lang="ko-KR" altLang="en-US" dirty="0">
+                <a:highlight>
+                  <a:srgbClr val="FFFF00"/>
+                </a:highlight>
+              </a:rPr>
+              <a:t>파악 후 설명 문구 전달 드리겠습니다</a:t>
+            </a:r>
+            <a:r>
+              <a:rPr lang="en-US" altLang="ko-KR" dirty="0">
+                <a:highlight>
+                  <a:srgbClr val="FFFF00"/>
+                </a:highlight>
+              </a:rPr>
+              <a:t>.</a:t>
+            </a:r>
+          </a:p>
+        </p:txBody>
+      </p:sp>
+      <p:sp>
+        <p:nvSpPr>
+          <p:cNvPr id="13" name="직사각형 12">
+            <a:extLst>
+              <a:ext uri="{FF2B5EF4-FFF2-40B4-BE49-F238E27FC236}">
+                <a16:creationId xmlns:a16="http://schemas.microsoft.com/office/drawing/2014/main" id="{1DAE601F-C90B-A461-45AE-F592AA3FA5D0}"/>
+              </a:ext>
+            </a:extLst>
+          </p:cNvPr>
+          <p:cNvSpPr/>
+          <p:nvPr/>
+        </p:nvSpPr>
+        <p:spPr>
+          <a:xfrm>
+            <a:off x="8108791" y="1450931"/>
+            <a:ext cx="3449866" cy="180459"/>
+          </a:xfrm>
+          <a:prstGeom prst="rect">
+            <a:avLst/>
+          </a:prstGeom>
+          <a:noFill/>
+          <a:ln>
+            <a:solidFill>
+              <a:srgbClr val="C00000"/>
+            </a:solidFill>
+            <a:prstDash val="sysDash"/>
+          </a:ln>
+        </p:spPr>
+        <p:style>
+          <a:lnRef idx="2">
+            <a:schemeClr val="accent1">
+              <a:shade val="15000"/>
+            </a:schemeClr>
+          </a:lnRef>
+          <a:fillRef idx="1">
+            <a:schemeClr val="accent1"/>
+          </a:fillRef>
+          <a:effectRef idx="0">
+            <a:schemeClr val="accent1"/>
+          </a:effectRef>
+          <a:fontRef idx="minor">
+            <a:schemeClr val="lt1"/>
+          </a:fontRef>
+        </p:style>
+        <p:txBody>
+          <a:bodyPr rtlCol="0" anchor="ctr"/>
+          <a:lstStyle/>
+          <a:p>
+            <a:pPr algn="ctr"/>
+            <a:endParaRPr lang="ko-KR" altLang="en-US" dirty="0"/>
+          </a:p>
+        </p:txBody>
+      </p:sp>
     </p:spTree>
     <p:extLst>
       <p:ext uri="{BB962C8B-B14F-4D97-AF65-F5344CB8AC3E}">

</xml_diff>

<commit_message>
vault backup: 2026-07-04 08:51:20
</commit_message>
<xml_diff>
--- a/assets/06-dataspace/image.pptx
+++ b/assets/06-dataspace/image.pptx
@@ -146,7 +146,7 @@
   <pc:docChgLst>
     <pc:chgData name="헌정 임" userId="eb9ca9bd79f0560f" providerId="LiveId" clId="{A6339E56-8272-42D6-9D95-12E1A8284411}"/>
     <pc:docChg chg="undo custSel addSld delSld modSld sldOrd">
-      <pc:chgData name="헌정 임" userId="eb9ca9bd79f0560f" providerId="LiveId" clId="{A6339E56-8272-42D6-9D95-12E1A8284411}" dt="2026-07-03T23:50:52.908" v="2103" actId="1076"/>
+      <pc:chgData name="헌정 임" userId="eb9ca9bd79f0560f" providerId="LiveId" clId="{A6339E56-8272-42D6-9D95-12E1A8284411}" dt="2026-07-03T23:51:14.933" v="2108" actId="14100"/>
       <pc:docMkLst>
         <pc:docMk/>
       </pc:docMkLst>
@@ -547,7 +547,7 @@
         </pc:picChg>
       </pc:sldChg>
       <pc:sldChg chg="addSp delSp modSp new mod">
-        <pc:chgData name="헌정 임" userId="eb9ca9bd79f0560f" providerId="LiveId" clId="{A6339E56-8272-42D6-9D95-12E1A8284411}" dt="2026-07-03T23:50:52.908" v="2103" actId="1076"/>
+        <pc:chgData name="헌정 임" userId="eb9ca9bd79f0560f" providerId="LiveId" clId="{A6339E56-8272-42D6-9D95-12E1A8284411}" dt="2026-07-03T23:51:14.933" v="2108" actId="14100"/>
         <pc:sldMkLst>
           <pc:docMk/>
           <pc:sldMk cId="1109579226" sldId="388"/>
@@ -569,7 +569,7 @@
           </ac:spMkLst>
         </pc:spChg>
         <pc:spChg chg="add mod">
-          <ac:chgData name="헌정 임" userId="eb9ca9bd79f0560f" providerId="LiveId" clId="{A6339E56-8272-42D6-9D95-12E1A8284411}" dt="2026-07-03T23:50:52.908" v="2103" actId="1076"/>
+          <ac:chgData name="헌정 임" userId="eb9ca9bd79f0560f" providerId="LiveId" clId="{A6339E56-8272-42D6-9D95-12E1A8284411}" dt="2026-07-03T23:51:14.933" v="2108" actId="14100"/>
           <ac:spMkLst>
             <pc:docMk/>
             <pc:sldMk cId="1109579226" sldId="388"/>
@@ -584,8 +584,8 @@
             <ac:picMk id="4" creationId="{C981B778-07B5-E856-C945-43C97FBF7C74}"/>
           </ac:picMkLst>
         </pc:picChg>
-        <pc:picChg chg="add">
-          <ac:chgData name="헌정 임" userId="eb9ca9bd79f0560f" providerId="LiveId" clId="{A6339E56-8272-42D6-9D95-12E1A8284411}" dt="2026-07-03T12:18:18.247" v="84" actId="22"/>
+        <pc:picChg chg="add mod">
+          <ac:chgData name="헌정 임" userId="eb9ca9bd79f0560f" providerId="LiveId" clId="{A6339E56-8272-42D6-9D95-12E1A8284411}" dt="2026-07-03T23:51:01.131" v="2105" actId="1076"/>
           <ac:picMkLst>
             <pc:docMk/>
             <pc:sldMk cId="1109579226" sldId="388"/>
@@ -5352,8 +5352,8 @@
         </p:nvSpPr>
         <p:spPr>
           <a:xfrm>
-            <a:off x="8108791" y="1450931"/>
-            <a:ext cx="3449866" cy="180459"/>
+            <a:off x="4341745" y="3528963"/>
+            <a:ext cx="1654864" cy="552707"/>
           </a:xfrm>
           <a:prstGeom prst="rect">
             <a:avLst/>

</xml_diff>

<commit_message>
vault backup: 2026-07-04 09:01:06
</commit_message>
<xml_diff>
--- a/assets/06-dataspace/image.pptx
+++ b/assets/06-dataspace/image.pptx
@@ -14,19 +14,26 @@
     <p:sldId id="385" r:id="rId8"/>
     <p:sldId id="395" r:id="rId9"/>
     <p:sldId id="399" r:id="rId10"/>
-    <p:sldId id="397" r:id="rId11"/>
-    <p:sldId id="387" r:id="rId12"/>
-    <p:sldId id="388" r:id="rId13"/>
-    <p:sldId id="392" r:id="rId14"/>
-    <p:sldId id="398" r:id="rId15"/>
-    <p:sldId id="393" r:id="rId16"/>
-    <p:sldId id="396" r:id="rId17"/>
-    <p:sldId id="256" r:id="rId18"/>
-    <p:sldId id="257" r:id="rId19"/>
-    <p:sldId id="259" r:id="rId20"/>
-    <p:sldId id="258" r:id="rId21"/>
-    <p:sldId id="260" r:id="rId22"/>
-    <p:sldId id="380" r:id="rId23"/>
+    <p:sldId id="406" r:id="rId11"/>
+    <p:sldId id="397" r:id="rId12"/>
+    <p:sldId id="387" r:id="rId13"/>
+    <p:sldId id="388" r:id="rId14"/>
+    <p:sldId id="392" r:id="rId15"/>
+    <p:sldId id="400" r:id="rId16"/>
+    <p:sldId id="401" r:id="rId17"/>
+    <p:sldId id="402" r:id="rId18"/>
+    <p:sldId id="403" r:id="rId19"/>
+    <p:sldId id="404" r:id="rId20"/>
+    <p:sldId id="405" r:id="rId21"/>
+    <p:sldId id="398" r:id="rId22"/>
+    <p:sldId id="393" r:id="rId23"/>
+    <p:sldId id="396" r:id="rId24"/>
+    <p:sldId id="256" r:id="rId25"/>
+    <p:sldId id="257" r:id="rId26"/>
+    <p:sldId id="259" r:id="rId27"/>
+    <p:sldId id="258" r:id="rId28"/>
+    <p:sldId id="260" r:id="rId29"/>
+    <p:sldId id="380" r:id="rId30"/>
   </p:sldIdLst>
   <p:sldSz cx="12192000" cy="6858000"/>
   <p:notesSz cx="6858000" cy="9144000"/>
@@ -136,7 +143,7 @@
 <file path=ppt/revisionInfo.xml><?xml version="1.0" encoding="utf-8"?>
 <p1510:revInfo xmlns:a="http://schemas.openxmlformats.org/drawingml/2006/main" xmlns:r="http://schemas.openxmlformats.org/officeDocument/2006/relationships" xmlns:p1510="http://schemas.microsoft.com/office/powerpoint/2015/10/main">
   <p1510:revLst>
-    <p1510:client id="{77AFA03C-ADB3-48E7-9DEE-EC77C33AF38A}" v="188" dt="2026-07-03T23:50:49.459"/>
+    <p1510:client id="{77AFA03C-ADB3-48E7-9DEE-EC77C33AF38A}" v="245" dt="2026-07-04T00:00:06.344"/>
   </p1510:revLst>
 </p1510:revInfo>
 </file>
@@ -146,7 +153,7 @@
   <pc:docChgLst>
     <pc:chgData name="헌정 임" userId="eb9ca9bd79f0560f" providerId="LiveId" clId="{A6339E56-8272-42D6-9D95-12E1A8284411}"/>
     <pc:docChg chg="undo custSel addSld delSld modSld sldOrd">
-      <pc:chgData name="헌정 임" userId="eb9ca9bd79f0560f" providerId="LiveId" clId="{A6339E56-8272-42D6-9D95-12E1A8284411}" dt="2026-07-03T23:51:14.933" v="2108" actId="14100"/>
+      <pc:chgData name="헌정 임" userId="eb9ca9bd79f0560f" providerId="LiveId" clId="{A6339E56-8272-42D6-9D95-12E1A8284411}" dt="2026-07-04T00:00:12.473" v="2838" actId="1076"/>
       <pc:docMkLst>
         <pc:docMk/>
       </pc:docMkLst>
@@ -547,7 +554,7 @@
         </pc:picChg>
       </pc:sldChg>
       <pc:sldChg chg="addSp delSp modSp new mod">
-        <pc:chgData name="헌정 임" userId="eb9ca9bd79f0560f" providerId="LiveId" clId="{A6339E56-8272-42D6-9D95-12E1A8284411}" dt="2026-07-03T23:51:14.933" v="2108" actId="14100"/>
+        <pc:chgData name="헌정 임" userId="eb9ca9bd79f0560f" providerId="LiveId" clId="{A6339E56-8272-42D6-9D95-12E1A8284411}" dt="2026-07-03T23:54:35.367" v="2583" actId="20577"/>
         <pc:sldMkLst>
           <pc:docMk/>
           <pc:sldMk cId="1109579226" sldId="388"/>
@@ -561,7 +568,7 @@
           </ac:spMkLst>
         </pc:spChg>
         <pc:spChg chg="add mod">
-          <ac:chgData name="헌정 임" userId="eb9ca9bd79f0560f" providerId="LiveId" clId="{A6339E56-8272-42D6-9D95-12E1A8284411}" dt="2026-07-03T23:50:52.908" v="2103" actId="1076"/>
+          <ac:chgData name="헌정 임" userId="eb9ca9bd79f0560f" providerId="LiveId" clId="{A6339E56-8272-42D6-9D95-12E1A8284411}" dt="2026-07-03T23:54:35.367" v="2583" actId="20577"/>
           <ac:spMkLst>
             <pc:docMk/>
             <pc:sldMk cId="1109579226" sldId="388"/>
@@ -574,6 +581,14 @@
             <pc:docMk/>
             <pc:sldMk cId="1109579226" sldId="388"/>
             <ac:spMk id="13" creationId="{1DAE601F-C90B-A461-45AE-F592AA3FA5D0}"/>
+          </ac:spMkLst>
+        </pc:spChg>
+        <pc:spChg chg="add mod">
+          <ac:chgData name="헌정 임" userId="eb9ca9bd79f0560f" providerId="LiveId" clId="{A6339E56-8272-42D6-9D95-12E1A8284411}" dt="2026-07-03T23:53:12.729" v="2365" actId="1076"/>
+          <ac:spMkLst>
+            <pc:docMk/>
+            <pc:sldMk cId="1109579226" sldId="388"/>
+            <ac:spMk id="14" creationId="{A3FD006F-F833-AB48-1F9D-40FFB5983FE0}"/>
           </ac:spMkLst>
         </pc:spChg>
         <pc:picChg chg="add del mod modCrop">
@@ -1040,7 +1055,7 @@
         </pc:picChg>
       </pc:sldChg>
       <pc:sldChg chg="addSp delSp modSp new mod">
-        <pc:chgData name="헌정 임" userId="eb9ca9bd79f0560f" providerId="LiveId" clId="{A6339E56-8272-42D6-9D95-12E1A8284411}" dt="2026-07-03T23:49:18.103" v="1942" actId="20577"/>
+        <pc:chgData name="헌정 임" userId="eb9ca9bd79f0560f" providerId="LiveId" clId="{A6339E56-8272-42D6-9D95-12E1A8284411}" dt="2026-07-03T23:58:34.178" v="2595" actId="21"/>
         <pc:sldMkLst>
           <pc:docMk/>
           <pc:sldMk cId="3010018706" sldId="399"/>
@@ -1078,19 +1093,108 @@
           </ac:spMkLst>
         </pc:spChg>
         <pc:spChg chg="add mod">
-          <ac:chgData name="헌정 임" userId="eb9ca9bd79f0560f" providerId="LiveId" clId="{A6339E56-8272-42D6-9D95-12E1A8284411}" dt="2026-07-03T23:49:18.103" v="1942" actId="20577"/>
+          <ac:chgData name="헌정 임" userId="eb9ca9bd79f0560f" providerId="LiveId" clId="{A6339E56-8272-42D6-9D95-12E1A8284411}" dt="2026-07-03T23:58:30.189" v="2593" actId="1076"/>
           <ac:spMkLst>
             <pc:docMk/>
             <pc:sldMk cId="3010018706" sldId="399"/>
             <ac:spMk id="6" creationId="{8CBAADC2-493A-A8EC-B12E-55DE5B08C5B5}"/>
           </ac:spMkLst>
         </pc:spChg>
+        <pc:picChg chg="add del mod">
+          <ac:chgData name="헌정 임" userId="eb9ca9bd79f0560f" providerId="LiveId" clId="{A6339E56-8272-42D6-9D95-12E1A8284411}" dt="2026-07-03T23:58:34.178" v="2595" actId="21"/>
+          <ac:picMkLst>
+            <pc:docMk/>
+            <pc:sldMk cId="3010018706" sldId="399"/>
+            <ac:picMk id="7" creationId="{7BE41F11-17DB-1B2A-9573-FE3D93F57C8C}"/>
+          </ac:picMkLst>
+        </pc:picChg>
         <pc:picChg chg="add mod">
           <ac:chgData name="헌정 임" userId="eb9ca9bd79f0560f" providerId="LiveId" clId="{A6339E56-8272-42D6-9D95-12E1A8284411}" dt="2026-07-03T23:45:12.504" v="1427" actId="1076"/>
           <ac:picMkLst>
             <pc:docMk/>
             <pc:sldMk cId="3010018706" sldId="399"/>
             <ac:picMk id="8" creationId="{7C0EF117-428F-9EDD-E27F-AA9FBB041137}"/>
+          </ac:picMkLst>
+        </pc:picChg>
+      </pc:sldChg>
+      <pc:sldChg chg="new">
+        <pc:chgData name="헌정 임" userId="eb9ca9bd79f0560f" providerId="LiveId" clId="{A6339E56-8272-42D6-9D95-12E1A8284411}" dt="2026-07-03T23:55:56.943" v="2584" actId="680"/>
+        <pc:sldMkLst>
+          <pc:docMk/>
+          <pc:sldMk cId="1762703876" sldId="400"/>
+        </pc:sldMkLst>
+      </pc:sldChg>
+      <pc:sldChg chg="new">
+        <pc:chgData name="헌정 임" userId="eb9ca9bd79f0560f" providerId="LiveId" clId="{A6339E56-8272-42D6-9D95-12E1A8284411}" dt="2026-07-03T23:55:57.122" v="2585" actId="680"/>
+        <pc:sldMkLst>
+          <pc:docMk/>
+          <pc:sldMk cId="3187036238" sldId="401"/>
+        </pc:sldMkLst>
+      </pc:sldChg>
+      <pc:sldChg chg="new">
+        <pc:chgData name="헌정 임" userId="eb9ca9bd79f0560f" providerId="LiveId" clId="{A6339E56-8272-42D6-9D95-12E1A8284411}" dt="2026-07-03T23:55:57.286" v="2586" actId="680"/>
+        <pc:sldMkLst>
+          <pc:docMk/>
+          <pc:sldMk cId="1628367054" sldId="402"/>
+        </pc:sldMkLst>
+      </pc:sldChg>
+      <pc:sldChg chg="new">
+        <pc:chgData name="헌정 임" userId="eb9ca9bd79f0560f" providerId="LiveId" clId="{A6339E56-8272-42D6-9D95-12E1A8284411}" dt="2026-07-03T23:55:57.437" v="2587" actId="680"/>
+        <pc:sldMkLst>
+          <pc:docMk/>
+          <pc:sldMk cId="1740472668" sldId="403"/>
+        </pc:sldMkLst>
+      </pc:sldChg>
+      <pc:sldChg chg="addSp new mod">
+        <pc:chgData name="헌정 임" userId="eb9ca9bd79f0560f" providerId="LiveId" clId="{A6339E56-8272-42D6-9D95-12E1A8284411}" dt="2026-07-03T23:56:02.911" v="2589" actId="22"/>
+        <pc:sldMkLst>
+          <pc:docMk/>
+          <pc:sldMk cId="2421219215" sldId="404"/>
+        </pc:sldMkLst>
+        <pc:picChg chg="add">
+          <ac:chgData name="헌정 임" userId="eb9ca9bd79f0560f" providerId="LiveId" clId="{A6339E56-8272-42D6-9D95-12E1A8284411}" dt="2026-07-03T23:56:02.911" v="2589" actId="22"/>
+          <ac:picMkLst>
+            <pc:docMk/>
+            <pc:sldMk cId="2421219215" sldId="404"/>
+            <ac:picMk id="4" creationId="{A7A374BE-0F6E-3369-A9F2-3D53D6A0995D}"/>
+          </ac:picMkLst>
+        </pc:picChg>
+      </pc:sldChg>
+      <pc:sldChg chg="addSp new mod">
+        <pc:chgData name="헌정 임" userId="eb9ca9bd79f0560f" providerId="LiveId" clId="{A6339E56-8272-42D6-9D95-12E1A8284411}" dt="2026-07-03T23:56:42.082" v="2591" actId="22"/>
+        <pc:sldMkLst>
+          <pc:docMk/>
+          <pc:sldMk cId="1413464511" sldId="405"/>
+        </pc:sldMkLst>
+        <pc:picChg chg="add">
+          <ac:chgData name="헌정 임" userId="eb9ca9bd79f0560f" providerId="LiveId" clId="{A6339E56-8272-42D6-9D95-12E1A8284411}" dt="2026-07-03T23:56:42.082" v="2591" actId="22"/>
+          <ac:picMkLst>
+            <pc:docMk/>
+            <pc:sldMk cId="1413464511" sldId="405"/>
+            <ac:picMk id="4" creationId="{86663FFD-757A-B59F-D3BD-DEB11E2B0B10}"/>
+          </ac:picMkLst>
+        </pc:picChg>
+      </pc:sldChg>
+      <pc:sldChg chg="addSp modSp new mod">
+        <pc:chgData name="헌정 임" userId="eb9ca9bd79f0560f" providerId="LiveId" clId="{A6339E56-8272-42D6-9D95-12E1A8284411}" dt="2026-07-04T00:00:12.473" v="2838" actId="1076"/>
+        <pc:sldMkLst>
+          <pc:docMk/>
+          <pc:sldMk cId="1911614107" sldId="406"/>
+        </pc:sldMkLst>
+        <pc:spChg chg="add mod">
+          <ac:chgData name="헌정 임" userId="eb9ca9bd79f0560f" providerId="LiveId" clId="{A6339E56-8272-42D6-9D95-12E1A8284411}" dt="2026-07-04T00:00:12.473" v="2838" actId="1076"/>
+          <ac:spMkLst>
+            <pc:docMk/>
+            <pc:sldMk cId="1911614107" sldId="406"/>
+            <ac:spMk id="3" creationId="{F61295E9-507C-8BC4-D1E2-137D8BCE6A6F}"/>
+          </ac:spMkLst>
+        </pc:spChg>
+        <pc:picChg chg="add mod">
+          <ac:chgData name="헌정 임" userId="eb9ca9bd79f0560f" providerId="LiveId" clId="{A6339E56-8272-42D6-9D95-12E1A8284411}" dt="2026-07-03T23:58:38.019" v="2597" actId="1076"/>
+          <ac:picMkLst>
+            <pc:docMk/>
+            <pc:sldMk cId="1911614107" sldId="406"/>
+            <ac:picMk id="7" creationId="{7BE41F11-17DB-1B2A-9573-FE3D93F57C8C}"/>
           </ac:picMkLst>
         </pc:picChg>
       </pc:sldChg>
@@ -4782,6 +4886,205 @@
           <p:cNvPr id="2" name="제목 1">
             <a:extLst>
               <a:ext uri="{FF2B5EF4-FFF2-40B4-BE49-F238E27FC236}">
+                <a16:creationId xmlns:a16="http://schemas.microsoft.com/office/drawing/2014/main" id="{964224D5-44C5-5071-1AFD-9B0D4C7FB317}"/>
+              </a:ext>
+            </a:extLst>
+          </p:cNvPr>
+          <p:cNvSpPr>
+            <a:spLocks noGrp="1"/>
+          </p:cNvSpPr>
+          <p:nvPr>
+            <p:ph type="title"/>
+          </p:nvPr>
+        </p:nvSpPr>
+        <p:spPr/>
+        <p:txBody>
+          <a:bodyPr/>
+          <a:lstStyle/>
+          <a:p>
+            <a:endParaRPr lang="ko-KR" altLang="en-US"/>
+          </a:p>
+        </p:txBody>
+      </p:sp>
+      <p:pic>
+        <p:nvPicPr>
+          <p:cNvPr id="7" name="그림 6">
+            <a:extLst>
+              <a:ext uri="{FF2B5EF4-FFF2-40B4-BE49-F238E27FC236}">
+                <a16:creationId xmlns:a16="http://schemas.microsoft.com/office/drawing/2014/main" id="{7BE41F11-17DB-1B2A-9573-FE3D93F57C8C}"/>
+              </a:ext>
+            </a:extLst>
+          </p:cNvPr>
+          <p:cNvPicPr>
+            <a:picLocks noChangeAspect="1"/>
+          </p:cNvPicPr>
+          <p:nvPr/>
+        </p:nvPicPr>
+        <p:blipFill>
+          <a:blip r:embed="rId2"/>
+          <a:stretch>
+            <a:fillRect/>
+          </a:stretch>
+        </p:blipFill>
+        <p:spPr>
+          <a:xfrm>
+            <a:off x="1547781" y="365125"/>
+            <a:ext cx="4286281" cy="5581691"/>
+          </a:xfrm>
+          <a:prstGeom prst="rect">
+            <a:avLst/>
+          </a:prstGeom>
+        </p:spPr>
+      </p:pic>
+      <p:sp>
+        <p:nvSpPr>
+          <p:cNvPr id="3" name="TextBox 2">
+            <a:extLst>
+              <a:ext uri="{FF2B5EF4-FFF2-40B4-BE49-F238E27FC236}">
+                <a16:creationId xmlns:a16="http://schemas.microsoft.com/office/drawing/2014/main" id="{F61295E9-507C-8BC4-D1E2-137D8BCE6A6F}"/>
+              </a:ext>
+            </a:extLst>
+          </p:cNvPr>
+          <p:cNvSpPr txBox="1"/>
+          <p:nvPr/>
+        </p:nvSpPr>
+        <p:spPr>
+          <a:xfrm>
+            <a:off x="5913468" y="5285289"/>
+            <a:ext cx="4730751" cy="923330"/>
+          </a:xfrm>
+          <a:prstGeom prst="rect">
+            <a:avLst/>
+          </a:prstGeom>
+          <a:noFill/>
+        </p:spPr>
+        <p:txBody>
+          <a:bodyPr wrap="square" rtlCol="0">
+            <a:spAutoFit/>
+          </a:bodyPr>
+          <a:lstStyle/>
+          <a:p>
+            <a:r>
+              <a:rPr lang="ko-KR" altLang="en-US" dirty="0">
+                <a:highlight>
+                  <a:srgbClr val="FFFF00"/>
+                </a:highlight>
+              </a:rPr>
+              <a:t>생성 버튼 </a:t>
+            </a:r>
+            <a:r>
+              <a:rPr lang="ko-KR" altLang="en-US" dirty="0" err="1">
+                <a:highlight>
+                  <a:srgbClr val="FFFF00"/>
+                </a:highlight>
+              </a:rPr>
+              <a:t>클릭시</a:t>
+            </a:r>
+            <a:r>
+              <a:rPr lang="ko-KR" altLang="en-US" dirty="0">
+                <a:highlight>
+                  <a:srgbClr val="FFFF00"/>
+                </a:highlight>
+              </a:rPr>
+              <a:t> </a:t>
+            </a:r>
+            <a:r>
+              <a:rPr lang="en-US" altLang="ko-KR" dirty="0">
+                <a:highlight>
+                  <a:srgbClr val="FFFF00"/>
+                </a:highlight>
+              </a:rPr>
+              <a:t>or </a:t>
+            </a:r>
+            <a:r>
+              <a:rPr lang="ko-KR" altLang="en-US" dirty="0">
+                <a:highlight>
+                  <a:srgbClr val="FFFF00"/>
+                </a:highlight>
+              </a:rPr>
+              <a:t>매 입력 단계에서  </a:t>
+            </a:r>
+            <a:endParaRPr lang="en-US" altLang="ko-KR" dirty="0">
+              <a:highlight>
+                <a:srgbClr val="FFFF00"/>
+              </a:highlight>
+            </a:endParaRPr>
+          </a:p>
+          <a:p>
+            <a:pPr marL="285750" indent="-285750">
+              <a:buFontTx/>
+              <a:buChar char="-"/>
+            </a:pPr>
+            <a:r>
+              <a:rPr lang="ko-KR" altLang="en-US" dirty="0">
+                <a:highlight>
+                  <a:srgbClr val="FFFF00"/>
+                </a:highlight>
+              </a:rPr>
+              <a:t>위 네트워크 입력 정보가 맞는지</a:t>
+            </a:r>
+            <a:r>
+              <a:rPr lang="en-US" altLang="ko-KR" dirty="0">
+                <a:highlight>
+                  <a:srgbClr val="FFFF00"/>
+                </a:highlight>
+              </a:rPr>
+              <a:t>(</a:t>
+            </a:r>
+            <a:r>
+              <a:rPr lang="ko-KR" altLang="en-US" dirty="0">
+                <a:highlight>
+                  <a:srgbClr val="FFFF00"/>
+                </a:highlight>
+              </a:rPr>
+              <a:t>통신 되는지 체크</a:t>
+            </a:r>
+            <a:r>
+              <a:rPr lang="en-US" altLang="ko-KR" dirty="0">
+                <a:highlight>
+                  <a:srgbClr val="FFFF00"/>
+                </a:highlight>
+              </a:rPr>
+              <a:t>) </a:t>
+            </a:r>
+          </a:p>
+        </p:txBody>
+      </p:sp>
+    </p:spTree>
+    <p:extLst>
+      <p:ext uri="{BB962C8B-B14F-4D97-AF65-F5344CB8AC3E}">
+        <p14:creationId xmlns:p14="http://schemas.microsoft.com/office/powerpoint/2010/main" val="1911614107"/>
+      </p:ext>
+    </p:extLst>
+  </p:cSld>
+  <p:clrMapOvr>
+    <a:masterClrMapping/>
+  </p:clrMapOvr>
+</p:sld>
+</file>
+
+<file path=ppt/slides/slide11.xml><?xml version="1.0" encoding="utf-8"?>
+<p:sld xmlns:a="http://schemas.openxmlformats.org/drawingml/2006/main" xmlns:r="http://schemas.openxmlformats.org/officeDocument/2006/relationships" xmlns:p="http://schemas.openxmlformats.org/presentationml/2006/main">
+  <p:cSld>
+    <p:spTree>
+      <p:nvGrpSpPr>
+        <p:cNvPr id="1" name=""/>
+        <p:cNvGrpSpPr/>
+        <p:nvPr/>
+      </p:nvGrpSpPr>
+      <p:grpSpPr>
+        <a:xfrm>
+          <a:off x="0" y="0"/>
+          <a:ext cx="0" cy="0"/>
+          <a:chOff x="0" y="0"/>
+          <a:chExt cx="0" cy="0"/>
+        </a:xfrm>
+      </p:grpSpPr>
+      <p:sp>
+        <p:nvSpPr>
+          <p:cNvPr id="2" name="제목 1">
+            <a:extLst>
+              <a:ext uri="{FF2B5EF4-FFF2-40B4-BE49-F238E27FC236}">
                 <a16:creationId xmlns:a16="http://schemas.microsoft.com/office/drawing/2014/main" id="{D36E85DB-23E2-8AE2-7730-D2E6CFCBB814}"/>
               </a:ext>
             </a:extLst>
@@ -4845,7 +5148,7 @@
 </p:sld>
 </file>
 
-<file path=ppt/slides/slide11.xml><?xml version="1.0" encoding="utf-8"?>
+<file path=ppt/slides/slide12.xml><?xml version="1.0" encoding="utf-8"?>
 <p:sld xmlns:a="http://schemas.openxmlformats.org/drawingml/2006/main" xmlns:r="http://schemas.openxmlformats.org/officeDocument/2006/relationships" xmlns:p="http://schemas.openxmlformats.org/presentationml/2006/main">
   <p:cSld>
     <p:spTree>
@@ -5011,7 +5314,7 @@
 </p:sld>
 </file>
 
-<file path=ppt/slides/slide12.xml><?xml version="1.0" encoding="utf-8"?>
+<file path=ppt/slides/slide13.xml><?xml version="1.0" encoding="utf-8"?>
 <p:sld xmlns:a="http://schemas.openxmlformats.org/drawingml/2006/main" xmlns:r="http://schemas.openxmlformats.org/officeDocument/2006/relationships" xmlns:p="http://schemas.openxmlformats.org/presentationml/2006/main">
   <p:cSld>
     <p:spTree>
@@ -5178,8 +5481,8 @@
         </p:nvSpPr>
         <p:spPr>
           <a:xfrm>
-            <a:off x="7850256" y="2651800"/>
-            <a:ext cx="4730751" cy="1754326"/>
+            <a:off x="6988864" y="3027864"/>
+            <a:ext cx="4730751" cy="2308324"/>
           </a:xfrm>
           <a:prstGeom prst="rect">
             <a:avLst/>
@@ -5222,7 +5525,7 @@
                   <a:srgbClr val="FFFF00"/>
                 </a:highlight>
               </a:rPr>
-              <a:t>선택에 따라 </a:t>
+              <a:t>저장소를 등록 </a:t>
             </a:r>
             <a:r>
               <a:rPr lang="ko-KR" altLang="en-US" dirty="0" err="1">
@@ -5230,7 +5533,97 @@
                   <a:srgbClr val="FFFF00"/>
                 </a:highlight>
               </a:rPr>
-              <a:t>달라지는점</a:t>
+              <a:t>하는것인가요</a:t>
+            </a:r>
+            <a:r>
+              <a:rPr lang="en-US" altLang="ko-KR" dirty="0">
+                <a:highlight>
+                  <a:srgbClr val="FFFF00"/>
+                </a:highlight>
+              </a:rPr>
+              <a:t>?</a:t>
+            </a:r>
+          </a:p>
+          <a:p>
+            <a:endParaRPr lang="en-US" altLang="ko-KR" dirty="0">
+              <a:highlight>
+                <a:srgbClr val="FFFF00"/>
+              </a:highlight>
+            </a:endParaRPr>
+          </a:p>
+          <a:p>
+            <a:r>
+              <a:rPr lang="ko-KR" altLang="en-US" dirty="0">
+                <a:highlight>
+                  <a:srgbClr val="FFFF00"/>
+                </a:highlight>
+              </a:rPr>
+              <a:t>저장소내 특정 이미지를 저장 </a:t>
+            </a:r>
+            <a:r>
+              <a:rPr lang="ko-KR" altLang="en-US" dirty="0" err="1">
+                <a:highlight>
+                  <a:srgbClr val="FFFF00"/>
+                </a:highlight>
+              </a:rPr>
+              <a:t>하는것인가요</a:t>
+            </a:r>
+            <a:r>
+              <a:rPr lang="en-US" altLang="ko-KR" dirty="0">
+                <a:highlight>
+                  <a:srgbClr val="FFFF00"/>
+                </a:highlight>
+              </a:rPr>
+              <a:t>?</a:t>
+            </a:r>
+          </a:p>
+          <a:p>
+            <a:endParaRPr lang="en-US" altLang="ko-KR" dirty="0">
+              <a:highlight>
+                <a:srgbClr val="FFFF00"/>
+              </a:highlight>
+            </a:endParaRPr>
+          </a:p>
+          <a:p>
+            <a:r>
+              <a:rPr lang="en-US" altLang="ko-KR" dirty="0">
+                <a:highlight>
+                  <a:srgbClr val="FFFF00"/>
+                </a:highlight>
+              </a:rPr>
+              <a:t>Repository URL</a:t>
+            </a:r>
+            <a:r>
+              <a:rPr lang="ko-KR" altLang="en-US" dirty="0">
+                <a:highlight>
+                  <a:srgbClr val="FFFF00"/>
+                </a:highlight>
+              </a:rPr>
+              <a:t>을 내부 </a:t>
+            </a:r>
+            <a:r>
+              <a:rPr lang="en-US" altLang="ko-KR" dirty="0">
+                <a:highlight>
+                  <a:srgbClr val="FFFF00"/>
+                </a:highlight>
+              </a:rPr>
+              <a:t>Harbor</a:t>
+            </a:r>
+            <a:r>
+              <a:rPr lang="ko-KR" altLang="en-US" dirty="0">
+                <a:highlight>
+                  <a:srgbClr val="FFFF00"/>
+                </a:highlight>
+              </a:rPr>
+              <a:t>로 설정 하면  동작 할까요</a:t>
+            </a:r>
+            <a:r>
+              <a:rPr lang="en-US" altLang="ko-KR" dirty="0">
+                <a:highlight>
+                  <a:srgbClr val="FFFF00"/>
+                </a:highlight>
+              </a:rPr>
+              <a:t>? </a:t>
             </a:r>
             <a:br>
               <a:rPr lang="en-US" altLang="ko-KR" dirty="0">
@@ -5245,96 +5638,15 @@
                   <a:srgbClr val="FFFF00"/>
                 </a:highlight>
               </a:rPr>
-              <a:t>- </a:t>
-            </a:r>
-            <a:r>
-              <a:rPr lang="ko-KR" altLang="en-US" dirty="0">
-                <a:highlight>
-                  <a:srgbClr val="FFFF00"/>
-                </a:highlight>
-              </a:rPr>
-              <a:t>차량 데이터 수집 </a:t>
-            </a:r>
-            <a:r>
-              <a:rPr lang="en-US" altLang="ko-KR" dirty="0">
-                <a:highlight>
-                  <a:srgbClr val="FFFF00"/>
-                </a:highlight>
-              </a:rPr>
-              <a:t>= CAN  viewer</a:t>
+              <a:t>https://harbor.bigdata-car.kr</a:t>
             </a:r>
           </a:p>
           <a:p>
-            <a:r>
-              <a:rPr lang="en-US" altLang="ko-KR" dirty="0">
-                <a:highlight>
-                  <a:srgbClr val="FFFF00"/>
-                </a:highlight>
-              </a:rPr>
-              <a:t>- </a:t>
-            </a:r>
-            <a:r>
-              <a:rPr lang="ko-KR" altLang="en-US" dirty="0" err="1">
-                <a:highlight>
-                  <a:srgbClr val="FFFF00"/>
-                </a:highlight>
-              </a:rPr>
-              <a:t>레포지</a:t>
-            </a:r>
-            <a:r>
-              <a:rPr lang="ko-KR" altLang="en-US" dirty="0">
-                <a:highlight>
-                  <a:srgbClr val="FFFF00"/>
-                </a:highlight>
-              </a:rPr>
-              <a:t> 토리에서 보여 지는 항목이 다르게 하였었나요</a:t>
-            </a:r>
-            <a:r>
-              <a:rPr lang="en-US" altLang="ko-KR" dirty="0">
-                <a:highlight>
-                  <a:srgbClr val="FFFF00"/>
-                </a:highlight>
-              </a:rPr>
-              <a:t>?</a:t>
-            </a:r>
-            <a:br>
-              <a:rPr lang="en-US" altLang="ko-KR" dirty="0">
-                <a:highlight>
-                  <a:srgbClr val="FFFF00"/>
-                </a:highlight>
-              </a:rPr>
-            </a:br>
-            <a:br>
-              <a:rPr lang="en-US" altLang="ko-KR" dirty="0">
-                <a:highlight>
-                  <a:srgbClr val="FFFF00"/>
-                </a:highlight>
-              </a:rPr>
-            </a:br>
-            <a:r>
-              <a:rPr lang="en-US" altLang="ko-KR" dirty="0">
-                <a:highlight>
-                  <a:srgbClr val="FFFF00"/>
-                </a:highlight>
-              </a:rPr>
-              <a:t>* </a:t>
-            </a:r>
-            <a:r>
-              <a:rPr lang="ko-KR" altLang="en-US" dirty="0">
-                <a:highlight>
-                  <a:srgbClr val="FFFF00"/>
-                </a:highlight>
-              </a:rPr>
-              <a:t>파악 후 설명 문구 전달 드리겠습니다</a:t>
-            </a:r>
-            <a:r>
-              <a:rPr lang="en-US" altLang="ko-KR" dirty="0">
-                <a:highlight>
-                  <a:srgbClr val="FFFF00"/>
-                </a:highlight>
-              </a:rPr>
-              <a:t>.</a:t>
-            </a:r>
+            <a:endParaRPr lang="en-US" altLang="ko-KR" dirty="0">
+              <a:highlight>
+                <a:srgbClr val="FFFF00"/>
+              </a:highlight>
+            </a:endParaRPr>
           </a:p>
         </p:txBody>
       </p:sp>
@@ -5391,6 +5703,133 @@
           </a:p>
         </p:txBody>
       </p:sp>
+      <p:sp>
+        <p:nvSpPr>
+          <p:cNvPr id="14" name="직사각형 13">
+            <a:extLst>
+              <a:ext uri="{FF2B5EF4-FFF2-40B4-BE49-F238E27FC236}">
+                <a16:creationId xmlns:a16="http://schemas.microsoft.com/office/drawing/2014/main" id="{A3FD006F-F833-AB48-1F9D-40FFB5983FE0}"/>
+              </a:ext>
+            </a:extLst>
+          </p:cNvPr>
+          <p:cNvSpPr/>
+          <p:nvPr/>
+        </p:nvSpPr>
+        <p:spPr>
+          <a:xfrm>
+            <a:off x="4427128" y="2277258"/>
+            <a:ext cx="2927828" cy="223675"/>
+          </a:xfrm>
+          <a:prstGeom prst="rect">
+            <a:avLst/>
+          </a:prstGeom>
+          <a:solidFill>
+            <a:schemeClr val="bg1"/>
+          </a:solidFill>
+          <a:ln>
+            <a:noFill/>
+            <a:prstDash val="sysDash"/>
+          </a:ln>
+        </p:spPr>
+        <p:style>
+          <a:lnRef idx="2">
+            <a:schemeClr val="accent1">
+              <a:shade val="15000"/>
+            </a:schemeClr>
+          </a:lnRef>
+          <a:fillRef idx="1">
+            <a:schemeClr val="accent1"/>
+          </a:fillRef>
+          <a:effectRef idx="0">
+            <a:schemeClr val="accent1"/>
+          </a:effectRef>
+          <a:fontRef idx="minor">
+            <a:schemeClr val="lt1"/>
+          </a:fontRef>
+        </p:style>
+        <p:txBody>
+          <a:bodyPr lIns="0" tIns="0" rIns="0" bIns="0" rtlCol="0" anchor="ctr"/>
+          <a:lstStyle/>
+          <a:p>
+            <a:pPr algn="ctr"/>
+            <a:r>
+              <a:rPr lang="en-US" altLang="ko-KR" sz="1400" dirty="0" err="1">
+                <a:solidFill>
+                  <a:schemeClr val="bg1">
+                    <a:lumMod val="50000"/>
+                  </a:schemeClr>
+                </a:solidFill>
+                <a:highlight>
+                  <a:srgbClr val="FFFF00"/>
+                </a:highlight>
+              </a:rPr>
+              <a:t>Oooo</a:t>
+            </a:r>
+            <a:r>
+              <a:rPr lang="ko-KR" altLang="en-US" sz="1400" dirty="0">
+                <a:solidFill>
+                  <a:schemeClr val="bg1">
+                    <a:lumMod val="50000"/>
+                  </a:schemeClr>
+                </a:solidFill>
+                <a:highlight>
+                  <a:srgbClr val="FFFF00"/>
+                </a:highlight>
+              </a:rPr>
+              <a:t>의 </a:t>
+            </a:r>
+            <a:r>
+              <a:rPr lang="en-US" altLang="ko-KR" sz="1400" dirty="0">
+                <a:solidFill>
+                  <a:schemeClr val="bg1">
+                    <a:lumMod val="50000"/>
+                  </a:schemeClr>
+                </a:solidFill>
+                <a:highlight>
+                  <a:srgbClr val="FFFF00"/>
+                </a:highlight>
+              </a:rPr>
+              <a:t>repo </a:t>
+            </a:r>
+            <a:r>
+              <a:rPr lang="ko-KR" altLang="en-US" sz="1400" dirty="0">
+                <a:solidFill>
+                  <a:schemeClr val="bg1">
+                    <a:lumMod val="50000"/>
+                  </a:schemeClr>
+                </a:solidFill>
+                <a:highlight>
+                  <a:srgbClr val="FFFF00"/>
+                </a:highlight>
+              </a:rPr>
+              <a:t>정보만 수집 합니다</a:t>
+            </a:r>
+            <a:r>
+              <a:rPr lang="en-US" altLang="ko-KR" sz="1400" dirty="0">
+                <a:solidFill>
+                  <a:schemeClr val="bg1">
+                    <a:lumMod val="50000"/>
+                  </a:schemeClr>
+                </a:solidFill>
+                <a:highlight>
+                  <a:srgbClr val="FFFF00"/>
+                </a:highlight>
+              </a:rPr>
+              <a:t>.</a:t>
+            </a:r>
+            <a:endParaRPr lang="ko-KR" altLang="en-US" sz="1400" dirty="0">
+              <a:solidFill>
+                <a:schemeClr val="bg1">
+                  <a:lumMod val="50000"/>
+                </a:schemeClr>
+              </a:solidFill>
+              <a:highlight>
+                <a:srgbClr val="FFFF00"/>
+              </a:highlight>
+            </a:endParaRPr>
+          </a:p>
+        </p:txBody>
+      </p:sp>
     </p:spTree>
     <p:extLst>
       <p:ext uri="{BB962C8B-B14F-4D97-AF65-F5344CB8AC3E}">
@@ -5404,7 +5843,7 @@
 </p:sld>
 </file>
 
-<file path=ppt/slides/slide13.xml><?xml version="1.0" encoding="utf-8"?>
+<file path=ppt/slides/slide14.xml><?xml version="1.0" encoding="utf-8"?>
 <p:sld xmlns:a="http://schemas.openxmlformats.org/drawingml/2006/main" xmlns:r="http://schemas.openxmlformats.org/officeDocument/2006/relationships" xmlns:p="http://schemas.openxmlformats.org/presentationml/2006/main">
   <p:cSld>
     <p:spTree>
@@ -5739,7 +6178,477 @@
 </p:sld>
 </file>
 
-<file path=ppt/slides/slide14.xml><?xml version="1.0" encoding="utf-8"?>
+<file path=ppt/slides/slide15.xml><?xml version="1.0" encoding="utf-8"?>
+<p:sld xmlns:a="http://schemas.openxmlformats.org/drawingml/2006/main" xmlns:r="http://schemas.openxmlformats.org/officeDocument/2006/relationships" xmlns:p="http://schemas.openxmlformats.org/presentationml/2006/main">
+  <p:cSld>
+    <p:spTree>
+      <p:nvGrpSpPr>
+        <p:cNvPr id="1" name=""/>
+        <p:cNvGrpSpPr/>
+        <p:nvPr/>
+      </p:nvGrpSpPr>
+      <p:grpSpPr>
+        <a:xfrm>
+          <a:off x="0" y="0"/>
+          <a:ext cx="0" cy="0"/>
+          <a:chOff x="0" y="0"/>
+          <a:chExt cx="0" cy="0"/>
+        </a:xfrm>
+      </p:grpSpPr>
+      <p:sp>
+        <p:nvSpPr>
+          <p:cNvPr id="2" name="제목 1">
+            <a:extLst>
+              <a:ext uri="{FF2B5EF4-FFF2-40B4-BE49-F238E27FC236}">
+                <a16:creationId xmlns:a16="http://schemas.microsoft.com/office/drawing/2014/main" id="{37D1A40D-BC04-A34B-13F3-DC7C4CEE8F92}"/>
+              </a:ext>
+            </a:extLst>
+          </p:cNvPr>
+          <p:cNvSpPr>
+            <a:spLocks noGrp="1"/>
+          </p:cNvSpPr>
+          <p:nvPr>
+            <p:ph type="title"/>
+          </p:nvPr>
+        </p:nvSpPr>
+        <p:spPr/>
+        <p:txBody>
+          <a:bodyPr/>
+          <a:lstStyle/>
+          <a:p>
+            <a:endParaRPr lang="ko-KR" altLang="en-US"/>
+          </a:p>
+        </p:txBody>
+      </p:sp>
+    </p:spTree>
+    <p:extLst>
+      <p:ext uri="{BB962C8B-B14F-4D97-AF65-F5344CB8AC3E}">
+        <p14:creationId xmlns:p14="http://schemas.microsoft.com/office/powerpoint/2010/main" val="1762703876"/>
+      </p:ext>
+    </p:extLst>
+  </p:cSld>
+  <p:clrMapOvr>
+    <a:masterClrMapping/>
+  </p:clrMapOvr>
+</p:sld>
+</file>
+
+<file path=ppt/slides/slide16.xml><?xml version="1.0" encoding="utf-8"?>
+<p:sld xmlns:a="http://schemas.openxmlformats.org/drawingml/2006/main" xmlns:r="http://schemas.openxmlformats.org/officeDocument/2006/relationships" xmlns:p="http://schemas.openxmlformats.org/presentationml/2006/main">
+  <p:cSld>
+    <p:spTree>
+      <p:nvGrpSpPr>
+        <p:cNvPr id="1" name=""/>
+        <p:cNvGrpSpPr/>
+        <p:nvPr/>
+      </p:nvGrpSpPr>
+      <p:grpSpPr>
+        <a:xfrm>
+          <a:off x="0" y="0"/>
+          <a:ext cx="0" cy="0"/>
+          <a:chOff x="0" y="0"/>
+          <a:chExt cx="0" cy="0"/>
+        </a:xfrm>
+      </p:grpSpPr>
+      <p:sp>
+        <p:nvSpPr>
+          <p:cNvPr id="2" name="제목 1">
+            <a:extLst>
+              <a:ext uri="{FF2B5EF4-FFF2-40B4-BE49-F238E27FC236}">
+                <a16:creationId xmlns:a16="http://schemas.microsoft.com/office/drawing/2014/main" id="{793A819A-4022-0F07-25A4-FD57F6939A0D}"/>
+              </a:ext>
+            </a:extLst>
+          </p:cNvPr>
+          <p:cNvSpPr>
+            <a:spLocks noGrp="1"/>
+          </p:cNvSpPr>
+          <p:nvPr>
+            <p:ph type="title"/>
+          </p:nvPr>
+        </p:nvSpPr>
+        <p:spPr/>
+        <p:txBody>
+          <a:bodyPr/>
+          <a:lstStyle/>
+          <a:p>
+            <a:endParaRPr lang="ko-KR" altLang="en-US"/>
+          </a:p>
+        </p:txBody>
+      </p:sp>
+    </p:spTree>
+    <p:extLst>
+      <p:ext uri="{BB962C8B-B14F-4D97-AF65-F5344CB8AC3E}">
+        <p14:creationId xmlns:p14="http://schemas.microsoft.com/office/powerpoint/2010/main" val="3187036238"/>
+      </p:ext>
+    </p:extLst>
+  </p:cSld>
+  <p:clrMapOvr>
+    <a:masterClrMapping/>
+  </p:clrMapOvr>
+</p:sld>
+</file>
+
+<file path=ppt/slides/slide17.xml><?xml version="1.0" encoding="utf-8"?>
+<p:sld xmlns:a="http://schemas.openxmlformats.org/drawingml/2006/main" xmlns:r="http://schemas.openxmlformats.org/officeDocument/2006/relationships" xmlns:p="http://schemas.openxmlformats.org/presentationml/2006/main">
+  <p:cSld>
+    <p:spTree>
+      <p:nvGrpSpPr>
+        <p:cNvPr id="1" name=""/>
+        <p:cNvGrpSpPr/>
+        <p:nvPr/>
+      </p:nvGrpSpPr>
+      <p:grpSpPr>
+        <a:xfrm>
+          <a:off x="0" y="0"/>
+          <a:ext cx="0" cy="0"/>
+          <a:chOff x="0" y="0"/>
+          <a:chExt cx="0" cy="0"/>
+        </a:xfrm>
+      </p:grpSpPr>
+      <p:sp>
+        <p:nvSpPr>
+          <p:cNvPr id="2" name="제목 1">
+            <a:extLst>
+              <a:ext uri="{FF2B5EF4-FFF2-40B4-BE49-F238E27FC236}">
+                <a16:creationId xmlns:a16="http://schemas.microsoft.com/office/drawing/2014/main" id="{4F9F984E-4922-32EC-61B8-A2AA7CDEF79E}"/>
+              </a:ext>
+            </a:extLst>
+          </p:cNvPr>
+          <p:cNvSpPr>
+            <a:spLocks noGrp="1"/>
+          </p:cNvSpPr>
+          <p:nvPr>
+            <p:ph type="title"/>
+          </p:nvPr>
+        </p:nvSpPr>
+        <p:spPr/>
+        <p:txBody>
+          <a:bodyPr/>
+          <a:lstStyle/>
+          <a:p>
+            <a:endParaRPr lang="ko-KR" altLang="en-US"/>
+          </a:p>
+        </p:txBody>
+      </p:sp>
+    </p:spTree>
+    <p:extLst>
+      <p:ext uri="{BB962C8B-B14F-4D97-AF65-F5344CB8AC3E}">
+        <p14:creationId xmlns:p14="http://schemas.microsoft.com/office/powerpoint/2010/main" val="1628367054"/>
+      </p:ext>
+    </p:extLst>
+  </p:cSld>
+  <p:clrMapOvr>
+    <a:masterClrMapping/>
+  </p:clrMapOvr>
+</p:sld>
+</file>
+
+<file path=ppt/slides/slide18.xml><?xml version="1.0" encoding="utf-8"?>
+<p:sld xmlns:a="http://schemas.openxmlformats.org/drawingml/2006/main" xmlns:r="http://schemas.openxmlformats.org/officeDocument/2006/relationships" xmlns:p="http://schemas.openxmlformats.org/presentationml/2006/main">
+  <p:cSld>
+    <p:spTree>
+      <p:nvGrpSpPr>
+        <p:cNvPr id="1" name=""/>
+        <p:cNvGrpSpPr/>
+        <p:nvPr/>
+      </p:nvGrpSpPr>
+      <p:grpSpPr>
+        <a:xfrm>
+          <a:off x="0" y="0"/>
+          <a:ext cx="0" cy="0"/>
+          <a:chOff x="0" y="0"/>
+          <a:chExt cx="0" cy="0"/>
+        </a:xfrm>
+      </p:grpSpPr>
+      <p:sp>
+        <p:nvSpPr>
+          <p:cNvPr id="2" name="제목 1">
+            <a:extLst>
+              <a:ext uri="{FF2B5EF4-FFF2-40B4-BE49-F238E27FC236}">
+                <a16:creationId xmlns:a16="http://schemas.microsoft.com/office/drawing/2014/main" id="{620235F9-3DDB-CAD2-509F-8BAB26262095}"/>
+              </a:ext>
+            </a:extLst>
+          </p:cNvPr>
+          <p:cNvSpPr>
+            <a:spLocks noGrp="1"/>
+          </p:cNvSpPr>
+          <p:nvPr>
+            <p:ph type="title"/>
+          </p:nvPr>
+        </p:nvSpPr>
+        <p:spPr/>
+        <p:txBody>
+          <a:bodyPr/>
+          <a:lstStyle/>
+          <a:p>
+            <a:endParaRPr lang="ko-KR" altLang="en-US"/>
+          </a:p>
+        </p:txBody>
+      </p:sp>
+    </p:spTree>
+    <p:extLst>
+      <p:ext uri="{BB962C8B-B14F-4D97-AF65-F5344CB8AC3E}">
+        <p14:creationId xmlns:p14="http://schemas.microsoft.com/office/powerpoint/2010/main" val="1740472668"/>
+      </p:ext>
+    </p:extLst>
+  </p:cSld>
+  <p:clrMapOvr>
+    <a:masterClrMapping/>
+  </p:clrMapOvr>
+</p:sld>
+</file>
+
+<file path=ppt/slides/slide19.xml><?xml version="1.0" encoding="utf-8"?>
+<p:sld xmlns:a="http://schemas.openxmlformats.org/drawingml/2006/main" xmlns:r="http://schemas.openxmlformats.org/officeDocument/2006/relationships" xmlns:p="http://schemas.openxmlformats.org/presentationml/2006/main">
+  <p:cSld>
+    <p:spTree>
+      <p:nvGrpSpPr>
+        <p:cNvPr id="1" name=""/>
+        <p:cNvGrpSpPr/>
+        <p:nvPr/>
+      </p:nvGrpSpPr>
+      <p:grpSpPr>
+        <a:xfrm>
+          <a:off x="0" y="0"/>
+          <a:ext cx="0" cy="0"/>
+          <a:chOff x="0" y="0"/>
+          <a:chExt cx="0" cy="0"/>
+        </a:xfrm>
+      </p:grpSpPr>
+      <p:sp>
+        <p:nvSpPr>
+          <p:cNvPr id="2" name="제목 1">
+            <a:extLst>
+              <a:ext uri="{FF2B5EF4-FFF2-40B4-BE49-F238E27FC236}">
+                <a16:creationId xmlns:a16="http://schemas.microsoft.com/office/drawing/2014/main" id="{5D072BED-D4E0-AD79-B796-DCC0E4FC0ADC}"/>
+              </a:ext>
+            </a:extLst>
+          </p:cNvPr>
+          <p:cNvSpPr>
+            <a:spLocks noGrp="1"/>
+          </p:cNvSpPr>
+          <p:nvPr>
+            <p:ph type="title"/>
+          </p:nvPr>
+        </p:nvSpPr>
+        <p:spPr/>
+        <p:txBody>
+          <a:bodyPr/>
+          <a:lstStyle/>
+          <a:p>
+            <a:endParaRPr lang="ko-KR" altLang="en-US"/>
+          </a:p>
+        </p:txBody>
+      </p:sp>
+      <p:pic>
+        <p:nvPicPr>
+          <p:cNvPr id="4" name="그림 3">
+            <a:extLst>
+              <a:ext uri="{FF2B5EF4-FFF2-40B4-BE49-F238E27FC236}">
+                <a16:creationId xmlns:a16="http://schemas.microsoft.com/office/drawing/2014/main" id="{A7A374BE-0F6E-3369-A9F2-3D53D6A0995D}"/>
+              </a:ext>
+            </a:extLst>
+          </p:cNvPr>
+          <p:cNvPicPr>
+            <a:picLocks noChangeAspect="1"/>
+          </p:cNvPicPr>
+          <p:nvPr/>
+        </p:nvPicPr>
+        <p:blipFill>
+          <a:blip r:embed="rId2"/>
+          <a:stretch>
+            <a:fillRect/>
+          </a:stretch>
+        </p:blipFill>
+        <p:spPr>
+          <a:xfrm>
+            <a:off x="675822" y="0"/>
+            <a:ext cx="10840356" cy="6858000"/>
+          </a:xfrm>
+          <a:prstGeom prst="rect">
+            <a:avLst/>
+          </a:prstGeom>
+        </p:spPr>
+      </p:pic>
+    </p:spTree>
+    <p:extLst>
+      <p:ext uri="{BB962C8B-B14F-4D97-AF65-F5344CB8AC3E}">
+        <p14:creationId xmlns:p14="http://schemas.microsoft.com/office/powerpoint/2010/main" val="2421219215"/>
+      </p:ext>
+    </p:extLst>
+  </p:cSld>
+  <p:clrMapOvr>
+    <a:masterClrMapping/>
+  </p:clrMapOvr>
+</p:sld>
+</file>
+
+<file path=ppt/slides/slide2.xml><?xml version="1.0" encoding="utf-8"?>
+<p:sld xmlns:a="http://schemas.openxmlformats.org/drawingml/2006/main" xmlns:r="http://schemas.openxmlformats.org/officeDocument/2006/relationships" xmlns:p="http://schemas.openxmlformats.org/presentationml/2006/main">
+  <p:cSld>
+    <p:spTree>
+      <p:nvGrpSpPr>
+        <p:cNvPr id="1" name=""/>
+        <p:cNvGrpSpPr/>
+        <p:nvPr/>
+      </p:nvGrpSpPr>
+      <p:grpSpPr>
+        <a:xfrm>
+          <a:off x="0" y="0"/>
+          <a:ext cx="0" cy="0"/>
+          <a:chOff x="0" y="0"/>
+          <a:chExt cx="0" cy="0"/>
+        </a:xfrm>
+      </p:grpSpPr>
+      <p:sp>
+        <p:nvSpPr>
+          <p:cNvPr id="2" name="제목 1">
+            <a:extLst>
+              <a:ext uri="{FF2B5EF4-FFF2-40B4-BE49-F238E27FC236}">
+                <a16:creationId xmlns:a16="http://schemas.microsoft.com/office/drawing/2014/main" id="{6B72C4B6-F596-F78E-3A8C-23BCA79F7F76}"/>
+              </a:ext>
+            </a:extLst>
+          </p:cNvPr>
+          <p:cNvSpPr>
+            <a:spLocks noGrp="1"/>
+          </p:cNvSpPr>
+          <p:nvPr>
+            <p:ph type="title"/>
+          </p:nvPr>
+        </p:nvSpPr>
+        <p:spPr/>
+        <p:txBody>
+          <a:bodyPr/>
+          <a:lstStyle/>
+          <a:p>
+            <a:endParaRPr lang="ko-KR" altLang="en-US"/>
+          </a:p>
+        </p:txBody>
+      </p:sp>
+      <p:sp>
+        <p:nvSpPr>
+          <p:cNvPr id="3" name="내용 개체 틀 2">
+            <a:extLst>
+              <a:ext uri="{FF2B5EF4-FFF2-40B4-BE49-F238E27FC236}">
+                <a16:creationId xmlns:a16="http://schemas.microsoft.com/office/drawing/2014/main" id="{461B4D87-F7B2-AB98-E8DD-ED3981191125}"/>
+              </a:ext>
+            </a:extLst>
+          </p:cNvPr>
+          <p:cNvSpPr>
+            <a:spLocks noGrp="1"/>
+          </p:cNvSpPr>
+          <p:nvPr>
+            <p:ph idx="1"/>
+          </p:nvPr>
+        </p:nvSpPr>
+        <p:spPr/>
+        <p:txBody>
+          <a:bodyPr/>
+          <a:lstStyle/>
+          <a:p>
+            <a:endParaRPr lang="ko-KR" altLang="en-US"/>
+          </a:p>
+        </p:txBody>
+      </p:sp>
+    </p:spTree>
+    <p:extLst>
+      <p:ext uri="{BB962C8B-B14F-4D97-AF65-F5344CB8AC3E}">
+        <p14:creationId xmlns:p14="http://schemas.microsoft.com/office/powerpoint/2010/main" val="1772083265"/>
+      </p:ext>
+    </p:extLst>
+  </p:cSld>
+  <p:clrMapOvr>
+    <a:masterClrMapping/>
+  </p:clrMapOvr>
+</p:sld>
+</file>
+
+<file path=ppt/slides/slide20.xml><?xml version="1.0" encoding="utf-8"?>
+<p:sld xmlns:a="http://schemas.openxmlformats.org/drawingml/2006/main" xmlns:r="http://schemas.openxmlformats.org/officeDocument/2006/relationships" xmlns:p="http://schemas.openxmlformats.org/presentationml/2006/main">
+  <p:cSld>
+    <p:spTree>
+      <p:nvGrpSpPr>
+        <p:cNvPr id="1" name=""/>
+        <p:cNvGrpSpPr/>
+        <p:nvPr/>
+      </p:nvGrpSpPr>
+      <p:grpSpPr>
+        <a:xfrm>
+          <a:off x="0" y="0"/>
+          <a:ext cx="0" cy="0"/>
+          <a:chOff x="0" y="0"/>
+          <a:chExt cx="0" cy="0"/>
+        </a:xfrm>
+      </p:grpSpPr>
+      <p:sp>
+        <p:nvSpPr>
+          <p:cNvPr id="2" name="제목 1">
+            <a:extLst>
+              <a:ext uri="{FF2B5EF4-FFF2-40B4-BE49-F238E27FC236}">
+                <a16:creationId xmlns:a16="http://schemas.microsoft.com/office/drawing/2014/main" id="{AB78672C-B05B-6FC7-DA5D-4DC14CCB0CF5}"/>
+              </a:ext>
+            </a:extLst>
+          </p:cNvPr>
+          <p:cNvSpPr>
+            <a:spLocks noGrp="1"/>
+          </p:cNvSpPr>
+          <p:nvPr>
+            <p:ph type="title"/>
+          </p:nvPr>
+        </p:nvSpPr>
+        <p:spPr/>
+        <p:txBody>
+          <a:bodyPr/>
+          <a:lstStyle/>
+          <a:p>
+            <a:endParaRPr lang="ko-KR" altLang="en-US"/>
+          </a:p>
+        </p:txBody>
+      </p:sp>
+      <p:pic>
+        <p:nvPicPr>
+          <p:cNvPr id="4" name="그림 3">
+            <a:extLst>
+              <a:ext uri="{FF2B5EF4-FFF2-40B4-BE49-F238E27FC236}">
+                <a16:creationId xmlns:a16="http://schemas.microsoft.com/office/drawing/2014/main" id="{86663FFD-757A-B59F-D3BD-DEB11E2B0B10}"/>
+              </a:ext>
+            </a:extLst>
+          </p:cNvPr>
+          <p:cNvPicPr>
+            <a:picLocks noChangeAspect="1"/>
+          </p:cNvPicPr>
+          <p:nvPr/>
+        </p:nvPicPr>
+        <p:blipFill>
+          <a:blip r:embed="rId2"/>
+          <a:stretch>
+            <a:fillRect/>
+          </a:stretch>
+        </p:blipFill>
+        <p:spPr>
+          <a:xfrm>
+            <a:off x="3116347" y="0"/>
+            <a:ext cx="5959306" cy="6858000"/>
+          </a:xfrm>
+          <a:prstGeom prst="rect">
+            <a:avLst/>
+          </a:prstGeom>
+        </p:spPr>
+      </p:pic>
+    </p:spTree>
+    <p:extLst>
+      <p:ext uri="{BB962C8B-B14F-4D97-AF65-F5344CB8AC3E}">
+        <p14:creationId xmlns:p14="http://schemas.microsoft.com/office/powerpoint/2010/main" val="1413464511"/>
+      </p:ext>
+    </p:extLst>
+  </p:cSld>
+  <p:clrMapOvr>
+    <a:masterClrMapping/>
+  </p:clrMapOvr>
+</p:sld>
+</file>
+
+<file path=ppt/slides/slide21.xml><?xml version="1.0" encoding="utf-8"?>
 <p:sld xmlns:a="http://schemas.openxmlformats.org/drawingml/2006/main" xmlns:r="http://schemas.openxmlformats.org/officeDocument/2006/relationships" xmlns:p="http://schemas.openxmlformats.org/presentationml/2006/main">
   <p:cSld>
     <p:spTree>
@@ -5881,7 +6790,7 @@
 </p:sld>
 </file>
 
-<file path=ppt/slides/slide15.xml><?xml version="1.0" encoding="utf-8"?>
+<file path=ppt/slides/slide22.xml><?xml version="1.0" encoding="utf-8"?>
 <p:sld xmlns:a="http://schemas.openxmlformats.org/drawingml/2006/main" xmlns:r="http://schemas.openxmlformats.org/officeDocument/2006/relationships" xmlns:p="http://schemas.openxmlformats.org/presentationml/2006/main">
   <p:cSld>
     <p:spTree>
@@ -5936,7 +6845,7 @@
 </p:sld>
 </file>
 
-<file path=ppt/slides/slide16.xml><?xml version="1.0" encoding="utf-8"?>
+<file path=ppt/slides/slide23.xml><?xml version="1.0" encoding="utf-8"?>
 <p:sld xmlns:a="http://schemas.openxmlformats.org/drawingml/2006/main" xmlns:r="http://schemas.openxmlformats.org/officeDocument/2006/relationships" xmlns:p="http://schemas.openxmlformats.org/presentationml/2006/main">
   <p:cSld>
     <p:spTree>
@@ -6212,7 +7121,7 @@
 </p:sld>
 </file>
 
-<file path=ppt/slides/slide17.xml><?xml version="1.0" encoding="utf-8"?>
+<file path=ppt/slides/slide24.xml><?xml version="1.0" encoding="utf-8"?>
 <p:sld xmlns:a="http://schemas.openxmlformats.org/drawingml/2006/main" xmlns:r="http://schemas.openxmlformats.org/officeDocument/2006/relationships" xmlns:p="http://schemas.openxmlformats.org/presentationml/2006/main">
   <p:cSld>
     <p:spTree>
@@ -6420,7 +7329,7 @@
 </p:sld>
 </file>
 
-<file path=ppt/slides/slide18.xml><?xml version="1.0" encoding="utf-8"?>
+<file path=ppt/slides/slide25.xml><?xml version="1.0" encoding="utf-8"?>
 <p:sld xmlns:a="http://schemas.openxmlformats.org/drawingml/2006/main" xmlns:r="http://schemas.openxmlformats.org/officeDocument/2006/relationships" xmlns:p="http://schemas.openxmlformats.org/presentationml/2006/main">
   <p:cSld>
     <p:spTree>
@@ -31802,7 +32711,7 @@
 </p:sld>
 </file>
 
-<file path=ppt/slides/slide19.xml><?xml version="1.0" encoding="utf-8"?>
+<file path=ppt/slides/slide26.xml><?xml version="1.0" encoding="utf-8"?>
 <p:sld xmlns:a="http://schemas.openxmlformats.org/drawingml/2006/main" xmlns:r="http://schemas.openxmlformats.org/officeDocument/2006/relationships" xmlns:p="http://schemas.openxmlformats.org/presentationml/2006/main">
   <p:cSld>
     <p:spTree>
@@ -35180,87 +36089,7 @@
 </p:sld>
 </file>
 
-<file path=ppt/slides/slide2.xml><?xml version="1.0" encoding="utf-8"?>
-<p:sld xmlns:a="http://schemas.openxmlformats.org/drawingml/2006/main" xmlns:r="http://schemas.openxmlformats.org/officeDocument/2006/relationships" xmlns:p="http://schemas.openxmlformats.org/presentationml/2006/main">
-  <p:cSld>
-    <p:spTree>
-      <p:nvGrpSpPr>
-        <p:cNvPr id="1" name=""/>
-        <p:cNvGrpSpPr/>
-        <p:nvPr/>
-      </p:nvGrpSpPr>
-      <p:grpSpPr>
-        <a:xfrm>
-          <a:off x="0" y="0"/>
-          <a:ext cx="0" cy="0"/>
-          <a:chOff x="0" y="0"/>
-          <a:chExt cx="0" cy="0"/>
-        </a:xfrm>
-      </p:grpSpPr>
-      <p:sp>
-        <p:nvSpPr>
-          <p:cNvPr id="2" name="제목 1">
-            <a:extLst>
-              <a:ext uri="{FF2B5EF4-FFF2-40B4-BE49-F238E27FC236}">
-                <a16:creationId xmlns:a16="http://schemas.microsoft.com/office/drawing/2014/main" id="{6B72C4B6-F596-F78E-3A8C-23BCA79F7F76}"/>
-              </a:ext>
-            </a:extLst>
-          </p:cNvPr>
-          <p:cNvSpPr>
-            <a:spLocks noGrp="1"/>
-          </p:cNvSpPr>
-          <p:nvPr>
-            <p:ph type="title"/>
-          </p:nvPr>
-        </p:nvSpPr>
-        <p:spPr/>
-        <p:txBody>
-          <a:bodyPr/>
-          <a:lstStyle/>
-          <a:p>
-            <a:endParaRPr lang="ko-KR" altLang="en-US"/>
-          </a:p>
-        </p:txBody>
-      </p:sp>
-      <p:sp>
-        <p:nvSpPr>
-          <p:cNvPr id="3" name="내용 개체 틀 2">
-            <a:extLst>
-              <a:ext uri="{FF2B5EF4-FFF2-40B4-BE49-F238E27FC236}">
-                <a16:creationId xmlns:a16="http://schemas.microsoft.com/office/drawing/2014/main" id="{461B4D87-F7B2-AB98-E8DD-ED3981191125}"/>
-              </a:ext>
-            </a:extLst>
-          </p:cNvPr>
-          <p:cNvSpPr>
-            <a:spLocks noGrp="1"/>
-          </p:cNvSpPr>
-          <p:nvPr>
-            <p:ph idx="1"/>
-          </p:nvPr>
-        </p:nvSpPr>
-        <p:spPr/>
-        <p:txBody>
-          <a:bodyPr/>
-          <a:lstStyle/>
-          <a:p>
-            <a:endParaRPr lang="ko-KR" altLang="en-US"/>
-          </a:p>
-        </p:txBody>
-      </p:sp>
-    </p:spTree>
-    <p:extLst>
-      <p:ext uri="{BB962C8B-B14F-4D97-AF65-F5344CB8AC3E}">
-        <p14:creationId xmlns:p14="http://schemas.microsoft.com/office/powerpoint/2010/main" val="1772083265"/>
-      </p:ext>
-    </p:extLst>
-  </p:cSld>
-  <p:clrMapOvr>
-    <a:masterClrMapping/>
-  </p:clrMapOvr>
-</p:sld>
-</file>
-
-<file path=ppt/slides/slide20.xml><?xml version="1.0" encoding="utf-8"?>
+<file path=ppt/slides/slide27.xml><?xml version="1.0" encoding="utf-8"?>
 <p:sld xmlns:a="http://schemas.openxmlformats.org/drawingml/2006/main" xmlns:r="http://schemas.openxmlformats.org/officeDocument/2006/relationships" xmlns:p="http://schemas.openxmlformats.org/presentationml/2006/main">
   <p:cSld>
     <p:spTree>
@@ -38641,7 +39470,7 @@
 </p:sld>
 </file>
 
-<file path=ppt/slides/slide21.xml><?xml version="1.0" encoding="utf-8"?>
+<file path=ppt/slides/slide28.xml><?xml version="1.0" encoding="utf-8"?>
 <p:sld xmlns:a="http://schemas.openxmlformats.org/drawingml/2006/main" xmlns:r="http://schemas.openxmlformats.org/officeDocument/2006/relationships" xmlns:p="http://schemas.openxmlformats.org/presentationml/2006/main">
   <p:cSld>
     <p:spTree>
@@ -42018,7 +42847,7 @@
 </p:sld>
 </file>
 
-<file path=ppt/slides/slide22.xml><?xml version="1.0" encoding="utf-8"?>
+<file path=ppt/slides/slide29.xml><?xml version="1.0" encoding="utf-8"?>
 <p:sld xmlns:a="http://schemas.openxmlformats.org/drawingml/2006/main" xmlns:r="http://schemas.openxmlformats.org/officeDocument/2006/relationships" xmlns:p="http://schemas.openxmlformats.org/presentationml/2006/main">
   <p:cSld>
     <p:spTree>
@@ -45547,7 +46376,7 @@
         </p:nvSpPr>
         <p:spPr>
           <a:xfrm>
-            <a:off x="5121965" y="755432"/>
+            <a:off x="4973109" y="546943"/>
             <a:ext cx="6374296" cy="923330"/>
           </a:xfrm>
           <a:prstGeom prst="rect">

</xml_diff>